<commit_message>
Reportar solo afectaciones documentadas a servicios MTDH y corregir carga concurrente
</commit_message>
<xml_diff>
--- a/docs/reportes/Seguimiento_ENOS_2026-10-26.pptx
+++ b/docs/reportes/Seguimiento_ENOS_2026-10-26.pptx
@@ -140,28 +140,16 @@
           </c:spPr>
           <c:cat>
             <c:strRef>
-              <c:f>Sheet1!$A$2:$A$8</c:f>
+              <c:f>Sheet1!$A$2:$A$4</c:f>
               <c:strCache>
-                <c:ptCount val="7"/>
+                <c:ptCount val="3"/>
                 <c:pt idx="0">
-                  <c:v>Santa Elena</c:v>
+                  <c:v>Manabí</c:v>
                 </c:pt>
                 <c:pt idx="1">
-                  <c:v>Esmeraldas</c:v>
+                  <c:v>El Oro</c:v>
                 </c:pt>
                 <c:pt idx="2">
-                  <c:v>Cotopaxi</c:v>
-                </c:pt>
-                <c:pt idx="3">
-                  <c:v>Pichincha</c:v>
-                </c:pt>
-                <c:pt idx="4">
-                  <c:v>Manabí</c:v>
-                </c:pt>
-                <c:pt idx="5">
-                  <c:v>El Oro</c:v>
-                </c:pt>
-                <c:pt idx="6">
                   <c:v>Guayas</c:v>
                 </c:pt>
               </c:strCache>
@@ -169,30 +157,18 @@
           </c:cat>
           <c:val>
             <c:numRef>
-              <c:f>Sheet1!$B$2:$B$8</c:f>
+              <c:f>Sheet1!$B$2:$B$4</c:f>
               <c:numCache>
                 <c:formatCode>#,##0</c:formatCode>
-                <c:ptCount val="7"/>
+                <c:ptCount val="3"/>
                 <c:pt idx="0">
-                  <c:v>1</c:v>
+                  <c:v>2</c:v>
                 </c:pt>
                 <c:pt idx="1">
-                  <c:v>1</c:v>
+                  <c:v>2</c:v>
                 </c:pt>
                 <c:pt idx="2">
-                  <c:v>1</c:v>
-                </c:pt>
-                <c:pt idx="3">
-                  <c:v>2</c:v>
-                </c:pt>
-                <c:pt idx="4">
-                  <c:v>2</c:v>
-                </c:pt>
-                <c:pt idx="5">
-                  <c:v>3</c:v>
-                </c:pt>
-                <c:pt idx="6">
-                  <c:v>7</c:v>
+                  <c:v>4</c:v>
                 </c:pt>
               </c:numCache>
             </c:numRef>
@@ -689,7 +665,7 @@
           <a:lstStyle/>
           <a:p>
             <a:r>
-              <a:t>Alertas registradas: 17. Alertas abiertas: 16. UA identificadas en alertas: 10. Kits entregados: 802. 17 alertas registradas desde el 29/09 en 7 provincias.</a:t>
+              <a:t>Alertas de servicios MTDH: 8. Alertas abiertas: 8. UA con afectación documentada: 8. Kits entregados: 802. 8 alertas con afectación a servicios MTDH desde el 29/09 en 3 provincias.</a:t>
             </a:r>
           </a:p>
         </p:txBody>
@@ -759,6 +735,11 @@
           <a:lstStyle/>
           <a:p>
             <a:r>
+              <a:t>Ámbito: Solo afectaciones documentadas a servicios MTDH</a:t>
+            </a:r>
+          </a:p>
+          <a:p>
+            <a:r>
               <a:t>Alertas desde: 29/09/2026</a:t>
             </a:r>
           </a:p>
@@ -784,7 +765,7 @@
           </a:p>
           <a:p>
             <a:r>
-              <a:t>Alertas de desastre natural registradas desde el 29 de septiembre de 2026. La fecha corresponde al registro de la alerta; una alerta no equivale necesariamente a un evento único. El campo Afectados mezcla personas, familias y usuarios, por lo que no se presenta un total de personas únicas. La base no certifica atribución causal a ENOS.</a:t>
+              <a:t>Solo se incluyen alertas con afectación documentada a instalaciones, acceso, continuidad o modalidad de atención de los servicios MTDH, registradas desde el 29 de septiembre de 2026. Se excluyen daños externos o a viviendas de familias usuarias sin impacto documentado en el servicio. Un código UA por sí solo no acredita afectación. La fecha corresponde al registro de la alerta; una alerta no equivale necesariamente a un evento único. El campo Afectados mezcla personas, familias y usuarios, por lo que no se presenta un total de personas únicas. La base no certifica atribución causal a ENOS.</a:t>
             </a:r>
           </a:p>
           <a:p>
@@ -859,6 +840,11 @@
           <a:lstStyle/>
           <a:p>
             <a:r>
+              <a:t>Ámbito: Solo afectaciones documentadas a servicios MTDH</a:t>
+            </a:r>
+          </a:p>
+          <a:p>
+            <a:r>
               <a:t>Alertas desde: 29/09/2026</a:t>
             </a:r>
           </a:p>
@@ -884,7 +870,7 @@
           </a:p>
           <a:p>
             <a:r>
-              <a:t>Alertas de desastre natural registradas desde el 29 de septiembre de 2026. La fecha corresponde al registro de la alerta; una alerta no equivale necesariamente a un evento único. El campo Afectados mezcla personas, familias y usuarios, por lo que no se presenta un total de personas únicas. La base no certifica atribución causal a ENOS.</a:t>
+              <a:t>Solo se incluyen alertas con afectación documentada a instalaciones, acceso, continuidad o modalidad de atención de los servicios MTDH, registradas desde el 29 de septiembre de 2026. Se excluyen daños externos o a viviendas de familias usuarias sin impacto documentado en el servicio. Un código UA por sí solo no acredita afectación. La fecha corresponde al registro de la alerta; una alerta no equivale necesariamente a un evento único. El campo Afectados mezcla personas, familias y usuarios, por lo que no se presenta un total de personas únicas. La base no certifica atribución causal a ENOS.</a:t>
             </a:r>
           </a:p>
           <a:p>
@@ -959,6 +945,11 @@
           <a:lstStyle/>
           <a:p>
             <a:r>
+              <a:t>Ámbito: Solo afectaciones documentadas a servicios MTDH</a:t>
+            </a:r>
+          </a:p>
+          <a:p>
+            <a:r>
               <a:t>Alertas desde: 29/09/2026</a:t>
             </a:r>
           </a:p>
@@ -984,7 +975,7 @@
           </a:p>
           <a:p>
             <a:r>
-              <a:t>Alertas de desastre natural registradas desde el 29 de septiembre de 2026. La fecha corresponde al registro de la alerta; una alerta no equivale necesariamente a un evento único. El campo Afectados mezcla personas, familias y usuarios, por lo que no se presenta un total de personas únicas. La base no certifica atribución causal a ENOS.</a:t>
+              <a:t>Solo se incluyen alertas con afectación documentada a instalaciones, acceso, continuidad o modalidad de atención de los servicios MTDH, registradas desde el 29 de septiembre de 2026. Se excluyen daños externos o a viviendas de familias usuarias sin impacto documentado en el servicio. Un código UA por sí solo no acredita afectación. La fecha corresponde al registro de la alerta; una alerta no equivale necesariamente a un evento único. El campo Afectados mezcla personas, familias y usuarios, por lo que no se presenta un total de personas únicas. La base no certifica atribución causal a ENOS.</a:t>
             </a:r>
           </a:p>
           <a:p>
@@ -4144,13 +4135,13 @@
               </a:lnSpc>
             </a:pPr>
             <a:r>
-              <a:rPr sz="3600" b="1">
+              <a:rPr sz="3200" b="1">
                 <a:solidFill>
                   <a:srgbClr val="FFFFFF"/>
                 </a:solidFill>
                 <a:latin typeface="Century Gothic"/>
               </a:rPr>
-              <a:t>Seguimiento ENOS</a:t>
+              <a:t>Seguimiento y respuesta MTDH</a:t>
             </a:r>
           </a:p>
         </p:txBody>
@@ -4270,7 +4261,7 @@
                 </a:solidFill>
                 <a:latin typeface="Calibri"/>
               </a:rPr>
-              <a:t>Actualizado el 26 de octubre de 2026, 12:26</a:t>
+              <a:t>Actualizado el 26 de octubre de 2026, 13:05</a:t>
             </a:r>
           </a:p>
           <a:p>
@@ -4556,7 +4547,7 @@
                 </a:solidFill>
                 <a:latin typeface="Calibri"/>
               </a:rPr>
-              <a:t>Alertas registradas</a:t>
+              <a:t>Alertas de servicios MTDH</a:t>
             </a:r>
           </a:p>
         </p:txBody>
@@ -4591,7 +4582,7 @@
                 </a:solidFill>
                 <a:latin typeface="Century Gothic"/>
               </a:rPr>
-              <a:t>17</a:t>
+              <a:t>8</a:t>
             </a:r>
           </a:p>
         </p:txBody>
@@ -4818,7 +4809,7 @@
                 </a:solidFill>
                 <a:latin typeface="Century Gothic"/>
               </a:rPr>
-              <a:t>16</a:t>
+              <a:t>8</a:t>
             </a:r>
           </a:p>
         </p:txBody>
@@ -5010,7 +5001,7 @@
                 </a:solidFill>
                 <a:latin typeface="Calibri"/>
               </a:rPr>
-              <a:t>UA identificadas en alertas</a:t>
+              <a:t>UA con afectación documentada</a:t>
             </a:r>
           </a:p>
         </p:txBody>
@@ -5045,7 +5036,7 @@
                 </a:solidFill>
                 <a:latin typeface="Century Gothic"/>
               </a:rPr>
-              <a:t>10</a:t>
+              <a:t>8</a:t>
             </a:r>
           </a:p>
         </p:txBody>
@@ -5498,7 +5489,7 @@
                 </a:solidFill>
                 <a:latin typeface="Century Gothic"/>
               </a:rPr>
-              <a:t>Alertas territoriales</a:t>
+              <a:t>Afectaciones a servicios MTDH</a:t>
             </a:r>
           </a:p>
         </p:txBody>
@@ -5660,7 +5651,7 @@
         </p:nvGraphicFramePr>
         <p:xfrm>
           <a:off x="7406640" y="1554480"/>
-          <a:ext cx="4206239" cy="1828800"/>
+          <a:ext cx="4206239" cy="1371600"/>
         </p:xfrm>
         <a:graphic>
           <a:graphicData uri="http://schemas.openxmlformats.org/drawingml/2006/table">
@@ -5757,7 +5748,7 @@
                           </a:solidFill>
                           <a:latin typeface="Calibri"/>
                         </a:rPr>
-                        <a:t>9</a:t>
+                        <a:t>6</a:t>
                       </a:r>
                     </a:p>
                   </a:txBody>
@@ -5805,7 +5796,7 @@
                           </a:solidFill>
                           <a:latin typeface="Calibri"/>
                         </a:rPr>
-                        <a:t>7</a:t>
+                        <a:t>2</a:t>
                       </a:r>
                     </a:p>
                   </a:txBody>
@@ -5816,54 +5807,6 @@
                   </a:tcPr>
                 </a:tc>
               </a:tr>
-              <a:tr h="457200">
-                <a:tc>
-                  <a:txBody>
-                    <a:bodyPr wrap="square"/>
-                    <a:lstStyle/>
-                    <a:p>
-                      <a:pPr algn="l"/>
-                      <a:r>
-                        <a:rPr sz="1100" b="1">
-                          <a:solidFill>
-                            <a:srgbClr val="2B164F"/>
-                          </a:solidFill>
-                          <a:latin typeface="Calibri"/>
-                        </a:rPr>
-                        <a:t>Resuelto</a:t>
-                      </a:r>
-                    </a:p>
-                  </a:txBody>
-                  <a:tcPr marL="73152" marR="73152" marT="27432" marB="27432" anchor="ctr">
-                    <a:solidFill>
-                      <a:srgbClr val="FFFFFF"/>
-                    </a:solidFill>
-                  </a:tcPr>
-                </a:tc>
-                <a:tc>
-                  <a:txBody>
-                    <a:bodyPr wrap="square"/>
-                    <a:lstStyle/>
-                    <a:p>
-                      <a:pPr algn="r"/>
-                      <a:r>
-                        <a:rPr sz="1100" b="0">
-                          <a:solidFill>
-                            <a:srgbClr val="20202B"/>
-                          </a:solidFill>
-                          <a:latin typeface="Calibri"/>
-                        </a:rPr>
-                        <a:t>1</a:t>
-                      </a:r>
-                    </a:p>
-                  </a:txBody>
-                  <a:tcPr marL="73152" marR="73152" marT="27432" marB="27432" anchor="ctr">
-                    <a:solidFill>
-                      <a:srgbClr val="FFFFFF"/>
-                    </a:solidFill>
-                  </a:tcPr>
-                </a:tc>
-              </a:tr>
             </a:tbl>
           </a:graphicData>
         </a:graphic>
@@ -5898,7 +5841,7 @@
                 </a:solidFill>
                 <a:latin typeface="Calibri"/>
               </a:rPr>
-              <a:t>La base registra alertas, no eventos únicos. El número de personas afectadas no puede consolidarse porque el campo fuente mezcla unidades.</a:t>
+              <a:t>Solo afectaciones documentadas a servicios MTDH. Se excluyen daños externos sin impacto en su atención. El campo Afectados mezcla unidades y no se suma.</a:t>
             </a:r>
           </a:p>
         </p:txBody>

</xml_diff>

<commit_message>
Completar alertas desde el 14 de septiembre y validar tablero y exportables
</commit_message>
<xml_diff>
--- a/docs/reportes/Seguimiento_ENOS_2026-10-26.pptx
+++ b/docs/reportes/Seguimiento_ENOS_2026-10-26.pptx
@@ -144,13 +144,13 @@
               <c:strCache>
                 <c:ptCount val="3"/>
                 <c:pt idx="0">
-                  <c:v>Manabí</c:v>
+                  <c:v>El Oro</c:v>
                 </c:pt>
                 <c:pt idx="1">
-                  <c:v>El Oro</c:v>
+                  <c:v>Guayas</c:v>
                 </c:pt>
                 <c:pt idx="2">
-                  <c:v>Guayas</c:v>
+                  <c:v>Manabí</c:v>
                 </c:pt>
               </c:strCache>
             </c:strRef>
@@ -165,10 +165,10 @@
                   <c:v>2</c:v>
                 </c:pt>
                 <c:pt idx="1">
-                  <c:v>2</c:v>
+                  <c:v>5</c:v>
                 </c:pt>
                 <c:pt idx="2">
-                  <c:v>4</c:v>
+                  <c:v>6</c:v>
                 </c:pt>
               </c:numCache>
             </c:numRef>
@@ -665,7 +665,7 @@
           <a:lstStyle/>
           <a:p>
             <a:r>
-              <a:t>Alertas de servicios MTDH: 8. Alertas abiertas: 8. UA con afectación documentada: 8. Kits entregados: 802. 8 alertas con afectación a servicios MTDH desde el 14/09 en 3 provincias.</a:t>
+              <a:t>Alertas de servicios MTDH: 13. Alertas abiertas: 13. UA afectadas con código: 8. Kits entregados: 802. 13 alertas con afectación a servicios MTDH desde el 14/09 en 3 provincias.</a:t>
             </a:r>
           </a:p>
         </p:txBody>
@@ -4135,13 +4135,13 @@
               </a:lnSpc>
             </a:pPr>
             <a:r>
-              <a:rPr sz="3600" b="1">
+              <a:rPr sz="3200" b="1">
                 <a:solidFill>
                   <a:srgbClr val="FFFFFF"/>
                 </a:solidFill>
                 <a:latin typeface="Century Gothic"/>
               </a:rPr>
-              <a:t>Riesgos y respuesta</a:t>
+              <a:t>Seguimiento y respuesta MTDH</a:t>
             </a:r>
           </a:p>
         </p:txBody>
@@ -4261,7 +4261,7 @@
                 </a:solidFill>
                 <a:latin typeface="Calibri"/>
               </a:rPr>
-              <a:t>Actualizado el 26 de octubre de 2026, 13:05</a:t>
+              <a:t>Actualizado el 26 de octubre de 2026, 14:59</a:t>
             </a:r>
           </a:p>
           <a:p>
@@ -4582,7 +4582,7 @@
                 </a:solidFill>
                 <a:latin typeface="Century Gothic"/>
               </a:rPr>
-              <a:t>8</a:t>
+              <a:t>13</a:t>
             </a:r>
           </a:p>
         </p:txBody>
@@ -4809,7 +4809,7 @@
                 </a:solidFill>
                 <a:latin typeface="Century Gothic"/>
               </a:rPr>
-              <a:t>8</a:t>
+              <a:t>13</a:t>
             </a:r>
           </a:p>
         </p:txBody>
@@ -5001,7 +5001,7 @@
                 </a:solidFill>
                 <a:latin typeface="Calibri"/>
               </a:rPr>
-              <a:t>UA con afectación documentada</a:t>
+              <a:t>UA afectadas con código</a:t>
             </a:r>
           </a:p>
         </p:txBody>
@@ -5071,7 +5071,7 @@
                 </a:solidFill>
                 <a:latin typeface="Calibri"/>
               </a:rPr>
-              <a:t>Códigos de unidad distintos</a:t>
+              <a:t>Solo códigos registrados en la fuente</a:t>
             </a:r>
           </a:p>
         </p:txBody>
@@ -5725,7 +5725,7 @@
                           </a:solidFill>
                           <a:latin typeface="Calibri"/>
                         </a:rPr>
-                        <a:t>Pendiente</a:t>
+                        <a:t>En seguimiento</a:t>
                       </a:r>
                     </a:p>
                   </a:txBody>
@@ -5748,7 +5748,7 @@
                           </a:solidFill>
                           <a:latin typeface="Calibri"/>
                         </a:rPr>
-                        <a:t>6</a:t>
+                        <a:t>7</a:t>
                       </a:r>
                     </a:p>
                   </a:txBody>
@@ -5773,7 +5773,7 @@
                           </a:solidFill>
                           <a:latin typeface="Calibri"/>
                         </a:rPr>
-                        <a:t>En seguimiento</a:t>
+                        <a:t>Pendiente</a:t>
                       </a:r>
                     </a:p>
                   </a:txBody>
@@ -5796,7 +5796,7 @@
                           </a:solidFill>
                           <a:latin typeface="Calibri"/>
                         </a:rPr>
-                        <a:t>2</a:t>
+                        <a:t>6</a:t>
                       </a:r>
                     </a:p>
                   </a:txBody>

</xml_diff>

<commit_message>
Aclarar entregas de kits en provincias priorizadas en tablero y exportables
</commit_message>
<xml_diff>
--- a/docs/reportes/Seguimiento_ENOS_2026-10-26.pptx
+++ b/docs/reportes/Seguimiento_ENOS_2026-10-26.pptx
@@ -5298,7 +5298,7 @@
                 </a:solidFill>
                 <a:latin typeface="Calibri"/>
               </a:rPr>
-              <a:t>Fin de semana 24–25/10</a:t>
+              <a:t>Provincias priorizadas · 24–25/10</a:t>
             </a:r>
           </a:p>
         </p:txBody>
@@ -5997,7 +5997,7 @@
                 </a:solidFill>
                 <a:latin typeface="Century Gothic"/>
               </a:rPr>
-              <a:t>Kits entregados</a:t>
+              <a:t>Kits en provincias priorizadas</a:t>
             </a:r>
           </a:p>
         </p:txBody>
@@ -6976,7 +6976,7 @@
                 </a:solidFill>
                 <a:latin typeface="Calibri"/>
               </a:rPr>
-              <a:t>Entregas documentadas del 24 y 25 de octubre de 2026, corte 25/10 a las 19:00. No representan el acumulado desde el 14/09.</a:t>
+              <a:t>Kits entregados en provincias priorizadas el 24–25/10/2026; corte 25/10, 19:00. No es el acumulado desde el 14/09.</a:t>
             </a:r>
           </a:p>
         </p:txBody>

</xml_diff>

<commit_message>
Rediseñar el resumen ejecutivo de Riesgos en tres páginas y ajustar nota del bono
</commit_message>
<xml_diff>
--- a/docs/reportes/Seguimiento_ENOS_2026-10-26.pptx
+++ b/docs/reportes/Seguimiento_ENOS_2026-10-26.pptx
@@ -6455,7 +6455,7 @@
                 </a:solidFill>
                 <a:latin typeface="Calibri"/>
               </a:rPr>
-              <a:t>Gestionado no acredita cobro</a:t>
+              <a:t>Corte del bono: 23/10/2026</a:t>
             </a:r>
           </a:p>
         </p:txBody>
@@ -11152,7 +11152,7 @@
                 </a:solidFill>
                 <a:latin typeface="Calibri"/>
               </a:rPr>
-              <a:t>La ayuda memoria no identifica pagos exclusivamente atribuibles a ENOS ni fechas individuales para recortar desde el 14/09. Se muestran únicamente las filas de inundación como referencia: pagos gestionados desde el 29/08 y casos en articulación al 23/10. Gestionado no acredita cobro; articulación no equivale a pago. Las proyecciones corresponden a planificación nacional 2026–2027.</a:t>
+              <a:t>La ayuda memoria no identifica pagos exclusivamente atribuibles a ENOS ni fechas individuales para recortar desde el 14/09. Se muestran únicamente las filas de inundación como referencia: pagos gestionados desde el 29/08 y casos en articulación al 23/10. Articulación no equivale a pago. Las proyecciones corresponden a planificación nacional 2026–2027.</a:t>
             </a:r>
           </a:p>
         </p:txBody>
@@ -13294,7 +13294,7 @@
         <p:spPr>
           <a:xfrm>
             <a:off x="502920" y="3927652"/>
-            <a:ext cx="1828800" cy="851001"/>
+            <a:ext cx="1828800" cy="814425"/>
           </a:xfrm>
           <a:prstGeom prst="rect">
             <a:avLst/>
@@ -13329,7 +13329,7 @@
         <p:spPr>
           <a:xfrm>
             <a:off x="2468880" y="3927652"/>
-            <a:ext cx="9144000" cy="851001"/>
+            <a:ext cx="9144000" cy="814425"/>
           </a:xfrm>
           <a:prstGeom prst="rect">
             <a:avLst/>
@@ -13350,7 +13350,7 @@
                 </a:solidFill>
                 <a:latin typeface="Calibri"/>
               </a:rPr>
-              <a:t>La ayuda memoria no identifica pagos exclusivamente atribuibles a ENOS ni fechas individuales para recortar desde el 14/09. Se muestran únicamente las filas de inundación como referencia: pagos gestionados desde el 29/08 y casos en articulación al 23/10. Gestionado no acredita cobro; articulación no equivale a pago. Las proyecciones corresponden a planificación nacional 2026–2027.</a:t>
+              <a:t>La ayuda memoria no identifica pagos exclusivamente atribuibles a ENOS ni fechas individuales para recortar desde el 14/09. Se muestran únicamente las filas de inundación como referencia: pagos gestionados desde el 29/08 y casos en articulación al 23/10. Articulación no equivale a pago. Las proyecciones corresponden a planificación nacional 2026–2027.</a:t>
             </a:r>
           </a:p>
         </p:txBody>
@@ -13363,7 +13363,7 @@
         </p:nvSpPr>
         <p:spPr>
           <a:xfrm>
-            <a:off x="502920" y="4888382"/>
+            <a:off x="502920" y="4851806"/>
             <a:ext cx="1828800" cy="604723"/>
           </a:xfrm>
           <a:prstGeom prst="rect">
@@ -13398,7 +13398,7 @@
         </p:nvSpPr>
         <p:spPr>
           <a:xfrm>
-            <a:off x="2468880" y="4888382"/>
+            <a:off x="2468880" y="4851806"/>
             <a:ext cx="9144000" cy="604723"/>
           </a:xfrm>
           <a:prstGeom prst="rect">
@@ -13433,7 +13433,7 @@
         </p:nvSpPr>
         <p:spPr>
           <a:xfrm>
-            <a:off x="502920" y="5602833"/>
+            <a:off x="502920" y="5566257"/>
             <a:ext cx="11155680" cy="594360"/>
           </a:xfrm>
           <a:prstGeom prst="rect">

</xml_diff>

<commit_message>
Incorporar KPI de unidades cerradas y gráficos de continuidad en Riesgos
</commit_message>
<xml_diff>
--- a/docs/reportes/Seguimiento_ENOS_2026-10-26.pptx
+++ b/docs/reportes/Seguimiento_ENOS_2026-10-26.pptx
@@ -435,9 +435,9 @@
   <c:chart>
     <c:autoTitleDeleted val="1"/>
     <c:plotArea>
-      <c:lineChart>
-        <c:grouping val="standard"/>
-        <c:varyColors val="0"/>
+      <c:barChart>
+        <c:barDir val="bar"/>
+        <c:grouping val="clustered"/>
         <c:ser>
           <c:idx val="0"/>
           <c:order val="0"/>
@@ -447,677 +447,87 @@
               <c:strCache>
                 <c:ptCount val="1"/>
                 <c:pt idx="0">
-                  <c:v>Acumuladas</c:v>
+                  <c:v>Alertas por fecha</c:v>
                 </c:pt>
               </c:strCache>
             </c:strRef>
           </c:tx>
           <c:spPr>
-            <a:ln w="28575">
-              <a:solidFill>
-                <a:srgbClr val="512F8D"/>
-              </a:solidFill>
-            </a:ln>
+            <a:solidFill>
+              <a:srgbClr val="5A369A"/>
+            </a:solidFill>
           </c:spPr>
-          <c:marker>
-            <c:symbol val="circle"/>
-            <c:size val="7"/>
-            <c:spPr>
-              <a:solidFill>
-                <a:srgbClr val="512F8D"/>
-              </a:solidFill>
-              <a:ln>
-                <a:solidFill>
-                  <a:srgbClr val="FFFFFF"/>
-                </a:solidFill>
-              </a:ln>
-            </c:spPr>
-          </c:marker>
           <c:cat>
             <c:strRef>
-              <c:f>Sheet1!$A$2:$A$44</c:f>
+              <c:f>Sheet1!$A$2:$A$4</c:f>
               <c:strCache>
-                <c:ptCount val="43"/>
+                <c:ptCount val="3"/>
                 <c:pt idx="0">
-                  <c:v>14/09</c:v>
+                  <c:v>16/10</c:v>
                 </c:pt>
                 <c:pt idx="1">
-                  <c:v>15/09</c:v>
+                  <c:v>19/10</c:v>
                 </c:pt>
                 <c:pt idx="2">
-                  <c:v>16/09</c:v>
-                </c:pt>
-                <c:pt idx="3">
-                  <c:v>17/09</c:v>
-                </c:pt>
-                <c:pt idx="4">
-                  <c:v>18/09</c:v>
-                </c:pt>
-                <c:pt idx="5">
-                  <c:v>19/09</c:v>
-                </c:pt>
-                <c:pt idx="6">
-                  <c:v>20/09</c:v>
-                </c:pt>
-                <c:pt idx="7">
-                  <c:v>21/09</c:v>
-                </c:pt>
-                <c:pt idx="8">
-                  <c:v>22/09</c:v>
-                </c:pt>
-                <c:pt idx="9">
-                  <c:v>23/09</c:v>
-                </c:pt>
-                <c:pt idx="10">
-                  <c:v>24/09</c:v>
-                </c:pt>
-                <c:pt idx="11">
-                  <c:v>25/09</c:v>
-                </c:pt>
-                <c:pt idx="12">
-                  <c:v>26/09</c:v>
-                </c:pt>
-                <c:pt idx="13">
-                  <c:v>27/09</c:v>
-                </c:pt>
-                <c:pt idx="14">
-                  <c:v>28/09</c:v>
-                </c:pt>
-                <c:pt idx="15">
-                  <c:v>29/09</c:v>
-                </c:pt>
-                <c:pt idx="16">
-                  <c:v>30/09</c:v>
-                </c:pt>
-                <c:pt idx="17">
-                  <c:v>01/10</c:v>
-                </c:pt>
-                <c:pt idx="18">
-                  <c:v>02/10</c:v>
-                </c:pt>
-                <c:pt idx="19">
-                  <c:v>03/10</c:v>
-                </c:pt>
-                <c:pt idx="20">
-                  <c:v>04/10</c:v>
-                </c:pt>
-                <c:pt idx="21">
-                  <c:v>05/10</c:v>
-                </c:pt>
-                <c:pt idx="22">
-                  <c:v>06/10</c:v>
-                </c:pt>
-                <c:pt idx="23">
-                  <c:v>07/10</c:v>
-                </c:pt>
-                <c:pt idx="24">
-                  <c:v>08/10</c:v>
-                </c:pt>
-                <c:pt idx="25">
-                  <c:v>09/10</c:v>
-                </c:pt>
-                <c:pt idx="26">
-                  <c:v>10/10</c:v>
-                </c:pt>
-                <c:pt idx="27">
-                  <c:v>11/10</c:v>
-                </c:pt>
-                <c:pt idx="28">
-                  <c:v>12/10</c:v>
-                </c:pt>
-                <c:pt idx="29">
-                  <c:v>13/10</c:v>
-                </c:pt>
-                <c:pt idx="30">
-                  <c:v>14/10</c:v>
-                </c:pt>
-                <c:pt idx="31">
-                  <c:v>15/10</c:v>
-                </c:pt>
-                <c:pt idx="32">
-                  <c:v>16/10</c:v>
-                </c:pt>
-                <c:pt idx="33">
-                  <c:v>17/10</c:v>
-                </c:pt>
-                <c:pt idx="34">
-                  <c:v>18/10</c:v>
-                </c:pt>
-                <c:pt idx="35">
-                  <c:v>19/10</c:v>
-                </c:pt>
-                <c:pt idx="36">
                   <c:v>20/10</c:v>
-                </c:pt>
-                <c:pt idx="37">
-                  <c:v>21/10</c:v>
-                </c:pt>
-                <c:pt idx="38">
-                  <c:v>22/10</c:v>
-                </c:pt>
-                <c:pt idx="39">
-                  <c:v>23/10</c:v>
-                </c:pt>
-                <c:pt idx="40">
-                  <c:v>24/10</c:v>
-                </c:pt>
-                <c:pt idx="41">
-                  <c:v>25/10</c:v>
-                </c:pt>
-                <c:pt idx="42">
-                  <c:v>26/10</c:v>
                 </c:pt>
               </c:strCache>
             </c:strRef>
           </c:cat>
           <c:val>
             <c:numRef>
-              <c:f>Sheet1!$B$2:$B$44</c:f>
+              <c:f>Sheet1!$B$2:$B$4</c:f>
               <c:numCache>
                 <c:formatCode>#,##0</c:formatCode>
-                <c:ptCount val="43"/>
+                <c:ptCount val="3"/>
                 <c:pt idx="0">
-                  <c:v>0</c:v>
+                  <c:v>2</c:v>
                 </c:pt>
                 <c:pt idx="1">
-                  <c:v>0</c:v>
+                  <c:v>2</c:v>
                 </c:pt>
                 <c:pt idx="2">
-                  <c:v>0</c:v>
-                </c:pt>
-                <c:pt idx="3">
-                  <c:v>0</c:v>
-                </c:pt>
-                <c:pt idx="4">
-                  <c:v>0</c:v>
-                </c:pt>
-                <c:pt idx="5">
-                  <c:v>0</c:v>
-                </c:pt>
-                <c:pt idx="6">
-                  <c:v>0</c:v>
-                </c:pt>
-                <c:pt idx="7">
-                  <c:v>0</c:v>
-                </c:pt>
-                <c:pt idx="8">
-                  <c:v>0</c:v>
-                </c:pt>
-                <c:pt idx="9">
-                  <c:v>0</c:v>
-                </c:pt>
-                <c:pt idx="10">
-                  <c:v>0</c:v>
-                </c:pt>
-                <c:pt idx="11">
-                  <c:v>0</c:v>
-                </c:pt>
-                <c:pt idx="12">
-                  <c:v>0</c:v>
-                </c:pt>
-                <c:pt idx="13">
-                  <c:v>0</c:v>
-                </c:pt>
-                <c:pt idx="14">
-                  <c:v>0</c:v>
-                </c:pt>
-                <c:pt idx="15">
-                  <c:v>0</c:v>
-                </c:pt>
-                <c:pt idx="16">
-                  <c:v>0</c:v>
-                </c:pt>
-                <c:pt idx="17">
-                  <c:v>0</c:v>
-                </c:pt>
-                <c:pt idx="18">
-                  <c:v>0</c:v>
-                </c:pt>
-                <c:pt idx="19">
-                  <c:v>0</c:v>
-                </c:pt>
-                <c:pt idx="20">
-                  <c:v>0</c:v>
-                </c:pt>
-                <c:pt idx="21">
-                  <c:v>0</c:v>
-                </c:pt>
-                <c:pt idx="22">
-                  <c:v>0</c:v>
-                </c:pt>
-                <c:pt idx="23">
-                  <c:v>0</c:v>
-                </c:pt>
-                <c:pt idx="24">
-                  <c:v>0</c:v>
-                </c:pt>
-                <c:pt idx="25">
-                  <c:v>0</c:v>
-                </c:pt>
-                <c:pt idx="26">
-                  <c:v>0</c:v>
-                </c:pt>
-                <c:pt idx="27">
-                  <c:v>0</c:v>
-                </c:pt>
-                <c:pt idx="28">
-                  <c:v>0</c:v>
-                </c:pt>
-                <c:pt idx="29">
-                  <c:v>0</c:v>
-                </c:pt>
-                <c:pt idx="30">
-                  <c:v>0</c:v>
-                </c:pt>
-                <c:pt idx="31">
-                  <c:v>0</c:v>
-                </c:pt>
-                <c:pt idx="32">
-                  <c:v>2</c:v>
-                </c:pt>
-                <c:pt idx="33">
-                  <c:v>2</c:v>
-                </c:pt>
-                <c:pt idx="34">
-                  <c:v>2</c:v>
-                </c:pt>
-                <c:pt idx="35">
-                  <c:v>4</c:v>
-                </c:pt>
-                <c:pt idx="36">
-                  <c:v>10</c:v>
-                </c:pt>
-                <c:pt idx="37">
-                  <c:v>10</c:v>
-                </c:pt>
-                <c:pt idx="38">
-                  <c:v>10</c:v>
-                </c:pt>
-                <c:pt idx="39">
-                  <c:v>10</c:v>
-                </c:pt>
-                <c:pt idx="40">
-                  <c:v>10</c:v>
-                </c:pt>
-                <c:pt idx="41">
-                  <c:v>10</c:v>
-                </c:pt>
-                <c:pt idx="42">
-                  <c:v>10</c:v>
+                  <c:v>6</c:v>
                 </c:pt>
               </c:numCache>
             </c:numRef>
           </c:val>
-          <c:smooth val="0"/>
         </c:ser>
-        <c:ser>
-          <c:idx val="1"/>
-          <c:order val="1"/>
-          <c:tx>
-            <c:strRef>
-              <c:f>Sheet1!$C$1</c:f>
-              <c:strCache>
-                <c:ptCount val="1"/>
-                <c:pt idx="0">
-                  <c:v>Registradas en el día</c:v>
-                </c:pt>
-              </c:strCache>
-            </c:strRef>
-          </c:tx>
-          <c:spPr>
-            <a:ln w="19050">
-              <a:solidFill>
-                <a:srgbClr val="F8C018"/>
-              </a:solidFill>
-              <a:prstDash val="dash"/>
-            </a:ln>
-          </c:spPr>
-          <c:marker>
-            <c:symbol val="none"/>
-            <c:size val="7"/>
-            <c:spPr>
-              <a:solidFill>
-                <a:srgbClr val="F8C018"/>
-              </a:solidFill>
-              <a:ln>
-                <a:solidFill>
-                  <a:srgbClr val="FFFFFF"/>
-                </a:solidFill>
-              </a:ln>
-            </c:spPr>
-          </c:marker>
-          <c:cat>
-            <c:strRef>
-              <c:f>Sheet1!$A$2:$A$44</c:f>
-              <c:strCache>
-                <c:ptCount val="43"/>
-                <c:pt idx="0">
-                  <c:v>14/09</c:v>
-                </c:pt>
-                <c:pt idx="1">
-                  <c:v>15/09</c:v>
-                </c:pt>
-                <c:pt idx="2">
-                  <c:v>16/09</c:v>
-                </c:pt>
-                <c:pt idx="3">
-                  <c:v>17/09</c:v>
-                </c:pt>
-                <c:pt idx="4">
-                  <c:v>18/09</c:v>
-                </c:pt>
-                <c:pt idx="5">
-                  <c:v>19/09</c:v>
-                </c:pt>
-                <c:pt idx="6">
-                  <c:v>20/09</c:v>
-                </c:pt>
-                <c:pt idx="7">
-                  <c:v>21/09</c:v>
-                </c:pt>
-                <c:pt idx="8">
-                  <c:v>22/09</c:v>
-                </c:pt>
-                <c:pt idx="9">
-                  <c:v>23/09</c:v>
-                </c:pt>
-                <c:pt idx="10">
-                  <c:v>24/09</c:v>
-                </c:pt>
-                <c:pt idx="11">
-                  <c:v>25/09</c:v>
-                </c:pt>
-                <c:pt idx="12">
-                  <c:v>26/09</c:v>
-                </c:pt>
-                <c:pt idx="13">
-                  <c:v>27/09</c:v>
-                </c:pt>
-                <c:pt idx="14">
-                  <c:v>28/09</c:v>
-                </c:pt>
-                <c:pt idx="15">
-                  <c:v>29/09</c:v>
-                </c:pt>
-                <c:pt idx="16">
-                  <c:v>30/09</c:v>
-                </c:pt>
-                <c:pt idx="17">
-                  <c:v>01/10</c:v>
-                </c:pt>
-                <c:pt idx="18">
-                  <c:v>02/10</c:v>
-                </c:pt>
-                <c:pt idx="19">
-                  <c:v>03/10</c:v>
-                </c:pt>
-                <c:pt idx="20">
-                  <c:v>04/10</c:v>
-                </c:pt>
-                <c:pt idx="21">
-                  <c:v>05/10</c:v>
-                </c:pt>
-                <c:pt idx="22">
-                  <c:v>06/10</c:v>
-                </c:pt>
-                <c:pt idx="23">
-                  <c:v>07/10</c:v>
-                </c:pt>
-                <c:pt idx="24">
-                  <c:v>08/10</c:v>
-                </c:pt>
-                <c:pt idx="25">
-                  <c:v>09/10</c:v>
-                </c:pt>
-                <c:pt idx="26">
-                  <c:v>10/10</c:v>
-                </c:pt>
-                <c:pt idx="27">
-                  <c:v>11/10</c:v>
-                </c:pt>
-                <c:pt idx="28">
-                  <c:v>12/10</c:v>
-                </c:pt>
-                <c:pt idx="29">
-                  <c:v>13/10</c:v>
-                </c:pt>
-                <c:pt idx="30">
-                  <c:v>14/10</c:v>
-                </c:pt>
-                <c:pt idx="31">
-                  <c:v>15/10</c:v>
-                </c:pt>
-                <c:pt idx="32">
-                  <c:v>16/10</c:v>
-                </c:pt>
-                <c:pt idx="33">
-                  <c:v>17/10</c:v>
-                </c:pt>
-                <c:pt idx="34">
-                  <c:v>18/10</c:v>
-                </c:pt>
-                <c:pt idx="35">
-                  <c:v>19/10</c:v>
-                </c:pt>
-                <c:pt idx="36">
-                  <c:v>20/10</c:v>
-                </c:pt>
-                <c:pt idx="37">
-                  <c:v>21/10</c:v>
-                </c:pt>
-                <c:pt idx="38">
-                  <c:v>22/10</c:v>
-                </c:pt>
-                <c:pt idx="39">
-                  <c:v>23/10</c:v>
-                </c:pt>
-                <c:pt idx="40">
-                  <c:v>24/10</c:v>
-                </c:pt>
-                <c:pt idx="41">
-                  <c:v>25/10</c:v>
-                </c:pt>
-                <c:pt idx="42">
-                  <c:v>26/10</c:v>
-                </c:pt>
-              </c:strCache>
-            </c:strRef>
-          </c:cat>
-          <c:val>
-            <c:numRef>
-              <c:f>Sheet1!$C$2:$C$44</c:f>
-              <c:numCache>
-                <c:formatCode>#,##0</c:formatCode>
-                <c:ptCount val="43"/>
-                <c:pt idx="0">
-                  <c:v>0</c:v>
-                </c:pt>
-                <c:pt idx="1">
-                  <c:v>0</c:v>
-                </c:pt>
-                <c:pt idx="2">
-                  <c:v>0</c:v>
-                </c:pt>
-                <c:pt idx="3">
-                  <c:v>0</c:v>
-                </c:pt>
-                <c:pt idx="4">
-                  <c:v>0</c:v>
-                </c:pt>
-                <c:pt idx="5">
-                  <c:v>0</c:v>
-                </c:pt>
-                <c:pt idx="6">
-                  <c:v>0</c:v>
-                </c:pt>
-                <c:pt idx="7">
-                  <c:v>0</c:v>
-                </c:pt>
-                <c:pt idx="8">
-                  <c:v>0</c:v>
-                </c:pt>
-                <c:pt idx="9">
-                  <c:v>0</c:v>
-                </c:pt>
-                <c:pt idx="10">
-                  <c:v>0</c:v>
-                </c:pt>
-                <c:pt idx="11">
-                  <c:v>0</c:v>
-                </c:pt>
-                <c:pt idx="12">
-                  <c:v>0</c:v>
-                </c:pt>
-                <c:pt idx="13">
-                  <c:v>0</c:v>
-                </c:pt>
-                <c:pt idx="14">
-                  <c:v>0</c:v>
-                </c:pt>
-                <c:pt idx="15">
-                  <c:v>0</c:v>
-                </c:pt>
-                <c:pt idx="16">
-                  <c:v>0</c:v>
-                </c:pt>
-                <c:pt idx="17">
-                  <c:v>0</c:v>
-                </c:pt>
-                <c:pt idx="18">
-                  <c:v>0</c:v>
-                </c:pt>
-                <c:pt idx="19">
-                  <c:v>0</c:v>
-                </c:pt>
-                <c:pt idx="20">
-                  <c:v>0</c:v>
-                </c:pt>
-                <c:pt idx="21">
-                  <c:v>0</c:v>
-                </c:pt>
-                <c:pt idx="22">
-                  <c:v>0</c:v>
-                </c:pt>
-                <c:pt idx="23">
-                  <c:v>0</c:v>
-                </c:pt>
-                <c:pt idx="24">
-                  <c:v>0</c:v>
-                </c:pt>
-                <c:pt idx="25">
-                  <c:v>0</c:v>
-                </c:pt>
-                <c:pt idx="26">
-                  <c:v>0</c:v>
-                </c:pt>
-                <c:pt idx="27">
-                  <c:v>0</c:v>
-                </c:pt>
-                <c:pt idx="28">
-                  <c:v>0</c:v>
-                </c:pt>
-                <c:pt idx="29">
-                  <c:v>0</c:v>
-                </c:pt>
-                <c:pt idx="30">
-                  <c:v>0</c:v>
-                </c:pt>
-                <c:pt idx="31">
-                  <c:v>0</c:v>
-                </c:pt>
-                <c:pt idx="32">
-                  <c:v>2</c:v>
-                </c:pt>
-                <c:pt idx="33">
-                  <c:v>0</c:v>
-                </c:pt>
-                <c:pt idx="34">
-                  <c:v>0</c:v>
-                </c:pt>
-                <c:pt idx="35">
-                  <c:v>2</c:v>
-                </c:pt>
-                <c:pt idx="36">
-                  <c:v>6</c:v>
-                </c:pt>
-                <c:pt idx="37">
-                  <c:v>0</c:v>
-                </c:pt>
-                <c:pt idx="38">
-                  <c:v>0</c:v>
-                </c:pt>
-                <c:pt idx="39">
-                  <c:v>0</c:v>
-                </c:pt>
-                <c:pt idx="40">
-                  <c:v>0</c:v>
-                </c:pt>
-                <c:pt idx="41">
-                  <c:v>0</c:v>
-                </c:pt>
-                <c:pt idx="42">
-                  <c:v>0</c:v>
-                </c:pt>
-              </c:numCache>
-            </c:numRef>
-          </c:val>
-          <c:smooth val="0"/>
-        </c:ser>
-        <c:marker val="1"/>
-        <c:smooth val="0"/>
-        <c:axId val="2118791784"/>
-        <c:axId val="2140495176"/>
-      </c:lineChart>
+        <c:dLbls>
+          <c:numFmt formatCode="#,##0" sourceLinked="0"/>
+          <c:txPr>
+            <a:bodyPr/>
+            <a:lstStyle/>
+            <a:p>
+              <a:pPr>
+                <a:defRPr sz="1200" b="1">
+                  <a:solidFill>
+                    <a:srgbClr val="20202B"/>
+                  </a:solidFill>
+                </a:defRPr>
+              </a:pPr>
+            </a:p>
+          </c:txPr>
+          <c:dLblPos val="outEnd"/>
+          <c:showLegendKey val="0"/>
+          <c:showVal val="1"/>
+          <c:showCatName val="0"/>
+          <c:showSerName val="0"/>
+          <c:showPercent val="0"/>
+          <c:showBubbleSize val="0"/>
+          <c:showLeaderLines val="1"/>
+        </c:dLbls>
+        <c:gapWidth val="55"/>
+        <c:axId val="-2068027336"/>
+        <c:axId val="-2113994440"/>
+      </c:barChart>
       <c:catAx>
-        <c:axId val="2118791784"/>
+        <c:axId val="-2068027336"/>
         <c:scaling>
           <c:orientation val="minMax"/>
         </c:scaling>
         <c:delete val="0"/>
-        <c:axPos val="b"/>
-        <c:majorTickMark val="out"/>
-        <c:minorTickMark val="none"/>
-        <c:tickLblPos val="nextTo"/>
-        <c:spPr>
-          <a:ln>
-            <a:solidFill>
-              <a:srgbClr val="D8D0F4"/>
-            </a:solidFill>
-          </a:ln>
-        </c:spPr>
-        <c:txPr>
-          <a:bodyPr/>
-          <a:lstStyle/>
-          <a:p>
-            <a:pPr>
-              <a:defRPr sz="1100"/>
-            </a:pPr>
-          </a:p>
-        </c:txPr>
-        <c:crossAx val="2140495176"/>
-        <c:crosses val="autoZero"/>
-        <c:auto val="1"/>
-        <c:lblAlgn val="ctr"/>
-        <c:lblOffset val="100"/>
-        <c:noMultiLvlLbl val="0"/>
-      </c:catAx>
-      <c:valAx>
-        <c:axId val="2140495176"/>
-        <c:scaling>
-          <c:min val="0.0"/>
-        </c:scaling>
-        <c:delete val="0"/>
         <c:axPos val="l"/>
-        <c:majorGridlines>
-          <c:spPr>
-            <a:ln>
-              <a:solidFill>
-                <a:srgbClr val="EEEAF4"/>
-              </a:solidFill>
-            </a:ln>
-          </c:spPr>
-        </c:majorGridlines>
-        <c:numFmt formatCode="#,##0" sourceLinked="0"/>
         <c:majorTickMark val="out"/>
         <c:minorTickMark val="none"/>
         <c:tickLblPos val="nextTo"/>
@@ -1131,42 +541,359 @@
           <a:lstStyle/>
           <a:p>
             <a:pPr>
-              <a:defRPr sz="1000">
-                <a:solidFill>
-                  <a:srgbClr val="6E6880"/>
-                </a:solidFill>
-              </a:defRPr>
+              <a:defRPr sz="1200"/>
             </a:pPr>
           </a:p>
         </c:txPr>
-        <c:crossAx val="2118791784"/>
+        <c:crossAx val="-2113994440"/>
+        <c:crosses val="autoZero"/>
+        <c:auto val="1"/>
+        <c:lblAlgn val="ctr"/>
+        <c:lblOffset val="100"/>
+        <c:noMultiLvlLbl val="0"/>
+      </c:catAx>
+      <c:valAx>
+        <c:axId val="-2113994440"/>
+        <c:scaling>
+          <c:min val="0.0"/>
+        </c:scaling>
+        <c:delete/>
+        <c:axPos val="b"/>
+        <c:majorTickMark val="out"/>
+        <c:minorTickMark val="none"/>
+        <c:tickLblPos val="nextTo"/>
+        <c:crossAx val="-2068027336"/>
         <c:crosses val="autoZero"/>
       </c:valAx>
     </c:plotArea>
-    <c:legend>
-      <c:legendPos val="t"/>
-      <c:layout/>
-      <c:overlay val="0"/>
-      <c:txPr>
-        <a:bodyPr/>
-        <a:lstStyle/>
-        <a:p>
-          <a:pPr>
-            <a:defRPr sz="1100"/>
-          </a:pPr>
-        </a:p>
-      </c:txPr>
-    </c:legend>
-    <c:plotVisOnly val="1"/>
     <c:dispBlanksAs val="gap"/>
-    <c:showDLblsOverMax val="0"/>
   </c:chart>
   <c:txPr>
     <a:bodyPr/>
     <a:lstStyle/>
     <a:p>
       <a:pPr>
-        <a:defRPr sz="1100">
+        <a:defRPr sz="1200">
+          <a:solidFill>
+            <a:srgbClr val="20202B"/>
+          </a:solidFill>
+          <a:latin typeface="Calibri"/>
+        </a:defRPr>
+      </a:pPr>
+      <a:endParaRPr lang="en-US"/>
+    </a:p>
+  </c:txPr>
+  <c:externalData r:id="rId1">
+    <c:autoUpdate val="0"/>
+  </c:externalData>
+</c:chartSpace>
+</file>
+
+<file path=ppt/charts/chart4.xml><?xml version="1.0" encoding="utf-8"?>
+<c:chartSpace xmlns:c="http://schemas.openxmlformats.org/drawingml/2006/chart" xmlns:a="http://schemas.openxmlformats.org/drawingml/2006/main" xmlns:r="http://schemas.openxmlformats.org/officeDocument/2006/relationships">
+  <c:date1904 val="0"/>
+  <c:chart>
+    <c:autoTitleDeleted val="1"/>
+    <c:plotArea>
+      <c:barChart>
+        <c:barDir val="bar"/>
+        <c:grouping val="clustered"/>
+        <c:ser>
+          <c:idx val="0"/>
+          <c:order val="0"/>
+          <c:tx>
+            <c:strRef>
+              <c:f>Sheet1!$B$1</c:f>
+              <c:strCache>
+                <c:ptCount val="1"/>
+                <c:pt idx="0">
+                  <c:v>Unidades</c:v>
+                </c:pt>
+              </c:strCache>
+            </c:strRef>
+          </c:tx>
+          <c:spPr>
+            <a:solidFill>
+              <a:srgbClr val="5A369A"/>
+            </a:solidFill>
+          </c:spPr>
+          <c:cat>
+            <c:strRef>
+              <c:f>Sheet1!$A$2:$A$3</c:f>
+              <c:strCache>
+                <c:ptCount val="2"/>
+                <c:pt idx="0">
+                  <c:v>El Oro</c:v>
+                </c:pt>
+                <c:pt idx="1">
+                  <c:v>Santa Elena</c:v>
+                </c:pt>
+              </c:strCache>
+            </c:strRef>
+          </c:cat>
+          <c:val>
+            <c:numRef>
+              <c:f>Sheet1!$B$2:$B$3</c:f>
+              <c:numCache>
+                <c:formatCode>#,##0</c:formatCode>
+                <c:ptCount val="2"/>
+                <c:pt idx="0">
+                  <c:v>12</c:v>
+                </c:pt>
+                <c:pt idx="1">
+                  <c:v>7</c:v>
+                </c:pt>
+              </c:numCache>
+            </c:numRef>
+          </c:val>
+        </c:ser>
+        <c:dLbls>
+          <c:numFmt formatCode="#,##0" sourceLinked="0"/>
+          <c:txPr>
+            <a:bodyPr/>
+            <a:lstStyle/>
+            <a:p>
+              <a:pPr>
+                <a:defRPr sz="1200" b="1">
+                  <a:solidFill>
+                    <a:srgbClr val="20202B"/>
+                  </a:solidFill>
+                </a:defRPr>
+              </a:pPr>
+            </a:p>
+          </c:txPr>
+          <c:dLblPos val="outEnd"/>
+          <c:showLegendKey val="0"/>
+          <c:showVal val="1"/>
+          <c:showCatName val="0"/>
+          <c:showSerName val="0"/>
+          <c:showPercent val="0"/>
+          <c:showBubbleSize val="0"/>
+          <c:showLeaderLines val="1"/>
+        </c:dLbls>
+        <c:gapWidth val="55"/>
+        <c:axId val="-2068027336"/>
+        <c:axId val="-2113994440"/>
+      </c:barChart>
+      <c:catAx>
+        <c:axId val="-2068027336"/>
+        <c:scaling>
+          <c:orientation val="minMax"/>
+        </c:scaling>
+        <c:delete val="0"/>
+        <c:axPos val="l"/>
+        <c:majorTickMark val="out"/>
+        <c:minorTickMark val="none"/>
+        <c:tickLblPos val="nextTo"/>
+        <c:spPr>
+          <a:ln>
+            <a:noFill/>
+          </a:ln>
+        </c:spPr>
+        <c:txPr>
+          <a:bodyPr/>
+          <a:lstStyle/>
+          <a:p>
+            <a:pPr>
+              <a:defRPr sz="1200"/>
+            </a:pPr>
+          </a:p>
+        </c:txPr>
+        <c:crossAx val="-2113994440"/>
+        <c:crosses val="autoZero"/>
+        <c:auto val="1"/>
+        <c:lblAlgn val="ctr"/>
+        <c:lblOffset val="100"/>
+        <c:noMultiLvlLbl val="0"/>
+      </c:catAx>
+      <c:valAx>
+        <c:axId val="-2113994440"/>
+        <c:scaling>
+          <c:min val="0.0"/>
+        </c:scaling>
+        <c:delete/>
+        <c:axPos val="b"/>
+        <c:majorTickMark val="out"/>
+        <c:minorTickMark val="none"/>
+        <c:tickLblPos val="nextTo"/>
+        <c:crossAx val="-2068027336"/>
+        <c:crosses val="autoZero"/>
+      </c:valAx>
+    </c:plotArea>
+    <c:dispBlanksAs val="gap"/>
+  </c:chart>
+  <c:txPr>
+    <a:bodyPr/>
+    <a:lstStyle/>
+    <a:p>
+      <a:pPr>
+        <a:defRPr sz="1200">
+          <a:solidFill>
+            <a:srgbClr val="20202B"/>
+          </a:solidFill>
+          <a:latin typeface="Calibri"/>
+        </a:defRPr>
+      </a:pPr>
+      <a:endParaRPr lang="en-US"/>
+    </a:p>
+  </c:txPr>
+  <c:externalData r:id="rId1">
+    <c:autoUpdate val="0"/>
+  </c:externalData>
+</c:chartSpace>
+</file>
+
+<file path=ppt/charts/chart5.xml><?xml version="1.0" encoding="utf-8"?>
+<c:chartSpace xmlns:c="http://schemas.openxmlformats.org/drawingml/2006/chart" xmlns:a="http://schemas.openxmlformats.org/drawingml/2006/main" xmlns:r="http://schemas.openxmlformats.org/officeDocument/2006/relationships">
+  <c:date1904 val="0"/>
+  <c:chart>
+    <c:autoTitleDeleted val="1"/>
+    <c:plotArea>
+      <c:barChart>
+        <c:barDir val="bar"/>
+        <c:grouping val="clustered"/>
+        <c:ser>
+          <c:idx val="0"/>
+          <c:order val="0"/>
+          <c:tx>
+            <c:strRef>
+              <c:f>Sheet1!$B$1</c:f>
+              <c:strCache>
+                <c:ptCount val="1"/>
+                <c:pt idx="0">
+                  <c:v>Unidades</c:v>
+                </c:pt>
+              </c:strCache>
+            </c:strRef>
+          </c:tx>
+          <c:spPr>
+            <a:solidFill>
+              <a:srgbClr val="5A369A"/>
+            </a:solidFill>
+          </c:spPr>
+          <c:cat>
+            <c:strRef>
+              <c:f>Sheet1!$A$2:$A$5</c:f>
+              <c:strCache>
+                <c:ptCount val="4"/>
+                <c:pt idx="0">
+                  <c:v>CNH: suspensión presencial</c:v>
+                </c:pt>
+                <c:pt idx="1">
+                  <c:v>Cerradas / suspendidas</c:v>
+                </c:pt>
+                <c:pt idx="2">
+                  <c:v>Modalidad por confirmar</c:v>
+                </c:pt>
+                <c:pt idx="3">
+                  <c:v>CDI: atención virtual</c:v>
+                </c:pt>
+              </c:strCache>
+            </c:strRef>
+          </c:cat>
+          <c:val>
+            <c:numRef>
+              <c:f>Sheet1!$B$2:$B$5</c:f>
+              <c:numCache>
+                <c:formatCode>#,##0</c:formatCode>
+                <c:ptCount val="4"/>
+                <c:pt idx="0">
+                  <c:v>63</c:v>
+                </c:pt>
+                <c:pt idx="1">
+                  <c:v>19</c:v>
+                </c:pt>
+                <c:pt idx="2">
+                  <c:v>17</c:v>
+                </c:pt>
+                <c:pt idx="3">
+                  <c:v>11</c:v>
+                </c:pt>
+              </c:numCache>
+            </c:numRef>
+          </c:val>
+        </c:ser>
+        <c:dLbls>
+          <c:numFmt formatCode="#,##0" sourceLinked="0"/>
+          <c:txPr>
+            <a:bodyPr/>
+            <a:lstStyle/>
+            <a:p>
+              <a:pPr>
+                <a:defRPr sz="1200" b="1">
+                  <a:solidFill>
+                    <a:srgbClr val="20202B"/>
+                  </a:solidFill>
+                </a:defRPr>
+              </a:pPr>
+            </a:p>
+          </c:txPr>
+          <c:dLblPos val="outEnd"/>
+          <c:showLegendKey val="0"/>
+          <c:showVal val="1"/>
+          <c:showCatName val="0"/>
+          <c:showSerName val="0"/>
+          <c:showPercent val="0"/>
+          <c:showBubbleSize val="0"/>
+          <c:showLeaderLines val="1"/>
+        </c:dLbls>
+        <c:gapWidth val="55"/>
+        <c:axId val="-2068027336"/>
+        <c:axId val="-2113994440"/>
+      </c:barChart>
+      <c:catAx>
+        <c:axId val="-2068027336"/>
+        <c:scaling>
+          <c:orientation val="minMax"/>
+        </c:scaling>
+        <c:delete val="0"/>
+        <c:axPos val="l"/>
+        <c:majorTickMark val="out"/>
+        <c:minorTickMark val="none"/>
+        <c:tickLblPos val="nextTo"/>
+        <c:spPr>
+          <a:ln>
+            <a:noFill/>
+          </a:ln>
+        </c:spPr>
+        <c:txPr>
+          <a:bodyPr/>
+          <a:lstStyle/>
+          <a:p>
+            <a:pPr>
+              <a:defRPr sz="1200"/>
+            </a:pPr>
+          </a:p>
+        </c:txPr>
+        <c:crossAx val="-2113994440"/>
+        <c:crosses val="autoZero"/>
+        <c:auto val="1"/>
+        <c:lblAlgn val="ctr"/>
+        <c:lblOffset val="100"/>
+        <c:noMultiLvlLbl val="0"/>
+      </c:catAx>
+      <c:valAx>
+        <c:axId val="-2113994440"/>
+        <c:scaling>
+          <c:min val="0.0"/>
+        </c:scaling>
+        <c:delete/>
+        <c:axPos val="b"/>
+        <c:majorTickMark val="out"/>
+        <c:minorTickMark val="none"/>
+        <c:tickLblPos val="nextTo"/>
+        <c:crossAx val="-2068027336"/>
+        <c:crosses val="autoZero"/>
+      </c:valAx>
+    </c:plotArea>
+    <c:dispBlanksAs val="gap"/>
+  </c:chart>
+  <c:txPr>
+    <a:bodyPr/>
+    <a:lstStyle/>
+    <a:p>
+      <a:pPr>
+        <a:defRPr sz="1200">
           <a:solidFill>
             <a:srgbClr val="20202B"/>
           </a:solidFill>
@@ -1577,7 +1304,7 @@
           <a:lstStyle/>
           <a:p>
             <a:r>
-              <a:t>Alertas con código UA: 10. Kits entregados: 802. Núcleos con bono gestionado: 113. Monto de bonos gestionados: USD 33.200,80. 10 alertas con 10 códigos UA distintos: 8 Desarrollo Infantil; 2 Creciendo con Nuestros Hijos (CNH). 8 con afectación documentada y 2 por confirmar. Se excluyen los registros sin código UA; el código por sí solo no confirma una afectación.</a:t>
+              <a:t>Alertas con código UA: 10. Kits entregados: 802. Núcleos con bono gestionado: 113. Monto de bonos gestionados: USD 33.200,80. Unidades de atención cerradas: 19. 10 alertas con 10 códigos UA distintos: 8 Desarrollo Infantil; 2 Creciendo con Nuestros Hijos (CNH). 8 con afectación documentada y 2 por confirmar. Se excluyen los registros sin código UA.</a:t>
             </a:r>
           </a:p>
         </p:txBody>
@@ -1647,7 +1374,7 @@
           <a:lstStyle/>
           <a:p>
             <a:r>
-              <a:t>Subsecretaría Territorial (análisis de alertas); reporte ministerial de kits; ayuda memoria del bono de contingencia.</a:t>
+              <a:t>Subsecretaría Territorial (análisis de alertas); reporte ministerial de kits; ayuda memoria del bono de contingencia; base territorial de afectaciones por lluvias.</a:t>
             </a:r>
           </a:p>
         </p:txBody>
@@ -1717,7 +1444,7 @@
           <a:lstStyle/>
           <a:p>
             <a:r>
-              <a:t>Subsecretaría Territorial (análisis de alertas); reporte ministerial de kits; ayuda memoria del bono de contingencia.</a:t>
+              <a:t>Subsecretaría Territorial (análisis de alertas); reporte ministerial de kits; ayuda memoria del bono de contingencia; base territorial de afectaciones por lluvias.</a:t>
             </a:r>
           </a:p>
         </p:txBody>
@@ -1787,7 +1514,7 @@
           <a:lstStyle/>
           <a:p>
             <a:r>
-              <a:t>Subsecretaría Territorial (análisis de alertas); reporte ministerial de kits; ayuda memoria del bono de contingencia.</a:t>
+              <a:t>Subsecretaría Territorial (análisis de alertas); reporte ministerial de kits; ayuda memoria del bono de contingencia; base territorial de afectaciones por lluvias.</a:t>
             </a:r>
           </a:p>
         </p:txBody>
@@ -1857,7 +1584,7 @@
           <a:lstStyle/>
           <a:p>
             <a:r>
-              <a:t>Subsecretaría Territorial (análisis de alertas); reporte ministerial de kits; ayuda memoria del bono de contingencia.</a:t>
+              <a:t>Subsecretaría Territorial (análisis de alertas); reporte ministerial de kits; ayuda memoria del bono de contingencia; base territorial de afectaciones por lluvias.</a:t>
             </a:r>
           </a:p>
         </p:txBody>
@@ -1927,7 +1654,7 @@
           <a:lstStyle/>
           <a:p>
             <a:r>
-              <a:t>Subsecretaría Territorial (análisis de alertas); reporte ministerial de kits; ayuda memoria del bono de contingencia.</a:t>
+              <a:t>Subsecretaría Territorial (análisis de alertas); reporte ministerial de kits; ayuda memoria del bono de contingencia; base territorial de afectaciones por lluvias.</a:t>
             </a:r>
           </a:p>
         </p:txBody>
@@ -1997,7 +1724,7 @@
           <a:lstStyle/>
           <a:p>
             <a:r>
-              <a:t>Subsecretaría Territorial (análisis de alertas); reporte ministerial de kits; ayuda memoria del bono de contingencia.</a:t>
+              <a:t>Subsecretaría Territorial (análisis de alertas); reporte ministerial de kits; ayuda memoria del bono de contingencia; base territorial de afectaciones por lluvias.</a:t>
             </a:r>
           </a:p>
         </p:txBody>
@@ -2067,7 +1794,7 @@
           <a:lstStyle/>
           <a:p>
             <a:r>
-              <a:t>Subsecretaría Territorial (análisis de alertas); reporte ministerial de kits; ayuda memoria del bono de contingencia.</a:t>
+              <a:t>Subsecretaría Territorial (análisis de alertas); reporte ministerial de kits; ayuda memoria del bono de contingencia; base territorial de afectaciones por lluvias.</a:t>
             </a:r>
           </a:p>
         </p:txBody>
@@ -2137,7 +1864,7 @@
           <a:lstStyle/>
           <a:p>
             <a:r>
-              <a:t>Subsecretaría Territorial (análisis de alertas); reporte ministerial de kits; ayuda memoria del bono de contingencia.</a:t>
+              <a:t>Subsecretaría Territorial (análisis de alertas); reporte ministerial de kits; ayuda memoria del bono de contingencia; base territorial de afectaciones por lluvias.</a:t>
             </a:r>
           </a:p>
         </p:txBody>
@@ -6916,7 +6643,7 @@
                 </a:solidFill>
                 <a:latin typeface="Calibri"/>
               </a:rPr>
-              <a:t>10 alertas con 10 códigos UA distintos: 8 Desarrollo Infantil; 2 Creciendo con Nuestros Hijos (CNH). 8 con afectación documentada y 2 por confirmar. Se excluyen los registros sin código UA; el código por sí solo no confirma una afectación.</a:t>
+              <a:t>10 alertas con 10 códigos UA distintos: 8 Desarrollo Infantil; 2 Creciendo con Nuestros Hijos (CNH). 8 con afectación documentada y 2 por confirmar. Se excluyen los registros sin código UA.</a:t>
             </a:r>
           </a:p>
         </p:txBody>
@@ -7180,8 +6907,8 @@
           <p:nvPr/>
         </p:nvGraphicFramePr>
         <p:xfrm>
-          <a:off x="502920" y="1371600"/>
-          <a:ext cx="11155680" cy="4480560"/>
+          <a:off x="502920" y="1325880"/>
+          <a:ext cx="5486400" cy="1920240"/>
         </p:xfrm>
         <a:graphic>
           <a:graphicData uri="http://schemas.openxmlformats.org/drawingml/2006/chart">
@@ -7197,8 +6924,8 @@
         </p:nvSpPr>
         <p:spPr>
           <a:xfrm>
-            <a:off x="502920" y="5897880"/>
-            <a:ext cx="11155680" cy="274320"/>
+            <a:off x="6400800" y="1508760"/>
+            <a:ext cx="5029200" cy="548640"/>
           </a:xfrm>
           <a:prstGeom prst="rect">
             <a:avLst/>
@@ -7213,13 +6940,189 @@
           <a:p>
             <a:pPr algn="l"/>
             <a:r>
-              <a:rPr sz="1100" b="0">
+              <a:rPr sz="2200" b="1">
+                <a:solidFill>
+                  <a:srgbClr val="512F8D"/>
+                </a:solidFill>
+                <a:latin typeface="Calibri"/>
+              </a:rPr>
+              <a:t>19 Unidades de atención cerradas</a:t>
+            </a:r>
+          </a:p>
+        </p:txBody>
+      </p:sp>
+      <p:sp>
+        <p:nvSpPr>
+          <p:cNvPr id="11" name="TextBox 10"/>
+          <p:cNvSpPr txBox="1"/>
+          <p:nvPr/>
+        </p:nvSpPr>
+        <p:spPr>
+          <a:xfrm>
+            <a:off x="6400800" y="2148840"/>
+            <a:ext cx="5029200" cy="502920"/>
+          </a:xfrm>
+          <a:prstGeom prst="rect">
+            <a:avLst/>
+          </a:prstGeom>
+          <a:noFill/>
+        </p:spPr>
+        <p:txBody>
+          <a:bodyPr wrap="square" anchor="t" lIns="0" rIns="0" tIns="0" bIns="0">
+            <a:spAutoFit/>
+          </a:bodyPr>
+          <a:lstStyle/>
+          <a:p>
+            <a:pPr algn="l"/>
+            <a:r>
+              <a:rPr sz="1200" b="0">
                 <a:solidFill>
                   <a:srgbClr val="20202B"/>
                 </a:solidFill>
                 <a:latin typeface="Calibri"/>
               </a:rPr>
-              <a:t>Fecha de registro de la alerta; seguimiento desde 14/09/2026</a:t>
+              <a:t>Atención suspendida · corte 26/10/2026, 16:00</a:t>
+            </a:r>
+          </a:p>
+        </p:txBody>
+      </p:sp>
+      <p:sp>
+        <p:nvSpPr>
+          <p:cNvPr id="12" name="TextBox 11"/>
+          <p:cNvSpPr txBox="1"/>
+          <p:nvPr/>
+        </p:nvSpPr>
+        <p:spPr>
+          <a:xfrm>
+            <a:off x="502920" y="3291840"/>
+            <a:ext cx="5303520" cy="365760"/>
+          </a:xfrm>
+          <a:prstGeom prst="rect">
+            <a:avLst/>
+          </a:prstGeom>
+          <a:noFill/>
+        </p:spPr>
+        <p:txBody>
+          <a:bodyPr wrap="square" anchor="t" lIns="0" rIns="0" tIns="0" bIns="0">
+            <a:spAutoFit/>
+          </a:bodyPr>
+          <a:lstStyle/>
+          <a:p>
+            <a:pPr algn="l"/>
+            <a:r>
+              <a:rPr sz="1800" b="1">
+                <a:solidFill>
+                  <a:srgbClr val="2B164F"/>
+                </a:solidFill>
+                <a:latin typeface="Century Gothic"/>
+              </a:rPr>
+              <a:t>Unidades cerradas por provincia</a:t>
+            </a:r>
+          </a:p>
+        </p:txBody>
+      </p:sp>
+      <p:graphicFrame>
+        <p:nvGraphicFramePr>
+          <p:cNvPr id="13" name="Chart 12"/>
+          <p:cNvGraphicFramePr>
+            <a:graphicFrameLocks noGrp="1"/>
+          </p:cNvGraphicFramePr>
+          <p:nvPr/>
+        </p:nvGraphicFramePr>
+        <p:xfrm>
+          <a:off x="502920" y="3657600"/>
+          <a:ext cx="5303520" cy="1920240"/>
+        </p:xfrm>
+        <a:graphic>
+          <a:graphicData uri="http://schemas.openxmlformats.org/drawingml/2006/chart">
+            <c:chart xmlns:c="http://schemas.openxmlformats.org/drawingml/2006/chart" r:id="rId5"/>
+          </a:graphicData>
+        </a:graphic>
+      </p:graphicFrame>
+      <p:sp>
+        <p:nvSpPr>
+          <p:cNvPr id="14" name="TextBox 13"/>
+          <p:cNvSpPr txBox="1"/>
+          <p:nvPr/>
+        </p:nvSpPr>
+        <p:spPr>
+          <a:xfrm>
+            <a:off x="6217920" y="3291840"/>
+            <a:ext cx="5303520" cy="365760"/>
+          </a:xfrm>
+          <a:prstGeom prst="rect">
+            <a:avLst/>
+          </a:prstGeom>
+          <a:noFill/>
+        </p:spPr>
+        <p:txBody>
+          <a:bodyPr wrap="square" anchor="t" lIns="0" rIns="0" tIns="0" bIns="0">
+            <a:spAutoFit/>
+          </a:bodyPr>
+          <a:lstStyle/>
+          <a:p>
+            <a:pPr algn="l"/>
+            <a:r>
+              <a:rPr sz="1800" b="1">
+                <a:solidFill>
+                  <a:srgbClr val="2B164F"/>
+                </a:solidFill>
+                <a:latin typeface="Century Gothic"/>
+              </a:rPr>
+              <a:t>Estado de atención reportado</a:t>
+            </a:r>
+          </a:p>
+        </p:txBody>
+      </p:sp>
+      <p:graphicFrame>
+        <p:nvGraphicFramePr>
+          <p:cNvPr id="15" name="Chart 14"/>
+          <p:cNvGraphicFramePr>
+            <a:graphicFrameLocks noGrp="1"/>
+          </p:cNvGraphicFramePr>
+          <p:nvPr/>
+        </p:nvGraphicFramePr>
+        <p:xfrm>
+          <a:off x="6217920" y="3657600"/>
+          <a:ext cx="5303520" cy="1920240"/>
+        </p:xfrm>
+        <a:graphic>
+          <a:graphicData uri="http://schemas.openxmlformats.org/drawingml/2006/chart">
+            <c:chart xmlns:c="http://schemas.openxmlformats.org/drawingml/2006/chart" r:id="rId6"/>
+          </a:graphicData>
+        </a:graphic>
+      </p:graphicFrame>
+      <p:sp>
+        <p:nvSpPr>
+          <p:cNvPr id="16" name="TextBox 15"/>
+          <p:cNvSpPr txBox="1"/>
+          <p:nvPr/>
+        </p:nvSpPr>
+        <p:spPr>
+          <a:xfrm>
+            <a:off x="502920" y="5715000"/>
+            <a:ext cx="11155680" cy="594360"/>
+          </a:xfrm>
+          <a:prstGeom prst="rect">
+            <a:avLst/>
+          </a:prstGeom>
+          <a:noFill/>
+        </p:spPr>
+        <p:txBody>
+          <a:bodyPr wrap="square" anchor="t" lIns="0" rIns="0" tIns="0" bIns="0">
+            <a:spAutoFit/>
+          </a:bodyPr>
+          <a:lstStyle/>
+          <a:p>
+            <a:pPr algn="l"/>
+            <a:r>
+              <a:rPr sz="900" b="0">
+                <a:solidFill>
+                  <a:srgbClr val="20202B"/>
+                </a:solidFill>
+                <a:latin typeface="Calibri"/>
+              </a:rPr>
+              <a:t>Fuente: base territorial de afectaciones por lluvias, corte 26/10/2026, 16:00. Cerradas corresponde al estado Suspendida (18 CDI y 1 CNH). Los 63 CNH con suspensión presencial y los 11 CDI en atención virtual se muestran por separado. Son cifras reportadas, sin códigos UA en esta base; no se suman a las 10 alertas ni constituyen un censo nacional de cierres.</a:t>
             </a:r>
           </a:p>
         </p:txBody>
@@ -7679,8 +7582,7 @@
                           <a:latin typeface="Calibri"/>
                         </a:rPr>
                         <a:t>GOTITA DEL AMOR
-UA: 62210
-Desarrollo Infantil</a:t>
+UA 62210 · Desarrollo Infantil</a:t>
                       </a:r>
                     </a:p>
                   </a:txBody>
@@ -7823,8 +7725,7 @@
                           <a:latin typeface="Calibri"/>
                         </a:rPr>
                         <a:t>MIS PEQUEÑOS ANGELITOS
-UA: 14294
-Desarrollo Infantil</a:t>
+UA 14294 · Desarrollo Infantil</a:t>
                       </a:r>
                     </a:p>
                   </a:txBody>
@@ -7967,8 +7868,7 @@
                           <a:latin typeface="Calibri"/>
                         </a:rPr>
                         <a:t>NIÑOS JUGUETONES
-UA: 13916
-Desarrollo Infantil</a:t>
+UA 13916 · Desarrollo Infantil</a:t>
                       </a:r>
                     </a:p>
                   </a:txBody>
@@ -8111,8 +8011,7 @@
                           <a:latin typeface="Calibri"/>
                         </a:rPr>
                         <a:t>PEQUEÑOS JILGUERITOS
-UA: 62208
-Desarrollo Infantil</a:t>
+UA 62208 · Desarrollo Infantil</a:t>
                       </a:r>
                     </a:p>
                   </a:txBody>
@@ -8255,8 +8154,7 @@
                           <a:latin typeface="Calibri"/>
                         </a:rPr>
                         <a:t>CENTRO DE DESARROLLO INFANTIL ESTRELLITA DE MAR
-UA: 60221
-Desarrollo Infantil</a:t>
+UA 60221 · Desarrollo Infantil</a:t>
                       </a:r>
                     </a:p>
                   </a:txBody>
@@ -8854,8 +8752,7 @@
                           <a:latin typeface="Calibri"/>
                         </a:rPr>
                         <a:t>CENTRO DE DESARROLLO INFANTIL SUPER NIÑO
-UA: 60220
-Desarrollo Infantil</a:t>
+UA 60220 · Desarrollo Infantil</a:t>
                       </a:r>
                     </a:p>
                   </a:txBody>
@@ -8998,8 +8895,7 @@
                           <a:latin typeface="Calibri"/>
                         </a:rPr>
                         <a:t>CDI NIÑOS DE SAN RAFAEL
-UA: 58337
-Desarrollo Infantil</a:t>
+UA 58337 · Desarrollo Infantil</a:t>
                       </a:r>
                     </a:p>
                   </a:txBody>
@@ -9142,8 +9038,7 @@
                           <a:latin typeface="Calibri"/>
                         </a:rPr>
                         <a:t>CDI LOS NIÑOS DEL CISNE
-UA: 58336
-Desarrollo Infantil</a:t>
+UA 58336 · Desarrollo Infantil</a:t>
                       </a:r>
                     </a:p>
                   </a:txBody>
@@ -9286,8 +9181,7 @@
                           <a:latin typeface="Calibri"/>
                         </a:rPr>
                         <a:t>CNH ESTRELLITAS DEL AMANECER
-UA: 56744
-Creciendo con Nuestros Hijos (CNH)</a:t>
+UA 56744 · Creciendo con Nuestros Hijos (CNH)</a:t>
                       </a:r>
                     </a:p>
                   </a:txBody>
@@ -9430,8 +9324,7 @@
                           <a:latin typeface="Calibri"/>
                         </a:rPr>
                         <a:t>CORREO INFANTIL
-UA: 56204
-Creciendo con Nuestros Hijos (CNH)</a:t>
+UA 56204 · Creciendo con Nuestros Hijos (CNH)</a:t>
                       </a:r>
                     </a:p>
                   </a:txBody>
@@ -13084,7 +12977,7 @@
         <p:spPr>
           <a:xfrm>
             <a:off x="502920" y="1325880"/>
-            <a:ext cx="1828800" cy="1025347"/>
+            <a:ext cx="1828800" cy="961948"/>
           </a:xfrm>
           <a:prstGeom prst="rect">
             <a:avLst/>
@@ -13119,7 +13012,7 @@
         <p:spPr>
           <a:xfrm>
             <a:off x="2468880" y="1325880"/>
-            <a:ext cx="9144000" cy="1025347"/>
+            <a:ext cx="9144000" cy="961948"/>
           </a:xfrm>
           <a:prstGeom prst="rect">
             <a:avLst/>
@@ -13140,7 +13033,7 @@
                 </a:solidFill>
                 <a:latin typeface="Calibri"/>
               </a:rPr>
-              <a:t>Se muestran únicamente alertas revisadas con código UA registrado, desde el 14 de septiembre de 2026. El conteo corresponde a códigos de alerta distintos vinculados a unidades identificadas; tener código UA no confirma afectación al servicio. Los registros sin código quedan fuera de este alcance. La fecha corresponde al registro y una alerta no equivale necesariamente a un evento único. El campo Afectados mezcla personas, familias y usuarios; no se suma como personas únicas. La base no certifica atribución causal a ENOS.</a:t>
+              <a:t>Se muestran únicamente alertas revisadas con código UA registrado, desde el 14 de septiembre de 2026. El conteo corresponde a códigos de alerta distintos vinculados a unidades identificadas. Los registros sin código quedan fuera de este alcance. La fecha corresponde al registro y una alerta no equivale necesariamente a un evento único. El campo Afectados mezcla personas, familias y usuarios; no se suma como personas únicas. La base no certifica atribución causal a ENOS.</a:t>
             </a:r>
           </a:p>
         </p:txBody>
@@ -13153,7 +13046,7 @@
         </p:nvSpPr>
         <p:spPr>
           <a:xfrm>
-            <a:off x="502920" y="2460955"/>
+            <a:off x="502920" y="2397556"/>
             <a:ext cx="1828800" cy="724204"/>
           </a:xfrm>
           <a:prstGeom prst="rect">
@@ -13188,7 +13081,7 @@
         </p:nvSpPr>
         <p:spPr>
           <a:xfrm>
-            <a:off x="2468880" y="2460955"/>
+            <a:off x="2468880" y="2397556"/>
             <a:ext cx="9144000" cy="724204"/>
           </a:xfrm>
           <a:prstGeom prst="rect">
@@ -13223,7 +13116,7 @@
         </p:nvSpPr>
         <p:spPr>
           <a:xfrm>
-            <a:off x="502920" y="3294888"/>
+            <a:off x="502920" y="3231489"/>
             <a:ext cx="1828800" cy="523036"/>
           </a:xfrm>
           <a:prstGeom prst="rect">
@@ -13258,7 +13151,7 @@
         </p:nvSpPr>
         <p:spPr>
           <a:xfrm>
-            <a:off x="2468880" y="3294888"/>
+            <a:off x="2468880" y="3231489"/>
             <a:ext cx="9144000" cy="523036"/>
           </a:xfrm>
           <a:prstGeom prst="rect">
@@ -13293,7 +13186,7 @@
         </p:nvSpPr>
         <p:spPr>
           <a:xfrm>
-            <a:off x="502920" y="3927652"/>
+            <a:off x="502920" y="3864254"/>
             <a:ext cx="1828800" cy="814425"/>
           </a:xfrm>
           <a:prstGeom prst="rect">
@@ -13328,7 +13221,7 @@
         </p:nvSpPr>
         <p:spPr>
           <a:xfrm>
-            <a:off x="2468880" y="3927652"/>
+            <a:off x="2468880" y="3864254"/>
             <a:ext cx="9144000" cy="814425"/>
           </a:xfrm>
           <a:prstGeom prst="rect">
@@ -13363,8 +13256,8 @@
         </p:nvSpPr>
         <p:spPr>
           <a:xfrm>
-            <a:off x="502920" y="4851806"/>
-            <a:ext cx="1828800" cy="604723"/>
+            <a:off x="502920" y="4788408"/>
+            <a:ext cx="1828800" cy="624230"/>
           </a:xfrm>
           <a:prstGeom prst="rect">
             <a:avLst/>
@@ -13398,8 +13291,8 @@
         </p:nvSpPr>
         <p:spPr>
           <a:xfrm>
-            <a:off x="2468880" y="4851806"/>
-            <a:ext cx="9144000" cy="604723"/>
+            <a:off x="2468880" y="4788408"/>
+            <a:ext cx="9144000" cy="624230"/>
           </a:xfrm>
           <a:prstGeom prst="rect">
             <a:avLst/>
@@ -13420,7 +13313,7 @@
                 </a:solidFill>
                 <a:latin typeface="Calibri"/>
               </a:rPr>
-              <a:t>El territorio se aplica a todas las acciones; el servicio, solo a las alertas según la UA registrada. Kits y bono no se asocian a un servicio. La planificación del bono es nacional.</a:t>
+              <a:t>El territorio se aplica a todas las acciones; el servicio, a las alertas y al seguimiento de continuidad de atención. Kits y bono no se asocian a un servicio. La planificación del bono es nacional.</a:t>
             </a:r>
           </a:p>
         </p:txBody>
@@ -13433,7 +13326,7 @@
         </p:nvSpPr>
         <p:spPr>
           <a:xfrm>
-            <a:off x="502920" y="5566257"/>
+            <a:off x="502920" y="5522366"/>
             <a:ext cx="11155680" cy="594360"/>
           </a:xfrm>
           <a:prstGeom prst="rect">
@@ -13455,7 +13348,7 @@
                 </a:solidFill>
                 <a:latin typeface="Calibri"/>
               </a:rPr>
-              <a:t>Fuentes: Subsecretaría Territorial (análisis de alertas); reporte ministerial de kits; ayuda memoria del bono de contingencia.
+              <a:t>Fuentes: Subsecretaría Territorial (análisis de alertas); reporte ministerial de kits; ayuda memoria del bono de contingencia; base territorial de afectaciones por lluvias.
 Geoportal: https://geoportal.trabajo.gob.ec/ua_amenazas</a:t>
             </a:r>
           </a:p>

</xml_diff>

<commit_message>
Confirmar 13.390 kits oficiales, etiquetar núcleos familiares y actualizar fecha con montos verificados
</commit_message>
<xml_diff>
--- a/docs/reportes/Seguimiento_ENOS_2026-10-26.pptx
+++ b/docs/reportes/Seguimiento_ENOS_2026-10-26.pptx
@@ -1299,7 +1299,7 @@
           <a:lstStyle/>
           <a:p>
             <a:r>
-              <a:t>Alertas con código UA: 10. Kits entregados: 13.390. Núcleos con bono gestionado: 113. Monto de bonos gestionados: USD 33.200,80. Unidades cerradas / suspendidas: 99. 10 alertas con 10 códigos UA distintos: 8 Desarrollo Infantil; 2 Creciendo con Nuestros Hijos (CNH). 8 con afectación documentada y 2 por confirmar. Se excluyen los registros sin código UA.</a:t>
+              <a:t>Alertas con código UA: 10. Kits entregados: 13.390. Núcleos familiares con bono gestionado: 113. Monto de bonos gestionados: USD 33.200,80. Unidades cerradas / suspendidas: 99. 10 alertas con 10 códigos UA distintos: 8 Desarrollo Infantil; 2 Creciendo con Nuestros Hijos (CNH). 8 con afectación documentada y 2 por confirmar. Se excluyen los registros sin código UA.</a:t>
             </a:r>
           </a:p>
         </p:txBody>
@@ -5210,7 +5210,7 @@
                 </a:solidFill>
                 <a:latin typeface="Calibri"/>
               </a:rPr>
-              <a:t>Actualizado el 26 de octubre de 2026, 17:32</a:t>
+              <a:t>Actualizado el 26 de octubre de 2026, 17:54</a:t>
             </a:r>
           </a:p>
           <a:p>
@@ -5950,7 +5950,7 @@
                 </a:solidFill>
                 <a:latin typeface="Calibri"/>
               </a:rPr>
-              <a:t>Núcleos con bono gestionado</a:t>
+              <a:t>Núcleos familiares con bono gestionado</a:t>
             </a:r>
           </a:p>
         </p:txBody>
@@ -6721,7 +6721,7 @@
         <p:spPr>
           <a:xfrm>
             <a:off x="502920" y="3231489"/>
-            <a:ext cx="1828800" cy="744931"/>
+            <a:ext cx="1828800" cy="753465"/>
           </a:xfrm>
           <a:prstGeom prst="rect">
             <a:avLst/>
@@ -6756,7 +6756,7 @@
         <p:spPr>
           <a:xfrm>
             <a:off x="2468880" y="3231489"/>
-            <a:ext cx="9144000" cy="744931"/>
+            <a:ext cx="9144000" cy="753465"/>
           </a:xfrm>
           <a:prstGeom prst="rect">
             <a:avLst/>
@@ -6777,7 +6777,7 @@
                 </a:solidFill>
                 <a:latin typeface="Calibri"/>
               </a:rPr>
-              <a:t>Kits en provincias priorizadas: Kobo, corte 26/10/2026, 22:26:42. Entregas del 31/08 al 26/10; incluye fechas anteriores al inicio de las alertas. Reemplaza el corte anterior. Familias reportadas es una suma por entrega, no familias únicas. Datos declarados, pendientes de validación territorial.</a:t>
+              <a:t>Kits en provincias priorizadas: Kobo, corte 26/10/2026, 22:26:42. Entregas del 31/08 al 26/10; incluye fechas anteriores al inicio de las alertas. Reemplaza el corte anterior. Núcleos familiares reportados: suma por entrega, no núcleos únicos. El total de kits de este corte fue confirmado oficialmente.</a:t>
             </a:r>
           </a:p>
         </p:txBody>
@@ -6790,7 +6790,7 @@
         </p:nvSpPr>
         <p:spPr>
           <a:xfrm>
-            <a:off x="502920" y="4086148"/>
+            <a:off x="502920" y="4094683"/>
             <a:ext cx="1828800" cy="814425"/>
           </a:xfrm>
           <a:prstGeom prst="rect">
@@ -6825,7 +6825,7 @@
         </p:nvSpPr>
         <p:spPr>
           <a:xfrm>
-            <a:off x="2468880" y="4086148"/>
+            <a:off x="2468880" y="4094683"/>
             <a:ext cx="9144000" cy="814425"/>
           </a:xfrm>
           <a:prstGeom prst="rect">
@@ -6860,7 +6860,7 @@
         </p:nvSpPr>
         <p:spPr>
           <a:xfrm>
-            <a:off x="502920" y="5010302"/>
+            <a:off x="502920" y="5018836"/>
             <a:ext cx="1828800" cy="624230"/>
           </a:xfrm>
           <a:prstGeom prst="rect">
@@ -6895,7 +6895,7 @@
         </p:nvSpPr>
         <p:spPr>
           <a:xfrm>
-            <a:off x="2468880" y="5010302"/>
+            <a:off x="2468880" y="5018836"/>
             <a:ext cx="9144000" cy="624230"/>
           </a:xfrm>
           <a:prstGeom prst="rect">
@@ -6930,7 +6930,7 @@
         </p:nvSpPr>
         <p:spPr>
           <a:xfrm>
-            <a:off x="502920" y="5744260"/>
+            <a:off x="502920" y="5752795"/>
             <a:ext cx="11155680" cy="594360"/>
           </a:xfrm>
           <a:prstGeom prst="rect">
@@ -11754,7 +11754,7 @@
                           </a:solidFill>
                           <a:latin typeface="Calibri"/>
                         </a:rPr>
-                        <a:t>Bono núcleos</a:t>
+                        <a:t>Bono: núcleos familiares</a:t>
                       </a:r>
                     </a:p>
                   </a:txBody>
@@ -13464,7 +13464,7 @@
                           </a:solidFill>
                           <a:latin typeface="Calibri"/>
                         </a:rPr>
-                        <a:t>Bono núcleos</a:t>
+                        <a:t>Bono: núcleos familiares</a:t>
                       </a:r>
                     </a:p>
                   </a:txBody>
@@ -15211,7 +15211,7 @@
                           </a:solidFill>
                           <a:latin typeface="Calibri"/>
                         </a:rPr>
-                        <a:t>Familias*</a:t>
+                        <a:t>Núcleos familiares*</a:t>
                       </a:r>
                     </a:p>
                   </a:txBody>
@@ -16019,7 +16019,7 @@
                           </a:solidFill>
                           <a:latin typeface="Calibri"/>
                         </a:rPr>
-                        <a:t>Familias*</a:t>
+                        <a:t>Núcleos familiares*</a:t>
                       </a:r>
                     </a:p>
                   </a:txBody>
@@ -16774,7 +16774,7 @@
                 </a:solidFill>
                 <a:latin typeface="Calibri"/>
               </a:rPr>
-              <a:t>13.390 kits · 12.681 familias reportadas* · 89 registros. *No son familias únicas. Corte Kobo: 26/10/2026, 22:26.</a:t>
+              <a:t>13.390 kits · 12.681 núcleos familiares reportados* · 89 registros. *No son núcleos familiares únicos. Corte Kobo: 26/10/2026, 22:26.</a:t>
             </a:r>
           </a:p>
         </p:txBody>

</xml_diff>

<commit_message>
Retirar notas internas y refinar gráficos de Riesgos con cantidades y porcentajes
</commit_message>
<xml_diff>
--- a/docs/reportes/Seguimiento_ENOS_2026-10-26.pptx
+++ b/docs/reportes/Seguimiento_ENOS_2026-10-26.pptx
@@ -143,6 +143,9 @@
             <a:solidFill>
               <a:srgbClr val="5A369A"/>
             </a:solidFill>
+            <a:ln>
+              <a:noFill/>
+            </a:ln>
           </c:spPr>
           <c:cat>
             <c:strRef>
@@ -204,7 +207,7 @@
           <c:showBubbleSize val="0"/>
           <c:showLeaderLines val="1"/>
         </c:dLbls>
-        <c:gapWidth val="55"/>
+        <c:gapWidth val="190"/>
         <c:axId val="-2068027336"/>
         <c:axId val="-2113994440"/>
       </c:barChart>
@@ -228,7 +231,7 @@
           <a:lstStyle/>
           <a:p>
             <a:pPr>
-              <a:defRPr sz="1200"/>
+              <a:defRPr sz="1100"/>
             </a:pPr>
           </a:p>
         </c:txPr>
@@ -242,6 +245,7 @@
       <c:valAx>
         <c:axId val="-2113994440"/>
         <c:scaling>
+          <c:max val="10.0"/>
           <c:min val="0.0"/>
         </c:scaling>
         <c:delete/>
@@ -303,6 +307,9 @@
             <a:solidFill>
               <a:srgbClr val="5A369A"/>
             </a:solidFill>
+            <a:ln>
+              <a:noFill/>
+            </a:ln>
           </c:spPr>
           <c:cat>
             <c:strRef>
@@ -358,7 +365,7 @@
           <c:showBubbleSize val="0"/>
           <c:showLeaderLines val="1"/>
         </c:dLbls>
-        <c:gapWidth val="55"/>
+        <c:gapWidth val="190"/>
         <c:axId val="-2068027336"/>
         <c:axId val="-2113994440"/>
       </c:barChart>
@@ -382,7 +389,7 @@
           <a:lstStyle/>
           <a:p>
             <a:pPr>
-              <a:defRPr sz="1200"/>
+              <a:defRPr sz="1100"/>
             </a:pPr>
           </a:p>
         </c:txPr>
@@ -396,6 +403,7 @@
       <c:valAx>
         <c:axId val="-2113994440"/>
         <c:scaling>
+          <c:max val="10.0"/>
           <c:min val="0.0"/>
         </c:scaling>
         <c:delete/>
@@ -457,6 +465,9 @@
             <a:solidFill>
               <a:srgbClr val="5A369A"/>
             </a:solidFill>
+            <a:ln>
+              <a:noFill/>
+            </a:ln>
           </c:spPr>
           <c:cat>
             <c:strRef>
@@ -518,7 +529,7 @@
           <c:showBubbleSize val="0"/>
           <c:showLeaderLines val="1"/>
         </c:dLbls>
-        <c:gapWidth val="55"/>
+        <c:gapWidth val="190"/>
         <c:axId val="-2068027336"/>
         <c:axId val="-2113994440"/>
       </c:barChart>
@@ -542,7 +553,7 @@
           <a:lstStyle/>
           <a:p>
             <a:pPr>
-              <a:defRPr sz="1200"/>
+              <a:defRPr sz="1100"/>
             </a:pPr>
           </a:p>
         </c:txPr>
@@ -556,6 +567,7 @@
       <c:valAx>
         <c:axId val="-2113994440"/>
         <c:scaling>
+          <c:max val="10.0"/>
           <c:min val="0.0"/>
         </c:scaling>
         <c:delete/>
@@ -617,6 +629,9 @@
             <a:solidFill>
               <a:srgbClr val="5A369A"/>
             </a:solidFill>
+            <a:ln>
+              <a:noFill/>
+            </a:ln>
           </c:spPr>
           <c:cat>
             <c:strRef>
@@ -678,7 +693,7 @@
           <c:showBubbleSize val="0"/>
           <c:showLeaderLines val="1"/>
         </c:dLbls>
-        <c:gapWidth val="55"/>
+        <c:gapWidth val="190"/>
         <c:axId val="-2068027336"/>
         <c:axId val="-2113994440"/>
       </c:barChart>
@@ -702,7 +717,7 @@
           <a:lstStyle/>
           <a:p>
             <a:pPr>
-              <a:defRPr sz="1200"/>
+              <a:defRPr sz="1100"/>
             </a:pPr>
           </a:p>
         </c:txPr>
@@ -716,6 +731,7 @@
       <c:valAx>
         <c:axId val="-2113994440"/>
         <c:scaling>
+          <c:max val="99.0"/>
           <c:min val="0.0"/>
         </c:scaling>
         <c:delete/>
@@ -777,6 +793,9 @@
             <a:solidFill>
               <a:srgbClr val="5A369A"/>
             </a:solidFill>
+            <a:ln>
+              <a:noFill/>
+            </a:ln>
           </c:spPr>
           <c:cat>
             <c:strRef>
@@ -832,7 +851,7 @@
           <c:showBubbleSize val="0"/>
           <c:showLeaderLines val="1"/>
         </c:dLbls>
-        <c:gapWidth val="55"/>
+        <c:gapWidth val="190"/>
         <c:axId val="-2068027336"/>
         <c:axId val="-2113994440"/>
       </c:barChart>
@@ -856,7 +875,7 @@
           <a:lstStyle/>
           <a:p>
             <a:pPr>
-              <a:defRPr sz="1200"/>
+              <a:defRPr sz="1100"/>
             </a:pPr>
           </a:p>
         </c:txPr>
@@ -870,6 +889,7 @@
       <c:valAx>
         <c:axId val="-2113994440"/>
         <c:scaling>
+          <c:max val="99.0"/>
           <c:min val="0.0"/>
         </c:scaling>
         <c:delete/>
@@ -1299,7 +1319,7 @@
           <a:lstStyle/>
           <a:p>
             <a:r>
-              <a:t>Alertas con código UA: 10. Kits entregados: 13.390. Núcleos familiares con bono gestionado: 113. Monto de bonos gestionados: USD 33.200,80. Unidades cerradas / suspendidas: 99. 10 alertas con 10 códigos UA distintos: 8 Desarrollo Infantil; 2 Creciendo con Nuestros Hijos (CNH). 8 con afectación documentada y 2 por confirmar. Se excluyen los registros sin código UA.</a:t>
+              <a:t>Alertas con código UA: 10. Kits entregados: 13.390. Núcleos familiares con bono gestionado: 113. Monto de bonos gestionados: USD 33.200,80. Unidades cerradas / suspendidas: 99. 10 alertas con 10 códigos UA distintos: 8 Desarrollo Infantil; 2 Creciendo con Nuestros Hijos (CNH). Se excluyen los registros sin código UA.</a:t>
             </a:r>
           </a:p>
         </p:txBody>
@@ -5210,7 +5230,7 @@
                 </a:solidFill>
                 <a:latin typeface="Calibri"/>
               </a:rPr>
-              <a:t>Actualizado el 26 de octubre de 2026, 17:54</a:t>
+              <a:t>Actualizado el 26 de octubre de 2026, 18:00</a:t>
             </a:r>
           </a:p>
           <a:p>
@@ -6651,76 +6671,6 @@
         <p:spPr>
           <a:xfrm>
             <a:off x="502920" y="2397556"/>
-            <a:ext cx="1828800" cy="724204"/>
-          </a:xfrm>
-          <a:prstGeom prst="rect">
-            <a:avLst/>
-          </a:prstGeom>
-          <a:noFill/>
-        </p:spPr>
-        <p:txBody>
-          <a:bodyPr wrap="square" anchor="t" lIns="0" rIns="0" tIns="0" bIns="0">
-            <a:spAutoFit/>
-          </a:bodyPr>
-          <a:lstStyle/>
-          <a:p>
-            <a:pPr algn="l"/>
-            <a:r>
-              <a:rPr sz="1200" b="1">
-                <a:solidFill>
-                  <a:srgbClr val="512F8D"/>
-                </a:solidFill>
-                <a:latin typeface="Calibri"/>
-              </a:rPr>
-              <a:t>Revisión de alertas</a:t>
-            </a:r>
-          </a:p>
-        </p:txBody>
-      </p:sp>
-      <p:sp>
-        <p:nvSpPr>
-          <p:cNvPr id="12" name="TextBox 11"/>
-          <p:cNvSpPr txBox="1"/>
-          <p:nvPr/>
-        </p:nvSpPr>
-        <p:spPr>
-          <a:xfrm>
-            <a:off x="2468880" y="2397556"/>
-            <a:ext cx="9144000" cy="724204"/>
-          </a:xfrm>
-          <a:prstGeom prst="rect">
-            <a:avLst/>
-          </a:prstGeom>
-          <a:noFill/>
-        </p:spPr>
-        <p:txBody>
-          <a:bodyPr wrap="square" anchor="t" lIns="0" rIns="0" tIns="0" bIns="0">
-            <a:spAutoFit/>
-          </a:bodyPr>
-          <a:lstStyle/>
-          <a:p>
-            <a:pPr algn="l"/>
-            <a:r>
-              <a:rPr sz="1100" b="0">
-                <a:solidFill>
-                  <a:srgbClr val="20202B"/>
-                </a:solidFill>
-                <a:latin typeface="Calibri"/>
-              </a:rPr>
-              <a:t>En el corte nacional hay 10 alertas con 10 códigos UA distintos: 8 con afectación documentada y 2 por confirmar. ALT-2026-000315 y ALT-2026-000316 (Tenguel) tienen código UA, pero el relato solo describe inundación territorial; no se presentan como daños confirmados al servicio.</a:t>
-            </a:r>
-          </a:p>
-        </p:txBody>
-      </p:sp>
-      <p:sp>
-        <p:nvSpPr>
-          <p:cNvPr id="13" name="TextBox 12"/>
-          <p:cNvSpPr txBox="1"/>
-          <p:nvPr/>
-        </p:nvSpPr>
-        <p:spPr>
-          <a:xfrm>
-            <a:off x="502920" y="3231489"/>
             <a:ext cx="1828800" cy="753465"/>
           </a:xfrm>
           <a:prstGeom prst="rect">
@@ -6749,13 +6699,13 @@
       </p:sp>
       <p:sp>
         <p:nvSpPr>
-          <p:cNvPr id="14" name="TextBox 13"/>
+          <p:cNvPr id="12" name="TextBox 11"/>
           <p:cNvSpPr txBox="1"/>
           <p:nvPr/>
         </p:nvSpPr>
         <p:spPr>
           <a:xfrm>
-            <a:off x="2468880" y="3231489"/>
+            <a:off x="2468880" y="2397556"/>
             <a:ext cx="9144000" cy="753465"/>
           </a:xfrm>
           <a:prstGeom prst="rect">
@@ -6784,13 +6734,13 @@
       </p:sp>
       <p:sp>
         <p:nvSpPr>
-          <p:cNvPr id="15" name="TextBox 14"/>
+          <p:cNvPr id="13" name="TextBox 12"/>
           <p:cNvSpPr txBox="1"/>
           <p:nvPr/>
         </p:nvSpPr>
         <p:spPr>
           <a:xfrm>
-            <a:off x="502920" y="4094683"/>
+            <a:off x="502920" y="3260750"/>
             <a:ext cx="1828800" cy="814425"/>
           </a:xfrm>
           <a:prstGeom prst="rect">
@@ -6819,13 +6769,13 @@
       </p:sp>
       <p:sp>
         <p:nvSpPr>
-          <p:cNvPr id="16" name="TextBox 15"/>
+          <p:cNvPr id="14" name="TextBox 13"/>
           <p:cNvSpPr txBox="1"/>
           <p:nvPr/>
         </p:nvSpPr>
         <p:spPr>
           <a:xfrm>
-            <a:off x="2468880" y="4094683"/>
+            <a:off x="2468880" y="3260750"/>
             <a:ext cx="9144000" cy="814425"/>
           </a:xfrm>
           <a:prstGeom prst="rect">
@@ -6854,13 +6804,13 @@
       </p:sp>
       <p:sp>
         <p:nvSpPr>
-          <p:cNvPr id="17" name="TextBox 16"/>
+          <p:cNvPr id="15" name="TextBox 14"/>
           <p:cNvSpPr txBox="1"/>
           <p:nvPr/>
         </p:nvSpPr>
         <p:spPr>
           <a:xfrm>
-            <a:off x="502920" y="5018836"/>
+            <a:off x="502920" y="4184903"/>
             <a:ext cx="1828800" cy="624230"/>
           </a:xfrm>
           <a:prstGeom prst="rect">
@@ -6889,13 +6839,13 @@
       </p:sp>
       <p:sp>
         <p:nvSpPr>
-          <p:cNvPr id="18" name="TextBox 17"/>
+          <p:cNvPr id="16" name="TextBox 15"/>
           <p:cNvSpPr txBox="1"/>
           <p:nvPr/>
         </p:nvSpPr>
         <p:spPr>
           <a:xfrm>
-            <a:off x="2468880" y="5018836"/>
+            <a:off x="2468880" y="4184903"/>
             <a:ext cx="9144000" cy="624230"/>
           </a:xfrm>
           <a:prstGeom prst="rect">
@@ -6924,13 +6874,13 @@
       </p:sp>
       <p:sp>
         <p:nvSpPr>
-          <p:cNvPr id="19" name="TextBox 18"/>
+          <p:cNvPr id="17" name="TextBox 16"/>
           <p:cNvSpPr txBox="1"/>
           <p:nvPr/>
         </p:nvSpPr>
         <p:spPr>
           <a:xfrm>
-            <a:off x="502920" y="5752795"/>
+            <a:off x="502920" y="4918862"/>
             <a:ext cx="11155680" cy="594360"/>
           </a:xfrm>
           <a:prstGeom prst="rect">
@@ -7344,7 +7294,7 @@
                 </a:solidFill>
                 <a:latin typeface="Calibri"/>
               </a:rPr>
-              <a:t>10 alertas con 10 códigos UA distintos: 8 Desarrollo Infantil; 2 Creciendo con Nuestros Hijos (CNH). 8 con afectación documentada y 2 por confirmar. Se excluyen los registros sin código UA.</a:t>
+              <a:t>10 alertas con 10 códigos UA distintos: 8 Desarrollo Infantil; 2 Creciendo con Nuestros Hijos (CNH). Se excluyen los registros sin código UA.</a:t>
             </a:r>
           </a:p>
         </p:txBody>
@@ -7823,7 +7773,7 @@
                 </a:solidFill>
                 <a:latin typeface="Calibri"/>
               </a:rPr>
-              <a:t>Base territorial del 26/10/2026, 16:00, actualizada con la confirmación operativa posterior de Guayas: 99 UA suspendidas (35 CDI y 64 CNH). Las 17 CDI de Guayas se incluyen como suspendidas por confirmación recibida; su estado original se conserva para trazabilidad. Los 63 CNH de El Oro no tienen nombre ni cantón en la base. No constan códigos UA ni se suma este registro a las 10 alertas.</a:t>
+              <a:t>Fuente: reporte territorial de unidades con suspensión total o presencial. Corte: 26/10/2026, 16:00.</a:t>
             </a:r>
           </a:p>
         </p:txBody>
@@ -9043,41 +8993,6 @@
           </a:graphicData>
         </a:graphic>
       </p:graphicFrame>
-      <p:sp>
-        <p:nvSpPr>
-          <p:cNvPr id="10" name="TextBox 9"/>
-          <p:cNvSpPr txBox="1"/>
-          <p:nvPr/>
-        </p:nvSpPr>
-        <p:spPr>
-          <a:xfrm>
-            <a:off x="502920" y="5943600"/>
-            <a:ext cx="11155680" cy="320040"/>
-          </a:xfrm>
-          <a:prstGeom prst="rect">
-            <a:avLst/>
-          </a:prstGeom>
-          <a:noFill/>
-        </p:spPr>
-        <p:txBody>
-          <a:bodyPr wrap="square" anchor="t" lIns="0" rIns="0" tIns="0" bIns="0">
-            <a:spAutoFit/>
-          </a:bodyPr>
-          <a:lstStyle/>
-          <a:p>
-            <a:pPr algn="l"/>
-            <a:r>
-              <a:rPr sz="1100" b="0">
-                <a:solidFill>
-                  <a:srgbClr val="20202B"/>
-                </a:solidFill>
-                <a:latin typeface="Calibri"/>
-              </a:rPr>
-              <a:t>Código UA: no consta en la base. Los 63 CNH de El Oro no tienen nombre ni cantón registrados.</a:t>
-            </a:r>
-          </a:p>
-        </p:txBody>
-      </p:sp>
     </p:spTree>
   </p:cSld>
   <p:clrMapOvr>
@@ -10243,7 +10158,7 @@
                 </a:solidFill>
                 <a:latin typeface="Calibri"/>
               </a:rPr>
-              <a:t>En el corte nacional hay 10 alertas con 10 códigos UA distintos: 8 con afectación documentada y 2 por confirmar. ALT-2026-000315 y ALT-2026-000316 (Tenguel) tienen código UA, pero el relato solo describe inundación territorial; no se presentan como daños confirmados al servicio.</a:t>
+              <a:t/>
             </a:r>
           </a:p>
         </p:txBody>
@@ -11413,7 +11328,7 @@
                 </a:solidFill>
                 <a:latin typeface="Calibri"/>
               </a:rPr>
-              <a:t>En el corte nacional hay 10 alertas con 10 códigos UA distintos: 8 con afectación documentada y 2 por confirmar. ALT-2026-000315 y ALT-2026-000316 (Tenguel) tienen código UA, pero el relato solo describe inundación territorial; no se presentan como daños confirmados al servicio.</a:t>
+              <a:t/>
             </a:r>
           </a:p>
         </p:txBody>

</xml_diff>

<commit_message>
Quitar subtítulos de los alcances de Riesgos y enlazar el geoportal
- PDF «Alcances y fuentes», nota de la presentación y nota metodológica del tablero: cada alcance en
  su propio párrafo, sin subtítulos, en dos columnas (una en teléfono).
- Cierre común «Más información en el geoportal de unidades de atención y amenazas», con el nombre
  del geoportal como enlace en el PDF, la diapositiva y el tablero; en el libro, la fila Geoportal de
  la ficha técnica es un vínculo. La dirección ya no se imprime suelta.
- Página 3 del PDF con más aire para los kits y los alcances; prueba nueva (126 en total).

Co-Authored-By: Claude Opus 5.5 <noreply@anthropic.com>
Claude-Session: https://claude.ai/code/session_01AUCWMWZ6GMzdHUXxvK5iGa
</commit_message>
<xml_diff>
--- a/docs/reportes/Seguimiento_ENOS_2026-10-26.pptx
+++ b/docs/reportes/Seguimiento_ENOS_2026-10-26.pptx
@@ -6544,7 +6544,7 @@
         <p:spPr>
           <a:xfrm>
             <a:off x="502920" y="1325880"/>
-            <a:ext cx="1920240" cy="870966"/>
+            <a:ext cx="5440680" cy="4572000"/>
           </a:xfrm>
           <a:prstGeom prst="rect">
             <a:avLst/>
@@ -6552,49 +6552,18 @@
           <a:noFill/>
         </p:spPr>
         <p:txBody>
-          <a:bodyPr wrap="square" anchor="t" lIns="0" rIns="0" tIns="0" bIns="0">
+          <a:bodyPr wrap="square" lIns="0" rIns="0" tIns="0" bIns="0">
             <a:spAutoFit/>
           </a:bodyPr>
           <a:lstStyle/>
           <a:p>
-            <a:pPr algn="l"/>
-            <a:r>
-              <a:rPr sz="1200" b="1">
-                <a:solidFill>
-                  <a:srgbClr val="512F8D"/>
-                </a:solidFill>
-                <a:latin typeface="Calibri"/>
-              </a:rPr>
-              <a:t>Alertas</a:t>
-            </a:r>
-          </a:p>
-        </p:txBody>
-      </p:sp>
-      <p:sp>
-        <p:nvSpPr>
-          <p:cNvPr id="10" name="TextBox 9"/>
-          <p:cNvSpPr txBox="1"/>
-          <p:nvPr/>
-        </p:nvSpPr>
-        <p:spPr>
-          <a:xfrm>
-            <a:off x="2514600" y="1325880"/>
-            <a:ext cx="9144000" cy="870966"/>
-          </a:xfrm>
-          <a:prstGeom prst="rect">
-            <a:avLst/>
-          </a:prstGeom>
-          <a:noFill/>
-        </p:spPr>
-        <p:txBody>
-          <a:bodyPr wrap="square" anchor="t" lIns="0" rIns="0" tIns="0" bIns="0">
-            <a:spAutoFit/>
-          </a:bodyPr>
-          <a:lstStyle/>
-          <a:p>
-            <a:pPr algn="l"/>
-            <a:r>
-              <a:rPr sz="1100" b="0">
+            <a:pPr>
+              <a:spcAft>
+                <a:spcPts val="1000"/>
+              </a:spcAft>
+            </a:pPr>
+            <a:r>
+              <a:rPr sz="1250">
                 <a:solidFill>
                   <a:srgbClr val="20202B"/>
                 </a:solidFill>
@@ -6603,68 +6572,14 @@
               <a:t>Se muestran únicamente alertas revisadas con código UA registrado, desde el 14 de septiembre de 2026. El conteo corresponde a códigos de alerta distintos vinculados a unidades identificadas. Los registros sin código quedan fuera de este alcance. La fecha corresponde al registro y una alerta no equivale necesariamente a un evento único. El campo Afectados mezcla personas, familias y usuarios; no se suma como personas únicas. La base no certifica atribución causal a ENOS.</a:t>
             </a:r>
           </a:p>
-        </p:txBody>
-      </p:sp>
-      <p:sp>
-        <p:nvSpPr>
-          <p:cNvPr id="11" name="TextBox 10"/>
-          <p:cNvSpPr txBox="1"/>
-          <p:nvPr/>
-        </p:nvSpPr>
-        <p:spPr>
-          <a:xfrm>
-            <a:off x="502920" y="2288286"/>
-            <a:ext cx="1920240" cy="675513"/>
-          </a:xfrm>
-          <a:prstGeom prst="rect">
-            <a:avLst/>
-          </a:prstGeom>
-          <a:noFill/>
-        </p:spPr>
-        <p:txBody>
-          <a:bodyPr wrap="square" anchor="t" lIns="0" rIns="0" tIns="0" bIns="0">
-            <a:spAutoFit/>
-          </a:bodyPr>
-          <a:lstStyle/>
-          <a:p>
-            <a:pPr algn="l"/>
-            <a:r>
-              <a:rPr sz="1200" b="1">
-                <a:solidFill>
-                  <a:srgbClr val="512F8D"/>
-                </a:solidFill>
-                <a:latin typeface="Calibri"/>
-              </a:rPr>
-              <a:t>Kits</a:t>
-            </a:r>
-          </a:p>
-        </p:txBody>
-      </p:sp>
-      <p:sp>
-        <p:nvSpPr>
-          <p:cNvPr id="12" name="TextBox 11"/>
-          <p:cNvSpPr txBox="1"/>
-          <p:nvPr/>
-        </p:nvSpPr>
-        <p:spPr>
-          <a:xfrm>
-            <a:off x="2514600" y="2288286"/>
-            <a:ext cx="9144000" cy="675513"/>
-          </a:xfrm>
-          <a:prstGeom prst="rect">
-            <a:avLst/>
-          </a:prstGeom>
-          <a:noFill/>
-        </p:spPr>
-        <p:txBody>
-          <a:bodyPr wrap="square" anchor="t" lIns="0" rIns="0" tIns="0" bIns="0">
-            <a:spAutoFit/>
-          </a:bodyPr>
-          <a:lstStyle/>
-          <a:p>
-            <a:pPr algn="l"/>
-            <a:r>
-              <a:rPr sz="1100" b="0">
+          <a:p>
+            <a:pPr>
+              <a:spcAft>
+                <a:spcPts val="1000"/>
+              </a:spcAft>
+            </a:pPr>
+            <a:r>
+              <a:rPr sz="1250">
                 <a:solidFill>
                   <a:srgbClr val="20202B"/>
                 </a:solidFill>
@@ -6673,53 +6588,69 @@
               <a:t>Kits en provincias priorizadas: Kobo, corte 26/10/2026, 22:26:42. Entregas del 31/08 al 26/10; incluye fechas anteriores al inicio de las alertas. Reemplaza el corte anterior. Núcleos familiares reportados: suma por entrega, no núcleos únicos. El total de kits de este corte fue confirmado oficialmente.</a:t>
             </a:r>
           </a:p>
-        </p:txBody>
-      </p:sp>
-      <p:sp>
-        <p:nvSpPr>
-          <p:cNvPr id="13" name="TextBox 12"/>
-          <p:cNvSpPr txBox="1"/>
-          <p:nvPr/>
-        </p:nvSpPr>
-        <p:spPr>
-          <a:xfrm>
-            <a:off x="502920" y="3055239"/>
-            <a:ext cx="1920240" cy="732663"/>
-          </a:xfrm>
-          <a:prstGeom prst="rect">
-            <a:avLst/>
-          </a:prstGeom>
-          <a:noFill/>
-        </p:spPr>
-        <p:txBody>
-          <a:bodyPr wrap="square" anchor="t" lIns="0" rIns="0" tIns="0" bIns="0">
-            <a:spAutoFit/>
-          </a:bodyPr>
-          <a:lstStyle/>
-          <a:p>
-            <a:pPr algn="l"/>
-            <a:r>
-              <a:rPr sz="1200" b="1">
+          <a:p>
+            <a:pPr>
+              <a:spcAft>
+                <a:spcPts val="1000"/>
+              </a:spcAft>
+            </a:pPr>
+            <a:r>
+              <a:rPr sz="1250">
+                <a:solidFill>
+                  <a:srgbClr val="20202B"/>
+                </a:solidFill>
+                <a:latin typeface="Calibri"/>
+              </a:rPr>
+              <a:t>Fuente: reporte territorial de unidades con suspensión total o presencial. Corte: 26/10/2026, 16:00.</a:t>
+            </a:r>
+          </a:p>
+          <a:p>
+            <a:pPr>
+              <a:spcBef>
+                <a:spcPts val="600"/>
+              </a:spcBef>
+            </a:pPr>
+            <a:r>
+              <a:rPr sz="1350">
+                <a:solidFill>
+                  <a:srgbClr val="5A5765"/>
+                </a:solidFill>
+                <a:latin typeface="Calibri"/>
+              </a:rPr>
+              <a:t>Más información en el </a:t>
+            </a:r>
+            <a:r>
+              <a:rPr sz="1350" b="1" u="sng">
                 <a:solidFill>
                   <a:srgbClr val="512F8D"/>
                 </a:solidFill>
                 <a:latin typeface="Calibri"/>
+                <a:hlinkClick r:id="rId4"/>
               </a:rPr>
-              <a:t>Bono de contingencia</a:t>
-            </a:r>
-          </a:p>
-        </p:txBody>
-      </p:sp>
-      <p:sp>
-        <p:nvSpPr>
-          <p:cNvPr id="14" name="TextBox 13"/>
+              <a:t>geoportal de unidades de atención y amenazas</a:t>
+            </a:r>
+            <a:r>
+              <a:rPr sz="1350">
+                <a:solidFill>
+                  <a:srgbClr val="5A5765"/>
+                </a:solidFill>
+                <a:latin typeface="Calibri"/>
+              </a:rPr>
+              <a:t>.</a:t>
+            </a:r>
+          </a:p>
+        </p:txBody>
+      </p:sp>
+      <p:sp>
+        <p:nvSpPr>
+          <p:cNvPr id="10" name="TextBox 9"/>
           <p:cNvSpPr txBox="1"/>
           <p:nvPr/>
         </p:nvSpPr>
         <p:spPr>
           <a:xfrm>
-            <a:off x="2514600" y="3055239"/>
-            <a:ext cx="9144000" cy="732663"/>
+            <a:off x="6217920" y="1325880"/>
+            <a:ext cx="5440680" cy="4572000"/>
           </a:xfrm>
           <a:prstGeom prst="rect">
             <a:avLst/>
@@ -6727,14 +6658,18 @@
           <a:noFill/>
         </p:spPr>
         <p:txBody>
-          <a:bodyPr wrap="square" anchor="t" lIns="0" rIns="0" tIns="0" bIns="0">
+          <a:bodyPr wrap="square" lIns="0" rIns="0" tIns="0" bIns="0">
             <a:spAutoFit/>
           </a:bodyPr>
           <a:lstStyle/>
           <a:p>
-            <a:pPr algn="l"/>
-            <a:r>
-              <a:rPr sz="1100" b="0">
+            <a:pPr>
+              <a:spcAft>
+                <a:spcPts val="1000"/>
+              </a:spcAft>
+            </a:pPr>
+            <a:r>
+              <a:rPr sz="1250">
                 <a:solidFill>
                   <a:srgbClr val="20202B"/>
                 </a:solidFill>
@@ -6743,68 +6678,14 @@
               <a:t>La ayuda memoria no identifica pagos exclusivamente atribuibles a ENOS ni fechas individuales para recortar desde el 14/09. Se muestran únicamente las filas de inundación como referencia: pagos gestionados desde el 29/08 y casos en articulación al 23/10. Articulación no equivale a pago. Las proyecciones corresponden a planificación nacional 2026–2027.</a:t>
             </a:r>
           </a:p>
-        </p:txBody>
-      </p:sp>
-      <p:sp>
-        <p:nvSpPr>
-          <p:cNvPr id="15" name="TextBox 14"/>
-          <p:cNvSpPr txBox="1"/>
-          <p:nvPr/>
-        </p:nvSpPr>
-        <p:spPr>
-          <a:xfrm>
-            <a:off x="502920" y="3879341"/>
-            <a:ext cx="1920240" cy="554355"/>
-          </a:xfrm>
-          <a:prstGeom prst="rect">
-            <a:avLst/>
-          </a:prstGeom>
-          <a:noFill/>
-        </p:spPr>
-        <p:txBody>
-          <a:bodyPr wrap="square" anchor="t" lIns="0" rIns="0" tIns="0" bIns="0">
-            <a:spAutoFit/>
-          </a:bodyPr>
-          <a:lstStyle/>
-          <a:p>
-            <a:pPr algn="l"/>
-            <a:r>
-              <a:rPr sz="1200" b="1">
-                <a:solidFill>
-                  <a:srgbClr val="512F8D"/>
-                </a:solidFill>
-                <a:latin typeface="Calibri"/>
-              </a:rPr>
-              <a:t>Filtros</a:t>
-            </a:r>
-          </a:p>
-        </p:txBody>
-      </p:sp>
-      <p:sp>
-        <p:nvSpPr>
-          <p:cNvPr id="16" name="TextBox 15"/>
-          <p:cNvSpPr txBox="1"/>
-          <p:nvPr/>
-        </p:nvSpPr>
-        <p:spPr>
-          <a:xfrm>
-            <a:off x="2514600" y="3879341"/>
-            <a:ext cx="9144000" cy="554355"/>
-          </a:xfrm>
-          <a:prstGeom prst="rect">
-            <a:avLst/>
-          </a:prstGeom>
-          <a:noFill/>
-        </p:spPr>
-        <p:txBody>
-          <a:bodyPr wrap="square" anchor="t" lIns="0" rIns="0" tIns="0" bIns="0">
-            <a:spAutoFit/>
-          </a:bodyPr>
-          <a:lstStyle/>
-          <a:p>
-            <a:pPr algn="l"/>
-            <a:r>
-              <a:rPr sz="1100" b="0">
+          <a:p>
+            <a:pPr>
+              <a:spcAft>
+                <a:spcPts val="1000"/>
+              </a:spcAft>
+            </a:pPr>
+            <a:r>
+              <a:rPr sz="1250">
                 <a:solidFill>
                   <a:srgbClr val="20202B"/>
                 </a:solidFill>
@@ -6813,110 +6694,20 @@
               <a:t>El territorio se aplica a todas las acciones; el servicio, a las alertas y al seguimiento de continuidad de atención. Kits y bono no se asocian a un servicio. La planificación del bono es nacional.</a:t>
             </a:r>
           </a:p>
-        </p:txBody>
-      </p:sp>
-      <p:sp>
-        <p:nvSpPr>
-          <p:cNvPr id="17" name="TextBox 16"/>
-          <p:cNvSpPr txBox="1"/>
-          <p:nvPr/>
-        </p:nvSpPr>
-        <p:spPr>
-          <a:xfrm>
-            <a:off x="502920" y="4525137"/>
-            <a:ext cx="1920240" cy="443484"/>
-          </a:xfrm>
-          <a:prstGeom prst="rect">
-            <a:avLst/>
-          </a:prstGeom>
-          <a:noFill/>
-        </p:spPr>
-        <p:txBody>
-          <a:bodyPr wrap="square" anchor="t" lIns="0" rIns="0" tIns="0" bIns="0">
-            <a:spAutoFit/>
-          </a:bodyPr>
-          <a:lstStyle/>
-          <a:p>
-            <a:pPr algn="l"/>
-            <a:r>
-              <a:rPr sz="1200" b="1">
-                <a:solidFill>
-                  <a:srgbClr val="512F8D"/>
-                </a:solidFill>
-                <a:latin typeface="Calibri"/>
-              </a:rPr>
-              <a:t>Continuidad</a:t>
-            </a:r>
-          </a:p>
-        </p:txBody>
-      </p:sp>
-      <p:sp>
-        <p:nvSpPr>
-          <p:cNvPr id="18" name="TextBox 17"/>
-          <p:cNvSpPr txBox="1"/>
-          <p:nvPr/>
-        </p:nvSpPr>
-        <p:spPr>
-          <a:xfrm>
-            <a:off x="2514600" y="4525137"/>
-            <a:ext cx="9144000" cy="443484"/>
-          </a:xfrm>
-          <a:prstGeom prst="rect">
-            <a:avLst/>
-          </a:prstGeom>
-          <a:noFill/>
-        </p:spPr>
-        <p:txBody>
-          <a:bodyPr wrap="square" anchor="t" lIns="0" rIns="0" tIns="0" bIns="0">
-            <a:spAutoFit/>
-          </a:bodyPr>
-          <a:lstStyle/>
-          <a:p>
-            <a:pPr algn="l"/>
-            <a:r>
-              <a:rPr sz="1100" b="0">
+          <a:p>
+            <a:pPr>
+              <a:spcAft>
+                <a:spcPts val="1000"/>
+              </a:spcAft>
+            </a:pPr>
+            <a:r>
+              <a:rPr sz="1250">
                 <a:solidFill>
                   <a:srgbClr val="20202B"/>
                 </a:solidFill>
                 <a:latin typeface="Calibri"/>
               </a:rPr>
-              <a:t>Fuente: reporte territorial de unidades con suspensión total o presencial. Corte: 26/10/2026, 16:00.</a:t>
-            </a:r>
-          </a:p>
-        </p:txBody>
-      </p:sp>
-      <p:sp>
-        <p:nvSpPr>
-          <p:cNvPr id="19" name="TextBox 18"/>
-          <p:cNvSpPr txBox="1"/>
-          <p:nvPr/>
-        </p:nvSpPr>
-        <p:spPr>
-          <a:xfrm>
-            <a:off x="502920" y="5060061"/>
-            <a:ext cx="11155680" cy="548640"/>
-          </a:xfrm>
-          <a:prstGeom prst="rect">
-            <a:avLst/>
-          </a:prstGeom>
-          <a:noFill/>
-        </p:spPr>
-        <p:txBody>
-          <a:bodyPr wrap="square" anchor="t" lIns="0" rIns="0" tIns="0" bIns="0">
-            <a:spAutoFit/>
-          </a:bodyPr>
-          <a:lstStyle/>
-          <a:p>
-            <a:pPr algn="l"/>
-            <a:r>
-              <a:rPr sz="1000" b="0">
-                <a:solidFill>
-                  <a:srgbClr val="5A5765"/>
-                </a:solidFill>
-                <a:latin typeface="Calibri"/>
-              </a:rPr>
-              <a:t>Fuentes: Subsecretaría Territorial (análisis de alertas); corte Kobo de kits; ayuda memoria del bono de contingencia; base territorial de afectaciones por lluvias.
-Geoportal: https://geoportal.trabajo.gob.ec/ua_amenazas</a:t>
+              <a:t>Fuentes: Subsecretaría Territorial (análisis de alertas); corte Kobo de kits; ayuda memoria del bono de contingencia; base territorial de afectaciones por lluvias.</a:t>
             </a:r>
           </a:p>
         </p:txBody>

</xml_diff>

<commit_message>
Ajustar el resumen de Riesgos a la estructura aprobada del Plan ENOS
- Página 2 como en el PDF aprobado: nota, las 21 alertas, alertas por provincia y por servicio
  y evolución de las alertas; la tabla toma el mayor tamaño de letra que deja espacio al resto.
- Página 3 solo con la respuesta por provincia, cifras alineadas como en la tabla aprobada.
- Página 1: servicios con sus nombres del boletín aprobado, provincia en negrita en el detalle
  y barras con su separación original.
- Los 6 reportes gerontológicos con fecha de reporte 26/10/2026: la evolución suma las 21 alertas
  (se conserva la redacción de la fuente para trazabilidad).

Co-Authored-By: Claude Opus 5.5 <noreply@anthropic.com>
Claude-Session: https://claude.ai/code/session_01AUCWMWZ6GMzdHUXxvK5iGa
</commit_message>
<xml_diff>
--- a/docs/reportes/Seguimiento_ENOS_2026-10-26.pptx
+++ b/docs/reportes/Seguimiento_ENOS_2026-10-26.pptx
@@ -5762,13 +5762,13 @@
               </a:lnSpc>
             </a:pPr>
             <a:r>
-              <a:rPr sz="3600" b="1">
+              <a:rPr sz="3200" b="1">
                 <a:solidFill>
                   <a:srgbClr val="FFFFFF"/>
                 </a:solidFill>
                 <a:latin typeface="Century Gothic"/>
               </a:rPr>
-              <a:t>Riesgos</a:t>
+              <a:t>Riesgos · Respuesta del Ministerio</a:t>
             </a:r>
           </a:p>
         </p:txBody>
@@ -11185,6 +11185,726 @@
                           </a:solidFill>
                           <a:latin typeface="Calibri"/>
                         </a:rPr>
+                        <a:t>GER-2026-006
+26/10/2026</a:t>
+                      </a:r>
+                    </a:p>
+                  </a:txBody>
+                  <a:tcPr marL="73152" marR="73152" marT="27432" marB="27432" anchor="ctr">
+                    <a:solidFill>
+                      <a:srgbClr val="FFFFFF"/>
+                    </a:solidFill>
+                  </a:tcPr>
+                </a:tc>
+                <a:tc>
+                  <a:txBody>
+                    <a:bodyPr wrap="square"/>
+                    <a:lstStyle/>
+                    <a:p>
+                      <a:pPr algn="l"/>
+                      <a:r>
+                        <a:rPr sz="900" b="0">
+                          <a:solidFill>
+                            <a:srgbClr val="20202B"/>
+                          </a:solidFill>
+                          <a:latin typeface="Calibri"/>
+                        </a:rPr>
+                        <a:t>—
+Centros gerontológicos</a:t>
+                      </a:r>
+                    </a:p>
+                  </a:txBody>
+                  <a:tcPr marL="73152" marR="73152" marT="27432" marB="27432" anchor="ctr">
+                    <a:solidFill>
+                      <a:srgbClr val="FFFFFF"/>
+                    </a:solidFill>
+                  </a:tcPr>
+                </a:tc>
+                <a:tc>
+                  <a:txBody>
+                    <a:bodyPr wrap="square"/>
+                    <a:lstStyle/>
+                    <a:p>
+                      <a:pPr algn="l"/>
+                      <a:r>
+                        <a:rPr sz="900" b="0">
+                          <a:solidFill>
+                            <a:srgbClr val="20202B"/>
+                          </a:solidFill>
+                          <a:latin typeface="Calibri"/>
+                        </a:rPr>
+                        <a:t>Santo Domingo de los Tsáchilas
+Santo Domingo</a:t>
+                      </a:r>
+                    </a:p>
+                  </a:txBody>
+                  <a:tcPr marL="73152" marR="73152" marT="27432" marB="27432" anchor="ctr">
+                    <a:solidFill>
+                      <a:srgbClr val="FFFFFF"/>
+                    </a:solidFill>
+                  </a:tcPr>
+                </a:tc>
+                <a:tc>
+                  <a:txBody>
+                    <a:bodyPr wrap="square"/>
+                    <a:lstStyle/>
+                    <a:p>
+                      <a:pPr algn="l"/>
+                      <a:r>
+                        <a:rPr sz="900" b="0">
+                          <a:solidFill>
+                            <a:srgbClr val="20202B"/>
+                          </a:solidFill>
+                          <a:latin typeface="Calibri"/>
+                        </a:rPr>
+                        <a:t>Filtraciones y humedad; mitigación inmediata. Servicio operativo.</a:t>
+                      </a:r>
+                    </a:p>
+                  </a:txBody>
+                  <a:tcPr marL="73152" marR="73152" marT="27432" marB="27432" anchor="ctr">
+                    <a:solidFill>
+                      <a:srgbClr val="FFFFFF"/>
+                    </a:solidFill>
+                  </a:tcPr>
+                </a:tc>
+                <a:tc>
+                  <a:txBody>
+                    <a:bodyPr wrap="square"/>
+                    <a:lstStyle/>
+                    <a:p>
+                      <a:pPr algn="l"/>
+                      <a:r>
+                        <a:rPr sz="900" b="0">
+                          <a:solidFill>
+                            <a:srgbClr val="20202B"/>
+                          </a:solidFill>
+                          <a:latin typeface="Calibri"/>
+                        </a:rPr>
+                        <a:t>En seguimiento</a:t>
+                      </a:r>
+                    </a:p>
+                  </a:txBody>
+                  <a:tcPr marL="73152" marR="73152" marT="27432" marB="27432" anchor="ctr">
+                    <a:solidFill>
+                      <a:srgbClr val="FFFFFF"/>
+                    </a:solidFill>
+                  </a:tcPr>
+                </a:tc>
+              </a:tr>
+              <a:tr h="594360">
+                <a:tc>
+                  <a:txBody>
+                    <a:bodyPr wrap="square"/>
+                    <a:lstStyle/>
+                    <a:p>
+                      <a:pPr algn="l"/>
+                      <a:r>
+                        <a:rPr sz="900" b="1">
+                          <a:solidFill>
+                            <a:srgbClr val="2B164F"/>
+                          </a:solidFill>
+                          <a:latin typeface="Calibri"/>
+                        </a:rPr>
+                        <a:t>GER-2026-005
+26/10/2026</a:t>
+                      </a:r>
+                    </a:p>
+                  </a:txBody>
+                  <a:tcPr marL="73152" marR="73152" marT="27432" marB="27432" anchor="ctr">
+                    <a:solidFill>
+                      <a:srgbClr val="F7F5FA"/>
+                    </a:solidFill>
+                  </a:tcPr>
+                </a:tc>
+                <a:tc>
+                  <a:txBody>
+                    <a:bodyPr wrap="square"/>
+                    <a:lstStyle/>
+                    <a:p>
+                      <a:pPr algn="l"/>
+                      <a:r>
+                        <a:rPr sz="900" b="0">
+                          <a:solidFill>
+                            <a:srgbClr val="20202B"/>
+                          </a:solidFill>
+                          <a:latin typeface="Calibri"/>
+                        </a:rPr>
+                        <a:t>—
+Centros gerontológicos</a:t>
+                      </a:r>
+                    </a:p>
+                  </a:txBody>
+                  <a:tcPr marL="73152" marR="73152" marT="27432" marB="27432" anchor="ctr">
+                    <a:solidFill>
+                      <a:srgbClr val="F7F5FA"/>
+                    </a:solidFill>
+                  </a:tcPr>
+                </a:tc>
+                <a:tc>
+                  <a:txBody>
+                    <a:bodyPr wrap="square"/>
+                    <a:lstStyle/>
+                    <a:p>
+                      <a:pPr algn="l"/>
+                      <a:r>
+                        <a:rPr sz="900" b="0">
+                          <a:solidFill>
+                            <a:srgbClr val="20202B"/>
+                          </a:solidFill>
+                          <a:latin typeface="Calibri"/>
+                        </a:rPr>
+                        <a:t>Manabí
+Pedernales</a:t>
+                      </a:r>
+                    </a:p>
+                  </a:txBody>
+                  <a:tcPr marL="73152" marR="73152" marT="27432" marB="27432" anchor="ctr">
+                    <a:solidFill>
+                      <a:srgbClr val="F7F5FA"/>
+                    </a:solidFill>
+                  </a:tcPr>
+                </a:tc>
+                <a:tc>
+                  <a:txBody>
+                    <a:bodyPr wrap="square"/>
+                    <a:lstStyle/>
+                    <a:p>
+                      <a:pPr algn="l"/>
+                      <a:r>
+                        <a:rPr sz="900" b="0">
+                          <a:solidFill>
+                            <a:srgbClr val="20202B"/>
+                          </a:solidFill>
+                          <a:latin typeface="Calibri"/>
+                        </a:rPr>
+                        <a:t>Filtraciones y humedad; medidas de contingencia. Servicio operativo.</a:t>
+                      </a:r>
+                    </a:p>
+                  </a:txBody>
+                  <a:tcPr marL="73152" marR="73152" marT="27432" marB="27432" anchor="ctr">
+                    <a:solidFill>
+                      <a:srgbClr val="F7F5FA"/>
+                    </a:solidFill>
+                  </a:tcPr>
+                </a:tc>
+                <a:tc>
+                  <a:txBody>
+                    <a:bodyPr wrap="square"/>
+                    <a:lstStyle/>
+                    <a:p>
+                      <a:pPr algn="l"/>
+                      <a:r>
+                        <a:rPr sz="900" b="0">
+                          <a:solidFill>
+                            <a:srgbClr val="20202B"/>
+                          </a:solidFill>
+                          <a:latin typeface="Calibri"/>
+                        </a:rPr>
+                        <a:t>En seguimiento</a:t>
+                      </a:r>
+                    </a:p>
+                  </a:txBody>
+                  <a:tcPr marL="73152" marR="73152" marT="27432" marB="27432" anchor="ctr">
+                    <a:solidFill>
+                      <a:srgbClr val="F7F5FA"/>
+                    </a:solidFill>
+                  </a:tcPr>
+                </a:tc>
+              </a:tr>
+              <a:tr h="594360">
+                <a:tc>
+                  <a:txBody>
+                    <a:bodyPr wrap="square"/>
+                    <a:lstStyle/>
+                    <a:p>
+                      <a:pPr algn="l"/>
+                      <a:r>
+                        <a:rPr sz="900" b="1">
+                          <a:solidFill>
+                            <a:srgbClr val="2B164F"/>
+                          </a:solidFill>
+                          <a:latin typeface="Calibri"/>
+                        </a:rPr>
+                        <a:t>GER-2026-004
+26/10/2026</a:t>
+                      </a:r>
+                    </a:p>
+                  </a:txBody>
+                  <a:tcPr marL="73152" marR="73152" marT="27432" marB="27432" anchor="ctr">
+                    <a:solidFill>
+                      <a:srgbClr val="FFFFFF"/>
+                    </a:solidFill>
+                  </a:tcPr>
+                </a:tc>
+                <a:tc>
+                  <a:txBody>
+                    <a:bodyPr wrap="square"/>
+                    <a:lstStyle/>
+                    <a:p>
+                      <a:pPr algn="l"/>
+                      <a:r>
+                        <a:rPr sz="900" b="0">
+                          <a:solidFill>
+                            <a:srgbClr val="20202B"/>
+                          </a:solidFill>
+                          <a:latin typeface="Calibri"/>
+                        </a:rPr>
+                        <a:t>—
+Centros gerontológicos</a:t>
+                      </a:r>
+                    </a:p>
+                  </a:txBody>
+                  <a:tcPr marL="73152" marR="73152" marT="27432" marB="27432" anchor="ctr">
+                    <a:solidFill>
+                      <a:srgbClr val="FFFFFF"/>
+                    </a:solidFill>
+                  </a:tcPr>
+                </a:tc>
+                <a:tc>
+                  <a:txBody>
+                    <a:bodyPr wrap="square"/>
+                    <a:lstStyle/>
+                    <a:p>
+                      <a:pPr algn="l"/>
+                      <a:r>
+                        <a:rPr sz="900" b="0">
+                          <a:solidFill>
+                            <a:srgbClr val="20202B"/>
+                          </a:solidFill>
+                          <a:latin typeface="Calibri"/>
+                        </a:rPr>
+                        <a:t>Manabí
+Portoviejo</a:t>
+                      </a:r>
+                    </a:p>
+                  </a:txBody>
+                  <a:tcPr marL="73152" marR="73152" marT="27432" marB="27432" anchor="ctr">
+                    <a:solidFill>
+                      <a:srgbClr val="FFFFFF"/>
+                    </a:solidFill>
+                  </a:tcPr>
+                </a:tc>
+                <a:tc>
+                  <a:txBody>
+                    <a:bodyPr wrap="square"/>
+                    <a:lstStyle/>
+                    <a:p>
+                      <a:pPr algn="l"/>
+                      <a:r>
+                        <a:rPr sz="900" b="0">
+                          <a:solidFill>
+                            <a:srgbClr val="20202B"/>
+                          </a:solidFill>
+                          <a:latin typeface="Calibri"/>
+                        </a:rPr>
+                        <a:t>Filtraciones y humedad; adecuaciones provisionales. Servicio operativo.</a:t>
+                      </a:r>
+                    </a:p>
+                  </a:txBody>
+                  <a:tcPr marL="73152" marR="73152" marT="27432" marB="27432" anchor="ctr">
+                    <a:solidFill>
+                      <a:srgbClr val="FFFFFF"/>
+                    </a:solidFill>
+                  </a:tcPr>
+                </a:tc>
+                <a:tc>
+                  <a:txBody>
+                    <a:bodyPr wrap="square"/>
+                    <a:lstStyle/>
+                    <a:p>
+                      <a:pPr algn="l"/>
+                      <a:r>
+                        <a:rPr sz="900" b="0">
+                          <a:solidFill>
+                            <a:srgbClr val="20202B"/>
+                          </a:solidFill>
+                          <a:latin typeface="Calibri"/>
+                        </a:rPr>
+                        <a:t>En seguimiento</a:t>
+                      </a:r>
+                    </a:p>
+                  </a:txBody>
+                  <a:tcPr marL="73152" marR="73152" marT="27432" marB="27432" anchor="ctr">
+                    <a:solidFill>
+                      <a:srgbClr val="FFFFFF"/>
+                    </a:solidFill>
+                  </a:tcPr>
+                </a:tc>
+              </a:tr>
+              <a:tr h="594360">
+                <a:tc>
+                  <a:txBody>
+                    <a:bodyPr wrap="square"/>
+                    <a:lstStyle/>
+                    <a:p>
+                      <a:pPr algn="l"/>
+                      <a:r>
+                        <a:rPr sz="900" b="1">
+                          <a:solidFill>
+                            <a:srgbClr val="2B164F"/>
+                          </a:solidFill>
+                          <a:latin typeface="Calibri"/>
+                        </a:rPr>
+                        <a:t>GER-2026-003
+26/10/2026</a:t>
+                      </a:r>
+                    </a:p>
+                  </a:txBody>
+                  <a:tcPr marL="73152" marR="73152" marT="27432" marB="27432" anchor="ctr">
+                    <a:solidFill>
+                      <a:srgbClr val="F7F5FA"/>
+                    </a:solidFill>
+                  </a:tcPr>
+                </a:tc>
+                <a:tc>
+                  <a:txBody>
+                    <a:bodyPr wrap="square"/>
+                    <a:lstStyle/>
+                    <a:p>
+                      <a:pPr algn="l"/>
+                      <a:r>
+                        <a:rPr sz="900" b="0">
+                          <a:solidFill>
+                            <a:srgbClr val="20202B"/>
+                          </a:solidFill>
+                          <a:latin typeface="Calibri"/>
+                        </a:rPr>
+                        <a:t>—
+Centros gerontológicos</a:t>
+                      </a:r>
+                    </a:p>
+                  </a:txBody>
+                  <a:tcPr marL="73152" marR="73152" marT="27432" marB="27432" anchor="ctr">
+                    <a:solidFill>
+                      <a:srgbClr val="F7F5FA"/>
+                    </a:solidFill>
+                  </a:tcPr>
+                </a:tc>
+                <a:tc>
+                  <a:txBody>
+                    <a:bodyPr wrap="square"/>
+                    <a:lstStyle/>
+                    <a:p>
+                      <a:pPr algn="l"/>
+                      <a:r>
+                        <a:rPr sz="900" b="0">
+                          <a:solidFill>
+                            <a:srgbClr val="20202B"/>
+                          </a:solidFill>
+                          <a:latin typeface="Calibri"/>
+                        </a:rPr>
+                        <a:t>Guayas
+Milagro</a:t>
+                      </a:r>
+                    </a:p>
+                  </a:txBody>
+                  <a:tcPr marL="73152" marR="73152" marT="27432" marB="27432" anchor="ctr">
+                    <a:solidFill>
+                      <a:srgbClr val="F7F5FA"/>
+                    </a:solidFill>
+                  </a:tcPr>
+                </a:tc>
+                <a:tc>
+                  <a:txBody>
+                    <a:bodyPr wrap="square"/>
+                    <a:lstStyle/>
+                    <a:p>
+                      <a:pPr algn="l"/>
+                      <a:r>
+                        <a:rPr sz="900" b="0">
+                          <a:solidFill>
+                            <a:srgbClr val="20202B"/>
+                          </a:solidFill>
+                          <a:latin typeface="Calibri"/>
+                        </a:rPr>
+                        <a:t>Filtraciones y humedad; medidas preventivas y correctivas. Servicio operativo.</a:t>
+                      </a:r>
+                    </a:p>
+                  </a:txBody>
+                  <a:tcPr marL="73152" marR="73152" marT="27432" marB="27432" anchor="ctr">
+                    <a:solidFill>
+                      <a:srgbClr val="F7F5FA"/>
+                    </a:solidFill>
+                  </a:tcPr>
+                </a:tc>
+                <a:tc>
+                  <a:txBody>
+                    <a:bodyPr wrap="square"/>
+                    <a:lstStyle/>
+                    <a:p>
+                      <a:pPr algn="l"/>
+                      <a:r>
+                        <a:rPr sz="900" b="0">
+                          <a:solidFill>
+                            <a:srgbClr val="20202B"/>
+                          </a:solidFill>
+                          <a:latin typeface="Calibri"/>
+                        </a:rPr>
+                        <a:t>En seguimiento</a:t>
+                      </a:r>
+                    </a:p>
+                  </a:txBody>
+                  <a:tcPr marL="73152" marR="73152" marT="27432" marB="27432" anchor="ctr">
+                    <a:solidFill>
+                      <a:srgbClr val="F7F5FA"/>
+                    </a:solidFill>
+                  </a:tcPr>
+                </a:tc>
+              </a:tr>
+              <a:tr h="594360">
+                <a:tc>
+                  <a:txBody>
+                    <a:bodyPr wrap="square"/>
+                    <a:lstStyle/>
+                    <a:p>
+                      <a:pPr algn="l"/>
+                      <a:r>
+                        <a:rPr sz="900" b="1">
+                          <a:solidFill>
+                            <a:srgbClr val="2B164F"/>
+                          </a:solidFill>
+                          <a:latin typeface="Calibri"/>
+                        </a:rPr>
+                        <a:t>GER-2026-002
+26/10/2026</a:t>
+                      </a:r>
+                    </a:p>
+                  </a:txBody>
+                  <a:tcPr marL="73152" marR="73152" marT="27432" marB="27432" anchor="ctr">
+                    <a:solidFill>
+                      <a:srgbClr val="FFFFFF"/>
+                    </a:solidFill>
+                  </a:tcPr>
+                </a:tc>
+                <a:tc>
+                  <a:txBody>
+                    <a:bodyPr wrap="square"/>
+                    <a:lstStyle/>
+                    <a:p>
+                      <a:pPr algn="l"/>
+                      <a:r>
+                        <a:rPr sz="900" b="0">
+                          <a:solidFill>
+                            <a:srgbClr val="20202B"/>
+                          </a:solidFill>
+                          <a:latin typeface="Calibri"/>
+                        </a:rPr>
+                        <a:t>—
+Centros gerontológicos</a:t>
+                      </a:r>
+                    </a:p>
+                  </a:txBody>
+                  <a:tcPr marL="73152" marR="73152" marT="27432" marB="27432" anchor="ctr">
+                    <a:solidFill>
+                      <a:srgbClr val="FFFFFF"/>
+                    </a:solidFill>
+                  </a:tcPr>
+                </a:tc>
+                <a:tc>
+                  <a:txBody>
+                    <a:bodyPr wrap="square"/>
+                    <a:lstStyle/>
+                    <a:p>
+                      <a:pPr algn="l"/>
+                      <a:r>
+                        <a:rPr sz="900" b="0">
+                          <a:solidFill>
+                            <a:srgbClr val="20202B"/>
+                          </a:solidFill>
+                          <a:latin typeface="Calibri"/>
+                        </a:rPr>
+                        <a:t>Esmeraldas
+San Lorenzo</a:t>
+                      </a:r>
+                    </a:p>
+                  </a:txBody>
+                  <a:tcPr marL="73152" marR="73152" marT="27432" marB="27432" anchor="ctr">
+                    <a:solidFill>
+                      <a:srgbClr val="FFFFFF"/>
+                    </a:solidFill>
+                  </a:tcPr>
+                </a:tc>
+                <a:tc>
+                  <a:txBody>
+                    <a:bodyPr wrap="square"/>
+                    <a:lstStyle/>
+                    <a:p>
+                      <a:pPr algn="l"/>
+                      <a:r>
+                        <a:rPr sz="900" b="0">
+                          <a:solidFill>
+                            <a:srgbClr val="20202B"/>
+                          </a:solidFill>
+                          <a:latin typeface="Calibri"/>
+                        </a:rPr>
+                        <a:t>Filtraciones y humedad; intervención emergente. Servicio operativo.</a:t>
+                      </a:r>
+                    </a:p>
+                  </a:txBody>
+                  <a:tcPr marL="73152" marR="73152" marT="27432" marB="27432" anchor="ctr">
+                    <a:solidFill>
+                      <a:srgbClr val="FFFFFF"/>
+                    </a:solidFill>
+                  </a:tcPr>
+                </a:tc>
+                <a:tc>
+                  <a:txBody>
+                    <a:bodyPr wrap="square"/>
+                    <a:lstStyle/>
+                    <a:p>
+                      <a:pPr algn="l"/>
+                      <a:r>
+                        <a:rPr sz="900" b="0">
+                          <a:solidFill>
+                            <a:srgbClr val="20202B"/>
+                          </a:solidFill>
+                          <a:latin typeface="Calibri"/>
+                        </a:rPr>
+                        <a:t>En seguimiento</a:t>
+                      </a:r>
+                    </a:p>
+                  </a:txBody>
+                  <a:tcPr marL="73152" marR="73152" marT="27432" marB="27432" anchor="ctr">
+                    <a:solidFill>
+                      <a:srgbClr val="FFFFFF"/>
+                    </a:solidFill>
+                  </a:tcPr>
+                </a:tc>
+              </a:tr>
+              <a:tr h="594360">
+                <a:tc>
+                  <a:txBody>
+                    <a:bodyPr wrap="square"/>
+                    <a:lstStyle/>
+                    <a:p>
+                      <a:pPr algn="l"/>
+                      <a:r>
+                        <a:rPr sz="900" b="1">
+                          <a:solidFill>
+                            <a:srgbClr val="2B164F"/>
+                          </a:solidFill>
+                          <a:latin typeface="Calibri"/>
+                        </a:rPr>
+                        <a:t>GER-2026-001
+26/10/2026</a:t>
+                      </a:r>
+                    </a:p>
+                  </a:txBody>
+                  <a:tcPr marL="73152" marR="73152" marT="27432" marB="27432" anchor="ctr">
+                    <a:solidFill>
+                      <a:srgbClr val="F7F5FA"/>
+                    </a:solidFill>
+                  </a:tcPr>
+                </a:tc>
+                <a:tc>
+                  <a:txBody>
+                    <a:bodyPr wrap="square"/>
+                    <a:lstStyle/>
+                    <a:p>
+                      <a:pPr algn="l"/>
+                      <a:r>
+                        <a:rPr sz="900" b="0">
+                          <a:solidFill>
+                            <a:srgbClr val="20202B"/>
+                          </a:solidFill>
+                          <a:latin typeface="Calibri"/>
+                        </a:rPr>
+                        <a:t>—
+Centros gerontológicos</a:t>
+                      </a:r>
+                    </a:p>
+                  </a:txBody>
+                  <a:tcPr marL="73152" marR="73152" marT="27432" marB="27432" anchor="ctr">
+                    <a:solidFill>
+                      <a:srgbClr val="F7F5FA"/>
+                    </a:solidFill>
+                  </a:tcPr>
+                </a:tc>
+                <a:tc>
+                  <a:txBody>
+                    <a:bodyPr wrap="square"/>
+                    <a:lstStyle/>
+                    <a:p>
+                      <a:pPr algn="l"/>
+                      <a:r>
+                        <a:rPr sz="900" b="0">
+                          <a:solidFill>
+                            <a:srgbClr val="20202B"/>
+                          </a:solidFill>
+                          <a:latin typeface="Calibri"/>
+                        </a:rPr>
+                        <a:t>El Oro
+Huaquillas</a:t>
+                      </a:r>
+                    </a:p>
+                  </a:txBody>
+                  <a:tcPr marL="73152" marR="73152" marT="27432" marB="27432" anchor="ctr">
+                    <a:solidFill>
+                      <a:srgbClr val="F7F5FA"/>
+                    </a:solidFill>
+                  </a:tcPr>
+                </a:tc>
+                <a:tc>
+                  <a:txBody>
+                    <a:bodyPr wrap="square"/>
+                    <a:lstStyle/>
+                    <a:p>
+                      <a:pPr algn="l"/>
+                      <a:r>
+                        <a:rPr sz="900" b="0">
+                          <a:solidFill>
+                            <a:srgbClr val="20202B"/>
+                          </a:solidFill>
+                          <a:latin typeface="Calibri"/>
+                        </a:rPr>
+                        <a:t>Filtraciones en techo y daños en patio; mitigación temporal. Servicio operativo.</a:t>
+                      </a:r>
+                    </a:p>
+                  </a:txBody>
+                  <a:tcPr marL="73152" marR="73152" marT="27432" marB="27432" anchor="ctr">
+                    <a:solidFill>
+                      <a:srgbClr val="F7F5FA"/>
+                    </a:solidFill>
+                  </a:tcPr>
+                </a:tc>
+                <a:tc>
+                  <a:txBody>
+                    <a:bodyPr wrap="square"/>
+                    <a:lstStyle/>
+                    <a:p>
+                      <a:pPr algn="l"/>
+                      <a:r>
+                        <a:rPr sz="900" b="0">
+                          <a:solidFill>
+                            <a:srgbClr val="20202B"/>
+                          </a:solidFill>
+                          <a:latin typeface="Calibri"/>
+                        </a:rPr>
+                        <a:t>En seguimiento</a:t>
+                      </a:r>
+                    </a:p>
+                  </a:txBody>
+                  <a:tcPr marL="73152" marR="73152" marT="27432" marB="27432" anchor="ctr">
+                    <a:solidFill>
+                      <a:srgbClr val="F7F5FA"/>
+                    </a:solidFill>
+                  </a:tcPr>
+                </a:tc>
+              </a:tr>
+              <a:tr h="594360">
+                <a:tc>
+                  <a:txBody>
+                    <a:bodyPr wrap="square"/>
+                    <a:lstStyle/>
+                    <a:p>
+                      <a:pPr algn="l"/>
+                      <a:r>
+                        <a:rPr sz="900" b="1">
+                          <a:solidFill>
+                            <a:srgbClr val="2B164F"/>
+                          </a:solidFill>
+                          <a:latin typeface="Calibri"/>
+                        </a:rPr>
                         <a:t>DIS-2026-003
 26/10/2026</a:t>
                       </a:r>
@@ -11281,726 +12001,6 @@
                           <a:latin typeface="Calibri"/>
                         </a:rPr>
                         <a:t>En seguimiento</a:t>
-                      </a:r>
-                    </a:p>
-                  </a:txBody>
-                  <a:tcPr marL="73152" marR="73152" marT="27432" marB="27432" anchor="ctr">
-                    <a:solidFill>
-                      <a:srgbClr val="FFFFFF"/>
-                    </a:solidFill>
-                  </a:tcPr>
-                </a:tc>
-              </a:tr>
-              <a:tr h="594360">
-                <a:tc>
-                  <a:txBody>
-                    <a:bodyPr wrap="square"/>
-                    <a:lstStyle/>
-                    <a:p>
-                      <a:pPr algn="l"/>
-                      <a:r>
-                        <a:rPr sz="900" b="1">
-                          <a:solidFill>
-                            <a:srgbClr val="2B164F"/>
-                          </a:solidFill>
-                          <a:latin typeface="Calibri"/>
-                        </a:rPr>
-                        <a:t>DIS-2026-002
-26/10/2026</a:t>
-                      </a:r>
-                    </a:p>
-                  </a:txBody>
-                  <a:tcPr marL="73152" marR="73152" marT="27432" marB="27432" anchor="ctr">
-                    <a:solidFill>
-                      <a:srgbClr val="F7F5FA"/>
-                    </a:solidFill>
-                  </a:tcPr>
-                </a:tc>
-                <a:tc>
-                  <a:txBody>
-                    <a:bodyPr wrap="square"/>
-                    <a:lstStyle/>
-                    <a:p>
-                      <a:pPr algn="l"/>
-                      <a:r>
-                        <a:rPr sz="900" b="0">
-                          <a:solidFill>
-                            <a:srgbClr val="20202B"/>
-                          </a:solidFill>
-                          <a:latin typeface="Calibri"/>
-                        </a:rPr>
-                        <a:t>—
-Discapacidades · AHC</a:t>
-                      </a:r>
-                    </a:p>
-                  </a:txBody>
-                  <a:tcPr marL="73152" marR="73152" marT="27432" marB="27432" anchor="ctr">
-                    <a:solidFill>
-                      <a:srgbClr val="F7F5FA"/>
-                    </a:solidFill>
-                  </a:tcPr>
-                </a:tc>
-                <a:tc>
-                  <a:txBody>
-                    <a:bodyPr wrap="square"/>
-                    <a:lstStyle/>
-                    <a:p>
-                      <a:pPr algn="l"/>
-                      <a:r>
-                        <a:rPr sz="900" b="0">
-                          <a:solidFill>
-                            <a:srgbClr val="20202B"/>
-                          </a:solidFill>
-                          <a:latin typeface="Calibri"/>
-                        </a:rPr>
-                        <a:t>El Oro
-Pasaje</a:t>
-                      </a:r>
-                    </a:p>
-                  </a:txBody>
-                  <a:tcPr marL="73152" marR="73152" marT="27432" marB="27432" anchor="ctr">
-                    <a:solidFill>
-                      <a:srgbClr val="F7F5FA"/>
-                    </a:solidFill>
-                  </a:tcPr>
-                </a:tc>
-                <a:tc>
-                  <a:txBody>
-                    <a:bodyPr wrap="square"/>
-                    <a:lstStyle/>
-                    <a:p>
-                      <a:pPr algn="l"/>
-                      <a:r>
-                        <a:rPr sz="900" b="0">
-                          <a:solidFill>
-                            <a:srgbClr val="20202B"/>
-                          </a:solidFill>
-                          <a:latin typeface="Calibri"/>
-                        </a:rPr>
-                        <a:t>Inundaciones en viviendas de usuarios; monitoreo de facilitadores. Servicio operativo.</a:t>
-                      </a:r>
-                    </a:p>
-                  </a:txBody>
-                  <a:tcPr marL="73152" marR="73152" marT="27432" marB="27432" anchor="ctr">
-                    <a:solidFill>
-                      <a:srgbClr val="F7F5FA"/>
-                    </a:solidFill>
-                  </a:tcPr>
-                </a:tc>
-                <a:tc>
-                  <a:txBody>
-                    <a:bodyPr wrap="square"/>
-                    <a:lstStyle/>
-                    <a:p>
-                      <a:pPr algn="l"/>
-                      <a:r>
-                        <a:rPr sz="900" b="0">
-                          <a:solidFill>
-                            <a:srgbClr val="20202B"/>
-                          </a:solidFill>
-                          <a:latin typeface="Calibri"/>
-                        </a:rPr>
-                        <a:t>En seguimiento</a:t>
-                      </a:r>
-                    </a:p>
-                  </a:txBody>
-                  <a:tcPr marL="73152" marR="73152" marT="27432" marB="27432" anchor="ctr">
-                    <a:solidFill>
-                      <a:srgbClr val="F7F5FA"/>
-                    </a:solidFill>
-                  </a:tcPr>
-                </a:tc>
-              </a:tr>
-              <a:tr h="594360">
-                <a:tc>
-                  <a:txBody>
-                    <a:bodyPr wrap="square"/>
-                    <a:lstStyle/>
-                    <a:p>
-                      <a:pPr algn="l"/>
-                      <a:r>
-                        <a:rPr sz="900" b="1">
-                          <a:solidFill>
-                            <a:srgbClr val="2B164F"/>
-                          </a:solidFill>
-                          <a:latin typeface="Calibri"/>
-                        </a:rPr>
-                        <a:t>DIS-2026-001
-26/10/2026</a:t>
-                      </a:r>
-                    </a:p>
-                  </a:txBody>
-                  <a:tcPr marL="73152" marR="73152" marT="27432" marB="27432" anchor="ctr">
-                    <a:solidFill>
-                      <a:srgbClr val="FFFFFF"/>
-                    </a:solidFill>
-                  </a:tcPr>
-                </a:tc>
-                <a:tc>
-                  <a:txBody>
-                    <a:bodyPr wrap="square"/>
-                    <a:lstStyle/>
-                    <a:p>
-                      <a:pPr algn="l"/>
-                      <a:r>
-                        <a:rPr sz="900" b="0">
-                          <a:solidFill>
-                            <a:srgbClr val="20202B"/>
-                          </a:solidFill>
-                          <a:latin typeface="Calibri"/>
-                        </a:rPr>
-                        <a:t>—
-Discapacidades · AHC</a:t>
-                      </a:r>
-                    </a:p>
-                  </a:txBody>
-                  <a:tcPr marL="73152" marR="73152" marT="27432" marB="27432" anchor="ctr">
-                    <a:solidFill>
-                      <a:srgbClr val="FFFFFF"/>
-                    </a:solidFill>
-                  </a:tcPr>
-                </a:tc>
-                <a:tc>
-                  <a:txBody>
-                    <a:bodyPr wrap="square"/>
-                    <a:lstStyle/>
-                    <a:p>
-                      <a:pPr algn="l"/>
-                      <a:r>
-                        <a:rPr sz="900" b="0">
-                          <a:solidFill>
-                            <a:srgbClr val="20202B"/>
-                          </a:solidFill>
-                          <a:latin typeface="Calibri"/>
-                        </a:rPr>
-                        <a:t>El Oro
-Machala</a:t>
-                      </a:r>
-                    </a:p>
-                  </a:txBody>
-                  <a:tcPr marL="73152" marR="73152" marT="27432" marB="27432" anchor="ctr">
-                    <a:solidFill>
-                      <a:srgbClr val="FFFFFF"/>
-                    </a:solidFill>
-                  </a:tcPr>
-                </a:tc>
-                <a:tc>
-                  <a:txBody>
-                    <a:bodyPr wrap="square"/>
-                    <a:lstStyle/>
-                    <a:p>
-                      <a:pPr algn="l"/>
-                      <a:r>
-                        <a:rPr sz="900" b="0">
-                          <a:solidFill>
-                            <a:srgbClr val="20202B"/>
-                          </a:solidFill>
-                          <a:latin typeface="Calibri"/>
-                        </a:rPr>
-                        <a:t>Inundaciones en viviendas de usuarios; monitoreo de facilitadores. Servicio operativo.</a:t>
-                      </a:r>
-                    </a:p>
-                  </a:txBody>
-                  <a:tcPr marL="73152" marR="73152" marT="27432" marB="27432" anchor="ctr">
-                    <a:solidFill>
-                      <a:srgbClr val="FFFFFF"/>
-                    </a:solidFill>
-                  </a:tcPr>
-                </a:tc>
-                <a:tc>
-                  <a:txBody>
-                    <a:bodyPr wrap="square"/>
-                    <a:lstStyle/>
-                    <a:p>
-                      <a:pPr algn="l"/>
-                      <a:r>
-                        <a:rPr sz="900" b="0">
-                          <a:solidFill>
-                            <a:srgbClr val="20202B"/>
-                          </a:solidFill>
-                          <a:latin typeface="Calibri"/>
-                        </a:rPr>
-                        <a:t>En seguimiento</a:t>
-                      </a:r>
-                    </a:p>
-                  </a:txBody>
-                  <a:tcPr marL="73152" marR="73152" marT="27432" marB="27432" anchor="ctr">
-                    <a:solidFill>
-                      <a:srgbClr val="FFFFFF"/>
-                    </a:solidFill>
-                  </a:tcPr>
-                </a:tc>
-              </a:tr>
-              <a:tr h="594360">
-                <a:tc>
-                  <a:txBody>
-                    <a:bodyPr wrap="square"/>
-                    <a:lstStyle/>
-                    <a:p>
-                      <a:pPr algn="l"/>
-                      <a:r>
-                        <a:rPr sz="900" b="1">
-                          <a:solidFill>
-                            <a:srgbClr val="2B164F"/>
-                          </a:solidFill>
-                          <a:latin typeface="Calibri"/>
-                        </a:rPr>
-                        <a:t>DIS-2026-005
-25/10/2026</a:t>
-                      </a:r>
-                    </a:p>
-                  </a:txBody>
-                  <a:tcPr marL="73152" marR="73152" marT="27432" marB="27432" anchor="ctr">
-                    <a:solidFill>
-                      <a:srgbClr val="F7F5FA"/>
-                    </a:solidFill>
-                  </a:tcPr>
-                </a:tc>
-                <a:tc>
-                  <a:txBody>
-                    <a:bodyPr wrap="square"/>
-                    <a:lstStyle/>
-                    <a:p>
-                      <a:pPr algn="l"/>
-                      <a:r>
-                        <a:rPr sz="900" b="0">
-                          <a:solidFill>
-                            <a:srgbClr val="20202B"/>
-                          </a:solidFill>
-                          <a:latin typeface="Calibri"/>
-                        </a:rPr>
-                        <a:t>Familia por un Buen Vivir para Personas con Discapacidad 7
-Discapacidades · AHC</a:t>
-                      </a:r>
-                    </a:p>
-                  </a:txBody>
-                  <a:tcPr marL="73152" marR="73152" marT="27432" marB="27432" anchor="ctr">
-                    <a:solidFill>
-                      <a:srgbClr val="F7F5FA"/>
-                    </a:solidFill>
-                  </a:tcPr>
-                </a:tc>
-                <a:tc>
-                  <a:txBody>
-                    <a:bodyPr wrap="square"/>
-                    <a:lstStyle/>
-                    <a:p>
-                      <a:pPr algn="l"/>
-                      <a:r>
-                        <a:rPr sz="900" b="0">
-                          <a:solidFill>
-                            <a:srgbClr val="20202B"/>
-                          </a:solidFill>
-                          <a:latin typeface="Calibri"/>
-                        </a:rPr>
-                        <a:t>Los Ríos
-Babahoyo</a:t>
-                      </a:r>
-                    </a:p>
-                  </a:txBody>
-                  <a:tcPr marL="73152" marR="73152" marT="27432" marB="27432" anchor="ctr">
-                    <a:solidFill>
-                      <a:srgbClr val="F7F5FA"/>
-                    </a:solidFill>
-                  </a:tcPr>
-                </a:tc>
-                <a:tc>
-                  <a:txBody>
-                    <a:bodyPr wrap="square"/>
-                    <a:lstStyle/>
-                    <a:p>
-                      <a:pPr algn="l"/>
-                      <a:r>
-                        <a:rPr sz="900" b="0">
-                          <a:solidFill>
-                            <a:srgbClr val="20202B"/>
-                          </a:solidFill>
-                          <a:latin typeface="Calibri"/>
-                        </a:rPr>
-                        <a:t>Inundación de vivienda de un núcleo familiar; levantamiento de información. Servicio operativo.</a:t>
-                      </a:r>
-                    </a:p>
-                  </a:txBody>
-                  <a:tcPr marL="73152" marR="73152" marT="27432" marB="27432" anchor="ctr">
-                    <a:solidFill>
-                      <a:srgbClr val="F7F5FA"/>
-                    </a:solidFill>
-                  </a:tcPr>
-                </a:tc>
-                <a:tc>
-                  <a:txBody>
-                    <a:bodyPr wrap="square"/>
-                    <a:lstStyle/>
-                    <a:p>
-                      <a:pPr algn="l"/>
-                      <a:r>
-                        <a:rPr sz="900" b="0">
-                          <a:solidFill>
-                            <a:srgbClr val="20202B"/>
-                          </a:solidFill>
-                          <a:latin typeface="Calibri"/>
-                        </a:rPr>
-                        <a:t>En seguimiento</a:t>
-                      </a:r>
-                    </a:p>
-                  </a:txBody>
-                  <a:tcPr marL="73152" marR="73152" marT="27432" marB="27432" anchor="ctr">
-                    <a:solidFill>
-                      <a:srgbClr val="F7F5FA"/>
-                    </a:solidFill>
-                  </a:tcPr>
-                </a:tc>
-              </a:tr>
-              <a:tr h="594360">
-                <a:tc>
-                  <a:txBody>
-                    <a:bodyPr wrap="square"/>
-                    <a:lstStyle/>
-                    <a:p>
-                      <a:pPr algn="l"/>
-                      <a:r>
-                        <a:rPr sz="900" b="1">
-                          <a:solidFill>
-                            <a:srgbClr val="2B164F"/>
-                          </a:solidFill>
-                          <a:latin typeface="Calibri"/>
-                        </a:rPr>
-                        <a:t>DIS-2026-004
-25/10/2026</a:t>
-                      </a:r>
-                    </a:p>
-                  </a:txBody>
-                  <a:tcPr marL="73152" marR="73152" marT="27432" marB="27432" anchor="ctr">
-                    <a:solidFill>
-                      <a:srgbClr val="FFFFFF"/>
-                    </a:solidFill>
-                  </a:tcPr>
-                </a:tc>
-                <a:tc>
-                  <a:txBody>
-                    <a:bodyPr wrap="square"/>
-                    <a:lstStyle/>
-                    <a:p>
-                      <a:pPr algn="l"/>
-                      <a:r>
-                        <a:rPr sz="900" b="0">
-                          <a:solidFill>
-                            <a:srgbClr val="20202B"/>
-                          </a:solidFill>
-                          <a:latin typeface="Calibri"/>
-                        </a:rPr>
-                        <a:t>Familia por un Buen Vivir para Personas con Discapacidad 5
-Discapacidades · AHC</a:t>
-                      </a:r>
-                    </a:p>
-                  </a:txBody>
-                  <a:tcPr marL="73152" marR="73152" marT="27432" marB="27432" anchor="ctr">
-                    <a:solidFill>
-                      <a:srgbClr val="FFFFFF"/>
-                    </a:solidFill>
-                  </a:tcPr>
-                </a:tc>
-                <a:tc>
-                  <a:txBody>
-                    <a:bodyPr wrap="square"/>
-                    <a:lstStyle/>
-                    <a:p>
-                      <a:pPr algn="l"/>
-                      <a:r>
-                        <a:rPr sz="900" b="0">
-                          <a:solidFill>
-                            <a:srgbClr val="20202B"/>
-                          </a:solidFill>
-                          <a:latin typeface="Calibri"/>
-                        </a:rPr>
-                        <a:t>Los Ríos
-Babahoyo</a:t>
-                      </a:r>
-                    </a:p>
-                  </a:txBody>
-                  <a:tcPr marL="73152" marR="73152" marT="27432" marB="27432" anchor="ctr">
-                    <a:solidFill>
-                      <a:srgbClr val="FFFFFF"/>
-                    </a:solidFill>
-                  </a:tcPr>
-                </a:tc>
-                <a:tc>
-                  <a:txBody>
-                    <a:bodyPr wrap="square"/>
-                    <a:lstStyle/>
-                    <a:p>
-                      <a:pPr algn="l"/>
-                      <a:r>
-                        <a:rPr sz="900" b="0">
-                          <a:solidFill>
-                            <a:srgbClr val="20202B"/>
-                          </a:solidFill>
-                          <a:latin typeface="Calibri"/>
-                        </a:rPr>
-                        <a:t>Colapso de vivienda de un usuario; evaluación de necesidades. Servicio operativo.</a:t>
-                      </a:r>
-                    </a:p>
-                  </a:txBody>
-                  <a:tcPr marL="73152" marR="73152" marT="27432" marB="27432" anchor="ctr">
-                    <a:solidFill>
-                      <a:srgbClr val="FFFFFF"/>
-                    </a:solidFill>
-                  </a:tcPr>
-                </a:tc>
-                <a:tc>
-                  <a:txBody>
-                    <a:bodyPr wrap="square"/>
-                    <a:lstStyle/>
-                    <a:p>
-                      <a:pPr algn="l"/>
-                      <a:r>
-                        <a:rPr sz="900" b="0">
-                          <a:solidFill>
-                            <a:srgbClr val="20202B"/>
-                          </a:solidFill>
-                          <a:latin typeface="Calibri"/>
-                        </a:rPr>
-                        <a:t>En seguimiento</a:t>
-                      </a:r>
-                    </a:p>
-                  </a:txBody>
-                  <a:tcPr marL="73152" marR="73152" marT="27432" marB="27432" anchor="ctr">
-                    <a:solidFill>
-                      <a:srgbClr val="FFFFFF"/>
-                    </a:solidFill>
-                  </a:tcPr>
-                </a:tc>
-              </a:tr>
-              <a:tr h="594360">
-                <a:tc>
-                  <a:txBody>
-                    <a:bodyPr wrap="square"/>
-                    <a:lstStyle/>
-                    <a:p>
-                      <a:pPr algn="l"/>
-                      <a:r>
-                        <a:rPr sz="900" b="1">
-                          <a:solidFill>
-                            <a:srgbClr val="2B164F"/>
-                          </a:solidFill>
-                          <a:latin typeface="Calibri"/>
-                        </a:rPr>
-                        <a:t>ALT-2026-000325
-20/10/2026</a:t>
-                      </a:r>
-                    </a:p>
-                  </a:txBody>
-                  <a:tcPr marL="73152" marR="73152" marT="27432" marB="27432" anchor="ctr">
-                    <a:solidFill>
-                      <a:srgbClr val="F7F5FA"/>
-                    </a:solidFill>
-                  </a:tcPr>
-                </a:tc>
-                <a:tc>
-                  <a:txBody>
-                    <a:bodyPr wrap="square"/>
-                    <a:lstStyle/>
-                    <a:p>
-                      <a:pPr algn="l"/>
-                      <a:r>
-                        <a:rPr sz="900" b="0">
-                          <a:solidFill>
-                            <a:srgbClr val="20202B"/>
-                          </a:solidFill>
-                          <a:latin typeface="Calibri"/>
-                        </a:rPr>
-                        <a:t>Gotita del Amor
-UA 62210 · Desarrollo Infantil</a:t>
-                      </a:r>
-                    </a:p>
-                  </a:txBody>
-                  <a:tcPr marL="73152" marR="73152" marT="27432" marB="27432" anchor="ctr">
-                    <a:solidFill>
-                      <a:srgbClr val="F7F5FA"/>
-                    </a:solidFill>
-                  </a:tcPr>
-                </a:tc>
-                <a:tc>
-                  <a:txBody>
-                    <a:bodyPr wrap="square"/>
-                    <a:lstStyle/>
-                    <a:p>
-                      <a:pPr algn="l"/>
-                      <a:r>
-                        <a:rPr sz="900" b="0">
-                          <a:solidFill>
-                            <a:srgbClr val="20202B"/>
-                          </a:solidFill>
-                          <a:latin typeface="Calibri"/>
-                        </a:rPr>
-                        <a:t>Guayas
-Milagro</a:t>
-                      </a:r>
-                    </a:p>
-                  </a:txBody>
-                  <a:tcPr marL="73152" marR="73152" marT="27432" marB="27432" anchor="ctr">
-                    <a:solidFill>
-                      <a:srgbClr val="F7F5FA"/>
-                    </a:solidFill>
-                  </a:tcPr>
-                </a:tc>
-                <a:tc>
-                  <a:txBody>
-                    <a:bodyPr wrap="square"/>
-                    <a:lstStyle/>
-                    <a:p>
-                      <a:pPr algn="l"/>
-                      <a:r>
-                        <a:rPr sz="900" b="0">
-                          <a:solidFill>
-                            <a:srgbClr val="20202B"/>
-                          </a:solidFill>
-                          <a:latin typeface="Calibri"/>
-                        </a:rPr>
-                        <a:t>Ingreso de agua en la unidad; sin energía ni agua</a:t>
-                      </a:r>
-                    </a:p>
-                  </a:txBody>
-                  <a:tcPr marL="73152" marR="73152" marT="27432" marB="27432" anchor="ctr">
-                    <a:solidFill>
-                      <a:srgbClr val="F7F5FA"/>
-                    </a:solidFill>
-                  </a:tcPr>
-                </a:tc>
-                <a:tc>
-                  <a:txBody>
-                    <a:bodyPr wrap="square"/>
-                    <a:lstStyle/>
-                    <a:p>
-                      <a:pPr algn="l"/>
-                      <a:r>
-                        <a:rPr sz="900" b="0">
-                          <a:solidFill>
-                            <a:srgbClr val="20202B"/>
-                          </a:solidFill>
-                          <a:latin typeface="Calibri"/>
-                        </a:rPr>
-                        <a:t>Pendiente</a:t>
-                      </a:r>
-                    </a:p>
-                  </a:txBody>
-                  <a:tcPr marL="73152" marR="73152" marT="27432" marB="27432" anchor="ctr">
-                    <a:solidFill>
-                      <a:srgbClr val="F7F5FA"/>
-                    </a:solidFill>
-                  </a:tcPr>
-                </a:tc>
-              </a:tr>
-              <a:tr h="594360">
-                <a:tc>
-                  <a:txBody>
-                    <a:bodyPr wrap="square"/>
-                    <a:lstStyle/>
-                    <a:p>
-                      <a:pPr algn="l"/>
-                      <a:r>
-                        <a:rPr sz="900" b="1">
-                          <a:solidFill>
-                            <a:srgbClr val="2B164F"/>
-                          </a:solidFill>
-                          <a:latin typeface="Calibri"/>
-                        </a:rPr>
-                        <a:t>ALT-2026-000323
-20/10/2026</a:t>
-                      </a:r>
-                    </a:p>
-                  </a:txBody>
-                  <a:tcPr marL="73152" marR="73152" marT="27432" marB="27432" anchor="ctr">
-                    <a:solidFill>
-                      <a:srgbClr val="FFFFFF"/>
-                    </a:solidFill>
-                  </a:tcPr>
-                </a:tc>
-                <a:tc>
-                  <a:txBody>
-                    <a:bodyPr wrap="square"/>
-                    <a:lstStyle/>
-                    <a:p>
-                      <a:pPr algn="l"/>
-                      <a:r>
-                        <a:rPr sz="900" b="0">
-                          <a:solidFill>
-                            <a:srgbClr val="20202B"/>
-                          </a:solidFill>
-                          <a:latin typeface="Calibri"/>
-                        </a:rPr>
-                        <a:t>Mis Pequeños Angelitos
-UA 14294 · Desarrollo Infantil</a:t>
-                      </a:r>
-                    </a:p>
-                  </a:txBody>
-                  <a:tcPr marL="73152" marR="73152" marT="27432" marB="27432" anchor="ctr">
-                    <a:solidFill>
-                      <a:srgbClr val="FFFFFF"/>
-                    </a:solidFill>
-                  </a:tcPr>
-                </a:tc>
-                <a:tc>
-                  <a:txBody>
-                    <a:bodyPr wrap="square"/>
-                    <a:lstStyle/>
-                    <a:p>
-                      <a:pPr algn="l"/>
-                      <a:r>
-                        <a:rPr sz="900" b="0">
-                          <a:solidFill>
-                            <a:srgbClr val="20202B"/>
-                          </a:solidFill>
-                          <a:latin typeface="Calibri"/>
-                        </a:rPr>
-                        <a:t>Guayas
-Milagro</a:t>
-                      </a:r>
-                    </a:p>
-                  </a:txBody>
-                  <a:tcPr marL="73152" marR="73152" marT="27432" marB="27432" anchor="ctr">
-                    <a:solidFill>
-                      <a:srgbClr val="FFFFFF"/>
-                    </a:solidFill>
-                  </a:tcPr>
-                </a:tc>
-                <a:tc>
-                  <a:txBody>
-                    <a:bodyPr wrap="square"/>
-                    <a:lstStyle/>
-                    <a:p>
-                      <a:pPr algn="l"/>
-                      <a:r>
-                        <a:rPr sz="900" b="0">
-                          <a:solidFill>
-                            <a:srgbClr val="20202B"/>
-                          </a:solidFill>
-                          <a:latin typeface="Calibri"/>
-                        </a:rPr>
-                        <a:t>Ingreso de agua y goteras en la unidad</a:t>
-                      </a:r>
-                    </a:p>
-                  </a:txBody>
-                  <a:tcPr marL="73152" marR="73152" marT="27432" marB="27432" anchor="ctr">
-                    <a:solidFill>
-                      <a:srgbClr val="FFFFFF"/>
-                    </a:solidFill>
-                  </a:tcPr>
-                </a:tc>
-                <a:tc>
-                  <a:txBody>
-                    <a:bodyPr wrap="square"/>
-                    <a:lstStyle/>
-                    <a:p>
-                      <a:pPr algn="l"/>
-                      <a:r>
-                        <a:rPr sz="900" b="0">
-                          <a:solidFill>
-                            <a:srgbClr val="20202B"/>
-                          </a:solidFill>
-                          <a:latin typeface="Calibri"/>
-                        </a:rPr>
-                        <a:t>Pendiente</a:t>
                       </a:r>
                     </a:p>
                   </a:txBody>
@@ -12421,6 +12421,726 @@
                           </a:solidFill>
                           <a:latin typeface="Calibri"/>
                         </a:rPr>
+                        <a:t>DIS-2026-002
+26/10/2026</a:t>
+                      </a:r>
+                    </a:p>
+                  </a:txBody>
+                  <a:tcPr marL="73152" marR="73152" marT="27432" marB="27432" anchor="ctr">
+                    <a:solidFill>
+                      <a:srgbClr val="FFFFFF"/>
+                    </a:solidFill>
+                  </a:tcPr>
+                </a:tc>
+                <a:tc>
+                  <a:txBody>
+                    <a:bodyPr wrap="square"/>
+                    <a:lstStyle/>
+                    <a:p>
+                      <a:pPr algn="l"/>
+                      <a:r>
+                        <a:rPr sz="900" b="0">
+                          <a:solidFill>
+                            <a:srgbClr val="20202B"/>
+                          </a:solidFill>
+                          <a:latin typeface="Calibri"/>
+                        </a:rPr>
+                        <a:t>—
+Discapacidades · AHC</a:t>
+                      </a:r>
+                    </a:p>
+                  </a:txBody>
+                  <a:tcPr marL="73152" marR="73152" marT="27432" marB="27432" anchor="ctr">
+                    <a:solidFill>
+                      <a:srgbClr val="FFFFFF"/>
+                    </a:solidFill>
+                  </a:tcPr>
+                </a:tc>
+                <a:tc>
+                  <a:txBody>
+                    <a:bodyPr wrap="square"/>
+                    <a:lstStyle/>
+                    <a:p>
+                      <a:pPr algn="l"/>
+                      <a:r>
+                        <a:rPr sz="900" b="0">
+                          <a:solidFill>
+                            <a:srgbClr val="20202B"/>
+                          </a:solidFill>
+                          <a:latin typeface="Calibri"/>
+                        </a:rPr>
+                        <a:t>El Oro
+Pasaje</a:t>
+                      </a:r>
+                    </a:p>
+                  </a:txBody>
+                  <a:tcPr marL="73152" marR="73152" marT="27432" marB="27432" anchor="ctr">
+                    <a:solidFill>
+                      <a:srgbClr val="FFFFFF"/>
+                    </a:solidFill>
+                  </a:tcPr>
+                </a:tc>
+                <a:tc>
+                  <a:txBody>
+                    <a:bodyPr wrap="square"/>
+                    <a:lstStyle/>
+                    <a:p>
+                      <a:pPr algn="l"/>
+                      <a:r>
+                        <a:rPr sz="900" b="0">
+                          <a:solidFill>
+                            <a:srgbClr val="20202B"/>
+                          </a:solidFill>
+                          <a:latin typeface="Calibri"/>
+                        </a:rPr>
+                        <a:t>Inundaciones en viviendas de usuarios; monitoreo de facilitadores. Servicio operativo.</a:t>
+                      </a:r>
+                    </a:p>
+                  </a:txBody>
+                  <a:tcPr marL="73152" marR="73152" marT="27432" marB="27432" anchor="ctr">
+                    <a:solidFill>
+                      <a:srgbClr val="FFFFFF"/>
+                    </a:solidFill>
+                  </a:tcPr>
+                </a:tc>
+                <a:tc>
+                  <a:txBody>
+                    <a:bodyPr wrap="square"/>
+                    <a:lstStyle/>
+                    <a:p>
+                      <a:pPr algn="l"/>
+                      <a:r>
+                        <a:rPr sz="900" b="0">
+                          <a:solidFill>
+                            <a:srgbClr val="20202B"/>
+                          </a:solidFill>
+                          <a:latin typeface="Calibri"/>
+                        </a:rPr>
+                        <a:t>En seguimiento</a:t>
+                      </a:r>
+                    </a:p>
+                  </a:txBody>
+                  <a:tcPr marL="73152" marR="73152" marT="27432" marB="27432" anchor="ctr">
+                    <a:solidFill>
+                      <a:srgbClr val="FFFFFF"/>
+                    </a:solidFill>
+                  </a:tcPr>
+                </a:tc>
+              </a:tr>
+              <a:tr h="594360">
+                <a:tc>
+                  <a:txBody>
+                    <a:bodyPr wrap="square"/>
+                    <a:lstStyle/>
+                    <a:p>
+                      <a:pPr algn="l"/>
+                      <a:r>
+                        <a:rPr sz="900" b="1">
+                          <a:solidFill>
+                            <a:srgbClr val="2B164F"/>
+                          </a:solidFill>
+                          <a:latin typeface="Calibri"/>
+                        </a:rPr>
+                        <a:t>DIS-2026-001
+26/10/2026</a:t>
+                      </a:r>
+                    </a:p>
+                  </a:txBody>
+                  <a:tcPr marL="73152" marR="73152" marT="27432" marB="27432" anchor="ctr">
+                    <a:solidFill>
+                      <a:srgbClr val="F7F5FA"/>
+                    </a:solidFill>
+                  </a:tcPr>
+                </a:tc>
+                <a:tc>
+                  <a:txBody>
+                    <a:bodyPr wrap="square"/>
+                    <a:lstStyle/>
+                    <a:p>
+                      <a:pPr algn="l"/>
+                      <a:r>
+                        <a:rPr sz="900" b="0">
+                          <a:solidFill>
+                            <a:srgbClr val="20202B"/>
+                          </a:solidFill>
+                          <a:latin typeface="Calibri"/>
+                        </a:rPr>
+                        <a:t>—
+Discapacidades · AHC</a:t>
+                      </a:r>
+                    </a:p>
+                  </a:txBody>
+                  <a:tcPr marL="73152" marR="73152" marT="27432" marB="27432" anchor="ctr">
+                    <a:solidFill>
+                      <a:srgbClr val="F7F5FA"/>
+                    </a:solidFill>
+                  </a:tcPr>
+                </a:tc>
+                <a:tc>
+                  <a:txBody>
+                    <a:bodyPr wrap="square"/>
+                    <a:lstStyle/>
+                    <a:p>
+                      <a:pPr algn="l"/>
+                      <a:r>
+                        <a:rPr sz="900" b="0">
+                          <a:solidFill>
+                            <a:srgbClr val="20202B"/>
+                          </a:solidFill>
+                          <a:latin typeface="Calibri"/>
+                        </a:rPr>
+                        <a:t>El Oro
+Machala</a:t>
+                      </a:r>
+                    </a:p>
+                  </a:txBody>
+                  <a:tcPr marL="73152" marR="73152" marT="27432" marB="27432" anchor="ctr">
+                    <a:solidFill>
+                      <a:srgbClr val="F7F5FA"/>
+                    </a:solidFill>
+                  </a:tcPr>
+                </a:tc>
+                <a:tc>
+                  <a:txBody>
+                    <a:bodyPr wrap="square"/>
+                    <a:lstStyle/>
+                    <a:p>
+                      <a:pPr algn="l"/>
+                      <a:r>
+                        <a:rPr sz="900" b="0">
+                          <a:solidFill>
+                            <a:srgbClr val="20202B"/>
+                          </a:solidFill>
+                          <a:latin typeface="Calibri"/>
+                        </a:rPr>
+                        <a:t>Inundaciones en viviendas de usuarios; monitoreo de facilitadores. Servicio operativo.</a:t>
+                      </a:r>
+                    </a:p>
+                  </a:txBody>
+                  <a:tcPr marL="73152" marR="73152" marT="27432" marB="27432" anchor="ctr">
+                    <a:solidFill>
+                      <a:srgbClr val="F7F5FA"/>
+                    </a:solidFill>
+                  </a:tcPr>
+                </a:tc>
+                <a:tc>
+                  <a:txBody>
+                    <a:bodyPr wrap="square"/>
+                    <a:lstStyle/>
+                    <a:p>
+                      <a:pPr algn="l"/>
+                      <a:r>
+                        <a:rPr sz="900" b="0">
+                          <a:solidFill>
+                            <a:srgbClr val="20202B"/>
+                          </a:solidFill>
+                          <a:latin typeface="Calibri"/>
+                        </a:rPr>
+                        <a:t>En seguimiento</a:t>
+                      </a:r>
+                    </a:p>
+                  </a:txBody>
+                  <a:tcPr marL="73152" marR="73152" marT="27432" marB="27432" anchor="ctr">
+                    <a:solidFill>
+                      <a:srgbClr val="F7F5FA"/>
+                    </a:solidFill>
+                  </a:tcPr>
+                </a:tc>
+              </a:tr>
+              <a:tr h="594360">
+                <a:tc>
+                  <a:txBody>
+                    <a:bodyPr wrap="square"/>
+                    <a:lstStyle/>
+                    <a:p>
+                      <a:pPr algn="l"/>
+                      <a:r>
+                        <a:rPr sz="900" b="1">
+                          <a:solidFill>
+                            <a:srgbClr val="2B164F"/>
+                          </a:solidFill>
+                          <a:latin typeface="Calibri"/>
+                        </a:rPr>
+                        <a:t>DIS-2026-005
+25/10/2026</a:t>
+                      </a:r>
+                    </a:p>
+                  </a:txBody>
+                  <a:tcPr marL="73152" marR="73152" marT="27432" marB="27432" anchor="ctr">
+                    <a:solidFill>
+                      <a:srgbClr val="FFFFFF"/>
+                    </a:solidFill>
+                  </a:tcPr>
+                </a:tc>
+                <a:tc>
+                  <a:txBody>
+                    <a:bodyPr wrap="square"/>
+                    <a:lstStyle/>
+                    <a:p>
+                      <a:pPr algn="l"/>
+                      <a:r>
+                        <a:rPr sz="900" b="0">
+                          <a:solidFill>
+                            <a:srgbClr val="20202B"/>
+                          </a:solidFill>
+                          <a:latin typeface="Calibri"/>
+                        </a:rPr>
+                        <a:t>Familia por un Buen Vivir para Personas con Discapacidad 7
+Discapacidades · AHC</a:t>
+                      </a:r>
+                    </a:p>
+                  </a:txBody>
+                  <a:tcPr marL="73152" marR="73152" marT="27432" marB="27432" anchor="ctr">
+                    <a:solidFill>
+                      <a:srgbClr val="FFFFFF"/>
+                    </a:solidFill>
+                  </a:tcPr>
+                </a:tc>
+                <a:tc>
+                  <a:txBody>
+                    <a:bodyPr wrap="square"/>
+                    <a:lstStyle/>
+                    <a:p>
+                      <a:pPr algn="l"/>
+                      <a:r>
+                        <a:rPr sz="900" b="0">
+                          <a:solidFill>
+                            <a:srgbClr val="20202B"/>
+                          </a:solidFill>
+                          <a:latin typeface="Calibri"/>
+                        </a:rPr>
+                        <a:t>Los Ríos
+Babahoyo</a:t>
+                      </a:r>
+                    </a:p>
+                  </a:txBody>
+                  <a:tcPr marL="73152" marR="73152" marT="27432" marB="27432" anchor="ctr">
+                    <a:solidFill>
+                      <a:srgbClr val="FFFFFF"/>
+                    </a:solidFill>
+                  </a:tcPr>
+                </a:tc>
+                <a:tc>
+                  <a:txBody>
+                    <a:bodyPr wrap="square"/>
+                    <a:lstStyle/>
+                    <a:p>
+                      <a:pPr algn="l"/>
+                      <a:r>
+                        <a:rPr sz="900" b="0">
+                          <a:solidFill>
+                            <a:srgbClr val="20202B"/>
+                          </a:solidFill>
+                          <a:latin typeface="Calibri"/>
+                        </a:rPr>
+                        <a:t>Inundación de vivienda de un núcleo familiar; levantamiento de información. Servicio operativo.</a:t>
+                      </a:r>
+                    </a:p>
+                  </a:txBody>
+                  <a:tcPr marL="73152" marR="73152" marT="27432" marB="27432" anchor="ctr">
+                    <a:solidFill>
+                      <a:srgbClr val="FFFFFF"/>
+                    </a:solidFill>
+                  </a:tcPr>
+                </a:tc>
+                <a:tc>
+                  <a:txBody>
+                    <a:bodyPr wrap="square"/>
+                    <a:lstStyle/>
+                    <a:p>
+                      <a:pPr algn="l"/>
+                      <a:r>
+                        <a:rPr sz="900" b="0">
+                          <a:solidFill>
+                            <a:srgbClr val="20202B"/>
+                          </a:solidFill>
+                          <a:latin typeface="Calibri"/>
+                        </a:rPr>
+                        <a:t>En seguimiento</a:t>
+                      </a:r>
+                    </a:p>
+                  </a:txBody>
+                  <a:tcPr marL="73152" marR="73152" marT="27432" marB="27432" anchor="ctr">
+                    <a:solidFill>
+                      <a:srgbClr val="FFFFFF"/>
+                    </a:solidFill>
+                  </a:tcPr>
+                </a:tc>
+              </a:tr>
+              <a:tr h="594360">
+                <a:tc>
+                  <a:txBody>
+                    <a:bodyPr wrap="square"/>
+                    <a:lstStyle/>
+                    <a:p>
+                      <a:pPr algn="l"/>
+                      <a:r>
+                        <a:rPr sz="900" b="1">
+                          <a:solidFill>
+                            <a:srgbClr val="2B164F"/>
+                          </a:solidFill>
+                          <a:latin typeface="Calibri"/>
+                        </a:rPr>
+                        <a:t>DIS-2026-004
+25/10/2026</a:t>
+                      </a:r>
+                    </a:p>
+                  </a:txBody>
+                  <a:tcPr marL="73152" marR="73152" marT="27432" marB="27432" anchor="ctr">
+                    <a:solidFill>
+                      <a:srgbClr val="F7F5FA"/>
+                    </a:solidFill>
+                  </a:tcPr>
+                </a:tc>
+                <a:tc>
+                  <a:txBody>
+                    <a:bodyPr wrap="square"/>
+                    <a:lstStyle/>
+                    <a:p>
+                      <a:pPr algn="l"/>
+                      <a:r>
+                        <a:rPr sz="900" b="0">
+                          <a:solidFill>
+                            <a:srgbClr val="20202B"/>
+                          </a:solidFill>
+                          <a:latin typeface="Calibri"/>
+                        </a:rPr>
+                        <a:t>Familia por un Buen Vivir para Personas con Discapacidad 5
+Discapacidades · AHC</a:t>
+                      </a:r>
+                    </a:p>
+                  </a:txBody>
+                  <a:tcPr marL="73152" marR="73152" marT="27432" marB="27432" anchor="ctr">
+                    <a:solidFill>
+                      <a:srgbClr val="F7F5FA"/>
+                    </a:solidFill>
+                  </a:tcPr>
+                </a:tc>
+                <a:tc>
+                  <a:txBody>
+                    <a:bodyPr wrap="square"/>
+                    <a:lstStyle/>
+                    <a:p>
+                      <a:pPr algn="l"/>
+                      <a:r>
+                        <a:rPr sz="900" b="0">
+                          <a:solidFill>
+                            <a:srgbClr val="20202B"/>
+                          </a:solidFill>
+                          <a:latin typeface="Calibri"/>
+                        </a:rPr>
+                        <a:t>Los Ríos
+Babahoyo</a:t>
+                      </a:r>
+                    </a:p>
+                  </a:txBody>
+                  <a:tcPr marL="73152" marR="73152" marT="27432" marB="27432" anchor="ctr">
+                    <a:solidFill>
+                      <a:srgbClr val="F7F5FA"/>
+                    </a:solidFill>
+                  </a:tcPr>
+                </a:tc>
+                <a:tc>
+                  <a:txBody>
+                    <a:bodyPr wrap="square"/>
+                    <a:lstStyle/>
+                    <a:p>
+                      <a:pPr algn="l"/>
+                      <a:r>
+                        <a:rPr sz="900" b="0">
+                          <a:solidFill>
+                            <a:srgbClr val="20202B"/>
+                          </a:solidFill>
+                          <a:latin typeface="Calibri"/>
+                        </a:rPr>
+                        <a:t>Colapso de vivienda de un usuario; evaluación de necesidades. Servicio operativo.</a:t>
+                      </a:r>
+                    </a:p>
+                  </a:txBody>
+                  <a:tcPr marL="73152" marR="73152" marT="27432" marB="27432" anchor="ctr">
+                    <a:solidFill>
+                      <a:srgbClr val="F7F5FA"/>
+                    </a:solidFill>
+                  </a:tcPr>
+                </a:tc>
+                <a:tc>
+                  <a:txBody>
+                    <a:bodyPr wrap="square"/>
+                    <a:lstStyle/>
+                    <a:p>
+                      <a:pPr algn="l"/>
+                      <a:r>
+                        <a:rPr sz="900" b="0">
+                          <a:solidFill>
+                            <a:srgbClr val="20202B"/>
+                          </a:solidFill>
+                          <a:latin typeface="Calibri"/>
+                        </a:rPr>
+                        <a:t>En seguimiento</a:t>
+                      </a:r>
+                    </a:p>
+                  </a:txBody>
+                  <a:tcPr marL="73152" marR="73152" marT="27432" marB="27432" anchor="ctr">
+                    <a:solidFill>
+                      <a:srgbClr val="F7F5FA"/>
+                    </a:solidFill>
+                  </a:tcPr>
+                </a:tc>
+              </a:tr>
+              <a:tr h="594360">
+                <a:tc>
+                  <a:txBody>
+                    <a:bodyPr wrap="square"/>
+                    <a:lstStyle/>
+                    <a:p>
+                      <a:pPr algn="l"/>
+                      <a:r>
+                        <a:rPr sz="900" b="1">
+                          <a:solidFill>
+                            <a:srgbClr val="2B164F"/>
+                          </a:solidFill>
+                          <a:latin typeface="Calibri"/>
+                        </a:rPr>
+                        <a:t>ALT-2026-000325
+20/10/2026</a:t>
+                      </a:r>
+                    </a:p>
+                  </a:txBody>
+                  <a:tcPr marL="73152" marR="73152" marT="27432" marB="27432" anchor="ctr">
+                    <a:solidFill>
+                      <a:srgbClr val="FFFFFF"/>
+                    </a:solidFill>
+                  </a:tcPr>
+                </a:tc>
+                <a:tc>
+                  <a:txBody>
+                    <a:bodyPr wrap="square"/>
+                    <a:lstStyle/>
+                    <a:p>
+                      <a:pPr algn="l"/>
+                      <a:r>
+                        <a:rPr sz="900" b="0">
+                          <a:solidFill>
+                            <a:srgbClr val="20202B"/>
+                          </a:solidFill>
+                          <a:latin typeface="Calibri"/>
+                        </a:rPr>
+                        <a:t>Gotita del Amor
+UA 62210 · Desarrollo Infantil</a:t>
+                      </a:r>
+                    </a:p>
+                  </a:txBody>
+                  <a:tcPr marL="73152" marR="73152" marT="27432" marB="27432" anchor="ctr">
+                    <a:solidFill>
+                      <a:srgbClr val="FFFFFF"/>
+                    </a:solidFill>
+                  </a:tcPr>
+                </a:tc>
+                <a:tc>
+                  <a:txBody>
+                    <a:bodyPr wrap="square"/>
+                    <a:lstStyle/>
+                    <a:p>
+                      <a:pPr algn="l"/>
+                      <a:r>
+                        <a:rPr sz="900" b="0">
+                          <a:solidFill>
+                            <a:srgbClr val="20202B"/>
+                          </a:solidFill>
+                          <a:latin typeface="Calibri"/>
+                        </a:rPr>
+                        <a:t>Guayas
+Milagro</a:t>
+                      </a:r>
+                    </a:p>
+                  </a:txBody>
+                  <a:tcPr marL="73152" marR="73152" marT="27432" marB="27432" anchor="ctr">
+                    <a:solidFill>
+                      <a:srgbClr val="FFFFFF"/>
+                    </a:solidFill>
+                  </a:tcPr>
+                </a:tc>
+                <a:tc>
+                  <a:txBody>
+                    <a:bodyPr wrap="square"/>
+                    <a:lstStyle/>
+                    <a:p>
+                      <a:pPr algn="l"/>
+                      <a:r>
+                        <a:rPr sz="900" b="0">
+                          <a:solidFill>
+                            <a:srgbClr val="20202B"/>
+                          </a:solidFill>
+                          <a:latin typeface="Calibri"/>
+                        </a:rPr>
+                        <a:t>Ingreso de agua en la unidad; sin energía ni agua</a:t>
+                      </a:r>
+                    </a:p>
+                  </a:txBody>
+                  <a:tcPr marL="73152" marR="73152" marT="27432" marB="27432" anchor="ctr">
+                    <a:solidFill>
+                      <a:srgbClr val="FFFFFF"/>
+                    </a:solidFill>
+                  </a:tcPr>
+                </a:tc>
+                <a:tc>
+                  <a:txBody>
+                    <a:bodyPr wrap="square"/>
+                    <a:lstStyle/>
+                    <a:p>
+                      <a:pPr algn="l"/>
+                      <a:r>
+                        <a:rPr sz="900" b="0">
+                          <a:solidFill>
+                            <a:srgbClr val="20202B"/>
+                          </a:solidFill>
+                          <a:latin typeface="Calibri"/>
+                        </a:rPr>
+                        <a:t>Pendiente</a:t>
+                      </a:r>
+                    </a:p>
+                  </a:txBody>
+                  <a:tcPr marL="73152" marR="73152" marT="27432" marB="27432" anchor="ctr">
+                    <a:solidFill>
+                      <a:srgbClr val="FFFFFF"/>
+                    </a:solidFill>
+                  </a:tcPr>
+                </a:tc>
+              </a:tr>
+              <a:tr h="594360">
+                <a:tc>
+                  <a:txBody>
+                    <a:bodyPr wrap="square"/>
+                    <a:lstStyle/>
+                    <a:p>
+                      <a:pPr algn="l"/>
+                      <a:r>
+                        <a:rPr sz="900" b="1">
+                          <a:solidFill>
+                            <a:srgbClr val="2B164F"/>
+                          </a:solidFill>
+                          <a:latin typeface="Calibri"/>
+                        </a:rPr>
+                        <a:t>ALT-2026-000323
+20/10/2026</a:t>
+                      </a:r>
+                    </a:p>
+                  </a:txBody>
+                  <a:tcPr marL="73152" marR="73152" marT="27432" marB="27432" anchor="ctr">
+                    <a:solidFill>
+                      <a:srgbClr val="F7F5FA"/>
+                    </a:solidFill>
+                  </a:tcPr>
+                </a:tc>
+                <a:tc>
+                  <a:txBody>
+                    <a:bodyPr wrap="square"/>
+                    <a:lstStyle/>
+                    <a:p>
+                      <a:pPr algn="l"/>
+                      <a:r>
+                        <a:rPr sz="900" b="0">
+                          <a:solidFill>
+                            <a:srgbClr val="20202B"/>
+                          </a:solidFill>
+                          <a:latin typeface="Calibri"/>
+                        </a:rPr>
+                        <a:t>Mis Pequeños Angelitos
+UA 14294 · Desarrollo Infantil</a:t>
+                      </a:r>
+                    </a:p>
+                  </a:txBody>
+                  <a:tcPr marL="73152" marR="73152" marT="27432" marB="27432" anchor="ctr">
+                    <a:solidFill>
+                      <a:srgbClr val="F7F5FA"/>
+                    </a:solidFill>
+                  </a:tcPr>
+                </a:tc>
+                <a:tc>
+                  <a:txBody>
+                    <a:bodyPr wrap="square"/>
+                    <a:lstStyle/>
+                    <a:p>
+                      <a:pPr algn="l"/>
+                      <a:r>
+                        <a:rPr sz="900" b="0">
+                          <a:solidFill>
+                            <a:srgbClr val="20202B"/>
+                          </a:solidFill>
+                          <a:latin typeface="Calibri"/>
+                        </a:rPr>
+                        <a:t>Guayas
+Milagro</a:t>
+                      </a:r>
+                    </a:p>
+                  </a:txBody>
+                  <a:tcPr marL="73152" marR="73152" marT="27432" marB="27432" anchor="ctr">
+                    <a:solidFill>
+                      <a:srgbClr val="F7F5FA"/>
+                    </a:solidFill>
+                  </a:tcPr>
+                </a:tc>
+                <a:tc>
+                  <a:txBody>
+                    <a:bodyPr wrap="square"/>
+                    <a:lstStyle/>
+                    <a:p>
+                      <a:pPr algn="l"/>
+                      <a:r>
+                        <a:rPr sz="900" b="0">
+                          <a:solidFill>
+                            <a:srgbClr val="20202B"/>
+                          </a:solidFill>
+                          <a:latin typeface="Calibri"/>
+                        </a:rPr>
+                        <a:t>Ingreso de agua y goteras en la unidad</a:t>
+                      </a:r>
+                    </a:p>
+                  </a:txBody>
+                  <a:tcPr marL="73152" marR="73152" marT="27432" marB="27432" anchor="ctr">
+                    <a:solidFill>
+                      <a:srgbClr val="F7F5FA"/>
+                    </a:solidFill>
+                  </a:tcPr>
+                </a:tc>
+                <a:tc>
+                  <a:txBody>
+                    <a:bodyPr wrap="square"/>
+                    <a:lstStyle/>
+                    <a:p>
+                      <a:pPr algn="l"/>
+                      <a:r>
+                        <a:rPr sz="900" b="0">
+                          <a:solidFill>
+                            <a:srgbClr val="20202B"/>
+                          </a:solidFill>
+                          <a:latin typeface="Calibri"/>
+                        </a:rPr>
+                        <a:t>Pendiente</a:t>
+                      </a:r>
+                    </a:p>
+                  </a:txBody>
+                  <a:tcPr marL="73152" marR="73152" marT="27432" marB="27432" anchor="ctr">
+                    <a:solidFill>
+                      <a:srgbClr val="F7F5FA"/>
+                    </a:solidFill>
+                  </a:tcPr>
+                </a:tc>
+              </a:tr>
+              <a:tr h="594360">
+                <a:tc>
+                  <a:txBody>
+                    <a:bodyPr wrap="square"/>
+                    <a:lstStyle/>
+                    <a:p>
+                      <a:pPr algn="l"/>
+                      <a:r>
+                        <a:rPr sz="900" b="1">
+                          <a:solidFill>
+                            <a:srgbClr val="2B164F"/>
+                          </a:solidFill>
+                          <a:latin typeface="Calibri"/>
+                        </a:rPr>
                         <a:t>ALT-2026-000322
 20/10/2026</a:t>
                       </a:r>
@@ -12494,726 +13214,6 @@
                           <a:latin typeface="Calibri"/>
                         </a:rPr>
                         <a:t>Agua dentro y fuera de la unidad</a:t>
-                      </a:r>
-                    </a:p>
-                  </a:txBody>
-                  <a:tcPr marL="73152" marR="73152" marT="27432" marB="27432" anchor="ctr">
-                    <a:solidFill>
-                      <a:srgbClr val="FFFFFF"/>
-                    </a:solidFill>
-                  </a:tcPr>
-                </a:tc>
-                <a:tc>
-                  <a:txBody>
-                    <a:bodyPr wrap="square"/>
-                    <a:lstStyle/>
-                    <a:p>
-                      <a:pPr algn="l"/>
-                      <a:r>
-                        <a:rPr sz="900" b="0">
-                          <a:solidFill>
-                            <a:srgbClr val="20202B"/>
-                          </a:solidFill>
-                          <a:latin typeface="Calibri"/>
-                        </a:rPr>
-                        <a:t>Pendiente</a:t>
-                      </a:r>
-                    </a:p>
-                  </a:txBody>
-                  <a:tcPr marL="73152" marR="73152" marT="27432" marB="27432" anchor="ctr">
-                    <a:solidFill>
-                      <a:srgbClr val="FFFFFF"/>
-                    </a:solidFill>
-                  </a:tcPr>
-                </a:tc>
-              </a:tr>
-              <a:tr h="594360">
-                <a:tc>
-                  <a:txBody>
-                    <a:bodyPr wrap="square"/>
-                    <a:lstStyle/>
-                    <a:p>
-                      <a:pPr algn="l"/>
-                      <a:r>
-                        <a:rPr sz="900" b="1">
-                          <a:solidFill>
-                            <a:srgbClr val="2B164F"/>
-                          </a:solidFill>
-                          <a:latin typeface="Calibri"/>
-                        </a:rPr>
-                        <a:t>ALT-2026-000321
-20/10/2026</a:t>
-                      </a:r>
-                    </a:p>
-                  </a:txBody>
-                  <a:tcPr marL="73152" marR="73152" marT="27432" marB="27432" anchor="ctr">
-                    <a:solidFill>
-                      <a:srgbClr val="F7F5FA"/>
-                    </a:solidFill>
-                  </a:tcPr>
-                </a:tc>
-                <a:tc>
-                  <a:txBody>
-                    <a:bodyPr wrap="square"/>
-                    <a:lstStyle/>
-                    <a:p>
-                      <a:pPr algn="l"/>
-                      <a:r>
-                        <a:rPr sz="900" b="0">
-                          <a:solidFill>
-                            <a:srgbClr val="20202B"/>
-                          </a:solidFill>
-                          <a:latin typeface="Calibri"/>
-                        </a:rPr>
-                        <a:t>Pequeños Jilgueritos
-UA 62208 · Desarrollo Infantil</a:t>
-                      </a:r>
-                    </a:p>
-                  </a:txBody>
-                  <a:tcPr marL="73152" marR="73152" marT="27432" marB="27432" anchor="ctr">
-                    <a:solidFill>
-                      <a:srgbClr val="F7F5FA"/>
-                    </a:solidFill>
-                  </a:tcPr>
-                </a:tc>
-                <a:tc>
-                  <a:txBody>
-                    <a:bodyPr wrap="square"/>
-                    <a:lstStyle/>
-                    <a:p>
-                      <a:pPr algn="l"/>
-                      <a:r>
-                        <a:rPr sz="900" b="0">
-                          <a:solidFill>
-                            <a:srgbClr val="20202B"/>
-                          </a:solidFill>
-                          <a:latin typeface="Calibri"/>
-                        </a:rPr>
-                        <a:t>Guayas
-Milagro</a:t>
-                      </a:r>
-                    </a:p>
-                  </a:txBody>
-                  <a:tcPr marL="73152" marR="73152" marT="27432" marB="27432" anchor="ctr">
-                    <a:solidFill>
-                      <a:srgbClr val="F7F5FA"/>
-                    </a:solidFill>
-                  </a:tcPr>
-                </a:tc>
-                <a:tc>
-                  <a:txBody>
-                    <a:bodyPr wrap="square"/>
-                    <a:lstStyle/>
-                    <a:p>
-                      <a:pPr algn="l"/>
-                      <a:r>
-                        <a:rPr sz="900" b="0">
-                          <a:solidFill>
-                            <a:srgbClr val="20202B"/>
-                          </a:solidFill>
-                          <a:latin typeface="Calibri"/>
-                        </a:rPr>
-                        <a:t>Acumulación de agua en la entrada de la unidad</a:t>
-                      </a:r>
-                    </a:p>
-                  </a:txBody>
-                  <a:tcPr marL="73152" marR="73152" marT="27432" marB="27432" anchor="ctr">
-                    <a:solidFill>
-                      <a:srgbClr val="F7F5FA"/>
-                    </a:solidFill>
-                  </a:tcPr>
-                </a:tc>
-                <a:tc>
-                  <a:txBody>
-                    <a:bodyPr wrap="square"/>
-                    <a:lstStyle/>
-                    <a:p>
-                      <a:pPr algn="l"/>
-                      <a:r>
-                        <a:rPr sz="900" b="0">
-                          <a:solidFill>
-                            <a:srgbClr val="20202B"/>
-                          </a:solidFill>
-                          <a:latin typeface="Calibri"/>
-                        </a:rPr>
-                        <a:t>Pendiente</a:t>
-                      </a:r>
-                    </a:p>
-                  </a:txBody>
-                  <a:tcPr marL="73152" marR="73152" marT="27432" marB="27432" anchor="ctr">
-                    <a:solidFill>
-                      <a:srgbClr val="F7F5FA"/>
-                    </a:solidFill>
-                  </a:tcPr>
-                </a:tc>
-              </a:tr>
-              <a:tr h="594360">
-                <a:tc>
-                  <a:txBody>
-                    <a:bodyPr wrap="square"/>
-                    <a:lstStyle/>
-                    <a:p>
-                      <a:pPr algn="l"/>
-                      <a:r>
-                        <a:rPr sz="900" b="1">
-                          <a:solidFill>
-                            <a:srgbClr val="2B164F"/>
-                          </a:solidFill>
-                          <a:latin typeface="Calibri"/>
-                        </a:rPr>
-                        <a:t>ALT-2026-000319
-20/10/2026</a:t>
-                      </a:r>
-                    </a:p>
-                  </a:txBody>
-                  <a:tcPr marL="73152" marR="73152" marT="27432" marB="27432" anchor="ctr">
-                    <a:solidFill>
-                      <a:srgbClr val="FFFFFF"/>
-                    </a:solidFill>
-                  </a:tcPr>
-                </a:tc>
-                <a:tc>
-                  <a:txBody>
-                    <a:bodyPr wrap="square"/>
-                    <a:lstStyle/>
-                    <a:p>
-                      <a:pPr algn="l"/>
-                      <a:r>
-                        <a:rPr sz="900" b="0">
-                          <a:solidFill>
-                            <a:srgbClr val="20202B"/>
-                          </a:solidFill>
-                          <a:latin typeface="Calibri"/>
-                        </a:rPr>
-                        <a:t>Centro de Desarrollo Infantil Estrellita de Mar
-UA 60221 · Desarrollo Infantil</a:t>
-                      </a:r>
-                    </a:p>
-                  </a:txBody>
-                  <a:tcPr marL="73152" marR="73152" marT="27432" marB="27432" anchor="ctr">
-                    <a:solidFill>
-                      <a:srgbClr val="FFFFFF"/>
-                    </a:solidFill>
-                  </a:tcPr>
-                </a:tc>
-                <a:tc>
-                  <a:txBody>
-                    <a:bodyPr wrap="square"/>
-                    <a:lstStyle/>
-                    <a:p>
-                      <a:pPr algn="l"/>
-                      <a:r>
-                        <a:rPr sz="900" b="0">
-                          <a:solidFill>
-                            <a:srgbClr val="20202B"/>
-                          </a:solidFill>
-                          <a:latin typeface="Calibri"/>
-                        </a:rPr>
-                        <a:t>El Oro
-El Guabo</a:t>
-                      </a:r>
-                    </a:p>
-                  </a:txBody>
-                  <a:tcPr marL="73152" marR="73152" marT="27432" marB="27432" anchor="ctr">
-                    <a:solidFill>
-                      <a:srgbClr val="FFFFFF"/>
-                    </a:solidFill>
-                  </a:tcPr>
-                </a:tc>
-                <a:tc>
-                  <a:txBody>
-                    <a:bodyPr wrap="square"/>
-                    <a:lstStyle/>
-                    <a:p>
-                      <a:pPr algn="l"/>
-                      <a:r>
-                        <a:rPr sz="900" b="0">
-                          <a:solidFill>
-                            <a:srgbClr val="20202B"/>
-                          </a:solidFill>
-                          <a:latin typeface="Calibri"/>
-                        </a:rPr>
-                        <a:t>Ingreso de agua; cambio temporal a modalidad virtual</a:t>
-                      </a:r>
-                    </a:p>
-                  </a:txBody>
-                  <a:tcPr marL="73152" marR="73152" marT="27432" marB="27432" anchor="ctr">
-                    <a:solidFill>
-                      <a:srgbClr val="FFFFFF"/>
-                    </a:solidFill>
-                  </a:tcPr>
-                </a:tc>
-                <a:tc>
-                  <a:txBody>
-                    <a:bodyPr wrap="square"/>
-                    <a:lstStyle/>
-                    <a:p>
-                      <a:pPr algn="l"/>
-                      <a:r>
-                        <a:rPr sz="900" b="0">
-                          <a:solidFill>
-                            <a:srgbClr val="20202B"/>
-                          </a:solidFill>
-                          <a:latin typeface="Calibri"/>
-                        </a:rPr>
-                        <a:t>En seguimiento</a:t>
-                      </a:r>
-                    </a:p>
-                  </a:txBody>
-                  <a:tcPr marL="73152" marR="73152" marT="27432" marB="27432" anchor="ctr">
-                    <a:solidFill>
-                      <a:srgbClr val="FFFFFF"/>
-                    </a:solidFill>
-                  </a:tcPr>
-                </a:tc>
-              </a:tr>
-              <a:tr h="594360">
-                <a:tc>
-                  <a:txBody>
-                    <a:bodyPr wrap="square"/>
-                    <a:lstStyle/>
-                    <a:p>
-                      <a:pPr algn="l"/>
-                      <a:r>
-                        <a:rPr sz="900" b="1">
-                          <a:solidFill>
-                            <a:srgbClr val="2B164F"/>
-                          </a:solidFill>
-                          <a:latin typeface="Calibri"/>
-                        </a:rPr>
-                        <a:t>ALT-2026-000318
-20/10/2026</a:t>
-                      </a:r>
-                    </a:p>
-                  </a:txBody>
-                  <a:tcPr marL="73152" marR="73152" marT="27432" marB="27432" anchor="ctr">
-                    <a:solidFill>
-                      <a:srgbClr val="F7F5FA"/>
-                    </a:solidFill>
-                  </a:tcPr>
-                </a:tc>
-                <a:tc>
-                  <a:txBody>
-                    <a:bodyPr wrap="square"/>
-                    <a:lstStyle/>
-                    <a:p>
-                      <a:pPr algn="l"/>
-                      <a:r>
-                        <a:rPr sz="900" b="0">
-                          <a:solidFill>
-                            <a:srgbClr val="20202B"/>
-                          </a:solidFill>
-                          <a:latin typeface="Calibri"/>
-                        </a:rPr>
-                        <a:t>Centro de Desarrollo Infantil Súper Niño
-UA 60220 · Desarrollo Infantil</a:t>
-                      </a:r>
-                    </a:p>
-                  </a:txBody>
-                  <a:tcPr marL="73152" marR="73152" marT="27432" marB="27432" anchor="ctr">
-                    <a:solidFill>
-                      <a:srgbClr val="F7F5FA"/>
-                    </a:solidFill>
-                  </a:tcPr>
-                </a:tc>
-                <a:tc>
-                  <a:txBody>
-                    <a:bodyPr wrap="square"/>
-                    <a:lstStyle/>
-                    <a:p>
-                      <a:pPr algn="l"/>
-                      <a:r>
-                        <a:rPr sz="900" b="0">
-                          <a:solidFill>
-                            <a:srgbClr val="20202B"/>
-                          </a:solidFill>
-                          <a:latin typeface="Calibri"/>
-                        </a:rPr>
-                        <a:t>El Oro
-El Guabo</a:t>
-                      </a:r>
-                    </a:p>
-                  </a:txBody>
-                  <a:tcPr marL="73152" marR="73152" marT="27432" marB="27432" anchor="ctr">
-                    <a:solidFill>
-                      <a:srgbClr val="F7F5FA"/>
-                    </a:solidFill>
-                  </a:tcPr>
-                </a:tc>
-                <a:tc>
-                  <a:txBody>
-                    <a:bodyPr wrap="square"/>
-                    <a:lstStyle/>
-                    <a:p>
-                      <a:pPr algn="l"/>
-                      <a:r>
-                        <a:rPr sz="900" b="0">
-                          <a:solidFill>
-                            <a:srgbClr val="20202B"/>
-                          </a:solidFill>
-                          <a:latin typeface="Calibri"/>
-                        </a:rPr>
-                        <a:t>Ingreso de agua; cambio temporal a modalidad virtual</a:t>
-                      </a:r>
-                    </a:p>
-                  </a:txBody>
-                  <a:tcPr marL="73152" marR="73152" marT="27432" marB="27432" anchor="ctr">
-                    <a:solidFill>
-                      <a:srgbClr val="F7F5FA"/>
-                    </a:solidFill>
-                  </a:tcPr>
-                </a:tc>
-                <a:tc>
-                  <a:txBody>
-                    <a:bodyPr wrap="square"/>
-                    <a:lstStyle/>
-                    <a:p>
-                      <a:pPr algn="l"/>
-                      <a:r>
-                        <a:rPr sz="900" b="0">
-                          <a:solidFill>
-                            <a:srgbClr val="20202B"/>
-                          </a:solidFill>
-                          <a:latin typeface="Calibri"/>
-                        </a:rPr>
-                        <a:t>En seguimiento</a:t>
-                      </a:r>
-                    </a:p>
-                  </a:txBody>
-                  <a:tcPr marL="73152" marR="73152" marT="27432" marB="27432" anchor="ctr">
-                    <a:solidFill>
-                      <a:srgbClr val="F7F5FA"/>
-                    </a:solidFill>
-                  </a:tcPr>
-                </a:tc>
-              </a:tr>
-              <a:tr h="594360">
-                <a:tc>
-                  <a:txBody>
-                    <a:bodyPr wrap="square"/>
-                    <a:lstStyle/>
-                    <a:p>
-                      <a:pPr algn="l"/>
-                      <a:r>
-                        <a:rPr sz="900" b="1">
-                          <a:solidFill>
-                            <a:srgbClr val="2B164F"/>
-                          </a:solidFill>
-                          <a:latin typeface="Calibri"/>
-                        </a:rPr>
-                        <a:t>ALT-2026-000316
-19/10/2026</a:t>
-                      </a:r>
-                    </a:p>
-                  </a:txBody>
-                  <a:tcPr marL="73152" marR="73152" marT="27432" marB="27432" anchor="ctr">
-                    <a:solidFill>
-                      <a:srgbClr val="FFFFFF"/>
-                    </a:solidFill>
-                  </a:tcPr>
-                </a:tc>
-                <a:tc>
-                  <a:txBody>
-                    <a:bodyPr wrap="square"/>
-                    <a:lstStyle/>
-                    <a:p>
-                      <a:pPr algn="l"/>
-                      <a:r>
-                        <a:rPr sz="900" b="0">
-                          <a:solidFill>
-                            <a:srgbClr val="20202B"/>
-                          </a:solidFill>
-                          <a:latin typeface="Calibri"/>
-                        </a:rPr>
-                        <a:t>CDI Niños de San Rafael
-UA 58337 · Desarrollo Infantil</a:t>
-                      </a:r>
-                    </a:p>
-                  </a:txBody>
-                  <a:tcPr marL="73152" marR="73152" marT="27432" marB="27432" anchor="ctr">
-                    <a:solidFill>
-                      <a:srgbClr val="FFFFFF"/>
-                    </a:solidFill>
-                  </a:tcPr>
-                </a:tc>
-                <a:tc>
-                  <a:txBody>
-                    <a:bodyPr wrap="square"/>
-                    <a:lstStyle/>
-                    <a:p>
-                      <a:pPr algn="l"/>
-                      <a:r>
-                        <a:rPr sz="900" b="0">
-                          <a:solidFill>
-                            <a:srgbClr val="20202B"/>
-                          </a:solidFill>
-                          <a:latin typeface="Calibri"/>
-                        </a:rPr>
-                        <a:t>Guayas
-Guayaquil</a:t>
-                      </a:r>
-                    </a:p>
-                  </a:txBody>
-                  <a:tcPr marL="73152" marR="73152" marT="27432" marB="27432" anchor="ctr">
-                    <a:solidFill>
-                      <a:srgbClr val="FFFFFF"/>
-                    </a:solidFill>
-                  </a:tcPr>
-                </a:tc>
-                <a:tc>
-                  <a:txBody>
-                    <a:bodyPr wrap="square"/>
-                    <a:lstStyle/>
-                    <a:p>
-                      <a:pPr algn="l"/>
-                      <a:r>
-                        <a:rPr sz="900" b="0">
-                          <a:solidFill>
-                            <a:srgbClr val="20202B"/>
-                          </a:solidFill>
-                          <a:latin typeface="Calibri"/>
-                        </a:rPr>
-                        <a:t>Alerta por inundación en Tenguel vinculada a la UA; afectación al servicio por confirmar.</a:t>
-                      </a:r>
-                    </a:p>
-                  </a:txBody>
-                  <a:tcPr marL="73152" marR="73152" marT="27432" marB="27432" anchor="ctr">
-                    <a:solidFill>
-                      <a:srgbClr val="FFFFFF"/>
-                    </a:solidFill>
-                  </a:tcPr>
-                </a:tc>
-                <a:tc>
-                  <a:txBody>
-                    <a:bodyPr wrap="square"/>
-                    <a:lstStyle/>
-                    <a:p>
-                      <a:pPr algn="l"/>
-                      <a:r>
-                        <a:rPr sz="900" b="0">
-                          <a:solidFill>
-                            <a:srgbClr val="20202B"/>
-                          </a:solidFill>
-                          <a:latin typeface="Calibri"/>
-                        </a:rPr>
-                        <a:t>Pendiente</a:t>
-                      </a:r>
-                    </a:p>
-                  </a:txBody>
-                  <a:tcPr marL="73152" marR="73152" marT="27432" marB="27432" anchor="ctr">
-                    <a:solidFill>
-                      <a:srgbClr val="FFFFFF"/>
-                    </a:solidFill>
-                  </a:tcPr>
-                </a:tc>
-              </a:tr>
-              <a:tr h="594360">
-                <a:tc>
-                  <a:txBody>
-                    <a:bodyPr wrap="square"/>
-                    <a:lstStyle/>
-                    <a:p>
-                      <a:pPr algn="l"/>
-                      <a:r>
-                        <a:rPr sz="900" b="1">
-                          <a:solidFill>
-                            <a:srgbClr val="2B164F"/>
-                          </a:solidFill>
-                          <a:latin typeface="Calibri"/>
-                        </a:rPr>
-                        <a:t>ALT-2026-000315
-19/10/2026</a:t>
-                      </a:r>
-                    </a:p>
-                  </a:txBody>
-                  <a:tcPr marL="73152" marR="73152" marT="27432" marB="27432" anchor="ctr">
-                    <a:solidFill>
-                      <a:srgbClr val="F7F5FA"/>
-                    </a:solidFill>
-                  </a:tcPr>
-                </a:tc>
-                <a:tc>
-                  <a:txBody>
-                    <a:bodyPr wrap="square"/>
-                    <a:lstStyle/>
-                    <a:p>
-                      <a:pPr algn="l"/>
-                      <a:r>
-                        <a:rPr sz="900" b="0">
-                          <a:solidFill>
-                            <a:srgbClr val="20202B"/>
-                          </a:solidFill>
-                          <a:latin typeface="Calibri"/>
-                        </a:rPr>
-                        <a:t>CDI Los Niños del Cisne
-UA 58336 · Desarrollo Infantil</a:t>
-                      </a:r>
-                    </a:p>
-                  </a:txBody>
-                  <a:tcPr marL="73152" marR="73152" marT="27432" marB="27432" anchor="ctr">
-                    <a:solidFill>
-                      <a:srgbClr val="F7F5FA"/>
-                    </a:solidFill>
-                  </a:tcPr>
-                </a:tc>
-                <a:tc>
-                  <a:txBody>
-                    <a:bodyPr wrap="square"/>
-                    <a:lstStyle/>
-                    <a:p>
-                      <a:pPr algn="l"/>
-                      <a:r>
-                        <a:rPr sz="900" b="0">
-                          <a:solidFill>
-                            <a:srgbClr val="20202B"/>
-                          </a:solidFill>
-                          <a:latin typeface="Calibri"/>
-                        </a:rPr>
-                        <a:t>Guayas
-Guayaquil</a:t>
-                      </a:r>
-                    </a:p>
-                  </a:txBody>
-                  <a:tcPr marL="73152" marR="73152" marT="27432" marB="27432" anchor="ctr">
-                    <a:solidFill>
-                      <a:srgbClr val="F7F5FA"/>
-                    </a:solidFill>
-                  </a:tcPr>
-                </a:tc>
-                <a:tc>
-                  <a:txBody>
-                    <a:bodyPr wrap="square"/>
-                    <a:lstStyle/>
-                    <a:p>
-                      <a:pPr algn="l"/>
-                      <a:r>
-                        <a:rPr sz="900" b="0">
-                          <a:solidFill>
-                            <a:srgbClr val="20202B"/>
-                          </a:solidFill>
-                          <a:latin typeface="Calibri"/>
-                        </a:rPr>
-                        <a:t>Alerta por inundación en Tenguel vinculada a la UA; afectación al servicio por confirmar.</a:t>
-                      </a:r>
-                    </a:p>
-                  </a:txBody>
-                  <a:tcPr marL="73152" marR="73152" marT="27432" marB="27432" anchor="ctr">
-                    <a:solidFill>
-                      <a:srgbClr val="F7F5FA"/>
-                    </a:solidFill>
-                  </a:tcPr>
-                </a:tc>
-                <a:tc>
-                  <a:txBody>
-                    <a:bodyPr wrap="square"/>
-                    <a:lstStyle/>
-                    <a:p>
-                      <a:pPr algn="l"/>
-                      <a:r>
-                        <a:rPr sz="900" b="0">
-                          <a:solidFill>
-                            <a:srgbClr val="20202B"/>
-                          </a:solidFill>
-                          <a:latin typeface="Calibri"/>
-                        </a:rPr>
-                        <a:t>Pendiente</a:t>
-                      </a:r>
-                    </a:p>
-                  </a:txBody>
-                  <a:tcPr marL="73152" marR="73152" marT="27432" marB="27432" anchor="ctr">
-                    <a:solidFill>
-                      <a:srgbClr val="F7F5FA"/>
-                    </a:solidFill>
-                  </a:tcPr>
-                </a:tc>
-              </a:tr>
-              <a:tr h="594360">
-                <a:tc>
-                  <a:txBody>
-                    <a:bodyPr wrap="square"/>
-                    <a:lstStyle/>
-                    <a:p>
-                      <a:pPr algn="l"/>
-                      <a:r>
-                        <a:rPr sz="900" b="1">
-                          <a:solidFill>
-                            <a:srgbClr val="2B164F"/>
-                          </a:solidFill>
-                          <a:latin typeface="Calibri"/>
-                        </a:rPr>
-                        <a:t>ALT-2026-000310
-16/10/2026</a:t>
-                      </a:r>
-                    </a:p>
-                  </a:txBody>
-                  <a:tcPr marL="73152" marR="73152" marT="27432" marB="27432" anchor="ctr">
-                    <a:solidFill>
-                      <a:srgbClr val="FFFFFF"/>
-                    </a:solidFill>
-                  </a:tcPr>
-                </a:tc>
-                <a:tc>
-                  <a:txBody>
-                    <a:bodyPr wrap="square"/>
-                    <a:lstStyle/>
-                    <a:p>
-                      <a:pPr algn="l"/>
-                      <a:r>
-                        <a:rPr sz="900" b="0">
-                          <a:solidFill>
-                            <a:srgbClr val="20202B"/>
-                          </a:solidFill>
-                          <a:latin typeface="Calibri"/>
-                        </a:rPr>
-                        <a:t>CNH Estrellitas del Amanecer
-UA 56744 · Creciendo con Nuestros Hijos (CNH)</a:t>
-                      </a:r>
-                    </a:p>
-                  </a:txBody>
-                  <a:tcPr marL="73152" marR="73152" marT="27432" marB="27432" anchor="ctr">
-                    <a:solidFill>
-                      <a:srgbClr val="FFFFFF"/>
-                    </a:solidFill>
-                  </a:tcPr>
-                </a:tc>
-                <a:tc>
-                  <a:txBody>
-                    <a:bodyPr wrap="square"/>
-                    <a:lstStyle/>
-                    <a:p>
-                      <a:pPr algn="l"/>
-                      <a:r>
-                        <a:rPr sz="900" b="0">
-                          <a:solidFill>
-                            <a:srgbClr val="20202B"/>
-                          </a:solidFill>
-                          <a:latin typeface="Calibri"/>
-                        </a:rPr>
-                        <a:t>Manabí
-Flavio Alfaro</a:t>
-                      </a:r>
-                    </a:p>
-                  </a:txBody>
-                  <a:tcPr marL="73152" marR="73152" marT="27432" marB="27432" anchor="ctr">
-                    <a:solidFill>
-                      <a:srgbClr val="FFFFFF"/>
-                    </a:solidFill>
-                  </a:tcPr>
-                </a:tc>
-                <a:tc>
-                  <a:txBody>
-                    <a:bodyPr wrap="square"/>
-                    <a:lstStyle/>
-                    <a:p>
-                      <a:pPr algn="l"/>
-                      <a:r>
-                        <a:rPr sz="900" b="0">
-                          <a:solidFill>
-                            <a:srgbClr val="20202B"/>
-                          </a:solidFill>
-                          <a:latin typeface="Calibri"/>
-                        </a:rPr>
-                        <a:t>Acceso impedido para atención presencial; contacto telefónico temporal</a:t>
                       </a:r>
                     </a:p>
                   </a:txBody>
@@ -13657,6 +13657,726 @@
                           </a:solidFill>
                           <a:latin typeface="Calibri"/>
                         </a:rPr>
+                        <a:t>ALT-2026-000321
+20/10/2026</a:t>
+                      </a:r>
+                    </a:p>
+                  </a:txBody>
+                  <a:tcPr marL="73152" marR="73152" marT="27432" marB="27432" anchor="ctr">
+                    <a:solidFill>
+                      <a:srgbClr val="FFFFFF"/>
+                    </a:solidFill>
+                  </a:tcPr>
+                </a:tc>
+                <a:tc>
+                  <a:txBody>
+                    <a:bodyPr wrap="square"/>
+                    <a:lstStyle/>
+                    <a:p>
+                      <a:pPr algn="l"/>
+                      <a:r>
+                        <a:rPr sz="900" b="0">
+                          <a:solidFill>
+                            <a:srgbClr val="20202B"/>
+                          </a:solidFill>
+                          <a:latin typeface="Calibri"/>
+                        </a:rPr>
+                        <a:t>Pequeños Jilgueritos
+UA 62208 · Desarrollo Infantil</a:t>
+                      </a:r>
+                    </a:p>
+                  </a:txBody>
+                  <a:tcPr marL="73152" marR="73152" marT="27432" marB="27432" anchor="ctr">
+                    <a:solidFill>
+                      <a:srgbClr val="FFFFFF"/>
+                    </a:solidFill>
+                  </a:tcPr>
+                </a:tc>
+                <a:tc>
+                  <a:txBody>
+                    <a:bodyPr wrap="square"/>
+                    <a:lstStyle/>
+                    <a:p>
+                      <a:pPr algn="l"/>
+                      <a:r>
+                        <a:rPr sz="900" b="0">
+                          <a:solidFill>
+                            <a:srgbClr val="20202B"/>
+                          </a:solidFill>
+                          <a:latin typeface="Calibri"/>
+                        </a:rPr>
+                        <a:t>Guayas
+Milagro</a:t>
+                      </a:r>
+                    </a:p>
+                  </a:txBody>
+                  <a:tcPr marL="73152" marR="73152" marT="27432" marB="27432" anchor="ctr">
+                    <a:solidFill>
+                      <a:srgbClr val="FFFFFF"/>
+                    </a:solidFill>
+                  </a:tcPr>
+                </a:tc>
+                <a:tc>
+                  <a:txBody>
+                    <a:bodyPr wrap="square"/>
+                    <a:lstStyle/>
+                    <a:p>
+                      <a:pPr algn="l"/>
+                      <a:r>
+                        <a:rPr sz="900" b="0">
+                          <a:solidFill>
+                            <a:srgbClr val="20202B"/>
+                          </a:solidFill>
+                          <a:latin typeface="Calibri"/>
+                        </a:rPr>
+                        <a:t>Acumulación de agua en la entrada de la unidad</a:t>
+                      </a:r>
+                    </a:p>
+                  </a:txBody>
+                  <a:tcPr marL="73152" marR="73152" marT="27432" marB="27432" anchor="ctr">
+                    <a:solidFill>
+                      <a:srgbClr val="FFFFFF"/>
+                    </a:solidFill>
+                  </a:tcPr>
+                </a:tc>
+                <a:tc>
+                  <a:txBody>
+                    <a:bodyPr wrap="square"/>
+                    <a:lstStyle/>
+                    <a:p>
+                      <a:pPr algn="l"/>
+                      <a:r>
+                        <a:rPr sz="900" b="0">
+                          <a:solidFill>
+                            <a:srgbClr val="20202B"/>
+                          </a:solidFill>
+                          <a:latin typeface="Calibri"/>
+                        </a:rPr>
+                        <a:t>Pendiente</a:t>
+                      </a:r>
+                    </a:p>
+                  </a:txBody>
+                  <a:tcPr marL="73152" marR="73152" marT="27432" marB="27432" anchor="ctr">
+                    <a:solidFill>
+                      <a:srgbClr val="FFFFFF"/>
+                    </a:solidFill>
+                  </a:tcPr>
+                </a:tc>
+              </a:tr>
+              <a:tr h="594360">
+                <a:tc>
+                  <a:txBody>
+                    <a:bodyPr wrap="square"/>
+                    <a:lstStyle/>
+                    <a:p>
+                      <a:pPr algn="l"/>
+                      <a:r>
+                        <a:rPr sz="900" b="1">
+                          <a:solidFill>
+                            <a:srgbClr val="2B164F"/>
+                          </a:solidFill>
+                          <a:latin typeface="Calibri"/>
+                        </a:rPr>
+                        <a:t>ALT-2026-000319
+20/10/2026</a:t>
+                      </a:r>
+                    </a:p>
+                  </a:txBody>
+                  <a:tcPr marL="73152" marR="73152" marT="27432" marB="27432" anchor="ctr">
+                    <a:solidFill>
+                      <a:srgbClr val="F7F5FA"/>
+                    </a:solidFill>
+                  </a:tcPr>
+                </a:tc>
+                <a:tc>
+                  <a:txBody>
+                    <a:bodyPr wrap="square"/>
+                    <a:lstStyle/>
+                    <a:p>
+                      <a:pPr algn="l"/>
+                      <a:r>
+                        <a:rPr sz="900" b="0">
+                          <a:solidFill>
+                            <a:srgbClr val="20202B"/>
+                          </a:solidFill>
+                          <a:latin typeface="Calibri"/>
+                        </a:rPr>
+                        <a:t>Centro de Desarrollo Infantil Estrellita de Mar
+UA 60221 · Desarrollo Infantil</a:t>
+                      </a:r>
+                    </a:p>
+                  </a:txBody>
+                  <a:tcPr marL="73152" marR="73152" marT="27432" marB="27432" anchor="ctr">
+                    <a:solidFill>
+                      <a:srgbClr val="F7F5FA"/>
+                    </a:solidFill>
+                  </a:tcPr>
+                </a:tc>
+                <a:tc>
+                  <a:txBody>
+                    <a:bodyPr wrap="square"/>
+                    <a:lstStyle/>
+                    <a:p>
+                      <a:pPr algn="l"/>
+                      <a:r>
+                        <a:rPr sz="900" b="0">
+                          <a:solidFill>
+                            <a:srgbClr val="20202B"/>
+                          </a:solidFill>
+                          <a:latin typeface="Calibri"/>
+                        </a:rPr>
+                        <a:t>El Oro
+El Guabo</a:t>
+                      </a:r>
+                    </a:p>
+                  </a:txBody>
+                  <a:tcPr marL="73152" marR="73152" marT="27432" marB="27432" anchor="ctr">
+                    <a:solidFill>
+                      <a:srgbClr val="F7F5FA"/>
+                    </a:solidFill>
+                  </a:tcPr>
+                </a:tc>
+                <a:tc>
+                  <a:txBody>
+                    <a:bodyPr wrap="square"/>
+                    <a:lstStyle/>
+                    <a:p>
+                      <a:pPr algn="l"/>
+                      <a:r>
+                        <a:rPr sz="900" b="0">
+                          <a:solidFill>
+                            <a:srgbClr val="20202B"/>
+                          </a:solidFill>
+                          <a:latin typeface="Calibri"/>
+                        </a:rPr>
+                        <a:t>Ingreso de agua; cambio temporal a modalidad virtual</a:t>
+                      </a:r>
+                    </a:p>
+                  </a:txBody>
+                  <a:tcPr marL="73152" marR="73152" marT="27432" marB="27432" anchor="ctr">
+                    <a:solidFill>
+                      <a:srgbClr val="F7F5FA"/>
+                    </a:solidFill>
+                  </a:tcPr>
+                </a:tc>
+                <a:tc>
+                  <a:txBody>
+                    <a:bodyPr wrap="square"/>
+                    <a:lstStyle/>
+                    <a:p>
+                      <a:pPr algn="l"/>
+                      <a:r>
+                        <a:rPr sz="900" b="0">
+                          <a:solidFill>
+                            <a:srgbClr val="20202B"/>
+                          </a:solidFill>
+                          <a:latin typeface="Calibri"/>
+                        </a:rPr>
+                        <a:t>En seguimiento</a:t>
+                      </a:r>
+                    </a:p>
+                  </a:txBody>
+                  <a:tcPr marL="73152" marR="73152" marT="27432" marB="27432" anchor="ctr">
+                    <a:solidFill>
+                      <a:srgbClr val="F7F5FA"/>
+                    </a:solidFill>
+                  </a:tcPr>
+                </a:tc>
+              </a:tr>
+              <a:tr h="594360">
+                <a:tc>
+                  <a:txBody>
+                    <a:bodyPr wrap="square"/>
+                    <a:lstStyle/>
+                    <a:p>
+                      <a:pPr algn="l"/>
+                      <a:r>
+                        <a:rPr sz="900" b="1">
+                          <a:solidFill>
+                            <a:srgbClr val="2B164F"/>
+                          </a:solidFill>
+                          <a:latin typeface="Calibri"/>
+                        </a:rPr>
+                        <a:t>ALT-2026-000318
+20/10/2026</a:t>
+                      </a:r>
+                    </a:p>
+                  </a:txBody>
+                  <a:tcPr marL="73152" marR="73152" marT="27432" marB="27432" anchor="ctr">
+                    <a:solidFill>
+                      <a:srgbClr val="FFFFFF"/>
+                    </a:solidFill>
+                  </a:tcPr>
+                </a:tc>
+                <a:tc>
+                  <a:txBody>
+                    <a:bodyPr wrap="square"/>
+                    <a:lstStyle/>
+                    <a:p>
+                      <a:pPr algn="l"/>
+                      <a:r>
+                        <a:rPr sz="900" b="0">
+                          <a:solidFill>
+                            <a:srgbClr val="20202B"/>
+                          </a:solidFill>
+                          <a:latin typeface="Calibri"/>
+                        </a:rPr>
+                        <a:t>Centro de Desarrollo Infantil Súper Niño
+UA 60220 · Desarrollo Infantil</a:t>
+                      </a:r>
+                    </a:p>
+                  </a:txBody>
+                  <a:tcPr marL="73152" marR="73152" marT="27432" marB="27432" anchor="ctr">
+                    <a:solidFill>
+                      <a:srgbClr val="FFFFFF"/>
+                    </a:solidFill>
+                  </a:tcPr>
+                </a:tc>
+                <a:tc>
+                  <a:txBody>
+                    <a:bodyPr wrap="square"/>
+                    <a:lstStyle/>
+                    <a:p>
+                      <a:pPr algn="l"/>
+                      <a:r>
+                        <a:rPr sz="900" b="0">
+                          <a:solidFill>
+                            <a:srgbClr val="20202B"/>
+                          </a:solidFill>
+                          <a:latin typeface="Calibri"/>
+                        </a:rPr>
+                        <a:t>El Oro
+El Guabo</a:t>
+                      </a:r>
+                    </a:p>
+                  </a:txBody>
+                  <a:tcPr marL="73152" marR="73152" marT="27432" marB="27432" anchor="ctr">
+                    <a:solidFill>
+                      <a:srgbClr val="FFFFFF"/>
+                    </a:solidFill>
+                  </a:tcPr>
+                </a:tc>
+                <a:tc>
+                  <a:txBody>
+                    <a:bodyPr wrap="square"/>
+                    <a:lstStyle/>
+                    <a:p>
+                      <a:pPr algn="l"/>
+                      <a:r>
+                        <a:rPr sz="900" b="0">
+                          <a:solidFill>
+                            <a:srgbClr val="20202B"/>
+                          </a:solidFill>
+                          <a:latin typeface="Calibri"/>
+                        </a:rPr>
+                        <a:t>Ingreso de agua; cambio temporal a modalidad virtual</a:t>
+                      </a:r>
+                    </a:p>
+                  </a:txBody>
+                  <a:tcPr marL="73152" marR="73152" marT="27432" marB="27432" anchor="ctr">
+                    <a:solidFill>
+                      <a:srgbClr val="FFFFFF"/>
+                    </a:solidFill>
+                  </a:tcPr>
+                </a:tc>
+                <a:tc>
+                  <a:txBody>
+                    <a:bodyPr wrap="square"/>
+                    <a:lstStyle/>
+                    <a:p>
+                      <a:pPr algn="l"/>
+                      <a:r>
+                        <a:rPr sz="900" b="0">
+                          <a:solidFill>
+                            <a:srgbClr val="20202B"/>
+                          </a:solidFill>
+                          <a:latin typeface="Calibri"/>
+                        </a:rPr>
+                        <a:t>En seguimiento</a:t>
+                      </a:r>
+                    </a:p>
+                  </a:txBody>
+                  <a:tcPr marL="73152" marR="73152" marT="27432" marB="27432" anchor="ctr">
+                    <a:solidFill>
+                      <a:srgbClr val="FFFFFF"/>
+                    </a:solidFill>
+                  </a:tcPr>
+                </a:tc>
+              </a:tr>
+              <a:tr h="594360">
+                <a:tc>
+                  <a:txBody>
+                    <a:bodyPr wrap="square"/>
+                    <a:lstStyle/>
+                    <a:p>
+                      <a:pPr algn="l"/>
+                      <a:r>
+                        <a:rPr sz="900" b="1">
+                          <a:solidFill>
+                            <a:srgbClr val="2B164F"/>
+                          </a:solidFill>
+                          <a:latin typeface="Calibri"/>
+                        </a:rPr>
+                        <a:t>ALT-2026-000316
+19/10/2026</a:t>
+                      </a:r>
+                    </a:p>
+                  </a:txBody>
+                  <a:tcPr marL="73152" marR="73152" marT="27432" marB="27432" anchor="ctr">
+                    <a:solidFill>
+                      <a:srgbClr val="F7F5FA"/>
+                    </a:solidFill>
+                  </a:tcPr>
+                </a:tc>
+                <a:tc>
+                  <a:txBody>
+                    <a:bodyPr wrap="square"/>
+                    <a:lstStyle/>
+                    <a:p>
+                      <a:pPr algn="l"/>
+                      <a:r>
+                        <a:rPr sz="900" b="0">
+                          <a:solidFill>
+                            <a:srgbClr val="20202B"/>
+                          </a:solidFill>
+                          <a:latin typeface="Calibri"/>
+                        </a:rPr>
+                        <a:t>CDI Niños de San Rafael
+UA 58337 · Desarrollo Infantil</a:t>
+                      </a:r>
+                    </a:p>
+                  </a:txBody>
+                  <a:tcPr marL="73152" marR="73152" marT="27432" marB="27432" anchor="ctr">
+                    <a:solidFill>
+                      <a:srgbClr val="F7F5FA"/>
+                    </a:solidFill>
+                  </a:tcPr>
+                </a:tc>
+                <a:tc>
+                  <a:txBody>
+                    <a:bodyPr wrap="square"/>
+                    <a:lstStyle/>
+                    <a:p>
+                      <a:pPr algn="l"/>
+                      <a:r>
+                        <a:rPr sz="900" b="0">
+                          <a:solidFill>
+                            <a:srgbClr val="20202B"/>
+                          </a:solidFill>
+                          <a:latin typeface="Calibri"/>
+                        </a:rPr>
+                        <a:t>Guayas
+Guayaquil</a:t>
+                      </a:r>
+                    </a:p>
+                  </a:txBody>
+                  <a:tcPr marL="73152" marR="73152" marT="27432" marB="27432" anchor="ctr">
+                    <a:solidFill>
+                      <a:srgbClr val="F7F5FA"/>
+                    </a:solidFill>
+                  </a:tcPr>
+                </a:tc>
+                <a:tc>
+                  <a:txBody>
+                    <a:bodyPr wrap="square"/>
+                    <a:lstStyle/>
+                    <a:p>
+                      <a:pPr algn="l"/>
+                      <a:r>
+                        <a:rPr sz="900" b="0">
+                          <a:solidFill>
+                            <a:srgbClr val="20202B"/>
+                          </a:solidFill>
+                          <a:latin typeface="Calibri"/>
+                        </a:rPr>
+                        <a:t>Alerta por inundación en Tenguel vinculada a la UA; afectación al servicio por confirmar.</a:t>
+                      </a:r>
+                    </a:p>
+                  </a:txBody>
+                  <a:tcPr marL="73152" marR="73152" marT="27432" marB="27432" anchor="ctr">
+                    <a:solidFill>
+                      <a:srgbClr val="F7F5FA"/>
+                    </a:solidFill>
+                  </a:tcPr>
+                </a:tc>
+                <a:tc>
+                  <a:txBody>
+                    <a:bodyPr wrap="square"/>
+                    <a:lstStyle/>
+                    <a:p>
+                      <a:pPr algn="l"/>
+                      <a:r>
+                        <a:rPr sz="900" b="0">
+                          <a:solidFill>
+                            <a:srgbClr val="20202B"/>
+                          </a:solidFill>
+                          <a:latin typeface="Calibri"/>
+                        </a:rPr>
+                        <a:t>Pendiente</a:t>
+                      </a:r>
+                    </a:p>
+                  </a:txBody>
+                  <a:tcPr marL="73152" marR="73152" marT="27432" marB="27432" anchor="ctr">
+                    <a:solidFill>
+                      <a:srgbClr val="F7F5FA"/>
+                    </a:solidFill>
+                  </a:tcPr>
+                </a:tc>
+              </a:tr>
+              <a:tr h="594360">
+                <a:tc>
+                  <a:txBody>
+                    <a:bodyPr wrap="square"/>
+                    <a:lstStyle/>
+                    <a:p>
+                      <a:pPr algn="l"/>
+                      <a:r>
+                        <a:rPr sz="900" b="1">
+                          <a:solidFill>
+                            <a:srgbClr val="2B164F"/>
+                          </a:solidFill>
+                          <a:latin typeface="Calibri"/>
+                        </a:rPr>
+                        <a:t>ALT-2026-000315
+19/10/2026</a:t>
+                      </a:r>
+                    </a:p>
+                  </a:txBody>
+                  <a:tcPr marL="73152" marR="73152" marT="27432" marB="27432" anchor="ctr">
+                    <a:solidFill>
+                      <a:srgbClr val="FFFFFF"/>
+                    </a:solidFill>
+                  </a:tcPr>
+                </a:tc>
+                <a:tc>
+                  <a:txBody>
+                    <a:bodyPr wrap="square"/>
+                    <a:lstStyle/>
+                    <a:p>
+                      <a:pPr algn="l"/>
+                      <a:r>
+                        <a:rPr sz="900" b="0">
+                          <a:solidFill>
+                            <a:srgbClr val="20202B"/>
+                          </a:solidFill>
+                          <a:latin typeface="Calibri"/>
+                        </a:rPr>
+                        <a:t>CDI Los Niños del Cisne
+UA 58336 · Desarrollo Infantil</a:t>
+                      </a:r>
+                    </a:p>
+                  </a:txBody>
+                  <a:tcPr marL="73152" marR="73152" marT="27432" marB="27432" anchor="ctr">
+                    <a:solidFill>
+                      <a:srgbClr val="FFFFFF"/>
+                    </a:solidFill>
+                  </a:tcPr>
+                </a:tc>
+                <a:tc>
+                  <a:txBody>
+                    <a:bodyPr wrap="square"/>
+                    <a:lstStyle/>
+                    <a:p>
+                      <a:pPr algn="l"/>
+                      <a:r>
+                        <a:rPr sz="900" b="0">
+                          <a:solidFill>
+                            <a:srgbClr val="20202B"/>
+                          </a:solidFill>
+                          <a:latin typeface="Calibri"/>
+                        </a:rPr>
+                        <a:t>Guayas
+Guayaquil</a:t>
+                      </a:r>
+                    </a:p>
+                  </a:txBody>
+                  <a:tcPr marL="73152" marR="73152" marT="27432" marB="27432" anchor="ctr">
+                    <a:solidFill>
+                      <a:srgbClr val="FFFFFF"/>
+                    </a:solidFill>
+                  </a:tcPr>
+                </a:tc>
+                <a:tc>
+                  <a:txBody>
+                    <a:bodyPr wrap="square"/>
+                    <a:lstStyle/>
+                    <a:p>
+                      <a:pPr algn="l"/>
+                      <a:r>
+                        <a:rPr sz="900" b="0">
+                          <a:solidFill>
+                            <a:srgbClr val="20202B"/>
+                          </a:solidFill>
+                          <a:latin typeface="Calibri"/>
+                        </a:rPr>
+                        <a:t>Alerta por inundación en Tenguel vinculada a la UA; afectación al servicio por confirmar.</a:t>
+                      </a:r>
+                    </a:p>
+                  </a:txBody>
+                  <a:tcPr marL="73152" marR="73152" marT="27432" marB="27432" anchor="ctr">
+                    <a:solidFill>
+                      <a:srgbClr val="FFFFFF"/>
+                    </a:solidFill>
+                  </a:tcPr>
+                </a:tc>
+                <a:tc>
+                  <a:txBody>
+                    <a:bodyPr wrap="square"/>
+                    <a:lstStyle/>
+                    <a:p>
+                      <a:pPr algn="l"/>
+                      <a:r>
+                        <a:rPr sz="900" b="0">
+                          <a:solidFill>
+                            <a:srgbClr val="20202B"/>
+                          </a:solidFill>
+                          <a:latin typeface="Calibri"/>
+                        </a:rPr>
+                        <a:t>Pendiente</a:t>
+                      </a:r>
+                    </a:p>
+                  </a:txBody>
+                  <a:tcPr marL="73152" marR="73152" marT="27432" marB="27432" anchor="ctr">
+                    <a:solidFill>
+                      <a:srgbClr val="FFFFFF"/>
+                    </a:solidFill>
+                  </a:tcPr>
+                </a:tc>
+              </a:tr>
+              <a:tr h="594360">
+                <a:tc>
+                  <a:txBody>
+                    <a:bodyPr wrap="square"/>
+                    <a:lstStyle/>
+                    <a:p>
+                      <a:pPr algn="l"/>
+                      <a:r>
+                        <a:rPr sz="900" b="1">
+                          <a:solidFill>
+                            <a:srgbClr val="2B164F"/>
+                          </a:solidFill>
+                          <a:latin typeface="Calibri"/>
+                        </a:rPr>
+                        <a:t>ALT-2026-000310
+16/10/2026</a:t>
+                      </a:r>
+                    </a:p>
+                  </a:txBody>
+                  <a:tcPr marL="73152" marR="73152" marT="27432" marB="27432" anchor="ctr">
+                    <a:solidFill>
+                      <a:srgbClr val="F7F5FA"/>
+                    </a:solidFill>
+                  </a:tcPr>
+                </a:tc>
+                <a:tc>
+                  <a:txBody>
+                    <a:bodyPr wrap="square"/>
+                    <a:lstStyle/>
+                    <a:p>
+                      <a:pPr algn="l"/>
+                      <a:r>
+                        <a:rPr sz="900" b="0">
+                          <a:solidFill>
+                            <a:srgbClr val="20202B"/>
+                          </a:solidFill>
+                          <a:latin typeface="Calibri"/>
+                        </a:rPr>
+                        <a:t>CNH Estrellitas del Amanecer
+UA 56744 · Creciendo con Nuestros Hijos (CNH)</a:t>
+                      </a:r>
+                    </a:p>
+                  </a:txBody>
+                  <a:tcPr marL="73152" marR="73152" marT="27432" marB="27432" anchor="ctr">
+                    <a:solidFill>
+                      <a:srgbClr val="F7F5FA"/>
+                    </a:solidFill>
+                  </a:tcPr>
+                </a:tc>
+                <a:tc>
+                  <a:txBody>
+                    <a:bodyPr wrap="square"/>
+                    <a:lstStyle/>
+                    <a:p>
+                      <a:pPr algn="l"/>
+                      <a:r>
+                        <a:rPr sz="900" b="0">
+                          <a:solidFill>
+                            <a:srgbClr val="20202B"/>
+                          </a:solidFill>
+                          <a:latin typeface="Calibri"/>
+                        </a:rPr>
+                        <a:t>Manabí
+Flavio Alfaro</a:t>
+                      </a:r>
+                    </a:p>
+                  </a:txBody>
+                  <a:tcPr marL="73152" marR="73152" marT="27432" marB="27432" anchor="ctr">
+                    <a:solidFill>
+                      <a:srgbClr val="F7F5FA"/>
+                    </a:solidFill>
+                  </a:tcPr>
+                </a:tc>
+                <a:tc>
+                  <a:txBody>
+                    <a:bodyPr wrap="square"/>
+                    <a:lstStyle/>
+                    <a:p>
+                      <a:pPr algn="l"/>
+                      <a:r>
+                        <a:rPr sz="900" b="0">
+                          <a:solidFill>
+                            <a:srgbClr val="20202B"/>
+                          </a:solidFill>
+                          <a:latin typeface="Calibri"/>
+                        </a:rPr>
+                        <a:t>Acceso impedido para atención presencial; contacto telefónico temporal</a:t>
+                      </a:r>
+                    </a:p>
+                  </a:txBody>
+                  <a:tcPr marL="73152" marR="73152" marT="27432" marB="27432" anchor="ctr">
+                    <a:solidFill>
+                      <a:srgbClr val="F7F5FA"/>
+                    </a:solidFill>
+                  </a:tcPr>
+                </a:tc>
+                <a:tc>
+                  <a:txBody>
+                    <a:bodyPr wrap="square"/>
+                    <a:lstStyle/>
+                    <a:p>
+                      <a:pPr algn="l"/>
+                      <a:r>
+                        <a:rPr sz="900" b="0">
+                          <a:solidFill>
+                            <a:srgbClr val="20202B"/>
+                          </a:solidFill>
+                          <a:latin typeface="Calibri"/>
+                        </a:rPr>
+                        <a:t>Pendiente</a:t>
+                      </a:r>
+                    </a:p>
+                  </a:txBody>
+                  <a:tcPr marL="73152" marR="73152" marT="27432" marB="27432" anchor="ctr">
+                    <a:solidFill>
+                      <a:srgbClr val="F7F5FA"/>
+                    </a:solidFill>
+                  </a:tcPr>
+                </a:tc>
+              </a:tr>
+              <a:tr h="594360">
+                <a:tc>
+                  <a:txBody>
+                    <a:bodyPr wrap="square"/>
+                    <a:lstStyle/>
+                    <a:p>
+                      <a:pPr algn="l"/>
+                      <a:r>
+                        <a:rPr sz="900" b="1">
+                          <a:solidFill>
+                            <a:srgbClr val="2B164F"/>
+                          </a:solidFill>
+                          <a:latin typeface="Calibri"/>
+                        </a:rPr>
                         <a:t>ALT-2026-000309
 16/10/2026</a:t>
                       </a:r>
@@ -13753,726 +14473,6 @@
                           <a:latin typeface="Calibri"/>
                         </a:rPr>
                         <a:t>Pendiente</a:t>
-                      </a:r>
-                    </a:p>
-                  </a:txBody>
-                  <a:tcPr marL="73152" marR="73152" marT="27432" marB="27432" anchor="ctr">
-                    <a:solidFill>
-                      <a:srgbClr val="FFFFFF"/>
-                    </a:solidFill>
-                  </a:tcPr>
-                </a:tc>
-              </a:tr>
-              <a:tr h="594360">
-                <a:tc>
-                  <a:txBody>
-                    <a:bodyPr wrap="square"/>
-                    <a:lstStyle/>
-                    <a:p>
-                      <a:pPr algn="l"/>
-                      <a:r>
-                        <a:rPr sz="900" b="1">
-                          <a:solidFill>
-                            <a:srgbClr val="2B164F"/>
-                          </a:solidFill>
-                          <a:latin typeface="Calibri"/>
-                        </a:rPr>
-                        <a:t>GER-2026-006
-Agosto 2026 (sin día)</a:t>
-                      </a:r>
-                    </a:p>
-                  </a:txBody>
-                  <a:tcPr marL="73152" marR="73152" marT="27432" marB="27432" anchor="ctr">
-                    <a:solidFill>
-                      <a:srgbClr val="F7F5FA"/>
-                    </a:solidFill>
-                  </a:tcPr>
-                </a:tc>
-                <a:tc>
-                  <a:txBody>
-                    <a:bodyPr wrap="square"/>
-                    <a:lstStyle/>
-                    <a:p>
-                      <a:pPr algn="l"/>
-                      <a:r>
-                        <a:rPr sz="900" b="0">
-                          <a:solidFill>
-                            <a:srgbClr val="20202B"/>
-                          </a:solidFill>
-                          <a:latin typeface="Calibri"/>
-                        </a:rPr>
-                        <a:t>—
-Centros gerontológicos</a:t>
-                      </a:r>
-                    </a:p>
-                  </a:txBody>
-                  <a:tcPr marL="73152" marR="73152" marT="27432" marB="27432" anchor="ctr">
-                    <a:solidFill>
-                      <a:srgbClr val="F7F5FA"/>
-                    </a:solidFill>
-                  </a:tcPr>
-                </a:tc>
-                <a:tc>
-                  <a:txBody>
-                    <a:bodyPr wrap="square"/>
-                    <a:lstStyle/>
-                    <a:p>
-                      <a:pPr algn="l"/>
-                      <a:r>
-                        <a:rPr sz="900" b="0">
-                          <a:solidFill>
-                            <a:srgbClr val="20202B"/>
-                          </a:solidFill>
-                          <a:latin typeface="Calibri"/>
-                        </a:rPr>
-                        <a:t>Santo Domingo de los Tsáchilas
-Santo Domingo</a:t>
-                      </a:r>
-                    </a:p>
-                  </a:txBody>
-                  <a:tcPr marL="73152" marR="73152" marT="27432" marB="27432" anchor="ctr">
-                    <a:solidFill>
-                      <a:srgbClr val="F7F5FA"/>
-                    </a:solidFill>
-                  </a:tcPr>
-                </a:tc>
-                <a:tc>
-                  <a:txBody>
-                    <a:bodyPr wrap="square"/>
-                    <a:lstStyle/>
-                    <a:p>
-                      <a:pPr algn="l"/>
-                      <a:r>
-                        <a:rPr sz="900" b="0">
-                          <a:solidFill>
-                            <a:srgbClr val="20202B"/>
-                          </a:solidFill>
-                          <a:latin typeface="Calibri"/>
-                        </a:rPr>
-                        <a:t>Filtraciones y humedad; mitigación inmediata. Servicio operativo.</a:t>
-                      </a:r>
-                    </a:p>
-                  </a:txBody>
-                  <a:tcPr marL="73152" marR="73152" marT="27432" marB="27432" anchor="ctr">
-                    <a:solidFill>
-                      <a:srgbClr val="F7F5FA"/>
-                    </a:solidFill>
-                  </a:tcPr>
-                </a:tc>
-                <a:tc>
-                  <a:txBody>
-                    <a:bodyPr wrap="square"/>
-                    <a:lstStyle/>
-                    <a:p>
-                      <a:pPr algn="l"/>
-                      <a:r>
-                        <a:rPr sz="900" b="0">
-                          <a:solidFill>
-                            <a:srgbClr val="20202B"/>
-                          </a:solidFill>
-                          <a:latin typeface="Calibri"/>
-                        </a:rPr>
-                        <a:t>En seguimiento</a:t>
-                      </a:r>
-                    </a:p>
-                  </a:txBody>
-                  <a:tcPr marL="73152" marR="73152" marT="27432" marB="27432" anchor="ctr">
-                    <a:solidFill>
-                      <a:srgbClr val="F7F5FA"/>
-                    </a:solidFill>
-                  </a:tcPr>
-                </a:tc>
-              </a:tr>
-              <a:tr h="594360">
-                <a:tc>
-                  <a:txBody>
-                    <a:bodyPr wrap="square"/>
-                    <a:lstStyle/>
-                    <a:p>
-                      <a:pPr algn="l"/>
-                      <a:r>
-                        <a:rPr sz="900" b="1">
-                          <a:solidFill>
-                            <a:srgbClr val="2B164F"/>
-                          </a:solidFill>
-                          <a:latin typeface="Calibri"/>
-                        </a:rPr>
-                        <a:t>GER-2026-005
-Agosto 2026 (sin día)</a:t>
-                      </a:r>
-                    </a:p>
-                  </a:txBody>
-                  <a:tcPr marL="73152" marR="73152" marT="27432" marB="27432" anchor="ctr">
-                    <a:solidFill>
-                      <a:srgbClr val="FFFFFF"/>
-                    </a:solidFill>
-                  </a:tcPr>
-                </a:tc>
-                <a:tc>
-                  <a:txBody>
-                    <a:bodyPr wrap="square"/>
-                    <a:lstStyle/>
-                    <a:p>
-                      <a:pPr algn="l"/>
-                      <a:r>
-                        <a:rPr sz="900" b="0">
-                          <a:solidFill>
-                            <a:srgbClr val="20202B"/>
-                          </a:solidFill>
-                          <a:latin typeface="Calibri"/>
-                        </a:rPr>
-                        <a:t>—
-Centros gerontológicos</a:t>
-                      </a:r>
-                    </a:p>
-                  </a:txBody>
-                  <a:tcPr marL="73152" marR="73152" marT="27432" marB="27432" anchor="ctr">
-                    <a:solidFill>
-                      <a:srgbClr val="FFFFFF"/>
-                    </a:solidFill>
-                  </a:tcPr>
-                </a:tc>
-                <a:tc>
-                  <a:txBody>
-                    <a:bodyPr wrap="square"/>
-                    <a:lstStyle/>
-                    <a:p>
-                      <a:pPr algn="l"/>
-                      <a:r>
-                        <a:rPr sz="900" b="0">
-                          <a:solidFill>
-                            <a:srgbClr val="20202B"/>
-                          </a:solidFill>
-                          <a:latin typeface="Calibri"/>
-                        </a:rPr>
-                        <a:t>Manabí
-Pedernales</a:t>
-                      </a:r>
-                    </a:p>
-                  </a:txBody>
-                  <a:tcPr marL="73152" marR="73152" marT="27432" marB="27432" anchor="ctr">
-                    <a:solidFill>
-                      <a:srgbClr val="FFFFFF"/>
-                    </a:solidFill>
-                  </a:tcPr>
-                </a:tc>
-                <a:tc>
-                  <a:txBody>
-                    <a:bodyPr wrap="square"/>
-                    <a:lstStyle/>
-                    <a:p>
-                      <a:pPr algn="l"/>
-                      <a:r>
-                        <a:rPr sz="900" b="0">
-                          <a:solidFill>
-                            <a:srgbClr val="20202B"/>
-                          </a:solidFill>
-                          <a:latin typeface="Calibri"/>
-                        </a:rPr>
-                        <a:t>Filtraciones y humedad; medidas de contingencia. Servicio operativo.</a:t>
-                      </a:r>
-                    </a:p>
-                  </a:txBody>
-                  <a:tcPr marL="73152" marR="73152" marT="27432" marB="27432" anchor="ctr">
-                    <a:solidFill>
-                      <a:srgbClr val="FFFFFF"/>
-                    </a:solidFill>
-                  </a:tcPr>
-                </a:tc>
-                <a:tc>
-                  <a:txBody>
-                    <a:bodyPr wrap="square"/>
-                    <a:lstStyle/>
-                    <a:p>
-                      <a:pPr algn="l"/>
-                      <a:r>
-                        <a:rPr sz="900" b="0">
-                          <a:solidFill>
-                            <a:srgbClr val="20202B"/>
-                          </a:solidFill>
-                          <a:latin typeface="Calibri"/>
-                        </a:rPr>
-                        <a:t>En seguimiento</a:t>
-                      </a:r>
-                    </a:p>
-                  </a:txBody>
-                  <a:tcPr marL="73152" marR="73152" marT="27432" marB="27432" anchor="ctr">
-                    <a:solidFill>
-                      <a:srgbClr val="FFFFFF"/>
-                    </a:solidFill>
-                  </a:tcPr>
-                </a:tc>
-              </a:tr>
-              <a:tr h="594360">
-                <a:tc>
-                  <a:txBody>
-                    <a:bodyPr wrap="square"/>
-                    <a:lstStyle/>
-                    <a:p>
-                      <a:pPr algn="l"/>
-                      <a:r>
-                        <a:rPr sz="900" b="1">
-                          <a:solidFill>
-                            <a:srgbClr val="2B164F"/>
-                          </a:solidFill>
-                          <a:latin typeface="Calibri"/>
-                        </a:rPr>
-                        <a:t>GER-2026-004
-Agosto 2026 (sin día)</a:t>
-                      </a:r>
-                    </a:p>
-                  </a:txBody>
-                  <a:tcPr marL="73152" marR="73152" marT="27432" marB="27432" anchor="ctr">
-                    <a:solidFill>
-                      <a:srgbClr val="F7F5FA"/>
-                    </a:solidFill>
-                  </a:tcPr>
-                </a:tc>
-                <a:tc>
-                  <a:txBody>
-                    <a:bodyPr wrap="square"/>
-                    <a:lstStyle/>
-                    <a:p>
-                      <a:pPr algn="l"/>
-                      <a:r>
-                        <a:rPr sz="900" b="0">
-                          <a:solidFill>
-                            <a:srgbClr val="20202B"/>
-                          </a:solidFill>
-                          <a:latin typeface="Calibri"/>
-                        </a:rPr>
-                        <a:t>—
-Centros gerontológicos</a:t>
-                      </a:r>
-                    </a:p>
-                  </a:txBody>
-                  <a:tcPr marL="73152" marR="73152" marT="27432" marB="27432" anchor="ctr">
-                    <a:solidFill>
-                      <a:srgbClr val="F7F5FA"/>
-                    </a:solidFill>
-                  </a:tcPr>
-                </a:tc>
-                <a:tc>
-                  <a:txBody>
-                    <a:bodyPr wrap="square"/>
-                    <a:lstStyle/>
-                    <a:p>
-                      <a:pPr algn="l"/>
-                      <a:r>
-                        <a:rPr sz="900" b="0">
-                          <a:solidFill>
-                            <a:srgbClr val="20202B"/>
-                          </a:solidFill>
-                          <a:latin typeface="Calibri"/>
-                        </a:rPr>
-                        <a:t>Manabí
-Portoviejo</a:t>
-                      </a:r>
-                    </a:p>
-                  </a:txBody>
-                  <a:tcPr marL="73152" marR="73152" marT="27432" marB="27432" anchor="ctr">
-                    <a:solidFill>
-                      <a:srgbClr val="F7F5FA"/>
-                    </a:solidFill>
-                  </a:tcPr>
-                </a:tc>
-                <a:tc>
-                  <a:txBody>
-                    <a:bodyPr wrap="square"/>
-                    <a:lstStyle/>
-                    <a:p>
-                      <a:pPr algn="l"/>
-                      <a:r>
-                        <a:rPr sz="900" b="0">
-                          <a:solidFill>
-                            <a:srgbClr val="20202B"/>
-                          </a:solidFill>
-                          <a:latin typeface="Calibri"/>
-                        </a:rPr>
-                        <a:t>Filtraciones y humedad; adecuaciones provisionales. Servicio operativo.</a:t>
-                      </a:r>
-                    </a:p>
-                  </a:txBody>
-                  <a:tcPr marL="73152" marR="73152" marT="27432" marB="27432" anchor="ctr">
-                    <a:solidFill>
-                      <a:srgbClr val="F7F5FA"/>
-                    </a:solidFill>
-                  </a:tcPr>
-                </a:tc>
-                <a:tc>
-                  <a:txBody>
-                    <a:bodyPr wrap="square"/>
-                    <a:lstStyle/>
-                    <a:p>
-                      <a:pPr algn="l"/>
-                      <a:r>
-                        <a:rPr sz="900" b="0">
-                          <a:solidFill>
-                            <a:srgbClr val="20202B"/>
-                          </a:solidFill>
-                          <a:latin typeface="Calibri"/>
-                        </a:rPr>
-                        <a:t>En seguimiento</a:t>
-                      </a:r>
-                    </a:p>
-                  </a:txBody>
-                  <a:tcPr marL="73152" marR="73152" marT="27432" marB="27432" anchor="ctr">
-                    <a:solidFill>
-                      <a:srgbClr val="F7F5FA"/>
-                    </a:solidFill>
-                  </a:tcPr>
-                </a:tc>
-              </a:tr>
-              <a:tr h="594360">
-                <a:tc>
-                  <a:txBody>
-                    <a:bodyPr wrap="square"/>
-                    <a:lstStyle/>
-                    <a:p>
-                      <a:pPr algn="l"/>
-                      <a:r>
-                        <a:rPr sz="900" b="1">
-                          <a:solidFill>
-                            <a:srgbClr val="2B164F"/>
-                          </a:solidFill>
-                          <a:latin typeface="Calibri"/>
-                        </a:rPr>
-                        <a:t>GER-2026-003
-Agosto 2026 (sin día)</a:t>
-                      </a:r>
-                    </a:p>
-                  </a:txBody>
-                  <a:tcPr marL="73152" marR="73152" marT="27432" marB="27432" anchor="ctr">
-                    <a:solidFill>
-                      <a:srgbClr val="FFFFFF"/>
-                    </a:solidFill>
-                  </a:tcPr>
-                </a:tc>
-                <a:tc>
-                  <a:txBody>
-                    <a:bodyPr wrap="square"/>
-                    <a:lstStyle/>
-                    <a:p>
-                      <a:pPr algn="l"/>
-                      <a:r>
-                        <a:rPr sz="900" b="0">
-                          <a:solidFill>
-                            <a:srgbClr val="20202B"/>
-                          </a:solidFill>
-                          <a:latin typeface="Calibri"/>
-                        </a:rPr>
-                        <a:t>—
-Centros gerontológicos</a:t>
-                      </a:r>
-                    </a:p>
-                  </a:txBody>
-                  <a:tcPr marL="73152" marR="73152" marT="27432" marB="27432" anchor="ctr">
-                    <a:solidFill>
-                      <a:srgbClr val="FFFFFF"/>
-                    </a:solidFill>
-                  </a:tcPr>
-                </a:tc>
-                <a:tc>
-                  <a:txBody>
-                    <a:bodyPr wrap="square"/>
-                    <a:lstStyle/>
-                    <a:p>
-                      <a:pPr algn="l"/>
-                      <a:r>
-                        <a:rPr sz="900" b="0">
-                          <a:solidFill>
-                            <a:srgbClr val="20202B"/>
-                          </a:solidFill>
-                          <a:latin typeface="Calibri"/>
-                        </a:rPr>
-                        <a:t>Guayas
-Milagro</a:t>
-                      </a:r>
-                    </a:p>
-                  </a:txBody>
-                  <a:tcPr marL="73152" marR="73152" marT="27432" marB="27432" anchor="ctr">
-                    <a:solidFill>
-                      <a:srgbClr val="FFFFFF"/>
-                    </a:solidFill>
-                  </a:tcPr>
-                </a:tc>
-                <a:tc>
-                  <a:txBody>
-                    <a:bodyPr wrap="square"/>
-                    <a:lstStyle/>
-                    <a:p>
-                      <a:pPr algn="l"/>
-                      <a:r>
-                        <a:rPr sz="900" b="0">
-                          <a:solidFill>
-                            <a:srgbClr val="20202B"/>
-                          </a:solidFill>
-                          <a:latin typeface="Calibri"/>
-                        </a:rPr>
-                        <a:t>Filtraciones y humedad; medidas preventivas y correctivas. Servicio operativo.</a:t>
-                      </a:r>
-                    </a:p>
-                  </a:txBody>
-                  <a:tcPr marL="73152" marR="73152" marT="27432" marB="27432" anchor="ctr">
-                    <a:solidFill>
-                      <a:srgbClr val="FFFFFF"/>
-                    </a:solidFill>
-                  </a:tcPr>
-                </a:tc>
-                <a:tc>
-                  <a:txBody>
-                    <a:bodyPr wrap="square"/>
-                    <a:lstStyle/>
-                    <a:p>
-                      <a:pPr algn="l"/>
-                      <a:r>
-                        <a:rPr sz="900" b="0">
-                          <a:solidFill>
-                            <a:srgbClr val="20202B"/>
-                          </a:solidFill>
-                          <a:latin typeface="Calibri"/>
-                        </a:rPr>
-                        <a:t>En seguimiento</a:t>
-                      </a:r>
-                    </a:p>
-                  </a:txBody>
-                  <a:tcPr marL="73152" marR="73152" marT="27432" marB="27432" anchor="ctr">
-                    <a:solidFill>
-                      <a:srgbClr val="FFFFFF"/>
-                    </a:solidFill>
-                  </a:tcPr>
-                </a:tc>
-              </a:tr>
-              <a:tr h="594360">
-                <a:tc>
-                  <a:txBody>
-                    <a:bodyPr wrap="square"/>
-                    <a:lstStyle/>
-                    <a:p>
-                      <a:pPr algn="l"/>
-                      <a:r>
-                        <a:rPr sz="900" b="1">
-                          <a:solidFill>
-                            <a:srgbClr val="2B164F"/>
-                          </a:solidFill>
-                          <a:latin typeface="Calibri"/>
-                        </a:rPr>
-                        <a:t>GER-2026-002
-Agosto 2026 (sin día)</a:t>
-                      </a:r>
-                    </a:p>
-                  </a:txBody>
-                  <a:tcPr marL="73152" marR="73152" marT="27432" marB="27432" anchor="ctr">
-                    <a:solidFill>
-                      <a:srgbClr val="F7F5FA"/>
-                    </a:solidFill>
-                  </a:tcPr>
-                </a:tc>
-                <a:tc>
-                  <a:txBody>
-                    <a:bodyPr wrap="square"/>
-                    <a:lstStyle/>
-                    <a:p>
-                      <a:pPr algn="l"/>
-                      <a:r>
-                        <a:rPr sz="900" b="0">
-                          <a:solidFill>
-                            <a:srgbClr val="20202B"/>
-                          </a:solidFill>
-                          <a:latin typeface="Calibri"/>
-                        </a:rPr>
-                        <a:t>—
-Centros gerontológicos</a:t>
-                      </a:r>
-                    </a:p>
-                  </a:txBody>
-                  <a:tcPr marL="73152" marR="73152" marT="27432" marB="27432" anchor="ctr">
-                    <a:solidFill>
-                      <a:srgbClr val="F7F5FA"/>
-                    </a:solidFill>
-                  </a:tcPr>
-                </a:tc>
-                <a:tc>
-                  <a:txBody>
-                    <a:bodyPr wrap="square"/>
-                    <a:lstStyle/>
-                    <a:p>
-                      <a:pPr algn="l"/>
-                      <a:r>
-                        <a:rPr sz="900" b="0">
-                          <a:solidFill>
-                            <a:srgbClr val="20202B"/>
-                          </a:solidFill>
-                          <a:latin typeface="Calibri"/>
-                        </a:rPr>
-                        <a:t>Esmeraldas
-San Lorenzo</a:t>
-                      </a:r>
-                    </a:p>
-                  </a:txBody>
-                  <a:tcPr marL="73152" marR="73152" marT="27432" marB="27432" anchor="ctr">
-                    <a:solidFill>
-                      <a:srgbClr val="F7F5FA"/>
-                    </a:solidFill>
-                  </a:tcPr>
-                </a:tc>
-                <a:tc>
-                  <a:txBody>
-                    <a:bodyPr wrap="square"/>
-                    <a:lstStyle/>
-                    <a:p>
-                      <a:pPr algn="l"/>
-                      <a:r>
-                        <a:rPr sz="900" b="0">
-                          <a:solidFill>
-                            <a:srgbClr val="20202B"/>
-                          </a:solidFill>
-                          <a:latin typeface="Calibri"/>
-                        </a:rPr>
-                        <a:t>Filtraciones y humedad; intervención emergente. Servicio operativo.</a:t>
-                      </a:r>
-                    </a:p>
-                  </a:txBody>
-                  <a:tcPr marL="73152" marR="73152" marT="27432" marB="27432" anchor="ctr">
-                    <a:solidFill>
-                      <a:srgbClr val="F7F5FA"/>
-                    </a:solidFill>
-                  </a:tcPr>
-                </a:tc>
-                <a:tc>
-                  <a:txBody>
-                    <a:bodyPr wrap="square"/>
-                    <a:lstStyle/>
-                    <a:p>
-                      <a:pPr algn="l"/>
-                      <a:r>
-                        <a:rPr sz="900" b="0">
-                          <a:solidFill>
-                            <a:srgbClr val="20202B"/>
-                          </a:solidFill>
-                          <a:latin typeface="Calibri"/>
-                        </a:rPr>
-                        <a:t>En seguimiento</a:t>
-                      </a:r>
-                    </a:p>
-                  </a:txBody>
-                  <a:tcPr marL="73152" marR="73152" marT="27432" marB="27432" anchor="ctr">
-                    <a:solidFill>
-                      <a:srgbClr val="F7F5FA"/>
-                    </a:solidFill>
-                  </a:tcPr>
-                </a:tc>
-              </a:tr>
-              <a:tr h="594360">
-                <a:tc>
-                  <a:txBody>
-                    <a:bodyPr wrap="square"/>
-                    <a:lstStyle/>
-                    <a:p>
-                      <a:pPr algn="l"/>
-                      <a:r>
-                        <a:rPr sz="900" b="1">
-                          <a:solidFill>
-                            <a:srgbClr val="2B164F"/>
-                          </a:solidFill>
-                          <a:latin typeface="Calibri"/>
-                        </a:rPr>
-                        <a:t>GER-2026-001
-Agosto 2026 (sin día)</a:t>
-                      </a:r>
-                    </a:p>
-                  </a:txBody>
-                  <a:tcPr marL="73152" marR="73152" marT="27432" marB="27432" anchor="ctr">
-                    <a:solidFill>
-                      <a:srgbClr val="FFFFFF"/>
-                    </a:solidFill>
-                  </a:tcPr>
-                </a:tc>
-                <a:tc>
-                  <a:txBody>
-                    <a:bodyPr wrap="square"/>
-                    <a:lstStyle/>
-                    <a:p>
-                      <a:pPr algn="l"/>
-                      <a:r>
-                        <a:rPr sz="900" b="0">
-                          <a:solidFill>
-                            <a:srgbClr val="20202B"/>
-                          </a:solidFill>
-                          <a:latin typeface="Calibri"/>
-                        </a:rPr>
-                        <a:t>—
-Centros gerontológicos</a:t>
-                      </a:r>
-                    </a:p>
-                  </a:txBody>
-                  <a:tcPr marL="73152" marR="73152" marT="27432" marB="27432" anchor="ctr">
-                    <a:solidFill>
-                      <a:srgbClr val="FFFFFF"/>
-                    </a:solidFill>
-                  </a:tcPr>
-                </a:tc>
-                <a:tc>
-                  <a:txBody>
-                    <a:bodyPr wrap="square"/>
-                    <a:lstStyle/>
-                    <a:p>
-                      <a:pPr algn="l"/>
-                      <a:r>
-                        <a:rPr sz="900" b="0">
-                          <a:solidFill>
-                            <a:srgbClr val="20202B"/>
-                          </a:solidFill>
-                          <a:latin typeface="Calibri"/>
-                        </a:rPr>
-                        <a:t>El Oro
-Huaquillas</a:t>
-                      </a:r>
-                    </a:p>
-                  </a:txBody>
-                  <a:tcPr marL="73152" marR="73152" marT="27432" marB="27432" anchor="ctr">
-                    <a:solidFill>
-                      <a:srgbClr val="FFFFFF"/>
-                    </a:solidFill>
-                  </a:tcPr>
-                </a:tc>
-                <a:tc>
-                  <a:txBody>
-                    <a:bodyPr wrap="square"/>
-                    <a:lstStyle/>
-                    <a:p>
-                      <a:pPr algn="l"/>
-                      <a:r>
-                        <a:rPr sz="900" b="0">
-                          <a:solidFill>
-                            <a:srgbClr val="20202B"/>
-                          </a:solidFill>
-                          <a:latin typeface="Calibri"/>
-                        </a:rPr>
-                        <a:t>Filtraciones en techo y daños en patio; mitigación temporal. Servicio operativo.</a:t>
-                      </a:r>
-                    </a:p>
-                  </a:txBody>
-                  <a:tcPr marL="73152" marR="73152" marT="27432" marB="27432" anchor="ctr">
-                    <a:solidFill>
-                      <a:srgbClr val="FFFFFF"/>
-                    </a:solidFill>
-                  </a:tcPr>
-                </a:tc>
-                <a:tc>
-                  <a:txBody>
-                    <a:bodyPr wrap="square"/>
-                    <a:lstStyle/>
-                    <a:p>
-                      <a:pPr algn="l"/>
-                      <a:r>
-                        <a:rPr sz="900" b="0">
-                          <a:solidFill>
-                            <a:srgbClr val="20202B"/>
-                          </a:solidFill>
-                          <a:latin typeface="Calibri"/>
-                        </a:rPr>
-                        <a:t>En seguimiento</a:t>
                       </a:r>
                     </a:p>
                   </a:txBody>
@@ -19747,7 +19747,7 @@
         <p:spPr>
           <a:xfrm>
             <a:off x="457200" y="1783080"/>
-            <a:ext cx="3657600" cy="4201160"/>
+            <a:ext cx="3657600" cy="4206240"/>
           </a:xfrm>
           <a:prstGeom prst="rect">
             <a:avLst/>
@@ -19806,7 +19806,7 @@
         <p:spPr>
           <a:xfrm>
             <a:off x="4251960" y="1783080"/>
-            <a:ext cx="3657600" cy="4201160"/>
+            <a:ext cx="3657600" cy="4206240"/>
           </a:xfrm>
           <a:prstGeom prst="rect">
             <a:avLst/>
@@ -19865,7 +19865,7 @@
         <p:spPr>
           <a:xfrm>
             <a:off x="8046720" y="1783080"/>
-            <a:ext cx="3657600" cy="4201160"/>
+            <a:ext cx="3657600" cy="4206240"/>
           </a:xfrm>
           <a:prstGeom prst="rect">
             <a:avLst/>
@@ -20156,7 +20156,7 @@
                 </a:solidFill>
                 <a:latin typeface="Calibri"/>
               </a:rPr>
-              <a:t>Seguimiento desde el 14/09/2026, complementado con reportes sectoriales de octubre: 10 alertas con código UA y 11 reportes sectoriales. Los 6 reportes gerontológicos describen sucesos de agosto sin día exacto; no se asignan a la evolución diaria. Los identificadores DIS/GER permiten localizar las filas incorporadas, no son códigos oficiales ni códigos UA. Las fuentes sectoriales indican que la prestación del servicio se mantiene. Alertas, unidades y personas son medidas distintas.</a:t>
+              <a:t>Seguimiento desde el 14/09/2026, complementado con reportes sectoriales de octubre: 10 alertas con código UA y 11 reportes sectoriales. Los 6 reportes gerontológicos se incorporan con fecha de reporte 26/10/2026. Los identificadores DIS/GER permiten localizar las filas incorporadas, no son códigos oficiales ni códigos UA. Las fuentes sectoriales indican que la prestación del servicio se mantiene. Alertas, unidades y personas son medidas distintas.</a:t>
             </a:r>
           </a:p>
           <a:p>

</xml_diff>

<commit_message>
Nombrar los servicios de continuidad sin siglas en Riesgos
- PAM, PCD, PE y AF se leen como Personas Adultas Mayores, Personas con Discapacidad, Protección
  Especial y Acompañamiento Familiar en el resumen, el tablero, la presentación y el libro; CNH y CDI
  conservan la forma del boletín aprobado.
- Resumen: leyenda de la banda en dos líneas y columna Servicio del detalle con espacio para el nombre.
- Tablero: la cifra de unidades suspendidas resume «67 CNH · 37 CDI · 39 en otros servicios» y el
  mosaico parte los nombres largos para conservar sus etiquetas.

Co-Authored-By: Claude Opus 5.5 <noreply@anthropic.com>
Claude-Session: https://claude.ai/code/session_01AUCWMWZ6GMzdHUXxvK5iGa
</commit_message>
<xml_diff>
--- a/docs/reportes/Seguimiento_ENOS_2026-10-26.pptx
+++ b/docs/reportes/Seguimiento_ENOS_2026-10-26.pptx
@@ -239,16 +239,16 @@
                   <c:v>CDI · 37 UA (25,9 %)</c:v>
                 </c:pt>
                 <c:pt idx="2">
-                  <c:v>PAM · 18 UA (12,6 %)</c:v>
+                  <c:v>Personas Adultas Mayores · 18 UA (12,6 %)</c:v>
                 </c:pt>
                 <c:pt idx="3">
-                  <c:v>PCD · 12 UA (8,4 %)</c:v>
+                  <c:v>Personas con Discapacidad · 12 UA (8,4 %)</c:v>
                 </c:pt>
                 <c:pt idx="4">
-                  <c:v>PE · 7 UA (4,9 %)</c:v>
+                  <c:v>Protección Especial · 7 UA (4,9 %)</c:v>
                 </c:pt>
                 <c:pt idx="5">
-                  <c:v>AF · 2 UA (1,4 %)</c:v>
+                  <c:v>Acompañamiento Familiar · 2 UA (1,4 %)</c:v>
                 </c:pt>
               </c:strCache>
             </c:strRef>
@@ -1347,7 +1347,7 @@
           <a:lstStyle/>
           <a:p>
             <a:r>
-              <a:t>Alertas reportadas: 21. Kits entregados: 13.981. Personas · Bono de Contingencia: 1.169. Monto · Bono de Contingencia: USD 354.379,41. Unidades cerradas / suspendidas: 143. 143 unidades de atención con atención suspendida (67 CNH · 37 CDI · 18 PAM · 12 PCD · 7 PE · 2 AF); El Oro concentra 119 (83,2 %).</a:t>
+              <a:t>Alertas reportadas: 21. Kits entregados: 13.981. Personas · Bono de Contingencia: 1.169. Monto · Bono de Contingencia: USD 354.379,41. Unidades cerradas / suspendidas: 143. 143 unidades de atención con atención suspendida (67 CNH · 37 CDI · 18 Personas Adultas Mayores · 12 Personas con Discapacidad · 7 Protección Especial · 2 Acompañamiento Familiar); El Oro concentra 119 (83,2 %).</a:t>
             </a:r>
           </a:p>
         </p:txBody>
@@ -7271,8 +7271,8 @@
               <a:tblGrid>
                 <a:gridCol w="1371600"/>
                 <a:gridCol w="1463040"/>
-                <a:gridCol w="685800"/>
-                <a:gridCol w="7680960"/>
+                <a:gridCol w="1920240"/>
+                <a:gridCol w="6446520"/>
               </a:tblGrid>
               <a:tr h="365760">
                 <a:tc>
@@ -7992,7 +7992,7 @@
                           </a:solidFill>
                           <a:latin typeface="Calibri"/>
                         </a:rPr>
-                        <a:t>PAM</a:t>
+                        <a:t>Personas Adultas Mayores</a:t>
                       </a:r>
                     </a:p>
                   </a:txBody>
@@ -8180,7 +8180,7 @@
                           </a:solidFill>
                           <a:latin typeface="Calibri"/>
                         </a:rPr>
-                        <a:t>PAM</a:t>
+                        <a:t>Personas Adultas Mayores</a:t>
                       </a:r>
                     </a:p>
                   </a:txBody>
@@ -8274,7 +8274,7 @@
                           </a:solidFill>
                           <a:latin typeface="Calibri"/>
                         </a:rPr>
-                        <a:t>AF</a:t>
+                        <a:t>Acompañamiento Familiar</a:t>
                       </a:r>
                     </a:p>
                   </a:txBody>
@@ -8368,7 +8368,7 @@
                           </a:solidFill>
                           <a:latin typeface="Calibri"/>
                         </a:rPr>
-                        <a:t>PAM</a:t>
+                        <a:t>Personas Adultas Mayores</a:t>
                       </a:r>
                     </a:p>
                   </a:txBody>
@@ -21107,8 +21107,8 @@
               <a:tblGrid>
                 <a:gridCol w="1371600"/>
                 <a:gridCol w="1463040"/>
-                <a:gridCol w="685800"/>
-                <a:gridCol w="7680960"/>
+                <a:gridCol w="1920240"/>
+                <a:gridCol w="6446520"/>
               </a:tblGrid>
               <a:tr h="365760">
                 <a:tc>
@@ -23171,8 +23171,8 @@
               <a:tblGrid>
                 <a:gridCol w="1371600"/>
                 <a:gridCol w="1463040"/>
-                <a:gridCol w="685800"/>
-                <a:gridCol w="7680960"/>
+                <a:gridCol w="1920240"/>
+                <a:gridCol w="6446520"/>
               </a:tblGrid>
               <a:tr h="365760">
                 <a:tc>
@@ -23892,7 +23892,7 @@
                           </a:solidFill>
                           <a:latin typeface="Calibri"/>
                         </a:rPr>
-                        <a:t>PCD</a:t>
+                        <a:t>Personas con Discapacidad</a:t>
                       </a:r>
                     </a:p>
                   </a:txBody>
@@ -23986,7 +23986,7 @@
                           </a:solidFill>
                           <a:latin typeface="Calibri"/>
                         </a:rPr>
-                        <a:t>PCD</a:t>
+                        <a:t>Personas con Discapacidad</a:t>
                       </a:r>
                     </a:p>
                   </a:txBody>
@@ -24080,7 +24080,7 @@
                           </a:solidFill>
                           <a:latin typeface="Calibri"/>
                         </a:rPr>
-                        <a:t>PAM</a:t>
+                        <a:t>Personas Adultas Mayores</a:t>
                       </a:r>
                     </a:p>
                   </a:txBody>
@@ -24174,7 +24174,7 @@
                           </a:solidFill>
                           <a:latin typeface="Calibri"/>
                         </a:rPr>
-                        <a:t>PCD</a:t>
+                        <a:t>Personas con Discapacidad</a:t>
                       </a:r>
                     </a:p>
                   </a:txBody>
@@ -25235,8 +25235,8 @@
               <a:tblGrid>
                 <a:gridCol w="1371600"/>
                 <a:gridCol w="1463040"/>
-                <a:gridCol w="685800"/>
-                <a:gridCol w="7680960"/>
+                <a:gridCol w="1920240"/>
+                <a:gridCol w="6446520"/>
               </a:tblGrid>
               <a:tr h="365760">
                 <a:tc>
@@ -26238,7 +26238,7 @@
                           </a:solidFill>
                           <a:latin typeface="Calibri"/>
                         </a:rPr>
-                        <a:t>PAM</a:t>
+                        <a:t>Personas Adultas Mayores</a:t>
                       </a:r>
                     </a:p>
                   </a:txBody>
@@ -26332,7 +26332,7 @@
                           </a:solidFill>
                           <a:latin typeface="Calibri"/>
                         </a:rPr>
-                        <a:t>PAM</a:t>
+                        <a:t>Personas Adultas Mayores</a:t>
                       </a:r>
                     </a:p>
                   </a:txBody>
@@ -26426,7 +26426,7 @@
                           </a:solidFill>
                           <a:latin typeface="Calibri"/>
                         </a:rPr>
-                        <a:t>PCD</a:t>
+                        <a:t>Personas con Discapacidad</a:t>
                       </a:r>
                     </a:p>
                   </a:txBody>
@@ -26614,7 +26614,7 @@
                           </a:solidFill>
                           <a:latin typeface="Calibri"/>
                         </a:rPr>
-                        <a:t>PAM</a:t>
+                        <a:t>Personas Adultas Mayores</a:t>
                       </a:r>
                     </a:p>
                   </a:txBody>
@@ -26708,7 +26708,7 @@
                           </a:solidFill>
                           <a:latin typeface="Calibri"/>
                         </a:rPr>
-                        <a:t>PE</a:t>
+                        <a:t>Protección Especial</a:t>
                       </a:r>
                     </a:p>
                   </a:txBody>
@@ -26896,7 +26896,7 @@
                           </a:solidFill>
                           <a:latin typeface="Calibri"/>
                         </a:rPr>
-                        <a:t>PCD</a:t>
+                        <a:t>Personas con Discapacidad</a:t>
                       </a:r>
                     </a:p>
                   </a:txBody>
@@ -26990,7 +26990,7 @@
                           </a:solidFill>
                           <a:latin typeface="Calibri"/>
                         </a:rPr>
-                        <a:t>PAM</a:t>
+                        <a:t>Personas Adultas Mayores</a:t>
                       </a:r>
                     </a:p>
                   </a:txBody>
@@ -27299,8 +27299,8 @@
               <a:tblGrid>
                 <a:gridCol w="1371600"/>
                 <a:gridCol w="1463040"/>
-                <a:gridCol w="685800"/>
-                <a:gridCol w="7680960"/>
+                <a:gridCol w="1920240"/>
+                <a:gridCol w="6446520"/>
               </a:tblGrid>
               <a:tr h="365760">
                 <a:tc>
@@ -27456,7 +27456,7 @@
                           </a:solidFill>
                           <a:latin typeface="Calibri"/>
                         </a:rPr>
-                        <a:t>PCD</a:t>
+                        <a:t>Personas con Discapacidad</a:t>
                       </a:r>
                     </a:p>
                   </a:txBody>
@@ -28490,7 +28490,7 @@
                           </a:solidFill>
                           <a:latin typeface="Calibri"/>
                         </a:rPr>
-                        <a:t>PAM</a:t>
+                        <a:t>Personas Adultas Mayores</a:t>
                       </a:r>
                     </a:p>
                   </a:txBody>
@@ -29363,8 +29363,8 @@
               <a:tblGrid>
                 <a:gridCol w="1371600"/>
                 <a:gridCol w="1463040"/>
-                <a:gridCol w="685800"/>
-                <a:gridCol w="7680960"/>
+                <a:gridCol w="1920240"/>
+                <a:gridCol w="6446520"/>
               </a:tblGrid>
               <a:tr h="365760">
                 <a:tc>
@@ -29614,7 +29614,7 @@
                           </a:solidFill>
                           <a:latin typeface="Calibri"/>
                         </a:rPr>
-                        <a:t>PCD</a:t>
+                        <a:t>Personas con Discapacidad</a:t>
                       </a:r>
                     </a:p>
                   </a:txBody>
@@ -29708,7 +29708,7 @@
                           </a:solidFill>
                           <a:latin typeface="Calibri"/>
                         </a:rPr>
-                        <a:t>PCD</a:t>
+                        <a:t>Personas con Discapacidad</a:t>
                       </a:r>
                     </a:p>
                   </a:txBody>
@@ -29802,7 +29802,7 @@
                           </a:solidFill>
                           <a:latin typeface="Calibri"/>
                         </a:rPr>
-                        <a:t>PAM</a:t>
+                        <a:t>Personas Adultas Mayores</a:t>
                       </a:r>
                     </a:p>
                   </a:txBody>
@@ -29896,7 +29896,7 @@
                           </a:solidFill>
                           <a:latin typeface="Calibri"/>
                         </a:rPr>
-                        <a:t>PE</a:t>
+                        <a:t>Protección Especial</a:t>
                       </a:r>
                     </a:p>
                   </a:txBody>
@@ -29990,7 +29990,7 @@
                           </a:solidFill>
                           <a:latin typeface="Calibri"/>
                         </a:rPr>
-                        <a:t>PAM</a:t>
+                        <a:t>Personas Adultas Mayores</a:t>
                       </a:r>
                     </a:p>
                   </a:txBody>
@@ -30084,7 +30084,7 @@
                           </a:solidFill>
                           <a:latin typeface="Calibri"/>
                         </a:rPr>
-                        <a:t>PAM</a:t>
+                        <a:t>Personas Adultas Mayores</a:t>
                       </a:r>
                     </a:p>
                   </a:txBody>
@@ -30178,7 +30178,7 @@
                           </a:solidFill>
                           <a:latin typeface="Calibri"/>
                         </a:rPr>
-                        <a:t>PAM</a:t>
+                        <a:t>Personas Adultas Mayores</a:t>
                       </a:r>
                     </a:p>
                   </a:txBody>
@@ -30460,7 +30460,7 @@
                           </a:solidFill>
                           <a:latin typeface="Calibri"/>
                         </a:rPr>
-                        <a:t>PE</a:t>
+                        <a:t>Protección Especial</a:t>
                       </a:r>
                     </a:p>
                   </a:txBody>
@@ -30554,7 +30554,7 @@
                           </a:solidFill>
                           <a:latin typeface="Calibri"/>
                         </a:rPr>
-                        <a:t>PAM</a:t>
+                        <a:t>Personas Adultas Mayores</a:t>
                       </a:r>
                     </a:p>
                   </a:txBody>
@@ -30648,7 +30648,7 @@
                           </a:solidFill>
                           <a:latin typeface="Calibri"/>
                         </a:rPr>
-                        <a:t>AF</a:t>
+                        <a:t>Acompañamiento Familiar</a:t>
                       </a:r>
                     </a:p>
                   </a:txBody>
@@ -30742,7 +30742,7 @@
                           </a:solidFill>
                           <a:latin typeface="Calibri"/>
                         </a:rPr>
-                        <a:t>PE</a:t>
+                        <a:t>Protección Especial</a:t>
                       </a:r>
                     </a:p>
                   </a:txBody>
@@ -30836,7 +30836,7 @@
                           </a:solidFill>
                           <a:latin typeface="Calibri"/>
                         </a:rPr>
-                        <a:t>PE</a:t>
+                        <a:t>Protección Especial</a:t>
                       </a:r>
                     </a:p>
                   </a:txBody>
@@ -30930,7 +30930,7 @@
                           </a:solidFill>
                           <a:latin typeface="Calibri"/>
                         </a:rPr>
-                        <a:t>PE</a:t>
+                        <a:t>Protección Especial</a:t>
                       </a:r>
                     </a:p>
                   </a:txBody>
@@ -31427,8 +31427,8 @@
               <a:tblGrid>
                 <a:gridCol w="1371600"/>
                 <a:gridCol w="1463040"/>
-                <a:gridCol w="685800"/>
-                <a:gridCol w="7680960"/>
+                <a:gridCol w="1920240"/>
+                <a:gridCol w="6446520"/>
               </a:tblGrid>
               <a:tr h="365760">
                 <a:tc>
@@ -31584,7 +31584,7 @@
                           </a:solidFill>
                           <a:latin typeface="Calibri"/>
                         </a:rPr>
-                        <a:t>PCD</a:t>
+                        <a:t>Personas con Discapacidad</a:t>
                       </a:r>
                     </a:p>
                   </a:txBody>
@@ -31678,7 +31678,7 @@
                           </a:solidFill>
                           <a:latin typeface="Calibri"/>
                         </a:rPr>
-                        <a:t>PCD</a:t>
+                        <a:t>Personas con Discapacidad</a:t>
                       </a:r>
                     </a:p>
                   </a:txBody>
@@ -31772,7 +31772,7 @@
                           </a:solidFill>
                           <a:latin typeface="Calibri"/>
                         </a:rPr>
-                        <a:t>PAM</a:t>
+                        <a:t>Personas Adultas Mayores</a:t>
                       </a:r>
                     </a:p>
                   </a:txBody>
@@ -33182,7 +33182,7 @@
                           </a:solidFill>
                           <a:latin typeface="Calibri"/>
                         </a:rPr>
-                        <a:t>PE</a:t>
+                        <a:t>Protección Especial</a:t>
                       </a:r>
                     </a:p>
                   </a:txBody>
@@ -33491,8 +33491,8 @@
               <a:tblGrid>
                 <a:gridCol w="1371600"/>
                 <a:gridCol w="1463040"/>
-                <a:gridCol w="685800"/>
-                <a:gridCol w="7680960"/>
+                <a:gridCol w="1920240"/>
+                <a:gridCol w="6446520"/>
               </a:tblGrid>
               <a:tr h="365760">
                 <a:tc>
@@ -33648,7 +33648,7 @@
                           </a:solidFill>
                           <a:latin typeface="Calibri"/>
                         </a:rPr>
-                        <a:t>PAM</a:t>
+                        <a:t>Personas Adultas Mayores</a:t>
                       </a:r>
                     </a:p>
                   </a:txBody>
@@ -33742,7 +33742,7 @@
                           </a:solidFill>
                           <a:latin typeface="Calibri"/>
                         </a:rPr>
-                        <a:t>PCD</a:t>
+                        <a:t>Personas con Discapacidad</a:t>
                       </a:r>
                     </a:p>
                   </a:txBody>
@@ -34682,7 +34682,7 @@
                           </a:solidFill>
                           <a:latin typeface="Calibri"/>
                         </a:rPr>
-                        <a:t>PAM</a:t>
+                        <a:t>Personas Adultas Mayores</a:t>
                       </a:r>
                     </a:p>
                   </a:txBody>
@@ -34776,7 +34776,7 @@
                           </a:solidFill>
                           <a:latin typeface="Calibri"/>
                         </a:rPr>
-                        <a:t>PCD</a:t>
+                        <a:t>Personas con Discapacidad</a:t>
                       </a:r>
                     </a:p>
                   </a:txBody>
@@ -35058,7 +35058,7 @@
                           </a:solidFill>
                           <a:latin typeface="Calibri"/>
                         </a:rPr>
-                        <a:t>PAM</a:t>
+                        <a:t>Personas Adultas Mayores</a:t>
                       </a:r>
                     </a:p>
                   </a:txBody>

</xml_diff>

<commit_message>
Aplicar el período de Riesgos desde el 28 de septiembre a dashboard y exportables
</commit_message>
<xml_diff>
--- a/docs/reportes/Seguimiento_ENOS_2026-10-26.pptx
+++ b/docs/reportes/Seguimiento_ENOS_2026-10-26.pptx
@@ -255,628 +255,6 @@
 </c:chartSpace>
 </file>
 
-<file path=ppt/charts/chart2.xml><?xml version="1.0" encoding="utf-8"?>
-<c:chartSpace xmlns:c="http://schemas.openxmlformats.org/drawingml/2006/chart" xmlns:a="http://schemas.openxmlformats.org/drawingml/2006/main" xmlns:r="http://schemas.openxmlformats.org/officeDocument/2006/relationships">
-  <c:date1904 val="0"/>
-  <c:chart>
-    <c:autoTitleDeleted val="1"/>
-    <c:plotArea>
-      <c:barChart>
-        <c:barDir val="bar"/>
-        <c:grouping val="percentStacked"/>
-        <c:ser>
-          <c:idx val="0"/>
-          <c:order val="0"/>
-          <c:tx>
-            <c:strRef>
-              <c:f>Sheet1!$B$1</c:f>
-              <c:strCache>
-                <c:ptCount val="1"/>
-                <c:pt idx="0">
-                  <c:v>Guayas</c:v>
-                </c:pt>
-              </c:strCache>
-            </c:strRef>
-          </c:tx>
-          <c:spPr>
-            <a:solidFill>
-              <a:srgbClr val="512F8D"/>
-            </a:solidFill>
-            <a:ln w="25400">
-              <a:solidFill>
-                <a:srgbClr val="FFFFFF"/>
-              </a:solidFill>
-            </a:ln>
-          </c:spPr>
-          <c:dLbls>
-            <c:numFmt formatCode="#,##0;-#,##0;&quot;&quot;" sourceLinked="0"/>
-            <c:txPr>
-              <a:bodyPr/>
-              <a:lstStyle/>
-              <a:p>
-                <a:pPr>
-                  <a:defRPr sz="1200" b="1">
-                    <a:solidFill>
-                      <a:srgbClr val="FFFFFF"/>
-                    </a:solidFill>
-                  </a:defRPr>
-                </a:pPr>
-              </a:p>
-            </c:txPr>
-            <c:dLblPos val="ctr"/>
-            <c:showLegendKey val="0"/>
-            <c:showVal val="1"/>
-            <c:showCatName val="0"/>
-            <c:showSerName val="0"/>
-            <c:showPercent val="0"/>
-            <c:showBubbleSize val="0"/>
-            <c:showLeaderLines val="1"/>
-          </c:dLbls>
-          <c:cat>
-            <c:strRef>
-              <c:f>Sheet1!$A$2:$A$3</c:f>
-              <c:strCache>
-                <c:ptCount val="2"/>
-                <c:pt idx="0">
-                  <c:v>Pago gestionado
-113 núcleos familiares · USD 33.200,80</c:v>
-                </c:pt>
-                <c:pt idx="1">
-                  <c:v>En articulación
-1.171 personas · USD 354.987,39</c:v>
-                </c:pt>
-              </c:strCache>
-            </c:strRef>
-          </c:cat>
-          <c:val>
-            <c:numRef>
-              <c:f>Sheet1!$B$2:$B$3</c:f>
-              <c:numCache>
-                <c:formatCode>#,##0</c:formatCode>
-                <c:ptCount val="2"/>
-                <c:pt idx="0">
-                  <c:v>67</c:v>
-                </c:pt>
-                <c:pt idx="1">
-                  <c:v>344</c:v>
-                </c:pt>
-              </c:numCache>
-            </c:numRef>
-          </c:val>
-        </c:ser>
-        <c:ser>
-          <c:idx val="1"/>
-          <c:order val="1"/>
-          <c:tx>
-            <c:strRef>
-              <c:f>Sheet1!$C$1</c:f>
-              <c:strCache>
-                <c:ptCount val="1"/>
-                <c:pt idx="0">
-                  <c:v>Esmeraldas</c:v>
-                </c:pt>
-              </c:strCache>
-            </c:strRef>
-          </c:tx>
-          <c:spPr>
-            <a:solidFill>
-              <a:srgbClr val="7657B9"/>
-            </a:solidFill>
-            <a:ln w="25400">
-              <a:solidFill>
-                <a:srgbClr val="FFFFFF"/>
-              </a:solidFill>
-            </a:ln>
-          </c:spPr>
-          <c:dLbls>
-            <c:numFmt formatCode="#,##0;-#,##0;&quot;&quot;" sourceLinked="0"/>
-            <c:txPr>
-              <a:bodyPr/>
-              <a:lstStyle/>
-              <a:p>
-                <a:pPr>
-                  <a:defRPr sz="1200" b="1">
-                    <a:solidFill>
-                      <a:srgbClr val="FFFFFF"/>
-                    </a:solidFill>
-                  </a:defRPr>
-                </a:pPr>
-              </a:p>
-            </c:txPr>
-            <c:dLblPos val="ctr"/>
-            <c:showLegendKey val="0"/>
-            <c:showVal val="1"/>
-            <c:showCatName val="0"/>
-            <c:showSerName val="0"/>
-            <c:showPercent val="0"/>
-            <c:showBubbleSize val="0"/>
-            <c:showLeaderLines val="1"/>
-          </c:dLbls>
-          <c:cat>
-            <c:strRef>
-              <c:f>Sheet1!$A$2:$A$3</c:f>
-              <c:strCache>
-                <c:ptCount val="2"/>
-                <c:pt idx="0">
-                  <c:v>Pago gestionado
-113 núcleos familiares · USD 33.200,80</c:v>
-                </c:pt>
-                <c:pt idx="1">
-                  <c:v>En articulación
-1.171 personas · USD 354.987,39</c:v>
-                </c:pt>
-              </c:strCache>
-            </c:strRef>
-          </c:cat>
-          <c:val>
-            <c:numRef>
-              <c:f>Sheet1!$C$2:$C$3</c:f>
-              <c:numCache>
-                <c:formatCode>#,##0</c:formatCode>
-                <c:ptCount val="2"/>
-                <c:pt idx="1">
-                  <c:v>530</c:v>
-                </c:pt>
-              </c:numCache>
-            </c:numRef>
-          </c:val>
-        </c:ser>
-        <c:ser>
-          <c:idx val="2"/>
-          <c:order val="2"/>
-          <c:tx>
-            <c:strRef>
-              <c:f>Sheet1!$D$1</c:f>
-              <c:strCache>
-                <c:ptCount val="1"/>
-                <c:pt idx="0">
-                  <c:v>Manabí</c:v>
-                </c:pt>
-              </c:strCache>
-            </c:strRef>
-          </c:tx>
-          <c:spPr>
-            <a:solidFill>
-              <a:srgbClr val="F8C018"/>
-            </a:solidFill>
-            <a:ln w="25400">
-              <a:solidFill>
-                <a:srgbClr val="FFFFFF"/>
-              </a:solidFill>
-            </a:ln>
-          </c:spPr>
-          <c:dLbls>
-            <c:numFmt formatCode="#,##0;-#,##0;&quot;&quot;" sourceLinked="0"/>
-            <c:txPr>
-              <a:bodyPr/>
-              <a:lstStyle/>
-              <a:p>
-                <a:pPr>
-                  <a:defRPr sz="1200" b="1">
-                    <a:solidFill>
-                      <a:srgbClr val="2B164F"/>
-                    </a:solidFill>
-                  </a:defRPr>
-                </a:pPr>
-              </a:p>
-            </c:txPr>
-            <c:dLblPos val="ctr"/>
-            <c:showLegendKey val="0"/>
-            <c:showVal val="1"/>
-            <c:showCatName val="0"/>
-            <c:showSerName val="0"/>
-            <c:showPercent val="0"/>
-            <c:showBubbleSize val="0"/>
-            <c:showLeaderLines val="1"/>
-          </c:dLbls>
-          <c:cat>
-            <c:strRef>
-              <c:f>Sheet1!$A$2:$A$3</c:f>
-              <c:strCache>
-                <c:ptCount val="2"/>
-                <c:pt idx="0">
-                  <c:v>Pago gestionado
-113 núcleos familiares · USD 33.200,80</c:v>
-                </c:pt>
-                <c:pt idx="1">
-                  <c:v>En articulación
-1.171 personas · USD 354.987,39</c:v>
-                </c:pt>
-              </c:strCache>
-            </c:strRef>
-          </c:cat>
-          <c:val>
-            <c:numRef>
-              <c:f>Sheet1!$D$2:$D$3</c:f>
-              <c:numCache>
-                <c:formatCode>#,##0</c:formatCode>
-                <c:ptCount val="2"/>
-                <c:pt idx="0">
-                  <c:v>45</c:v>
-                </c:pt>
-              </c:numCache>
-            </c:numRef>
-          </c:val>
-        </c:ser>
-        <c:ser>
-          <c:idx val="3"/>
-          <c:order val="3"/>
-          <c:tx>
-            <c:strRef>
-              <c:f>Sheet1!$E$1</c:f>
-              <c:strCache>
-                <c:ptCount val="1"/>
-                <c:pt idx="0">
-                  <c:v>El Oro</c:v>
-                </c:pt>
-              </c:strCache>
-            </c:strRef>
-          </c:tx>
-          <c:spPr>
-            <a:solidFill>
-              <a:srgbClr val="A995E0"/>
-            </a:solidFill>
-            <a:ln w="25400">
-              <a:solidFill>
-                <a:srgbClr val="FFFFFF"/>
-              </a:solidFill>
-            </a:ln>
-          </c:spPr>
-          <c:dLbls>
-            <c:numFmt formatCode="#,##0;-#,##0;&quot;&quot;" sourceLinked="0"/>
-            <c:txPr>
-              <a:bodyPr/>
-              <a:lstStyle/>
-              <a:p>
-                <a:pPr>
-                  <a:defRPr sz="1200" b="1">
-                    <a:solidFill>
-                      <a:srgbClr val="2B164F"/>
-                    </a:solidFill>
-                  </a:defRPr>
-                </a:pPr>
-              </a:p>
-            </c:txPr>
-            <c:dLblPos val="ctr"/>
-            <c:showLegendKey val="0"/>
-            <c:showVal val="1"/>
-            <c:showCatName val="0"/>
-            <c:showSerName val="0"/>
-            <c:showPercent val="0"/>
-            <c:showBubbleSize val="0"/>
-            <c:showLeaderLines val="1"/>
-          </c:dLbls>
-          <c:cat>
-            <c:strRef>
-              <c:f>Sheet1!$A$2:$A$3</c:f>
-              <c:strCache>
-                <c:ptCount val="2"/>
-                <c:pt idx="0">
-                  <c:v>Pago gestionado
-113 núcleos familiares · USD 33.200,80</c:v>
-                </c:pt>
-                <c:pt idx="1">
-                  <c:v>En articulación
-1.171 personas · USD 354.987,39</c:v>
-                </c:pt>
-              </c:strCache>
-            </c:strRef>
-          </c:cat>
-          <c:val>
-            <c:numRef>
-              <c:f>Sheet1!$E$2:$E$3</c:f>
-              <c:numCache>
-                <c:formatCode>#,##0</c:formatCode>
-                <c:ptCount val="2"/>
-                <c:pt idx="1">
-                  <c:v>181</c:v>
-                </c:pt>
-              </c:numCache>
-            </c:numRef>
-          </c:val>
-        </c:ser>
-        <c:ser>
-          <c:idx val="4"/>
-          <c:order val="4"/>
-          <c:tx>
-            <c:strRef>
-              <c:f>Sheet1!$F$1</c:f>
-              <c:strCache>
-                <c:ptCount val="1"/>
-                <c:pt idx="0">
-                  <c:v>Los Ríos</c:v>
-                </c:pt>
-              </c:strCache>
-            </c:strRef>
-          </c:tx>
-          <c:spPr>
-            <a:solidFill>
-              <a:srgbClr val="A32C74"/>
-            </a:solidFill>
-            <a:ln w="25400">
-              <a:solidFill>
-                <a:srgbClr val="FFFFFF"/>
-              </a:solidFill>
-            </a:ln>
-          </c:spPr>
-          <c:dLbls>
-            <c:numFmt formatCode="#,##0;-#,##0;&quot;&quot;" sourceLinked="0"/>
-            <c:txPr>
-              <a:bodyPr/>
-              <a:lstStyle/>
-              <a:p>
-                <a:pPr>
-                  <a:defRPr sz="1200" b="1">
-                    <a:solidFill>
-                      <a:srgbClr val="FFFFFF"/>
-                    </a:solidFill>
-                  </a:defRPr>
-                </a:pPr>
-              </a:p>
-            </c:txPr>
-            <c:dLblPos val="ctr"/>
-            <c:showLegendKey val="0"/>
-            <c:showVal val="1"/>
-            <c:showCatName val="0"/>
-            <c:showSerName val="0"/>
-            <c:showPercent val="0"/>
-            <c:showBubbleSize val="0"/>
-            <c:showLeaderLines val="1"/>
-          </c:dLbls>
-          <c:cat>
-            <c:strRef>
-              <c:f>Sheet1!$A$2:$A$3</c:f>
-              <c:strCache>
-                <c:ptCount val="2"/>
-                <c:pt idx="0">
-                  <c:v>Pago gestionado
-113 núcleos familiares · USD 33.200,80</c:v>
-                </c:pt>
-                <c:pt idx="1">
-                  <c:v>En articulación
-1.171 personas · USD 354.987,39</c:v>
-                </c:pt>
-              </c:strCache>
-            </c:strRef>
-          </c:cat>
-          <c:val>
-            <c:numRef>
-              <c:f>Sheet1!$F$2:$F$3</c:f>
-              <c:numCache>
-                <c:formatCode>#,##0</c:formatCode>
-                <c:ptCount val="2"/>
-                <c:pt idx="1">
-                  <c:v>111</c:v>
-                </c:pt>
-              </c:numCache>
-            </c:numRef>
-          </c:val>
-        </c:ser>
-        <c:ser>
-          <c:idx val="5"/>
-          <c:order val="5"/>
-          <c:tx>
-            <c:strRef>
-              <c:f>Sheet1!$G$1</c:f>
-              <c:strCache>
-                <c:ptCount val="1"/>
-                <c:pt idx="0">
-                  <c:v>Azuay</c:v>
-                </c:pt>
-              </c:strCache>
-            </c:strRef>
-          </c:tx>
-          <c:spPr>
-            <a:solidFill>
-              <a:srgbClr val="2B164F"/>
-            </a:solidFill>
-            <a:ln w="25400">
-              <a:solidFill>
-                <a:srgbClr val="FFFFFF"/>
-              </a:solidFill>
-            </a:ln>
-          </c:spPr>
-          <c:dLbls>
-            <c:dLbl>
-              <c:idx val="0"/>
-              <c:delete val="1"/>
-            </c:dLbl>
-            <c:numFmt formatCode="#,##0;-#,##0;&quot;&quot;" sourceLinked="0"/>
-            <c:txPr>
-              <a:bodyPr/>
-              <a:lstStyle/>
-              <a:p>
-                <a:pPr>
-                  <a:defRPr sz="1200" b="1">
-                    <a:solidFill>
-                      <a:srgbClr val="FFFFFF"/>
-                    </a:solidFill>
-                  </a:defRPr>
-                </a:pPr>
-              </a:p>
-            </c:txPr>
-            <c:dLblPos val="ctr"/>
-            <c:showLegendKey val="0"/>
-            <c:showVal val="1"/>
-            <c:showCatName val="0"/>
-            <c:showSerName val="0"/>
-            <c:showPercent val="0"/>
-            <c:showBubbleSize val="0"/>
-            <c:showLeaderLines val="1"/>
-          </c:dLbls>
-          <c:cat>
-            <c:strRef>
-              <c:f>Sheet1!$A$2:$A$3</c:f>
-              <c:strCache>
-                <c:ptCount val="2"/>
-                <c:pt idx="0">
-                  <c:v>Pago gestionado
-113 núcleos familiares · USD 33.200,80</c:v>
-                </c:pt>
-                <c:pt idx="1">
-                  <c:v>En articulación
-1.171 personas · USD 354.987,39</c:v>
-                </c:pt>
-              </c:strCache>
-            </c:strRef>
-          </c:cat>
-          <c:val>
-            <c:numRef>
-              <c:f>Sheet1!$G$2:$G$3</c:f>
-              <c:numCache>
-                <c:formatCode>#,##0</c:formatCode>
-                <c:ptCount val="2"/>
-                <c:pt idx="0">
-                  <c:v>1</c:v>
-                </c:pt>
-              </c:numCache>
-            </c:numRef>
-          </c:val>
-        </c:ser>
-        <c:ser>
-          <c:idx val="6"/>
-          <c:order val="6"/>
-          <c:tx>
-            <c:strRef>
-              <c:f>Sheet1!$H$1</c:f>
-              <c:strCache>
-                <c:ptCount val="1"/>
-                <c:pt idx="0">
-                  <c:v>Imbabura</c:v>
-                </c:pt>
-              </c:strCache>
-            </c:strRef>
-          </c:tx>
-          <c:spPr>
-            <a:solidFill>
-              <a:srgbClr val="E6A3C5"/>
-            </a:solidFill>
-            <a:ln w="25400">
-              <a:solidFill>
-                <a:srgbClr val="FFFFFF"/>
-              </a:solidFill>
-            </a:ln>
-          </c:spPr>
-          <c:dLbls>
-            <c:dLbl>
-              <c:idx val="1"/>
-              <c:delete val="1"/>
-            </c:dLbl>
-            <c:numFmt formatCode="#,##0;-#,##0;&quot;&quot;" sourceLinked="0"/>
-            <c:txPr>
-              <a:bodyPr/>
-              <a:lstStyle/>
-              <a:p>
-                <a:pPr>
-                  <a:defRPr sz="1200" b="1">
-                    <a:solidFill>
-                      <a:srgbClr val="2B164F"/>
-                    </a:solidFill>
-                  </a:defRPr>
-                </a:pPr>
-              </a:p>
-            </c:txPr>
-            <c:dLblPos val="ctr"/>
-            <c:showLegendKey val="0"/>
-            <c:showVal val="1"/>
-            <c:showCatName val="0"/>
-            <c:showSerName val="0"/>
-            <c:showPercent val="0"/>
-            <c:showBubbleSize val="0"/>
-            <c:showLeaderLines val="1"/>
-          </c:dLbls>
-          <c:cat>
-            <c:strRef>
-              <c:f>Sheet1!$A$2:$A$3</c:f>
-              <c:strCache>
-                <c:ptCount val="2"/>
-                <c:pt idx="0">
-                  <c:v>Pago gestionado
-113 núcleos familiares · USD 33.200,80</c:v>
-                </c:pt>
-                <c:pt idx="1">
-                  <c:v>En articulación
-1.171 personas · USD 354.987,39</c:v>
-                </c:pt>
-              </c:strCache>
-            </c:strRef>
-          </c:cat>
-          <c:val>
-            <c:numRef>
-              <c:f>Sheet1!$H$2:$H$3</c:f>
-              <c:numCache>
-                <c:formatCode>#,##0</c:formatCode>
-                <c:ptCount val="2"/>
-                <c:pt idx="1">
-                  <c:v>5</c:v>
-                </c:pt>
-              </c:numCache>
-            </c:numRef>
-          </c:val>
-        </c:ser>
-        <c:gapWidth val="70"/>
-        <c:overlap val="100"/>
-        <c:axId val="-2068027336"/>
-        <c:axId val="-2113994440"/>
-      </c:barChart>
-      <c:catAx>
-        <c:axId val="-2068027336"/>
-        <c:scaling>
-          <c:orientation val="maxMin"/>
-        </c:scaling>
-        <c:delete val="0"/>
-        <c:axPos val="l"/>
-        <c:majorTickMark val="out"/>
-        <c:minorTickMark val="none"/>
-        <c:tickLblPos val="nextTo"/>
-        <c:spPr>
-          <a:ln>
-            <a:noFill/>
-          </a:ln>
-        </c:spPr>
-        <c:crossAx val="-2113994440"/>
-        <c:crosses val="autoZero"/>
-        <c:auto val="1"/>
-        <c:lblAlgn val="ctr"/>
-        <c:lblOffset val="100"/>
-        <c:noMultiLvlLbl val="0"/>
-      </c:catAx>
-      <c:valAx>
-        <c:axId val="-2113994440"/>
-        <c:scaling/>
-        <c:delete/>
-        <c:axPos val="b"/>
-        <c:majorTickMark val="out"/>
-        <c:minorTickMark val="none"/>
-        <c:tickLblPos val="nextTo"/>
-        <c:crossAx val="-2068027336"/>
-        <c:crosses val="autoZero"/>
-      </c:valAx>
-    </c:plotArea>
-    <c:legend>
-      <c:legendPos val="b"/>
-      <c:overlay val="0"/>
-    </c:legend>
-    <c:dispBlanksAs val="gap"/>
-  </c:chart>
-  <c:txPr>
-    <a:bodyPr/>
-    <a:lstStyle/>
-    <a:p>
-      <a:pPr>
-        <a:defRPr sz="1200">
-          <a:latin typeface="Calibri"/>
-        </a:defRPr>
-      </a:pPr>
-      <a:endParaRPr lang="en-US"/>
-    </a:p>
-  </c:txPr>
-  <c:externalData r:id="rId1">
-    <c:autoUpdate val="0"/>
-  </c:externalData>
-</c:chartSpace>
-</file>
-
 <file path=ppt/notesMasters/notesMaster1.xml><?xml version="1.0" encoding="utf-8"?>
 <p:notesMaster xmlns:a="http://schemas.openxmlformats.org/drawingml/2006/main" xmlns:p="http://schemas.openxmlformats.org/presentationml/2006/main" xmlns:r="http://schemas.openxmlformats.org/officeDocument/2006/relationships">
   <p:cSld>
@@ -1272,7 +650,7 @@
           <a:lstStyle/>
           <a:p>
             <a:r>
-              <a:t>Alertas reportadas: 39. Kits entregados: 13.981. Personas · Bono de Contingencia: 1.171. Monto · Bono de Contingencia: USD 354.987,39. Unidades cerradas / suspendidas: 99. 99 unidades de atención con atención suspendida (64 CNH · 35 CDI); El Oro concentra 75 (75,8 %).</a:t>
+              <a:t>Alertas reportadas: 39. Kits entregados: 10.607. Personas · Bono de Contingencia: —. Monto · Bono de Contingencia: USD —. Unidades cerradas / suspendidas: 99. 99 unidades de atención con atención suspendida (64 CNH · 35 CDI); El Oro concentra 75 (75,8 %).</a:t>
             </a:r>
           </a:p>
         </p:txBody>
@@ -5724,7 +5102,7 @@
                 </a:solidFill>
                 <a:latin typeface="Calibri"/>
               </a:rPr>
-              <a:t>Del 14/09/2026 al 27/10/2026</a:t>
+              <a:t>Del 28/09/2026 al 27/10/2026</a:t>
             </a:r>
           </a:p>
         </p:txBody>
@@ -5883,7 +5261,7 @@
                 </a:solidFill>
                 <a:latin typeface="Calibri"/>
               </a:rPr>
-              <a:t>Actualizado el 27 de octubre de 2026, 10:12</a:t>
+              <a:t>Actualizado el 27 de octubre de 2026, 11:37</a:t>
             </a:r>
           </a:p>
           <a:p>
@@ -6012,7 +5390,7 @@
                 </a:solidFill>
                 <a:latin typeface="Calibri"/>
               </a:rPr>
-              <a:t>Riesgos · Del 14/09/2026 al 27/10/2026 · Nacional</a:t>
+              <a:t>Riesgos · Del 28/09/2026 al 27/10/2026 · Nacional</a:t>
             </a:r>
           </a:p>
         </p:txBody>
@@ -6431,7 +5809,7 @@
                 </a:solidFill>
                 <a:latin typeface="Century Gothic"/>
               </a:rPr>
-              <a:t>13.981</a:t>
+              <a:t>10.607</a:t>
             </a:r>
           </a:p>
         </p:txBody>
@@ -6466,7 +5844,7 @@
                 </a:solidFill>
                 <a:latin typeface="Calibri"/>
               </a:rPr>
-              <a:t>22 provincias priorizadas · corte 27/10, 13:35</a:t>
+              <a:t>21 provincias priorizadas · corte 27/10, 13:35</a:t>
             </a:r>
           </a:p>
         </p:txBody>
@@ -6658,7 +6036,7 @@
                 </a:solidFill>
                 <a:latin typeface="Century Gothic"/>
               </a:rPr>
-              <a:t>1.171</a:t>
+              <a:t>—</a:t>
             </a:r>
           </a:p>
         </p:txBody>
@@ -6693,7 +6071,7 @@
                 </a:solidFill>
                 <a:latin typeface="Calibri"/>
               </a:rPr>
-              <a:t>En articulación para el pago</a:t>
+              <a:t>Sin desglose temporal disponible</a:t>
             </a:r>
           </a:p>
         </p:txBody>
@@ -6879,13 +6257,13 @@
           <a:p>
             <a:pPr algn="l"/>
             <a:r>
-              <a:rPr sz="2400" b="1">
+              <a:rPr sz="2800" b="1">
                 <a:solidFill>
                   <a:srgbClr val="2B164F"/>
                 </a:solidFill>
                 <a:latin typeface="Century Gothic"/>
               </a:rPr>
-              <a:t>USD 354.987,39</a:t>
+              <a:t>USD —</a:t>
             </a:r>
           </a:p>
         </p:txBody>
@@ -6920,7 +6298,7 @@
                 </a:solidFill>
                 <a:latin typeface="Calibri"/>
               </a:rPr>
-              <a:t>Corte del bono: 27/10/2026</a:t>
+              <a:t>Sin desglose temporal disponible</a:t>
             </a:r>
           </a:p>
         </p:txBody>
@@ -7146,7 +6524,7 @@
                 </a:solidFill>
                 <a:latin typeface="Calibri"/>
               </a:rPr>
-              <a:t>Del 14/09/2026 al 27/10/2026 · Nacional · Todos los servicios</a:t>
+              <a:t>Del 28/09/2026 al 27/10/2026 · Nacional · Todos los servicios</a:t>
             </a:r>
           </a:p>
         </p:txBody>
@@ -8382,7 +7760,7 @@
                 </a:solidFill>
                 <a:latin typeface="Calibri"/>
               </a:rPr>
-              <a:t>Del 14/09/2026 al 27/10/2026 · Nacional · Todos los servicios</a:t>
+              <a:t>Del 28/09/2026 al 27/10/2026 · Nacional · Todos los servicios</a:t>
             </a:r>
           </a:p>
         </p:txBody>
@@ -9618,7 +8996,7 @@
                 </a:solidFill>
                 <a:latin typeface="Calibri"/>
               </a:rPr>
-              <a:t>Del 14/09/2026 al 27/10/2026 · Nacional · Todos los servicios</a:t>
+              <a:t>Del 28/09/2026 al 27/10/2026 · Nacional · Todos los servicios</a:t>
             </a:r>
           </a:p>
         </p:txBody>
@@ -10854,7 +10232,7 @@
                 </a:solidFill>
                 <a:latin typeface="Calibri"/>
               </a:rPr>
-              <a:t>Del 14/09/2026 al 27/10/2026 · Nacional · Todos los servicios</a:t>
+              <a:t>Del 28/09/2026 al 27/10/2026 · Nacional · Todos los servicios</a:t>
             </a:r>
           </a:p>
         </p:txBody>
@@ -12090,7 +11468,7 @@
                 </a:solidFill>
                 <a:latin typeface="Calibri"/>
               </a:rPr>
-              <a:t>Del 14/09/2026 al 27/10/2026 · Nacional · Todos los servicios</a:t>
+              <a:t>Del 28/09/2026 al 27/10/2026 · Nacional · Todos los servicios</a:t>
             </a:r>
           </a:p>
         </p:txBody>
@@ -13326,7 +12704,7 @@
                 </a:solidFill>
                 <a:latin typeface="Calibri"/>
               </a:rPr>
-              <a:t>Del 14/09/2026 al 27/10/2026 · Nacional · Todos los servicios</a:t>
+              <a:t>Del 28/09/2026 al 27/10/2026 · Nacional · Todos los servicios</a:t>
             </a:r>
           </a:p>
         </p:txBody>
@@ -14202,7 +13580,7 @@
                 </a:solidFill>
                 <a:latin typeface="Calibri"/>
               </a:rPr>
-              <a:t>Del 14/09/2026 al 27/10/2026 · Nacional · Todos los servicios</a:t>
+              <a:t>Del 28/09/2026 al 27/10/2026 · Nacional · Todos los servicios</a:t>
             </a:r>
           </a:p>
         </p:txBody>
@@ -14331,7 +13709,7 @@
                 </a:solidFill>
                 <a:latin typeface="Century Gothic"/>
               </a:rPr>
-              <a:t>13.981 kits en 22 provincias</a:t>
+              <a:t>10.607 kits en 21 provincias</a:t>
             </a:r>
           </a:p>
         </p:txBody>
@@ -14366,7 +13744,7 @@
                 </a:solidFill>
                 <a:latin typeface="Calibri"/>
               </a:rPr>
-              <a:t>111 registros Kobo · corte 27/10/2026, 13:35 · cada círculo es una entrega y su tamaño indica los kits</a:t>
+              <a:t>80 registros Kobo · corte 27/10/2026, 13:35 · cada círculo es una entrega y su tamaño indica los kits</a:t>
             </a:r>
           </a:p>
         </p:txBody>
@@ -14425,7 +13803,7 @@
                 </a:solidFill>
                 <a:latin typeface="Calibri"/>
               </a:rPr>
-              <a:t>Núcleos familiares reportados por entrega: 12.987; no son núcleos familiares únicos.</a:t>
+              <a:t>Núcleos familiares reportados por entrega: 9.761; no son núcleos familiares únicos.</a:t>
             </a:r>
           </a:p>
         </p:txBody>
@@ -14581,7 +13959,7 @@
                 </a:solidFill>
                 <a:latin typeface="Calibri"/>
               </a:rPr>
-              <a:t>Del 14/09/2026 al 27/10/2026 · Nacional · Todos los servicios</a:t>
+              <a:t>Del 28/09/2026 al 27/10/2026 · Nacional · Todos los servicios</a:t>
             </a:r>
           </a:p>
         </p:txBody>
@@ -14688,8 +14066,8 @@
         </p:nvSpPr>
         <p:spPr>
           <a:xfrm>
-            <a:off x="502920" y="1243584"/>
-            <a:ext cx="7040880" cy="365760"/>
+            <a:off x="502920" y="1463040"/>
+            <a:ext cx="7040880" cy="457200"/>
           </a:xfrm>
           <a:prstGeom prst="rect">
             <a:avLst/>
@@ -14704,73 +14082,20 @@
           <a:p>
             <a:pPr algn="l"/>
             <a:r>
-              <a:rPr sz="1800" b="1">
-                <a:solidFill>
-                  <a:srgbClr val="2B164F"/>
-                </a:solidFill>
-                <a:latin typeface="Century Gothic"/>
-              </a:rPr>
-              <a:t>Cada etapa, por provincia</a:t>
-            </a:r>
-          </a:p>
-        </p:txBody>
-      </p:sp>
-      <p:sp>
-        <p:nvSpPr>
-          <p:cNvPr id="10" name="TextBox 9"/>
-          <p:cNvSpPr txBox="1"/>
-          <p:nvPr/>
-        </p:nvSpPr>
-        <p:spPr>
-          <a:xfrm>
-            <a:off x="502920" y="1627632"/>
-            <a:ext cx="7040880" cy="274320"/>
-          </a:xfrm>
-          <a:prstGeom prst="rect">
-            <a:avLst/>
-          </a:prstGeom>
-          <a:noFill/>
-        </p:spPr>
-        <p:txBody>
-          <a:bodyPr wrap="square" anchor="t" lIns="0" rIns="0" tIns="0" bIns="0">
-            <a:spAutoFit/>
-          </a:bodyPr>
-          <a:lstStyle/>
-          <a:p>
-            <a:pPr algn="l"/>
-            <a:r>
-              <a:rPr sz="1150" b="0">
+              <a:rPr sz="1400" b="0">
                 <a:solidFill>
                   <a:srgbClr val="5A5765"/>
                 </a:solidFill>
                 <a:latin typeface="Calibri"/>
               </a:rPr>
-              <a:t>Inundaciones · cada barra suma el 100 % de su etapa; las etapas no se suman</a:t>
+              <a:t>Sin desglose temporal del bono para este período.</a:t>
             </a:r>
           </a:p>
         </p:txBody>
       </p:sp>
-      <p:graphicFrame>
-        <p:nvGraphicFramePr>
-          <p:cNvPr id="11" name="Chart 10"/>
-          <p:cNvGraphicFramePr>
-            <a:graphicFrameLocks noGrp="1"/>
-          </p:cNvGraphicFramePr>
-          <p:nvPr/>
-        </p:nvGraphicFramePr>
-        <p:xfrm>
-          <a:off x="411480" y="1874519"/>
-          <a:ext cx="7223760" cy="3566160"/>
-        </p:xfrm>
-        <a:graphic>
-          <a:graphicData uri="http://schemas.openxmlformats.org/drawingml/2006/chart">
-            <c:chart xmlns:c="http://schemas.openxmlformats.org/drawingml/2006/chart" r:id="rId4"/>
-          </a:graphicData>
-        </a:graphic>
-      </p:graphicFrame>
-      <p:sp>
-        <p:nvSpPr>
-          <p:cNvPr id="12" name="TextBox 11"/>
+      <p:sp>
+        <p:nvSpPr>
+          <p:cNvPr id="10" name="TextBox 9"/>
           <p:cNvSpPr txBox="1"/>
           <p:nvPr/>
         </p:nvSpPr>
@@ -14805,7 +14130,7 @@
       </p:sp>
       <p:sp>
         <p:nvSpPr>
-          <p:cNvPr id="13" name="TextBox 12"/>
+          <p:cNvPr id="11" name="TextBox 10"/>
           <p:cNvSpPr txBox="1"/>
           <p:nvPr/>
         </p:nvSpPr>
@@ -14840,7 +14165,7 @@
       </p:sp>
       <p:sp>
         <p:nvSpPr>
-          <p:cNvPr id="14" name="Rounded Rectangle 13"/>
+          <p:cNvPr id="12" name="Rounded Rectangle 11"/>
           <p:cNvSpPr/>
           <p:nvPr/>
         </p:nvSpPr>
@@ -14872,7 +14197,7 @@
       </p:sp>
       <p:sp>
         <p:nvSpPr>
-          <p:cNvPr id="15" name="Rectangle 14"/>
+          <p:cNvPr id="13" name="Rectangle 12"/>
           <p:cNvSpPr/>
           <p:nvPr/>
         </p:nvSpPr>
@@ -14902,7 +14227,7 @@
       </p:sp>
       <p:sp>
         <p:nvSpPr>
-          <p:cNvPr id="16" name="TextBox 15"/>
+          <p:cNvPr id="14" name="TextBox 13"/>
           <p:cNvSpPr txBox="1"/>
           <p:nvPr/>
         </p:nvSpPr>
@@ -14937,7 +14262,7 @@
       </p:sp>
       <p:sp>
         <p:nvSpPr>
-          <p:cNvPr id="17" name="TextBox 16"/>
+          <p:cNvPr id="15" name="TextBox 14"/>
           <p:cNvSpPr txBox="1"/>
           <p:nvPr/>
         </p:nvSpPr>
@@ -14972,7 +14297,7 @@
       </p:sp>
       <p:sp>
         <p:nvSpPr>
-          <p:cNvPr id="18" name="Rounded Rectangle 17"/>
+          <p:cNvPr id="16" name="Rounded Rectangle 15"/>
           <p:cNvSpPr/>
           <p:nvPr/>
         </p:nvSpPr>
@@ -15004,7 +14329,7 @@
       </p:sp>
       <p:sp>
         <p:nvSpPr>
-          <p:cNvPr id="19" name="Rectangle 18"/>
+          <p:cNvPr id="17" name="Rectangle 16"/>
           <p:cNvSpPr/>
           <p:nvPr/>
         </p:nvSpPr>
@@ -15034,7 +14359,7 @@
       </p:sp>
       <p:sp>
         <p:nvSpPr>
-          <p:cNvPr id="20" name="TextBox 19"/>
+          <p:cNvPr id="18" name="TextBox 17"/>
           <p:cNvSpPr txBox="1"/>
           <p:nvPr/>
         </p:nvSpPr>
@@ -15069,7 +14394,7 @@
       </p:sp>
       <p:sp>
         <p:nvSpPr>
-          <p:cNvPr id="21" name="TextBox 20"/>
+          <p:cNvPr id="19" name="TextBox 18"/>
           <p:cNvSpPr txBox="1"/>
           <p:nvPr/>
         </p:nvSpPr>
@@ -15104,7 +14429,7 @@
       </p:sp>
       <p:sp>
         <p:nvSpPr>
-          <p:cNvPr id="22" name="Rounded Rectangle 21"/>
+          <p:cNvPr id="20" name="Rounded Rectangle 19"/>
           <p:cNvSpPr/>
           <p:nvPr/>
         </p:nvSpPr>
@@ -15136,7 +14461,7 @@
       </p:sp>
       <p:sp>
         <p:nvSpPr>
-          <p:cNvPr id="23" name="Rectangle 22"/>
+          <p:cNvPr id="21" name="Rectangle 20"/>
           <p:cNvSpPr/>
           <p:nvPr/>
         </p:nvSpPr>
@@ -15166,7 +14491,7 @@
       </p:sp>
       <p:sp>
         <p:nvSpPr>
-          <p:cNvPr id="24" name="TextBox 23"/>
+          <p:cNvPr id="22" name="TextBox 21"/>
           <p:cNvSpPr txBox="1"/>
           <p:nvPr/>
         </p:nvSpPr>
@@ -15201,7 +14526,7 @@
       </p:sp>
       <p:sp>
         <p:nvSpPr>
-          <p:cNvPr id="25" name="TextBox 24"/>
+          <p:cNvPr id="23" name="TextBox 22"/>
           <p:cNvSpPr txBox="1"/>
           <p:nvPr/>
         </p:nvSpPr>
@@ -15236,7 +14561,7 @@
       </p:sp>
       <p:sp>
         <p:nvSpPr>
-          <p:cNvPr id="26" name="TextBox 25"/>
+          <p:cNvPr id="24" name="TextBox 23"/>
           <p:cNvSpPr txBox="1"/>
           <p:nvPr/>
         </p:nvSpPr>
@@ -15264,7 +14589,7 @@
                 </a:solidFill>
                 <a:latin typeface="Calibri"/>
               </a:rPr>
-              <a:t>Bono en articulación actualizado con la tabla provincial remitida el 27/10/2026: inundación, colapso estructural y vendaval. Pagos gestionados: ayuda memoria del 23/10, desde el 29/08. Articulación no equivale a pago. Las proyecciones corresponden a planificación nacional 2026–2027.</a:t>
+              <a:t>Sin desglose temporal disponible para bonos desde el 28/09/2026. Los acumulados recibidos no permiten identificar la fecha de cada gestión. Las proyecciones son una referencia de planificación, no ejecución del período.</a:t>
             </a:r>
           </a:p>
         </p:txBody>
@@ -15420,7 +14745,7 @@
                 </a:solidFill>
                 <a:latin typeface="Calibri"/>
               </a:rPr>
-              <a:t>Del 14/09/2026 al 27/10/2026 · Nacional · Todos los servicios</a:t>
+              <a:t>Del 28/09/2026 al 27/10/2026 · Nacional · Todos los servicios</a:t>
             </a:r>
           </a:p>
         </p:txBody>
@@ -15584,7 +14909,7 @@
                 </a:solidFill>
                 <a:latin typeface="Calibri"/>
               </a:rPr>
-              <a:t>22 provincias · kits, bono gestionado (núcleos familiares) y casos en articulación (personas)</a:t>
+              <a:t>21 provincias · kits, bono gestionado (núcleos familiares) y casos en articulación (personas)</a:t>
             </a:r>
           </a:p>
         </p:txBody>
@@ -15815,7 +15140,7 @@
                           </a:solidFill>
                           <a:latin typeface="Calibri"/>
                         </a:rPr>
-                        <a:t>1</a:t>
+                        <a:t>—</a:t>
                       </a:r>
                     </a:p>
                   </a:txBody>
@@ -15838,7 +15163,7 @@
                           </a:solidFill>
                           <a:latin typeface="Calibri"/>
                         </a:rPr>
-                        <a:t>303,99</a:t>
+                        <a:t>—</a:t>
                       </a:r>
                     </a:p>
                   </a:txBody>
@@ -16072,7 +15397,7 @@
                           </a:solidFill>
                           <a:latin typeface="Calibri"/>
                         </a:rPr>
-                        <a:t>780</a:t>
+                        <a:t>133</a:t>
                       </a:r>
                     </a:p>
                   </a:txBody>
@@ -16469,7 +15794,7 @@
                           </a:solidFill>
                           <a:latin typeface="Calibri"/>
                         </a:rPr>
-                        <a:t>Cotopaxi</a:t>
+                        <a:t>El Oro</a:t>
                       </a:r>
                     </a:p>
                   </a:txBody>
@@ -16492,7 +15817,7 @@
                           </a:solidFill>
                           <a:latin typeface="Calibri"/>
                         </a:rPr>
-                        <a:t>250</a:t>
+                        <a:t>66</a:t>
                       </a:r>
                     </a:p>
                   </a:txBody>
@@ -16609,7 +15934,7 @@
                           </a:solidFill>
                           <a:latin typeface="Calibri"/>
                         </a:rPr>
-                        <a:t>El Oro</a:t>
+                        <a:t>Esmeraldas</a:t>
                       </a:r>
                     </a:p>
                   </a:txBody>
@@ -16632,7 +15957,7 @@
                           </a:solidFill>
                           <a:latin typeface="Calibri"/>
                         </a:rPr>
-                        <a:t>66</a:t>
+                        <a:t>3.690</a:t>
                       </a:r>
                     </a:p>
                   </a:txBody>
@@ -16701,7 +16026,7 @@
                           </a:solidFill>
                           <a:latin typeface="Calibri"/>
                         </a:rPr>
-                        <a:t>181</a:t>
+                        <a:t>—</a:t>
                       </a:r>
                     </a:p>
                   </a:txBody>
@@ -16724,7 +16049,7 @@
                           </a:solidFill>
                           <a:latin typeface="Calibri"/>
                         </a:rPr>
-                        <a:t>55.022,19</a:t>
+                        <a:t>—</a:t>
                       </a:r>
                     </a:p>
                   </a:txBody>
@@ -16749,7 +16074,7 @@
                           </a:solidFill>
                           <a:latin typeface="Calibri"/>
                         </a:rPr>
-                        <a:t>Esmeraldas</a:t>
+                        <a:t>Guayas</a:t>
                       </a:r>
                     </a:p>
                   </a:txBody>
@@ -16772,7 +16097,7 @@
                           </a:solidFill>
                           <a:latin typeface="Calibri"/>
                         </a:rPr>
-                        <a:t>3.820</a:t>
+                        <a:t>4.650</a:t>
                       </a:r>
                     </a:p>
                   </a:txBody>
@@ -16841,7 +16166,7 @@
                           </a:solidFill>
                           <a:latin typeface="Calibri"/>
                         </a:rPr>
-                        <a:t>530</a:t>
+                        <a:t>—</a:t>
                       </a:r>
                     </a:p>
                   </a:txBody>
@@ -16864,7 +16189,7 @@
                           </a:solidFill>
                           <a:latin typeface="Calibri"/>
                         </a:rPr>
-                        <a:t>160.558,20</a:t>
+                        <a:t>—</a:t>
                       </a:r>
                     </a:p>
                   </a:txBody>
@@ -16889,7 +16214,7 @@
                           </a:solidFill>
                           <a:latin typeface="Calibri"/>
                         </a:rPr>
-                        <a:t>Guayas</a:t>
+                        <a:t>Imbabura</a:t>
                       </a:r>
                     </a:p>
                   </a:txBody>
@@ -16912,7 +16237,7 @@
                           </a:solidFill>
                           <a:latin typeface="Calibri"/>
                         </a:rPr>
-                        <a:t>6.850</a:t>
+                        <a:t>498</a:t>
                       </a:r>
                     </a:p>
                   </a:txBody>
@@ -16935,7 +16260,7 @@
                           </a:solidFill>
                           <a:latin typeface="Calibri"/>
                         </a:rPr>
-                        <a:t>67</a:t>
+                        <a:t>—</a:t>
                       </a:r>
                     </a:p>
                   </a:txBody>
@@ -16958,7 +16283,7 @@
                           </a:solidFill>
                           <a:latin typeface="Calibri"/>
                         </a:rPr>
-                        <a:t>19.264,51</a:t>
+                        <a:t>—</a:t>
                       </a:r>
                     </a:p>
                   </a:txBody>
@@ -16981,7 +16306,7 @@
                           </a:solidFill>
                           <a:latin typeface="Calibri"/>
                         </a:rPr>
-                        <a:t>344</a:t>
+                        <a:t>—</a:t>
                       </a:r>
                     </a:p>
                   </a:txBody>
@@ -17004,7 +16329,7 @@
                           </a:solidFill>
                           <a:latin typeface="Calibri"/>
                         </a:rPr>
-                        <a:t>104.246,01</a:t>
+                        <a:t>—</a:t>
                       </a:r>
                     </a:p>
                   </a:txBody>
@@ -17029,7 +16354,7 @@
                           </a:solidFill>
                           <a:latin typeface="Calibri"/>
                         </a:rPr>
-                        <a:t>Imbabura</a:t>
+                        <a:t>Loja</a:t>
                       </a:r>
                     </a:p>
                   </a:txBody>
@@ -17052,7 +16377,7 @@
                           </a:solidFill>
                           <a:latin typeface="Calibri"/>
                         </a:rPr>
-                        <a:t>498</a:t>
+                        <a:t>79</a:t>
                       </a:r>
                     </a:p>
                   </a:txBody>
@@ -17121,7 +16446,7 @@
                           </a:solidFill>
                           <a:latin typeface="Calibri"/>
                         </a:rPr>
-                        <a:t>5</a:t>
+                        <a:t>—</a:t>
                       </a:r>
                     </a:p>
                   </a:txBody>
@@ -17144,7 +16469,7 @@
                           </a:solidFill>
                           <a:latin typeface="Calibri"/>
                         </a:rPr>
-                        <a:t>1.519,95</a:t>
+                        <a:t>—</a:t>
                       </a:r>
                     </a:p>
                   </a:txBody>
@@ -17169,7 +16494,7 @@
                           </a:solidFill>
                           <a:latin typeface="Calibri"/>
                         </a:rPr>
-                        <a:t>Loja</a:t>
+                        <a:t>Los Ríos</a:t>
                       </a:r>
                     </a:p>
                   </a:txBody>
@@ -17192,7 +16517,7 @@
                           </a:solidFill>
                           <a:latin typeface="Calibri"/>
                         </a:rPr>
-                        <a:t>79</a:t>
+                        <a:t>64</a:t>
                       </a:r>
                     </a:p>
                   </a:txBody>
@@ -17309,7 +16634,7 @@
         </p:nvGraphicFramePr>
         <p:xfrm>
           <a:off x="6172200" y="1874519"/>
-          <a:ext cx="5486399" cy="4434840"/>
+          <a:ext cx="5486399" cy="4069080"/>
         </p:xfrm>
         <a:graphic>
           <a:graphicData uri="http://schemas.openxmlformats.org/drawingml/2006/table">
@@ -17479,7 +16804,7 @@
                           </a:solidFill>
                           <a:latin typeface="Calibri"/>
                         </a:rPr>
-                        <a:t>Los Ríos</a:t>
+                        <a:t>Manabí</a:t>
                       </a:r>
                     </a:p>
                   </a:txBody>
@@ -17502,7 +16827,7 @@
                           </a:solidFill>
                           <a:latin typeface="Calibri"/>
                         </a:rPr>
-                        <a:t>64</a:t>
+                        <a:t>110</a:t>
                       </a:r>
                     </a:p>
                   </a:txBody>
@@ -17571,7 +16896,7 @@
                           </a:solidFill>
                           <a:latin typeface="Calibri"/>
                         </a:rPr>
-                        <a:t>111</a:t>
+                        <a:t>—</a:t>
                       </a:r>
                     </a:p>
                   </a:txBody>
@@ -17594,7 +16919,7 @@
                           </a:solidFill>
                           <a:latin typeface="Calibri"/>
                         </a:rPr>
-                        <a:t>33.641,04</a:t>
+                        <a:t>—</a:t>
                       </a:r>
                     </a:p>
                   </a:txBody>
@@ -17619,7 +16944,7 @@
                           </a:solidFill>
                           <a:latin typeface="Calibri"/>
                         </a:rPr>
-                        <a:t>Manabí</a:t>
+                        <a:t>Morona Santiago</a:t>
                       </a:r>
                     </a:p>
                   </a:txBody>
@@ -17642,7 +16967,7 @@
                           </a:solidFill>
                           <a:latin typeface="Calibri"/>
                         </a:rPr>
-                        <a:t>110</a:t>
+                        <a:t>120</a:t>
                       </a:r>
                     </a:p>
                   </a:txBody>
@@ -17665,7 +16990,7 @@
                           </a:solidFill>
                           <a:latin typeface="Calibri"/>
                         </a:rPr>
-                        <a:t>45</a:t>
+                        <a:t>—</a:t>
                       </a:r>
                     </a:p>
                   </a:txBody>
@@ -17688,7 +17013,7 @@
                           </a:solidFill>
                           <a:latin typeface="Calibri"/>
                         </a:rPr>
-                        <a:t>13.632,30</a:t>
+                        <a:t>—</a:t>
                       </a:r>
                     </a:p>
                   </a:txBody>
@@ -17759,7 +17084,7 @@
                           </a:solidFill>
                           <a:latin typeface="Calibri"/>
                         </a:rPr>
-                        <a:t>Morona Santiago</a:t>
+                        <a:t>Napo</a:t>
                       </a:r>
                     </a:p>
                   </a:txBody>
@@ -17782,7 +17107,7 @@
                           </a:solidFill>
                           <a:latin typeface="Calibri"/>
                         </a:rPr>
-                        <a:t>205</a:t>
+                        <a:t>180</a:t>
                       </a:r>
                     </a:p>
                   </a:txBody>
@@ -17899,7 +17224,7 @@
                           </a:solidFill>
                           <a:latin typeface="Calibri"/>
                         </a:rPr>
-                        <a:t>Napo</a:t>
+                        <a:t>Pastaza</a:t>
                       </a:r>
                     </a:p>
                   </a:txBody>
@@ -17922,7 +17247,7 @@
                           </a:solidFill>
                           <a:latin typeface="Calibri"/>
                         </a:rPr>
-                        <a:t>180</a:t>
+                        <a:t>7</a:t>
                       </a:r>
                     </a:p>
                   </a:txBody>
@@ -18039,7 +17364,7 @@
                           </a:solidFill>
                           <a:latin typeface="Calibri"/>
                         </a:rPr>
-                        <a:t>Pastaza</a:t>
+                        <a:t>Pichincha</a:t>
                       </a:r>
                     </a:p>
                   </a:txBody>
@@ -18062,7 +17387,7 @@
                           </a:solidFill>
                           <a:latin typeface="Calibri"/>
                         </a:rPr>
-                        <a:t>7</a:t>
+                        <a:t>17</a:t>
                       </a:r>
                     </a:p>
                   </a:txBody>
@@ -18179,7 +17504,7 @@
                           </a:solidFill>
                           <a:latin typeface="Calibri"/>
                         </a:rPr>
-                        <a:t>Pichincha</a:t>
+                        <a:t>Santa Elena</a:t>
                       </a:r>
                     </a:p>
                   </a:txBody>
@@ -18202,7 +17527,7 @@
                           </a:solidFill>
                           <a:latin typeface="Calibri"/>
                         </a:rPr>
-                        <a:t>64</a:t>
+                        <a:t>10</a:t>
                       </a:r>
                     </a:p>
                   </a:txBody>
@@ -18319,7 +17644,7 @@
                           </a:solidFill>
                           <a:latin typeface="Calibri"/>
                         </a:rPr>
-                        <a:t>Santa Elena</a:t>
+                        <a:t>Santo Domingo de los Tsáchilas</a:t>
                       </a:r>
                     </a:p>
                   </a:txBody>
@@ -18342,7 +17667,7 @@
                           </a:solidFill>
                           <a:latin typeface="Calibri"/>
                         </a:rPr>
-                        <a:t>13</a:t>
+                        <a:t>17</a:t>
                       </a:r>
                     </a:p>
                   </a:txBody>
@@ -18459,7 +17784,7 @@
                           </a:solidFill>
                           <a:latin typeface="Calibri"/>
                         </a:rPr>
-                        <a:t>Santo Domingo de los Tsáchilas</a:t>
+                        <a:t>Sucumbíos</a:t>
                       </a:r>
                     </a:p>
                   </a:txBody>
@@ -18482,7 +17807,7 @@
                           </a:solidFill>
                           <a:latin typeface="Calibri"/>
                         </a:rPr>
-                        <a:t>17</a:t>
+                        <a:t>44</a:t>
                       </a:r>
                     </a:p>
                   </a:txBody>
@@ -18599,7 +17924,7 @@
                           </a:solidFill>
                           <a:latin typeface="Calibri"/>
                         </a:rPr>
-                        <a:t>Sucumbíos</a:t>
+                        <a:t>Tungurahua</a:t>
                       </a:r>
                     </a:p>
                   </a:txBody>
@@ -18622,7 +17947,7 @@
                           </a:solidFill>
                           <a:latin typeface="Calibri"/>
                         </a:rPr>
-                        <a:t>44</a:t>
+                        <a:t>5</a:t>
                       </a:r>
                     </a:p>
                   </a:txBody>
@@ -18739,7 +18064,7 @@
                           </a:solidFill>
                           <a:latin typeface="Calibri"/>
                         </a:rPr>
-                        <a:t>Tungurahua</a:t>
+                        <a:t>Zamora Chinchipe</a:t>
                       </a:r>
                     </a:p>
                   </a:txBody>
@@ -18762,7 +18087,7 @@
                           </a:solidFill>
                           <a:latin typeface="Calibri"/>
                         </a:rPr>
-                        <a:t>17</a:t>
+                        <a:t>11</a:t>
                       </a:r>
                     </a:p>
                   </a:txBody>
@@ -18861,146 +18186,6 @@
                   <a:tcPr marL="73152" marR="73152" marT="27432" marB="27432" anchor="ctr">
                     <a:solidFill>
                       <a:srgbClr val="F7F5FA"/>
-                    </a:solidFill>
-                  </a:tcPr>
-                </a:tc>
-              </a:tr>
-              <a:tr h="365760">
-                <a:tc>
-                  <a:txBody>
-                    <a:bodyPr wrap="square"/>
-                    <a:lstStyle/>
-                    <a:p>
-                      <a:pPr algn="l"/>
-                      <a:r>
-                        <a:rPr sz="950" b="1">
-                          <a:solidFill>
-                            <a:srgbClr val="2B164F"/>
-                          </a:solidFill>
-                          <a:latin typeface="Calibri"/>
-                        </a:rPr>
-                        <a:t>Zamora Chinchipe</a:t>
-                      </a:r>
-                    </a:p>
-                  </a:txBody>
-                  <a:tcPr marL="73152" marR="73152" marT="27432" marB="27432" anchor="ctr">
-                    <a:solidFill>
-                      <a:srgbClr val="FFFFFF"/>
-                    </a:solidFill>
-                  </a:tcPr>
-                </a:tc>
-                <a:tc>
-                  <a:txBody>
-                    <a:bodyPr wrap="square"/>
-                    <a:lstStyle/>
-                    <a:p>
-                      <a:pPr algn="r"/>
-                      <a:r>
-                        <a:rPr sz="950" b="0">
-                          <a:solidFill>
-                            <a:srgbClr val="20202B"/>
-                          </a:solidFill>
-                          <a:latin typeface="Calibri"/>
-                        </a:rPr>
-                        <a:t>11</a:t>
-                      </a:r>
-                    </a:p>
-                  </a:txBody>
-                  <a:tcPr marL="73152" marR="73152" marT="27432" marB="27432" anchor="ctr">
-                    <a:solidFill>
-                      <a:srgbClr val="FFFFFF"/>
-                    </a:solidFill>
-                  </a:tcPr>
-                </a:tc>
-                <a:tc>
-                  <a:txBody>
-                    <a:bodyPr wrap="square"/>
-                    <a:lstStyle/>
-                    <a:p>
-                      <a:pPr algn="r"/>
-                      <a:r>
-                        <a:rPr sz="950" b="0">
-                          <a:solidFill>
-                            <a:srgbClr val="20202B"/>
-                          </a:solidFill>
-                          <a:latin typeface="Calibri"/>
-                        </a:rPr>
-                        <a:t>—</a:t>
-                      </a:r>
-                    </a:p>
-                  </a:txBody>
-                  <a:tcPr marL="73152" marR="73152" marT="27432" marB="27432" anchor="ctr">
-                    <a:solidFill>
-                      <a:srgbClr val="FFFFFF"/>
-                    </a:solidFill>
-                  </a:tcPr>
-                </a:tc>
-                <a:tc>
-                  <a:txBody>
-                    <a:bodyPr wrap="square"/>
-                    <a:lstStyle/>
-                    <a:p>
-                      <a:pPr algn="r"/>
-                      <a:r>
-                        <a:rPr sz="950" b="0">
-                          <a:solidFill>
-                            <a:srgbClr val="20202B"/>
-                          </a:solidFill>
-                          <a:latin typeface="Calibri"/>
-                        </a:rPr>
-                        <a:t>—</a:t>
-                      </a:r>
-                    </a:p>
-                  </a:txBody>
-                  <a:tcPr marL="73152" marR="73152" marT="27432" marB="27432" anchor="ctr">
-                    <a:solidFill>
-                      <a:srgbClr val="FFFFFF"/>
-                    </a:solidFill>
-                  </a:tcPr>
-                </a:tc>
-                <a:tc>
-                  <a:txBody>
-                    <a:bodyPr wrap="square"/>
-                    <a:lstStyle/>
-                    <a:p>
-                      <a:pPr algn="r"/>
-                      <a:r>
-                        <a:rPr sz="950" b="0">
-                          <a:solidFill>
-                            <a:srgbClr val="20202B"/>
-                          </a:solidFill>
-                          <a:latin typeface="Calibri"/>
-                        </a:rPr>
-                        <a:t>—</a:t>
-                      </a:r>
-                    </a:p>
-                  </a:txBody>
-                  <a:tcPr marL="73152" marR="73152" marT="27432" marB="27432" anchor="ctr">
-                    <a:solidFill>
-                      <a:srgbClr val="FFFFFF"/>
-                    </a:solidFill>
-                  </a:tcPr>
-                </a:tc>
-                <a:tc>
-                  <a:txBody>
-                    <a:bodyPr wrap="square"/>
-                    <a:lstStyle/>
-                    <a:p>
-                      <a:pPr algn="r"/>
-                      <a:r>
-                        <a:rPr sz="950" b="0">
-                          <a:solidFill>
-                            <a:srgbClr val="20202B"/>
-                          </a:solidFill>
-                          <a:latin typeface="Calibri"/>
-                        </a:rPr>
-                        <a:t>—</a:t>
-                      </a:r>
-                    </a:p>
-                  </a:txBody>
-                  <a:tcPr marL="73152" marR="73152" marT="27432" marB="27432" anchor="ctr">
-                    <a:solidFill>
-                      <a:srgbClr val="FFFFFF"/>
                     </a:solidFill>
                   </a:tcPr>
                 </a:tc>
@@ -19160,7 +18345,7 @@
                 </a:solidFill>
                 <a:latin typeface="Calibri"/>
               </a:rPr>
-              <a:t>Del 14/09/2026 al 27/10/2026 · Nacional · Todos los servicios</a:t>
+              <a:t>Del 28/09/2026 al 27/10/2026 · Nacional · Todos los servicios</a:t>
             </a:r>
           </a:p>
         </p:txBody>
@@ -19587,7 +18772,7 @@
                 </a:solidFill>
                 <a:latin typeface="Calibri"/>
               </a:rPr>
-              <a:t>Del 14/09/2026 al 27/10/2026 · Nacional · Todos los servicios</a:t>
+              <a:t>Del 28/09/2026 al 27/10/2026 · Nacional · Todos los servicios</a:t>
             </a:r>
           </a:p>
         </p:txBody>
@@ -20124,7 +19309,7 @@
                 </a:solidFill>
                 <a:latin typeface="Calibri"/>
               </a:rPr>
-              <a:t>Del 14/09/2026 al 27/10/2026 · Nacional · Todos los servicios</a:t>
+              <a:t>Del 28/09/2026 al 27/10/2026 · Nacional · Todos los servicios</a:t>
             </a:r>
           </a:p>
         </p:txBody>
@@ -20257,7 +19442,7 @@
                 </a:solidFill>
                 <a:latin typeface="Calibri"/>
               </a:rPr>
-              <a:t>Seguimiento desde el 14/09/2026, complementado con reportes sectoriales de octubre. Los reportes gerontológicos utilizan su fecha de reporte. Los identificadores DIS/GER/DII permiten localizar las filas incorporadas; no son códigos oficiales ni códigos UA. Los registros repetidos de la base consolidada se cuentan una sola vez. Alertas, unidades y personas son medidas distintas.</a:t>
+              <a:t>Seguimiento desde el 28/09/2026, complementado con reportes sectoriales de octubre. Los reportes gerontológicos utilizan su fecha de reporte. Los identificadores DIS/GER/DII permiten localizar las filas incorporadas; no son códigos oficiales ni códigos UA. Los registros repetidos de la base consolidada se cuentan una sola vez. Alertas, unidades y personas son medidas distintas.</a:t>
             </a:r>
           </a:p>
           <a:p>
@@ -20273,7 +19458,7 @@
                 </a:solidFill>
                 <a:latin typeface="Calibri"/>
               </a:rPr>
-              <a:t>Kits en provincias priorizadas: Kobo, corte 27/10/2026, 13:35:45. Entregas del 31/08 al 27/10; reemplaza el corte anterior. 13.981 kits reportados en 111 registros. Núcleos familiares: suma por entrega, no núcleos únicos. El registro de Cañar declara 1 kit, pero su observación indica una solicitud no recibida; pendiente de validación territorial.</a:t>
+              <a:t>Kits en provincias priorizadas: entregas desde el 28/09/2026 hasta el corte Kobo del 27/10/2026, 13:35:45. El registro de Cañar declara 1 kit, pero su observación indica una solicitud no recibida; pendiente de validación territorial.</a:t>
             </a:r>
           </a:p>
           <a:p>
@@ -20363,7 +19548,7 @@
                 </a:solidFill>
                 <a:latin typeface="Calibri"/>
               </a:rPr>
-              <a:t>Bono en articulación actualizado con la tabla provincial remitida el 27/10/2026: inundación, colapso estructural y vendaval. Pagos gestionados: ayuda memoria del 23/10, desde el 29/08. Articulación no equivale a pago. Las proyecciones corresponden a planificación nacional 2026–2027.</a:t>
+              <a:t>Sin desglose temporal disponible para bonos desde el 28/09/2026. Los acumulados recibidos no permiten identificar la fecha de cada gestión. Las proyecciones son una referencia de planificación, no ejecución del período.</a:t>
             </a:r>
           </a:p>
           <a:p>
@@ -20551,7 +19736,7 @@
                 </a:solidFill>
                 <a:latin typeface="Calibri"/>
               </a:rPr>
-              <a:t>Del 14/09/2026 al 27/10/2026 · Nacional · Todos los servicios</a:t>
+              <a:t>Del 28/09/2026 al 27/10/2026 · Nacional · Todos los servicios</a:t>
             </a:r>
           </a:p>
         </p:txBody>
@@ -22615,7 +21800,7 @@
                 </a:solidFill>
                 <a:latin typeface="Calibri"/>
               </a:rPr>
-              <a:t>Del 14/09/2026 al 27/10/2026 · Nacional · Todos los servicios</a:t>
+              <a:t>Del 28/09/2026 al 27/10/2026 · Nacional · Todos los servicios</a:t>
             </a:r>
           </a:p>
         </p:txBody>
@@ -24679,7 +23864,7 @@
                 </a:solidFill>
                 <a:latin typeface="Calibri"/>
               </a:rPr>
-              <a:t>Del 14/09/2026 al 27/10/2026 · Nacional · Todos los servicios</a:t>
+              <a:t>Del 28/09/2026 al 27/10/2026 · Nacional · Todos los servicios</a:t>
             </a:r>
           </a:p>
         </p:txBody>
@@ -26743,7 +25928,7 @@
                 </a:solidFill>
                 <a:latin typeface="Calibri"/>
               </a:rPr>
-              <a:t>Del 14/09/2026 al 27/10/2026 · Nacional · Todos los servicios</a:t>
+              <a:t>Del 28/09/2026 al 27/10/2026 · Nacional · Todos los servicios</a:t>
             </a:r>
           </a:p>
         </p:txBody>
@@ -28807,7 +27992,7 @@
                 </a:solidFill>
                 <a:latin typeface="Calibri"/>
               </a:rPr>
-              <a:t>Del 14/09/2026 al 27/10/2026 · Nacional · Todos los servicios</a:t>
+              <a:t>Del 28/09/2026 al 27/10/2026 · Nacional · Todos los servicios</a:t>
             </a:r>
           </a:p>
         </p:txBody>
@@ -30871,7 +30056,7 @@
                 </a:solidFill>
                 <a:latin typeface="Calibri"/>
               </a:rPr>
-              <a:t>Del 14/09/2026 al 27/10/2026 · Nacional · Todos los servicios</a:t>
+              <a:t>Del 28/09/2026 al 27/10/2026 · Nacional · Todos los servicios</a:t>
             </a:r>
           </a:p>
         </p:txBody>
@@ -32089,7 +31274,7 @@
                 </a:solidFill>
                 <a:latin typeface="Calibri"/>
               </a:rPr>
-              <a:t>Del 14/09/2026 al 27/10/2026 · Nacional · Todos los servicios</a:t>
+              <a:t>Del 28/09/2026 al 27/10/2026 · Nacional · Todos los servicios</a:t>
             </a:r>
           </a:p>
         </p:txBody>
@@ -32253,7 +31438,7 @@
                 </a:solidFill>
                 <a:latin typeface="Calibri"/>
               </a:rPr>
-              <a:t>Registradas cada día y acumuladas desde el 14/09/2026</a:t>
+              <a:t>Registradas cada día y acumuladas desde el 28/09/2026</a:t>
             </a:r>
           </a:p>
         </p:txBody>
@@ -33091,7 +32276,7 @@
             </a:avLst>
           </a:prstGeom>
           <a:solidFill>
-            <a:srgbClr val="A995E0"/>
+            <a:srgbClr val="F8C018"/>
           </a:solidFill>
           <a:ln>
             <a:noFill/>
@@ -33115,6 +32300,38 @@
         <p:spPr>
           <a:xfrm>
             <a:off x="10241280" y="3154680"/>
+            <a:ext cx="301752" cy="301752"/>
+          </a:xfrm>
+          <a:prstGeom prst="roundRect">
+            <a:avLst>
+              <a:gd name="adj" fmla="val 12000"/>
+            </a:avLst>
+          </a:prstGeom>
+          <a:solidFill>
+            <a:srgbClr val="F8C018"/>
+          </a:solidFill>
+          <a:ln>
+            <a:noFill/>
+          </a:ln>
+          <a:effectLst/>
+        </p:spPr>
+        <p:txBody>
+          <a:bodyPr rtlCol="0" anchor="ctr"/>
+          <a:lstStyle/>
+          <a:p>
+            <a:pPr algn="ctr"/>
+          </a:p>
+        </p:txBody>
+      </p:sp>
+      <p:sp>
+        <p:nvSpPr>
+          <p:cNvPr id="38" name="Rounded Rectangle 37"/>
+          <p:cNvSpPr/>
+          <p:nvPr/>
+        </p:nvSpPr>
+        <p:spPr>
+          <a:xfrm>
+            <a:off x="10607040" y="3154680"/>
             <a:ext cx="301752" cy="301752"/>
           </a:xfrm>
           <a:prstGeom prst="roundRect">
@@ -33140,38 +32357,6 @@
       </p:sp>
       <p:sp>
         <p:nvSpPr>
-          <p:cNvPr id="38" name="Rounded Rectangle 37"/>
-          <p:cNvSpPr/>
-          <p:nvPr/>
-        </p:nvSpPr>
-        <p:spPr>
-          <a:xfrm>
-            <a:off x="10607040" y="3154680"/>
-            <a:ext cx="301752" cy="301752"/>
-          </a:xfrm>
-          <a:prstGeom prst="roundRect">
-            <a:avLst>
-              <a:gd name="adj" fmla="val 12000"/>
-            </a:avLst>
-          </a:prstGeom>
-          <a:solidFill>
-            <a:srgbClr val="F8C018"/>
-          </a:solidFill>
-          <a:ln>
-            <a:noFill/>
-          </a:ln>
-          <a:effectLst/>
-        </p:spPr>
-        <p:txBody>
-          <a:bodyPr rtlCol="0" anchor="ctr"/>
-          <a:lstStyle/>
-          <a:p>
-            <a:pPr algn="ctr"/>
-          </a:p>
-        </p:txBody>
-      </p:sp>
-      <p:sp>
-        <p:nvSpPr>
           <p:cNvPr id="39" name="Rounded Rectangle 38"/>
           <p:cNvSpPr/>
           <p:nvPr/>
@@ -33187,7 +32372,7 @@
             </a:avLst>
           </a:prstGeom>
           <a:solidFill>
-            <a:srgbClr val="F8C018"/>
+            <a:srgbClr val="A995E0"/>
           </a:solidFill>
           <a:ln>
             <a:noFill/>
@@ -33816,7 +33001,7 @@
             </a:avLst>
           </a:prstGeom>
           <a:solidFill>
-            <a:srgbClr val="A995E0"/>
+            <a:srgbClr val="F8C018"/>
           </a:solidFill>
           <a:ln>
             <a:noFill/>
@@ -33861,7 +33046,7 @@
                 </a:solidFill>
                 <a:latin typeface="Calibri"/>
               </a:rPr>
-              <a:t>CNH · 6</a:t>
+              <a:t>Gerontología · 6</a:t>
             </a:r>
           </a:p>
         </p:txBody>
@@ -33883,7 +33068,7 @@
             </a:avLst>
           </a:prstGeom>
           <a:solidFill>
-            <a:srgbClr val="F8C018"/>
+            <a:srgbClr val="A995E0"/>
           </a:solidFill>
           <a:ln>
             <a:noFill/>
@@ -33928,7 +33113,7 @@
                 </a:solidFill>
                 <a:latin typeface="Calibri"/>
               </a:rPr>
-              <a:t>Gerontología · 6</a:t>
+              <a:t>CNH · 6</a:t>
             </a:r>
           </a:p>
         </p:txBody>

</xml_diff>

<commit_message>
Restituir los 1.171 casos de bono confirmados para el período desde el 28/09
</commit_message>
<xml_diff>
--- a/docs/reportes/Seguimiento_ENOS_2026-10-26.pptx
+++ b/docs/reportes/Seguimiento_ENOS_2026-10-26.pptx
@@ -255,6 +255,447 @@
 </c:chartSpace>
 </file>
 
+<file path=ppt/charts/chart2.xml><?xml version="1.0" encoding="utf-8"?>
+<c:chartSpace xmlns:c="http://schemas.openxmlformats.org/drawingml/2006/chart" xmlns:a="http://schemas.openxmlformats.org/drawingml/2006/main" xmlns:r="http://schemas.openxmlformats.org/officeDocument/2006/relationships">
+  <c:date1904 val="0"/>
+  <c:chart>
+    <c:autoTitleDeleted val="1"/>
+    <c:plotArea>
+      <c:barChart>
+        <c:barDir val="bar"/>
+        <c:grouping val="percentStacked"/>
+        <c:ser>
+          <c:idx val="0"/>
+          <c:order val="0"/>
+          <c:tx>
+            <c:strRef>
+              <c:f>Sheet1!$B$1</c:f>
+              <c:strCache>
+                <c:ptCount val="1"/>
+                <c:pt idx="0">
+                  <c:v>Esmeraldas</c:v>
+                </c:pt>
+              </c:strCache>
+            </c:strRef>
+          </c:tx>
+          <c:spPr>
+            <a:solidFill>
+              <a:srgbClr val="7657B9"/>
+            </a:solidFill>
+            <a:ln w="25400">
+              <a:solidFill>
+                <a:srgbClr val="FFFFFF"/>
+              </a:solidFill>
+            </a:ln>
+          </c:spPr>
+          <c:dLbls>
+            <c:numFmt formatCode="#,##0;-#,##0;&quot;&quot;" sourceLinked="0"/>
+            <c:txPr>
+              <a:bodyPr/>
+              <a:lstStyle/>
+              <a:p>
+                <a:pPr>
+                  <a:defRPr sz="1200" b="1">
+                    <a:solidFill>
+                      <a:srgbClr val="FFFFFF"/>
+                    </a:solidFill>
+                  </a:defRPr>
+                </a:pPr>
+              </a:p>
+            </c:txPr>
+            <c:dLblPos val="ctr"/>
+            <c:showLegendKey val="0"/>
+            <c:showVal val="1"/>
+            <c:showCatName val="0"/>
+            <c:showSerName val="0"/>
+            <c:showPercent val="0"/>
+            <c:showBubbleSize val="0"/>
+            <c:showLeaderLines val="1"/>
+          </c:dLbls>
+          <c:cat>
+            <c:strRef>
+              <c:f>Sheet1!$A$2:$A$2</c:f>
+              <c:strCache>
+                <c:ptCount val="1"/>
+                <c:pt idx="0">
+                  <c:v>En articulación
+1.171 personas · USD 354.987,39</c:v>
+                </c:pt>
+              </c:strCache>
+            </c:strRef>
+          </c:cat>
+          <c:val>
+            <c:numRef>
+              <c:f>Sheet1!$B$2:$B$2</c:f>
+              <c:numCache>
+                <c:formatCode>#,##0</c:formatCode>
+                <c:ptCount val="1"/>
+                <c:pt idx="0">
+                  <c:v>530</c:v>
+                </c:pt>
+              </c:numCache>
+            </c:numRef>
+          </c:val>
+        </c:ser>
+        <c:ser>
+          <c:idx val="1"/>
+          <c:order val="1"/>
+          <c:tx>
+            <c:strRef>
+              <c:f>Sheet1!$C$1</c:f>
+              <c:strCache>
+                <c:ptCount val="1"/>
+                <c:pt idx="0">
+                  <c:v>Guayas</c:v>
+                </c:pt>
+              </c:strCache>
+            </c:strRef>
+          </c:tx>
+          <c:spPr>
+            <a:solidFill>
+              <a:srgbClr val="512F8D"/>
+            </a:solidFill>
+            <a:ln w="25400">
+              <a:solidFill>
+                <a:srgbClr val="FFFFFF"/>
+              </a:solidFill>
+            </a:ln>
+          </c:spPr>
+          <c:dLbls>
+            <c:numFmt formatCode="#,##0;-#,##0;&quot;&quot;" sourceLinked="0"/>
+            <c:txPr>
+              <a:bodyPr/>
+              <a:lstStyle/>
+              <a:p>
+                <a:pPr>
+                  <a:defRPr sz="1200" b="1">
+                    <a:solidFill>
+                      <a:srgbClr val="FFFFFF"/>
+                    </a:solidFill>
+                  </a:defRPr>
+                </a:pPr>
+              </a:p>
+            </c:txPr>
+            <c:dLblPos val="ctr"/>
+            <c:showLegendKey val="0"/>
+            <c:showVal val="1"/>
+            <c:showCatName val="0"/>
+            <c:showSerName val="0"/>
+            <c:showPercent val="0"/>
+            <c:showBubbleSize val="0"/>
+            <c:showLeaderLines val="1"/>
+          </c:dLbls>
+          <c:cat>
+            <c:strRef>
+              <c:f>Sheet1!$A$2:$A$2</c:f>
+              <c:strCache>
+                <c:ptCount val="1"/>
+                <c:pt idx="0">
+                  <c:v>En articulación
+1.171 personas · USD 354.987,39</c:v>
+                </c:pt>
+              </c:strCache>
+            </c:strRef>
+          </c:cat>
+          <c:val>
+            <c:numRef>
+              <c:f>Sheet1!$C$2:$C$2</c:f>
+              <c:numCache>
+                <c:formatCode>#,##0</c:formatCode>
+                <c:ptCount val="1"/>
+                <c:pt idx="0">
+                  <c:v>344</c:v>
+                </c:pt>
+              </c:numCache>
+            </c:numRef>
+          </c:val>
+        </c:ser>
+        <c:ser>
+          <c:idx val="2"/>
+          <c:order val="2"/>
+          <c:tx>
+            <c:strRef>
+              <c:f>Sheet1!$D$1</c:f>
+              <c:strCache>
+                <c:ptCount val="1"/>
+                <c:pt idx="0">
+                  <c:v>El Oro</c:v>
+                </c:pt>
+              </c:strCache>
+            </c:strRef>
+          </c:tx>
+          <c:spPr>
+            <a:solidFill>
+              <a:srgbClr val="A995E0"/>
+            </a:solidFill>
+            <a:ln w="25400">
+              <a:solidFill>
+                <a:srgbClr val="FFFFFF"/>
+              </a:solidFill>
+            </a:ln>
+          </c:spPr>
+          <c:dLbls>
+            <c:numFmt formatCode="#,##0;-#,##0;&quot;&quot;" sourceLinked="0"/>
+            <c:txPr>
+              <a:bodyPr/>
+              <a:lstStyle/>
+              <a:p>
+                <a:pPr>
+                  <a:defRPr sz="1200" b="1">
+                    <a:solidFill>
+                      <a:srgbClr val="2B164F"/>
+                    </a:solidFill>
+                  </a:defRPr>
+                </a:pPr>
+              </a:p>
+            </c:txPr>
+            <c:dLblPos val="ctr"/>
+            <c:showLegendKey val="0"/>
+            <c:showVal val="1"/>
+            <c:showCatName val="0"/>
+            <c:showSerName val="0"/>
+            <c:showPercent val="0"/>
+            <c:showBubbleSize val="0"/>
+            <c:showLeaderLines val="1"/>
+          </c:dLbls>
+          <c:cat>
+            <c:strRef>
+              <c:f>Sheet1!$A$2:$A$2</c:f>
+              <c:strCache>
+                <c:ptCount val="1"/>
+                <c:pt idx="0">
+                  <c:v>En articulación
+1.171 personas · USD 354.987,39</c:v>
+                </c:pt>
+              </c:strCache>
+            </c:strRef>
+          </c:cat>
+          <c:val>
+            <c:numRef>
+              <c:f>Sheet1!$D$2:$D$2</c:f>
+              <c:numCache>
+                <c:formatCode>#,##0</c:formatCode>
+                <c:ptCount val="1"/>
+                <c:pt idx="0">
+                  <c:v>181</c:v>
+                </c:pt>
+              </c:numCache>
+            </c:numRef>
+          </c:val>
+        </c:ser>
+        <c:ser>
+          <c:idx val="3"/>
+          <c:order val="3"/>
+          <c:tx>
+            <c:strRef>
+              <c:f>Sheet1!$E$1</c:f>
+              <c:strCache>
+                <c:ptCount val="1"/>
+                <c:pt idx="0">
+                  <c:v>Los Ríos</c:v>
+                </c:pt>
+              </c:strCache>
+            </c:strRef>
+          </c:tx>
+          <c:spPr>
+            <a:solidFill>
+              <a:srgbClr val="A32C74"/>
+            </a:solidFill>
+            <a:ln w="25400">
+              <a:solidFill>
+                <a:srgbClr val="FFFFFF"/>
+              </a:solidFill>
+            </a:ln>
+          </c:spPr>
+          <c:dLbls>
+            <c:numFmt formatCode="#,##0;-#,##0;&quot;&quot;" sourceLinked="0"/>
+            <c:txPr>
+              <a:bodyPr/>
+              <a:lstStyle/>
+              <a:p>
+                <a:pPr>
+                  <a:defRPr sz="1200" b="1">
+                    <a:solidFill>
+                      <a:srgbClr val="FFFFFF"/>
+                    </a:solidFill>
+                  </a:defRPr>
+                </a:pPr>
+              </a:p>
+            </c:txPr>
+            <c:dLblPos val="ctr"/>
+            <c:showLegendKey val="0"/>
+            <c:showVal val="1"/>
+            <c:showCatName val="0"/>
+            <c:showSerName val="0"/>
+            <c:showPercent val="0"/>
+            <c:showBubbleSize val="0"/>
+            <c:showLeaderLines val="1"/>
+          </c:dLbls>
+          <c:cat>
+            <c:strRef>
+              <c:f>Sheet1!$A$2:$A$2</c:f>
+              <c:strCache>
+                <c:ptCount val="1"/>
+                <c:pt idx="0">
+                  <c:v>En articulación
+1.171 personas · USD 354.987,39</c:v>
+                </c:pt>
+              </c:strCache>
+            </c:strRef>
+          </c:cat>
+          <c:val>
+            <c:numRef>
+              <c:f>Sheet1!$E$2:$E$2</c:f>
+              <c:numCache>
+                <c:formatCode>#,##0</c:formatCode>
+                <c:ptCount val="1"/>
+                <c:pt idx="0">
+                  <c:v>111</c:v>
+                </c:pt>
+              </c:numCache>
+            </c:numRef>
+          </c:val>
+        </c:ser>
+        <c:ser>
+          <c:idx val="4"/>
+          <c:order val="4"/>
+          <c:tx>
+            <c:strRef>
+              <c:f>Sheet1!$F$1</c:f>
+              <c:strCache>
+                <c:ptCount val="1"/>
+                <c:pt idx="0">
+                  <c:v>Imbabura</c:v>
+                </c:pt>
+              </c:strCache>
+            </c:strRef>
+          </c:tx>
+          <c:spPr>
+            <a:solidFill>
+              <a:srgbClr val="E6A3C5"/>
+            </a:solidFill>
+            <a:ln w="25400">
+              <a:solidFill>
+                <a:srgbClr val="FFFFFF"/>
+              </a:solidFill>
+            </a:ln>
+          </c:spPr>
+          <c:dLbls>
+            <c:dLbl>
+              <c:idx val="0"/>
+              <c:delete val="1"/>
+            </c:dLbl>
+            <c:numFmt formatCode="#,##0;-#,##0;&quot;&quot;" sourceLinked="0"/>
+            <c:txPr>
+              <a:bodyPr/>
+              <a:lstStyle/>
+              <a:p>
+                <a:pPr>
+                  <a:defRPr sz="1200" b="1">
+                    <a:solidFill>
+                      <a:srgbClr val="2B164F"/>
+                    </a:solidFill>
+                  </a:defRPr>
+                </a:pPr>
+              </a:p>
+            </c:txPr>
+            <c:dLblPos val="ctr"/>
+            <c:showLegendKey val="0"/>
+            <c:showVal val="1"/>
+            <c:showCatName val="0"/>
+            <c:showSerName val="0"/>
+            <c:showPercent val="0"/>
+            <c:showBubbleSize val="0"/>
+            <c:showLeaderLines val="1"/>
+          </c:dLbls>
+          <c:cat>
+            <c:strRef>
+              <c:f>Sheet1!$A$2:$A$2</c:f>
+              <c:strCache>
+                <c:ptCount val="1"/>
+                <c:pt idx="0">
+                  <c:v>En articulación
+1.171 personas · USD 354.987,39</c:v>
+                </c:pt>
+              </c:strCache>
+            </c:strRef>
+          </c:cat>
+          <c:val>
+            <c:numRef>
+              <c:f>Sheet1!$F$2:$F$2</c:f>
+              <c:numCache>
+                <c:formatCode>#,##0</c:formatCode>
+                <c:ptCount val="1"/>
+                <c:pt idx="0">
+                  <c:v>5</c:v>
+                </c:pt>
+              </c:numCache>
+            </c:numRef>
+          </c:val>
+        </c:ser>
+        <c:gapWidth val="70"/>
+        <c:overlap val="100"/>
+        <c:axId val="-2068027336"/>
+        <c:axId val="-2113994440"/>
+      </c:barChart>
+      <c:catAx>
+        <c:axId val="-2068027336"/>
+        <c:scaling>
+          <c:orientation val="maxMin"/>
+        </c:scaling>
+        <c:delete val="0"/>
+        <c:axPos val="l"/>
+        <c:majorTickMark val="out"/>
+        <c:minorTickMark val="none"/>
+        <c:tickLblPos val="nextTo"/>
+        <c:spPr>
+          <a:ln>
+            <a:noFill/>
+          </a:ln>
+        </c:spPr>
+        <c:crossAx val="-2113994440"/>
+        <c:crosses val="autoZero"/>
+        <c:auto val="1"/>
+        <c:lblAlgn val="ctr"/>
+        <c:lblOffset val="100"/>
+        <c:noMultiLvlLbl val="0"/>
+      </c:catAx>
+      <c:valAx>
+        <c:axId val="-2113994440"/>
+        <c:scaling/>
+        <c:delete/>
+        <c:axPos val="b"/>
+        <c:majorTickMark val="out"/>
+        <c:minorTickMark val="none"/>
+        <c:tickLblPos val="nextTo"/>
+        <c:crossAx val="-2068027336"/>
+        <c:crosses val="autoZero"/>
+      </c:valAx>
+    </c:plotArea>
+    <c:legend>
+      <c:legendPos val="b"/>
+      <c:overlay val="0"/>
+    </c:legend>
+    <c:dispBlanksAs val="gap"/>
+  </c:chart>
+  <c:txPr>
+    <a:bodyPr/>
+    <a:lstStyle/>
+    <a:p>
+      <a:pPr>
+        <a:defRPr sz="1200">
+          <a:latin typeface="Calibri"/>
+        </a:defRPr>
+      </a:pPr>
+      <a:endParaRPr lang="en-US"/>
+    </a:p>
+  </c:txPr>
+  <c:externalData r:id="rId1">
+    <c:autoUpdate val="0"/>
+  </c:externalData>
+</c:chartSpace>
+</file>
+
 <file path=ppt/notesMasters/notesMaster1.xml><?xml version="1.0" encoding="utf-8"?>
 <p:notesMaster xmlns:a="http://schemas.openxmlformats.org/drawingml/2006/main" xmlns:p="http://schemas.openxmlformats.org/presentationml/2006/main" xmlns:r="http://schemas.openxmlformats.org/officeDocument/2006/relationships">
   <p:cSld>
@@ -650,7 +1091,7 @@
           <a:lstStyle/>
           <a:p>
             <a:r>
-              <a:t>Alertas reportadas: 39. Kits entregados: 10.607. Personas · Bono de Contingencia: —. Monto · Bono de Contingencia: USD —. Unidades cerradas / suspendidas: 99. 99 unidades de atención con atención suspendida (64 CNH · 35 CDI); El Oro concentra 75 (75,8 %).</a:t>
+              <a:t>Alertas reportadas: 39. Kits entregados: 10.607. Personas · Bono de Contingencia: 1.171. Monto · Bono de Contingencia: USD 354.987,39. Unidades cerradas / suspendidas: 99. 99 unidades de atención con atención suspendida (64 CNH · 35 CDI); El Oro concentra 75 (75,8 %).</a:t>
             </a:r>
           </a:p>
         </p:txBody>
@@ -5261,7 +5702,7 @@
                 </a:solidFill>
                 <a:latin typeface="Calibri"/>
               </a:rPr>
-              <a:t>Actualizado el 27 de octubre de 2026, 11:37</a:t>
+              <a:t>Actualizado el 27 de octubre de 2026, 11:42</a:t>
             </a:r>
           </a:p>
           <a:p>
@@ -6036,7 +6477,7 @@
                 </a:solidFill>
                 <a:latin typeface="Century Gothic"/>
               </a:rPr>
-              <a:t>—</a:t>
+              <a:t>1.171</a:t>
             </a:r>
           </a:p>
         </p:txBody>
@@ -6071,7 +6512,7 @@
                 </a:solidFill>
                 <a:latin typeface="Calibri"/>
               </a:rPr>
-              <a:t>Sin desglose temporal disponible</a:t>
+              <a:t>En articulación para el pago</a:t>
             </a:r>
           </a:p>
         </p:txBody>
@@ -6257,13 +6698,13 @@
           <a:p>
             <a:pPr algn="l"/>
             <a:r>
-              <a:rPr sz="2800" b="1">
+              <a:rPr sz="2400" b="1">
                 <a:solidFill>
                   <a:srgbClr val="2B164F"/>
                 </a:solidFill>
                 <a:latin typeface="Century Gothic"/>
               </a:rPr>
-              <a:t>USD —</a:t>
+              <a:t>USD 354.987,39</a:t>
             </a:r>
           </a:p>
         </p:txBody>
@@ -6298,7 +6739,7 @@
                 </a:solidFill>
                 <a:latin typeface="Calibri"/>
               </a:rPr>
-              <a:t>Sin desglose temporal disponible</a:t>
+              <a:t>Corte del bono: 27/10/2026</a:t>
             </a:r>
           </a:p>
         </p:txBody>
@@ -14066,8 +14507,8 @@
         </p:nvSpPr>
         <p:spPr>
           <a:xfrm>
-            <a:off x="502920" y="1463040"/>
-            <a:ext cx="7040880" cy="457200"/>
+            <a:off x="502920" y="1243584"/>
+            <a:ext cx="7040880" cy="365760"/>
           </a:xfrm>
           <a:prstGeom prst="rect">
             <a:avLst/>
@@ -14082,20 +14523,73 @@
           <a:p>
             <a:pPr algn="l"/>
             <a:r>
-              <a:rPr sz="1400" b="0">
+              <a:rPr sz="1800" b="1">
+                <a:solidFill>
+                  <a:srgbClr val="2B164F"/>
+                </a:solidFill>
+                <a:latin typeface="Century Gothic"/>
+              </a:rPr>
+              <a:t>Cada etapa, por provincia</a:t>
+            </a:r>
+          </a:p>
+        </p:txBody>
+      </p:sp>
+      <p:sp>
+        <p:nvSpPr>
+          <p:cNvPr id="10" name="TextBox 9"/>
+          <p:cNvSpPr txBox="1"/>
+          <p:nvPr/>
+        </p:nvSpPr>
+        <p:spPr>
+          <a:xfrm>
+            <a:off x="502920" y="1627632"/>
+            <a:ext cx="7040880" cy="274320"/>
+          </a:xfrm>
+          <a:prstGeom prst="rect">
+            <a:avLst/>
+          </a:prstGeom>
+          <a:noFill/>
+        </p:spPr>
+        <p:txBody>
+          <a:bodyPr wrap="square" anchor="t" lIns="0" rIns="0" tIns="0" bIns="0">
+            <a:spAutoFit/>
+          </a:bodyPr>
+          <a:lstStyle/>
+          <a:p>
+            <a:pPr algn="l"/>
+            <a:r>
+              <a:rPr sz="1150" b="0">
                 <a:solidFill>
                   <a:srgbClr val="5A5765"/>
                 </a:solidFill>
                 <a:latin typeface="Calibri"/>
               </a:rPr>
-              <a:t>Sin desglose temporal del bono para este período.</a:t>
+              <a:t>Inundaciones · cada barra suma el 100 % de su etapa; las etapas no se suman</a:t>
             </a:r>
           </a:p>
         </p:txBody>
       </p:sp>
-      <p:sp>
-        <p:nvSpPr>
-          <p:cNvPr id="10" name="TextBox 9"/>
+      <p:graphicFrame>
+        <p:nvGraphicFramePr>
+          <p:cNvPr id="11" name="Chart 10"/>
+          <p:cNvGraphicFramePr>
+            <a:graphicFrameLocks noGrp="1"/>
+          </p:cNvGraphicFramePr>
+          <p:nvPr/>
+        </p:nvGraphicFramePr>
+        <p:xfrm>
+          <a:off x="411480" y="1874519"/>
+          <a:ext cx="7223760" cy="3566160"/>
+        </p:xfrm>
+        <a:graphic>
+          <a:graphicData uri="http://schemas.openxmlformats.org/drawingml/2006/chart">
+            <c:chart xmlns:c="http://schemas.openxmlformats.org/drawingml/2006/chart" r:id="rId4"/>
+          </a:graphicData>
+        </a:graphic>
+      </p:graphicFrame>
+      <p:sp>
+        <p:nvSpPr>
+          <p:cNvPr id="12" name="TextBox 11"/>
           <p:cNvSpPr txBox="1"/>
           <p:nvPr/>
         </p:nvSpPr>
@@ -14130,7 +14624,7 @@
       </p:sp>
       <p:sp>
         <p:nvSpPr>
-          <p:cNvPr id="11" name="TextBox 10"/>
+          <p:cNvPr id="13" name="TextBox 12"/>
           <p:cNvSpPr txBox="1"/>
           <p:nvPr/>
         </p:nvSpPr>
@@ -14165,7 +14659,7 @@
       </p:sp>
       <p:sp>
         <p:nvSpPr>
-          <p:cNvPr id="12" name="Rounded Rectangle 11"/>
+          <p:cNvPr id="14" name="Rounded Rectangle 13"/>
           <p:cNvSpPr/>
           <p:nvPr/>
         </p:nvSpPr>
@@ -14197,7 +14691,7 @@
       </p:sp>
       <p:sp>
         <p:nvSpPr>
-          <p:cNvPr id="13" name="Rectangle 12"/>
+          <p:cNvPr id="15" name="Rectangle 14"/>
           <p:cNvSpPr/>
           <p:nvPr/>
         </p:nvSpPr>
@@ -14227,7 +14721,7 @@
       </p:sp>
       <p:sp>
         <p:nvSpPr>
-          <p:cNvPr id="14" name="TextBox 13"/>
+          <p:cNvPr id="16" name="TextBox 15"/>
           <p:cNvSpPr txBox="1"/>
           <p:nvPr/>
         </p:nvSpPr>
@@ -14262,7 +14756,7 @@
       </p:sp>
       <p:sp>
         <p:nvSpPr>
-          <p:cNvPr id="15" name="TextBox 14"/>
+          <p:cNvPr id="17" name="TextBox 16"/>
           <p:cNvSpPr txBox="1"/>
           <p:nvPr/>
         </p:nvSpPr>
@@ -14297,7 +14791,7 @@
       </p:sp>
       <p:sp>
         <p:nvSpPr>
-          <p:cNvPr id="16" name="Rounded Rectangle 15"/>
+          <p:cNvPr id="18" name="Rounded Rectangle 17"/>
           <p:cNvSpPr/>
           <p:nvPr/>
         </p:nvSpPr>
@@ -14329,7 +14823,7 @@
       </p:sp>
       <p:sp>
         <p:nvSpPr>
-          <p:cNvPr id="17" name="Rectangle 16"/>
+          <p:cNvPr id="19" name="Rectangle 18"/>
           <p:cNvSpPr/>
           <p:nvPr/>
         </p:nvSpPr>
@@ -14359,7 +14853,7 @@
       </p:sp>
       <p:sp>
         <p:nvSpPr>
-          <p:cNvPr id="18" name="TextBox 17"/>
+          <p:cNvPr id="20" name="TextBox 19"/>
           <p:cNvSpPr txBox="1"/>
           <p:nvPr/>
         </p:nvSpPr>
@@ -14394,7 +14888,7 @@
       </p:sp>
       <p:sp>
         <p:nvSpPr>
-          <p:cNvPr id="19" name="TextBox 18"/>
+          <p:cNvPr id="21" name="TextBox 20"/>
           <p:cNvSpPr txBox="1"/>
           <p:nvPr/>
         </p:nvSpPr>
@@ -14429,7 +14923,7 @@
       </p:sp>
       <p:sp>
         <p:nvSpPr>
-          <p:cNvPr id="20" name="Rounded Rectangle 19"/>
+          <p:cNvPr id="22" name="Rounded Rectangle 21"/>
           <p:cNvSpPr/>
           <p:nvPr/>
         </p:nvSpPr>
@@ -14461,7 +14955,7 @@
       </p:sp>
       <p:sp>
         <p:nvSpPr>
-          <p:cNvPr id="21" name="Rectangle 20"/>
+          <p:cNvPr id="23" name="Rectangle 22"/>
           <p:cNvSpPr/>
           <p:nvPr/>
         </p:nvSpPr>
@@ -14491,7 +14985,7 @@
       </p:sp>
       <p:sp>
         <p:nvSpPr>
-          <p:cNvPr id="22" name="TextBox 21"/>
+          <p:cNvPr id="24" name="TextBox 23"/>
           <p:cNvSpPr txBox="1"/>
           <p:nvPr/>
         </p:nvSpPr>
@@ -14526,7 +15020,7 @@
       </p:sp>
       <p:sp>
         <p:nvSpPr>
-          <p:cNvPr id="23" name="TextBox 22"/>
+          <p:cNvPr id="25" name="TextBox 24"/>
           <p:cNvSpPr txBox="1"/>
           <p:nvPr/>
         </p:nvSpPr>
@@ -14561,7 +15055,7 @@
       </p:sp>
       <p:sp>
         <p:nvSpPr>
-          <p:cNvPr id="24" name="TextBox 23"/>
+          <p:cNvPr id="26" name="TextBox 25"/>
           <p:cNvSpPr txBox="1"/>
           <p:nvPr/>
         </p:nvSpPr>
@@ -14589,7 +15083,7 @@
                 </a:solidFill>
                 <a:latin typeface="Calibri"/>
               </a:rPr>
-              <a:t>Sin desglose temporal disponible para bonos desde el 28/09/2026. Los acumulados recibidos no permiten identificar la fecha de cada gestión. Las proyecciones son una referencia de planificación, no ejecución del período.</a:t>
+              <a:t>Bono en articulación: 1.171 personas y USD 354.987,39 correspondientes al período 28/09–27/10/2026. Los bonos gestionados no cuentan con desglose temporal para este período. Las proyecciones son una referencia de planificación.</a:t>
             </a:r>
           </a:p>
         </p:txBody>
@@ -15886,7 +16380,7 @@
                           </a:solidFill>
                           <a:latin typeface="Calibri"/>
                         </a:rPr>
-                        <a:t>—</a:t>
+                        <a:t>181</a:t>
                       </a:r>
                     </a:p>
                   </a:txBody>
@@ -15909,7 +16403,7 @@
                           </a:solidFill>
                           <a:latin typeface="Calibri"/>
                         </a:rPr>
-                        <a:t>—</a:t>
+                        <a:t>55.022,19</a:t>
                       </a:r>
                     </a:p>
                   </a:txBody>
@@ -16026,7 +16520,7 @@
                           </a:solidFill>
                           <a:latin typeface="Calibri"/>
                         </a:rPr>
-                        <a:t>—</a:t>
+                        <a:t>530</a:t>
                       </a:r>
                     </a:p>
                   </a:txBody>
@@ -16049,7 +16543,7 @@
                           </a:solidFill>
                           <a:latin typeface="Calibri"/>
                         </a:rPr>
-                        <a:t>—</a:t>
+                        <a:t>160.558,20</a:t>
                       </a:r>
                     </a:p>
                   </a:txBody>
@@ -16166,7 +16660,7 @@
                           </a:solidFill>
                           <a:latin typeface="Calibri"/>
                         </a:rPr>
-                        <a:t>—</a:t>
+                        <a:t>344</a:t>
                       </a:r>
                     </a:p>
                   </a:txBody>
@@ -16189,7 +16683,7 @@
                           </a:solidFill>
                           <a:latin typeface="Calibri"/>
                         </a:rPr>
-                        <a:t>—</a:t>
+                        <a:t>104.246,01</a:t>
                       </a:r>
                     </a:p>
                   </a:txBody>
@@ -16306,7 +16800,7 @@
                           </a:solidFill>
                           <a:latin typeface="Calibri"/>
                         </a:rPr>
-                        <a:t>—</a:t>
+                        <a:t>5</a:t>
                       </a:r>
                     </a:p>
                   </a:txBody>
@@ -16329,7 +16823,7 @@
                           </a:solidFill>
                           <a:latin typeface="Calibri"/>
                         </a:rPr>
-                        <a:t>—</a:t>
+                        <a:t>1.519,95</a:t>
                       </a:r>
                     </a:p>
                   </a:txBody>
@@ -16586,7 +17080,7 @@
                           </a:solidFill>
                           <a:latin typeface="Calibri"/>
                         </a:rPr>
-                        <a:t>—</a:t>
+                        <a:t>111</a:t>
                       </a:r>
                     </a:p>
                   </a:txBody>
@@ -16609,7 +17103,7 @@
                           </a:solidFill>
                           <a:latin typeface="Calibri"/>
                         </a:rPr>
-                        <a:t>—</a:t>
+                        <a:t>33.641,04</a:t>
                       </a:r>
                     </a:p>
                   </a:txBody>
@@ -19548,7 +20042,7 @@
                 </a:solidFill>
                 <a:latin typeface="Calibri"/>
               </a:rPr>
-              <a:t>Sin desglose temporal disponible para bonos desde el 28/09/2026. Los acumulados recibidos no permiten identificar la fecha de cada gestión. Las proyecciones son una referencia de planificación, no ejecución del período.</a:t>
+              <a:t>Bono en articulación: 1.171 personas y USD 354.987,39 correspondientes al período 28/09–27/10/2026. Los bonos gestionados no cuentan con desglose temporal para este período. Las proyecciones son una referencia de planificación.</a:t>
             </a:r>
           </a:p>
           <a:p>
@@ -32276,7 +32770,7 @@
             </a:avLst>
           </a:prstGeom>
           <a:solidFill>
-            <a:srgbClr val="F8C018"/>
+            <a:srgbClr val="A995E0"/>
           </a:solidFill>
           <a:ln>
             <a:noFill/>
@@ -32300,6 +32794,38 @@
         <p:spPr>
           <a:xfrm>
             <a:off x="10241280" y="3154680"/>
+            <a:ext cx="301752" cy="301752"/>
+          </a:xfrm>
+          <a:prstGeom prst="roundRect">
+            <a:avLst>
+              <a:gd name="adj" fmla="val 12000"/>
+            </a:avLst>
+          </a:prstGeom>
+          <a:solidFill>
+            <a:srgbClr val="A995E0"/>
+          </a:solidFill>
+          <a:ln>
+            <a:noFill/>
+          </a:ln>
+          <a:effectLst/>
+        </p:spPr>
+        <p:txBody>
+          <a:bodyPr rtlCol="0" anchor="ctr"/>
+          <a:lstStyle/>
+          <a:p>
+            <a:pPr algn="ctr"/>
+          </a:p>
+        </p:txBody>
+      </p:sp>
+      <p:sp>
+        <p:nvSpPr>
+          <p:cNvPr id="38" name="Rounded Rectangle 37"/>
+          <p:cNvSpPr/>
+          <p:nvPr/>
+        </p:nvSpPr>
+        <p:spPr>
+          <a:xfrm>
+            <a:off x="10607040" y="3154680"/>
             <a:ext cx="301752" cy="301752"/>
           </a:xfrm>
           <a:prstGeom prst="roundRect">
@@ -32325,38 +32851,6 @@
       </p:sp>
       <p:sp>
         <p:nvSpPr>
-          <p:cNvPr id="38" name="Rounded Rectangle 37"/>
-          <p:cNvSpPr/>
-          <p:nvPr/>
-        </p:nvSpPr>
-        <p:spPr>
-          <a:xfrm>
-            <a:off x="10607040" y="3154680"/>
-            <a:ext cx="301752" cy="301752"/>
-          </a:xfrm>
-          <a:prstGeom prst="roundRect">
-            <a:avLst>
-              <a:gd name="adj" fmla="val 12000"/>
-            </a:avLst>
-          </a:prstGeom>
-          <a:solidFill>
-            <a:srgbClr val="A995E0"/>
-          </a:solidFill>
-          <a:ln>
-            <a:noFill/>
-          </a:ln>
-          <a:effectLst/>
-        </p:spPr>
-        <p:txBody>
-          <a:bodyPr rtlCol="0" anchor="ctr"/>
-          <a:lstStyle/>
-          <a:p>
-            <a:pPr algn="ctr"/>
-          </a:p>
-        </p:txBody>
-      </p:sp>
-      <p:sp>
-        <p:nvSpPr>
           <p:cNvPr id="39" name="Rounded Rectangle 38"/>
           <p:cNvSpPr/>
           <p:nvPr/>
@@ -32372,7 +32866,7 @@
             </a:avLst>
           </a:prstGeom>
           <a:solidFill>
-            <a:srgbClr val="A995E0"/>
+            <a:srgbClr val="F8C018"/>
           </a:solidFill>
           <a:ln>
             <a:noFill/>
@@ -33001,7 +33495,7 @@
             </a:avLst>
           </a:prstGeom>
           <a:solidFill>
-            <a:srgbClr val="F8C018"/>
+            <a:srgbClr val="A995E0"/>
           </a:solidFill>
           <a:ln>
             <a:noFill/>
@@ -33046,7 +33540,7 @@
                 </a:solidFill>
                 <a:latin typeface="Calibri"/>
               </a:rPr>
-              <a:t>Gerontología · 6</a:t>
+              <a:t>CNH · 6</a:t>
             </a:r>
           </a:p>
         </p:txBody>
@@ -33068,7 +33562,7 @@
             </a:avLst>
           </a:prstGeom>
           <a:solidFill>
-            <a:srgbClr val="A995E0"/>
+            <a:srgbClr val="F8C018"/>
           </a:solidFill>
           <a:ln>
             <a:noFill/>
@@ -33113,7 +33607,7 @@
                 </a:solidFill>
                 <a:latin typeface="Calibri"/>
               </a:rPr>
-              <a:t>CNH · 6</a:t>
+              <a:t>Gerontología · 6</a:t>
             </a:r>
           </a:p>
         </p:txBody>

</xml_diff>